<commit_message>
Add faithful Tabla Síntesis slide (11 subíndices) to infra prioritization
El ranking mostraba solo el Puntaje Total; se agrega la Tabla Síntesis
original de CIPUV con los 11 subíndices por distrito y el código de colores
Óptimo/Mínimo/Crítico, para reproducir fielmente la tabla fuente.

- Nuevo asset: presentations/assets/tabla-sintesis-infraestructura.png
- Slide "Tabla Síntesis" tras el ranking (28 → 29 slides), en PPTX y HTML.
- Verificado: valores del ranking coinciden con la columna Puntaje Total.

Co-Authored-By: Claude Opus 4.8 <noreply@anthropic.com>
Claude-Session: https://claude.ai/code/session_01QZiauNhtTVEiLX1MmVDGUu
</commit_message>
<xml_diff>
--- a/presentations/lujan-de-cuyo-gestion-suelo.pptx
+++ b/presentations/lujan-de-cuyo-gestion-suelo.pptx
@@ -33,6 +33,7 @@
     <p:sldId id="281" r:id="rId33"/>
     <p:sldId id="282" r:id="rId34"/>
     <p:sldId id="283" r:id="rId35"/>
+    <p:sldId id="284" r:id="rId36"/>
   </p:sldIdLst>
   <p:sldSz cx="12191695" cy="6858000" type="screen4x3"/>
   <p:notesSz cx="6858000" cy="9144000"/>
@@ -1579,7 +1580,7 @@
           <a:lstStyle/>
           <a:p>
             <a:r>
-              <a:t>La honestidad del caso: sin regla, el dinero va a donde ya está bien. El ICD existe precisamente para forzar la corrección hacia los distritos D y E.</a:t>
+              <a:t>La tabla completa que sostiene el ranking: 11 subíndices por distrito, cada celda clasificada en Óptimo (verde), Mínimo (amarillo) o Crítico (rojo). El indicador 1.1 (infraestructura verde pública) queda pendiente por falta de datos. Es la tabla original del ejercicio piloto CIPUV.</a:t>
             </a:r>
           </a:p>
         </p:txBody>
@@ -1649,7 +1650,7 @@
           <a:lstStyle/>
           <a:p>
             <a:r>
-              <a:t>La escala en tres cifras: lo que ya hay, el potencial propio y la brecha que sólo cierra el apalancamiento. El fideicomiso es el puente entre la segunda y la tercera.</a:t>
+              <a:t>La honestidad del caso: sin regla, el dinero va a donde ya está bien. El ICD existe precisamente para forzar la corrección hacia los distritos D y E.</a:t>
             </a:r>
           </a:p>
         </p:txBody>
@@ -1719,7 +1720,7 @@
           <a:lstStyle/>
           <a:p>
             <a:r>
-              <a:t>La respuesta a la pregunta de examen: como el suelo es inelástico por el límite del agua, el impuesto no se traslada, recae en el dueño de la tierra. Es progresivo.</a:t>
+              <a:t>La escala en tres cifras: lo que ya hay, el potencial propio y la brecha que sólo cierra el apalancamiento. El fideicomiso es el puente entre la segunda y la tercera.</a:t>
             </a:r>
           </a:p>
         </p:txBody>
@@ -1789,7 +1790,7 @@
           <a:lstStyle/>
           <a:p>
             <a:r>
-              <a:t>El bonus: los mismos instrumentos que financian la adaptación también reducen emisiones. No hay que elegir entre adaptar y mitigar; aquí es la misma decisión.</a:t>
+              <a:t>La respuesta a la pregunta de examen: como el suelo es inelástico por el límite del agua, el impuesto no se traslada, recae en el dueño de la tierra. Es progresivo.</a:t>
             </a:r>
           </a:p>
         </p:txBody>
@@ -1859,7 +1860,7 @@
           <a:lstStyle/>
           <a:p>
             <a:r>
-              <a:t>Preguntas para abrir el debate. La primera y la última suelen dar la mejor discusión: incidencia del impuesto y sostenibilidad política.</a:t>
+              <a:t>El bonus: los mismos instrumentos que financian la adaptación también reducen emisiones. No hay que elegir entre adaptar y mitigar; aquí es la misma decisión.</a:t>
             </a:r>
           </a:p>
         </p:txBody>
@@ -1885,6 +1886,76 @@
 </file>
 
 <file path=ppt/notesSlides/notesSlide28.xml><?xml version="1.0" encoding="utf-8"?>
+<p:notes xmlns:a="http://schemas.openxmlformats.org/drawingml/2006/main" xmlns:p="http://schemas.openxmlformats.org/presentationml/2006/main" xmlns:r="http://schemas.openxmlformats.org/officeDocument/2006/relationships">
+  <p:cSld>
+    <p:spTree>
+      <p:nvGrpSpPr>
+        <p:cNvPr id="1" name=""/>
+        <p:cNvGrpSpPr/>
+        <p:nvPr/>
+      </p:nvGrpSpPr>
+      <p:grpSpPr>
+        <a:xfrm>
+          <a:off x="0" y="0"/>
+          <a:ext cx="0" cy="0"/>
+          <a:chOff x="0" y="0"/>
+          <a:chExt cx="0" cy="0"/>
+        </a:xfrm>
+      </p:grpSpPr>
+      <p:sp>
+        <p:nvSpPr>
+          <p:cNvPr id="2" name="Slide Image Placeholder 1"/>
+          <p:cNvSpPr>
+            <a:spLocks noGrp="1"/>
+          </p:cNvSpPr>
+          <p:nvPr>
+            <p:ph type="sldImg" idx="2"/>
+          </p:nvPr>
+        </p:nvSpPr>
+        <p:spPr/>
+      </p:sp>
+      <p:sp>
+        <p:nvSpPr>
+          <p:cNvPr id="3" name="Notes Placeholder 2"/>
+          <p:cNvSpPr>
+            <a:spLocks noGrp="1"/>
+          </p:cNvSpPr>
+          <p:nvPr>
+            <p:ph type="body" idx="3" sz="quarter"/>
+          </p:nvPr>
+        </p:nvSpPr>
+        <p:spPr/>
+        <p:txBody>
+          <a:bodyPr/>
+          <a:lstStyle/>
+          <a:p>
+            <a:r>
+              <a:t>Preguntas para abrir el debate. La primera y la última suelen dar la mejor discusión: incidencia del impuesto y sostenibilidad política.</a:t>
+            </a:r>
+          </a:p>
+        </p:txBody>
+      </p:sp>
+      <p:sp>
+        <p:nvSpPr>
+          <p:cNvPr id="4" name="Slide Number Placeholder 3"/>
+          <p:cNvSpPr>
+            <a:spLocks noGrp="1"/>
+          </p:cNvSpPr>
+          <p:nvPr>
+            <p:ph type="sldNum" idx="5" sz="quarter"/>
+          </p:nvPr>
+        </p:nvSpPr>
+        <p:spPr/>
+      </p:sp>
+    </p:spTree>
+  </p:cSld>
+  <p:clrMapOvr>
+    <a:masterClrMapping/>
+  </p:clrMapOvr>
+</p:notes>
+</file>
+
+<file path=ppt/notesSlides/notesSlide29.xml><?xml version="1.0" encoding="utf-8"?>
 <p:notes xmlns:a="http://schemas.openxmlformats.org/drawingml/2006/main" xmlns:p="http://schemas.openxmlformats.org/presentationml/2006/main" xmlns:r="http://schemas.openxmlformats.org/officeDocument/2006/relationships">
   <p:cSld>
     <p:spTree>
@@ -7985,7 +8056,7 @@
                 </a:solidFill>
                 <a:latin typeface="Calibri"/>
               </a:rPr>
-              <a:t>11 / 28</a:t>
+              <a:t>11 / 29</a:t>
             </a:r>
           </a:p>
         </p:txBody>
@@ -8629,7 +8700,7 @@
                 </a:solidFill>
                 <a:latin typeface="Calibri"/>
               </a:rPr>
-              <a:t>12 / 28</a:t>
+              <a:t>12 / 29</a:t>
             </a:r>
           </a:p>
         </p:txBody>
@@ -9641,7 +9712,7 @@
                 </a:solidFill>
                 <a:latin typeface="Calibri"/>
               </a:rPr>
-              <a:t>13 / 28</a:t>
+              <a:t>13 / 29</a:t>
             </a:r>
           </a:p>
         </p:txBody>
@@ -10294,7 +10365,7 @@
                 </a:solidFill>
                 <a:latin typeface="Calibri"/>
               </a:rPr>
-              <a:t>14 / 28</a:t>
+              <a:t>14 / 29</a:t>
             </a:r>
           </a:p>
         </p:txBody>
@@ -11153,7 +11224,7 @@
                 </a:solidFill>
                 <a:latin typeface="Calibri"/>
               </a:rPr>
-              <a:t>15 / 28</a:t>
+              <a:t>15 / 29</a:t>
             </a:r>
           </a:p>
         </p:txBody>
@@ -13942,7 +14013,7 @@
                 </a:solidFill>
                 <a:latin typeface="Calibri"/>
               </a:rPr>
-              <a:t>17 / 28</a:t>
+              <a:t>17 / 29</a:t>
             </a:r>
           </a:p>
         </p:txBody>
@@ -15000,7 +15071,7 @@
                 </a:solidFill>
                 <a:latin typeface="Calibri"/>
               </a:rPr>
-              <a:t>18 / 28</a:t>
+              <a:t>18 / 29</a:t>
             </a:r>
           </a:p>
         </p:txBody>
@@ -16056,7 +16127,7 @@
                 </a:solidFill>
                 <a:latin typeface="Calibri"/>
               </a:rPr>
-              <a:t>19 / 28</a:t>
+              <a:t>19 / 29</a:t>
             </a:r>
           </a:p>
         </p:txBody>
@@ -17493,7 +17564,7 @@
                 </a:solidFill>
                 <a:latin typeface="Calibri"/>
               </a:rPr>
-              <a:t>02 / 28</a:t>
+              <a:t>02 / 29</a:t>
             </a:r>
           </a:p>
         </p:txBody>
@@ -19452,7 +19523,7 @@
                 </a:solidFill>
                 <a:latin typeface="Calibri"/>
               </a:rPr>
-              <a:t>20 / 28</a:t>
+              <a:t>20 / 29</a:t>
             </a:r>
           </a:p>
         </p:txBody>
@@ -20756,7 +20827,7 @@
                 </a:solidFill>
                 <a:latin typeface="Calibri"/>
               </a:rPr>
-              <a:t>21 / 28</a:t>
+              <a:t>21 / 29</a:t>
             </a:r>
           </a:p>
         </p:txBody>
@@ -23405,7 +23476,7 @@
                 </a:solidFill>
                 <a:latin typeface="Calibri"/>
               </a:rPr>
-              <a:t>22 / 28</a:t>
+              <a:t>22 / 29</a:t>
             </a:r>
           </a:p>
         </p:txBody>
@@ -23495,6 +23566,324 @@
             <a:avLst/>
           </a:prstGeom>
           <a:solidFill>
+            <a:srgbClr val="5A8F6B"/>
+          </a:solidFill>
+          <a:ln>
+            <a:noFill/>
+          </a:ln>
+          <a:effectLst/>
+        </p:spPr>
+        <p:style>
+          <a:lnRef idx="1">
+            <a:schemeClr val="accent1"/>
+          </a:lnRef>
+          <a:fillRef idx="3">
+            <a:schemeClr val="accent1"/>
+          </a:fillRef>
+          <a:effectRef idx="2">
+            <a:schemeClr val="accent1"/>
+          </a:effectRef>
+          <a:fontRef idx="minor">
+            <a:schemeClr val="lt1"/>
+          </a:fontRef>
+        </p:style>
+        <p:txBody>
+          <a:bodyPr rtlCol="0" anchor="ctr"/>
+          <a:lstStyle/>
+          <a:p>
+            <a:pPr algn="ctr"/>
+          </a:p>
+        </p:txBody>
+      </p:sp>
+      <p:sp>
+        <p:nvSpPr>
+          <p:cNvPr id="4" name="TextBox 3"/>
+          <p:cNvSpPr txBox="1"/>
+          <p:nvPr/>
+        </p:nvSpPr>
+        <p:spPr>
+          <a:xfrm>
+            <a:off x="832104" y="566928"/>
+            <a:ext cx="10058400" cy="329184"/>
+          </a:xfrm>
+          <a:prstGeom prst="rect">
+            <a:avLst/>
+          </a:prstGeom>
+          <a:noFill/>
+        </p:spPr>
+        <p:txBody>
+          <a:bodyPr wrap="square" anchor="ctr" lIns="0" rIns="0" tIns="0" bIns="0">
+            <a:spAutoFit/>
+          </a:bodyPr>
+          <a:lstStyle/>
+          <a:p>
+            <a:pPr algn="l">
+              <a:lnSpc>
+                <a:spcPct val="106000"/>
+              </a:lnSpc>
+              <a:spcBef>
+                <a:spcPts val="0"/>
+              </a:spcBef>
+              <a:spcAft>
+                <a:spcPts val="0"/>
+              </a:spcAft>
+            </a:pPr>
+            <a:r>
+              <a:rPr sz="1500" b="1" i="0">
+                <a:solidFill>
+                  <a:srgbClr val="5A8F6B"/>
+                </a:solidFill>
+                <a:latin typeface="Calibri"/>
+              </a:rPr>
+              <a:t>SÍNTESIS · 05</a:t>
+            </a:r>
+          </a:p>
+        </p:txBody>
+      </p:sp>
+      <p:sp>
+        <p:nvSpPr>
+          <p:cNvPr id="5" name="TextBox 4"/>
+          <p:cNvSpPr txBox="1"/>
+          <p:nvPr/>
+        </p:nvSpPr>
+        <p:spPr>
+          <a:xfrm>
+            <a:off x="685800" y="987552"/>
+            <a:ext cx="10789920" cy="1188720"/>
+          </a:xfrm>
+          <a:prstGeom prst="rect">
+            <a:avLst/>
+          </a:prstGeom>
+          <a:noFill/>
+        </p:spPr>
+        <p:txBody>
+          <a:bodyPr wrap="square" anchor="t" lIns="0" rIns="0" tIns="0" bIns="0">
+            <a:spAutoFit/>
+          </a:bodyPr>
+          <a:lstStyle/>
+          <a:p>
+            <a:pPr algn="l">
+              <a:lnSpc>
+                <a:spcPct val="100000"/>
+              </a:lnSpc>
+              <a:spcBef>
+                <a:spcPts val="0"/>
+              </a:spcBef>
+              <a:spcAft>
+                <a:spcPts val="0"/>
+              </a:spcAft>
+            </a:pPr>
+            <a:r>
+              <a:rPr sz="3000" b="1" i="0">
+                <a:solidFill>
+                  <a:srgbClr val="4E5869"/>
+                </a:solidFill>
+                <a:latin typeface="Calibri"/>
+              </a:rPr>
+              <a:t>Tabla Síntesis: los 11 subíndices por distrito</a:t>
+            </a:r>
+          </a:p>
+        </p:txBody>
+      </p:sp>
+      <p:sp>
+        <p:nvSpPr>
+          <p:cNvPr id="6" name="Rounded Rectangle 5"/>
+          <p:cNvSpPr/>
+          <p:nvPr/>
+        </p:nvSpPr>
+        <p:spPr>
+          <a:xfrm>
+            <a:off x="8138160" y="1024128"/>
+            <a:ext cx="1234440" cy="384048"/>
+          </a:xfrm>
+          <a:prstGeom prst="roundRect">
+            <a:avLst>
+              <a:gd name="adj" fmla="val 50000"/>
+            </a:avLst>
+          </a:prstGeom>
+          <a:solidFill>
+            <a:srgbClr val="5A8F6B"/>
+          </a:solidFill>
+          <a:ln>
+            <a:noFill/>
+          </a:ln>
+          <a:effectLst/>
+        </p:spPr>
+        <p:style>
+          <a:lnRef idx="1">
+            <a:schemeClr val="accent1"/>
+          </a:lnRef>
+          <a:fillRef idx="3">
+            <a:schemeClr val="accent1"/>
+          </a:fillRef>
+          <a:effectRef idx="2">
+            <a:schemeClr val="accent1"/>
+          </a:effectRef>
+          <a:fontRef idx="minor">
+            <a:schemeClr val="lt1"/>
+          </a:fontRef>
+        </p:style>
+        <p:txBody>
+          <a:bodyPr rtlCol="0" anchor="ctr"/>
+          <a:lstStyle/>
+          <a:p>
+            <a:pPr algn="ctr"/>
+          </a:p>
+        </p:txBody>
+      </p:sp>
+      <p:sp>
+        <p:nvSpPr>
+          <p:cNvPr id="7" name="TextBox 6"/>
+          <p:cNvSpPr txBox="1"/>
+          <p:nvPr/>
+        </p:nvSpPr>
+        <p:spPr>
+          <a:xfrm>
+            <a:off x="8138160" y="1024128"/>
+            <a:ext cx="1234440" cy="384048"/>
+          </a:xfrm>
+          <a:prstGeom prst="rect">
+            <a:avLst/>
+          </a:prstGeom>
+          <a:noFill/>
+        </p:spPr>
+        <p:txBody>
+          <a:bodyPr wrap="square" anchor="ctr" lIns="0" rIns="0" tIns="0" bIns="0">
+            <a:spAutoFit/>
+          </a:bodyPr>
+          <a:lstStyle/>
+          <a:p>
+            <a:pPr algn="ctr">
+              <a:lnSpc>
+                <a:spcPct val="106000"/>
+              </a:lnSpc>
+              <a:spcBef>
+                <a:spcPts val="0"/>
+              </a:spcBef>
+              <a:spcAft>
+                <a:spcPts val="0"/>
+              </a:spcAft>
+            </a:pPr>
+            <a:r>
+              <a:rPr sz="1150" b="1" i="0">
+                <a:solidFill>
+                  <a:srgbClr val="FFFFFF"/>
+                </a:solidFill>
+                <a:latin typeface="Calibri"/>
+              </a:rPr>
+              <a:t>ÓPTIMO</a:t>
+            </a:r>
+          </a:p>
+        </p:txBody>
+      </p:sp>
+      <p:sp>
+        <p:nvSpPr>
+          <p:cNvPr id="8" name="Rounded Rectangle 7"/>
+          <p:cNvSpPr/>
+          <p:nvPr/>
+        </p:nvSpPr>
+        <p:spPr>
+          <a:xfrm>
+            <a:off x="9464040" y="1024128"/>
+            <a:ext cx="1234440" cy="384048"/>
+          </a:xfrm>
+          <a:prstGeom prst="roundRect">
+            <a:avLst>
+              <a:gd name="adj" fmla="val 50000"/>
+            </a:avLst>
+          </a:prstGeom>
+          <a:solidFill>
+            <a:srgbClr val="B8860B"/>
+          </a:solidFill>
+          <a:ln>
+            <a:noFill/>
+          </a:ln>
+          <a:effectLst/>
+        </p:spPr>
+        <p:style>
+          <a:lnRef idx="1">
+            <a:schemeClr val="accent1"/>
+          </a:lnRef>
+          <a:fillRef idx="3">
+            <a:schemeClr val="accent1"/>
+          </a:fillRef>
+          <a:effectRef idx="2">
+            <a:schemeClr val="accent1"/>
+          </a:effectRef>
+          <a:fontRef idx="minor">
+            <a:schemeClr val="lt1"/>
+          </a:fontRef>
+        </p:style>
+        <p:txBody>
+          <a:bodyPr rtlCol="0" anchor="ctr"/>
+          <a:lstStyle/>
+          <a:p>
+            <a:pPr algn="ctr"/>
+          </a:p>
+        </p:txBody>
+      </p:sp>
+      <p:sp>
+        <p:nvSpPr>
+          <p:cNvPr id="9" name="TextBox 8"/>
+          <p:cNvSpPr txBox="1"/>
+          <p:nvPr/>
+        </p:nvSpPr>
+        <p:spPr>
+          <a:xfrm>
+            <a:off x="9464040" y="1024128"/>
+            <a:ext cx="1234440" cy="384048"/>
+          </a:xfrm>
+          <a:prstGeom prst="rect">
+            <a:avLst/>
+          </a:prstGeom>
+          <a:noFill/>
+        </p:spPr>
+        <p:txBody>
+          <a:bodyPr wrap="square" anchor="ctr" lIns="0" rIns="0" tIns="0" bIns="0">
+            <a:spAutoFit/>
+          </a:bodyPr>
+          <a:lstStyle/>
+          <a:p>
+            <a:pPr algn="ctr">
+              <a:lnSpc>
+                <a:spcPct val="106000"/>
+              </a:lnSpc>
+              <a:spcBef>
+                <a:spcPts val="0"/>
+              </a:spcBef>
+              <a:spcAft>
+                <a:spcPts val="0"/>
+              </a:spcAft>
+            </a:pPr>
+            <a:r>
+              <a:rPr sz="1150" b="1" i="0">
+                <a:solidFill>
+                  <a:srgbClr val="FFFFFF"/>
+                </a:solidFill>
+                <a:latin typeface="Calibri"/>
+              </a:rPr>
+              <a:t>MÍNIMO</a:t>
+            </a:r>
+          </a:p>
+        </p:txBody>
+      </p:sp>
+      <p:sp>
+        <p:nvSpPr>
+          <p:cNvPr id="10" name="Rounded Rectangle 9"/>
+          <p:cNvSpPr/>
+          <p:nvPr/>
+        </p:nvSpPr>
+        <p:spPr>
+          <a:xfrm>
+            <a:off x="10789920" y="1024128"/>
+            <a:ext cx="1234440" cy="384048"/>
+          </a:xfrm>
+          <a:prstGeom prst="roundRect">
+            <a:avLst>
+              <a:gd name="adj" fmla="val 50000"/>
+            </a:avLst>
+          </a:prstGeom>
+          <a:solidFill>
             <a:srgbClr val="B1456A"/>
           </a:solidFill>
           <a:ln>
@@ -23526,14 +23915,14 @@
       </p:sp>
       <p:sp>
         <p:nvSpPr>
-          <p:cNvPr id="4" name="TextBox 3"/>
-          <p:cNvSpPr txBox="1"/>
-          <p:nvPr/>
-        </p:nvSpPr>
-        <p:spPr>
-          <a:xfrm>
-            <a:off x="832104" y="566928"/>
-            <a:ext cx="10058400" cy="329184"/>
+          <p:cNvPr id="11" name="TextBox 10"/>
+          <p:cNvSpPr txBox="1"/>
+          <p:nvPr/>
+        </p:nvSpPr>
+        <p:spPr>
+          <a:xfrm>
+            <a:off x="10789920" y="1024128"/>
+            <a:ext cx="1234440" cy="384048"/>
           </a:xfrm>
           <a:prstGeom prst="rect">
             <a:avLst/>
@@ -23546,6 +23935,75 @@
           </a:bodyPr>
           <a:lstStyle/>
           <a:p>
+            <a:pPr algn="ctr">
+              <a:lnSpc>
+                <a:spcPct val="106000"/>
+              </a:lnSpc>
+              <a:spcBef>
+                <a:spcPts val="0"/>
+              </a:spcBef>
+              <a:spcAft>
+                <a:spcPts val="0"/>
+              </a:spcAft>
+            </a:pPr>
+            <a:r>
+              <a:rPr sz="1150" b="1" i="0">
+                <a:solidFill>
+                  <a:srgbClr val="FFFFFF"/>
+                </a:solidFill>
+                <a:latin typeface="Calibri"/>
+              </a:rPr>
+              <a:t>CRÍTICO</a:t>
+            </a:r>
+          </a:p>
+        </p:txBody>
+      </p:sp>
+      <p:pic>
+        <p:nvPicPr>
+          <p:cNvPr id="12" name="Picture 11" descr="tabla-sintesis-infraestructura.png"/>
+          <p:cNvPicPr>
+            <a:picLocks noChangeAspect="1"/>
+          </p:cNvPicPr>
+          <p:nvPr/>
+        </p:nvPicPr>
+        <p:blipFill>
+          <a:blip r:embed="rId2"/>
+          <a:stretch>
+            <a:fillRect/>
+          </a:stretch>
+        </p:blipFill>
+        <p:spPr>
+          <a:xfrm>
+            <a:off x="792327" y="1554480"/>
+            <a:ext cx="10607040" cy="4828698"/>
+          </a:xfrm>
+          <a:prstGeom prst="rect">
+            <a:avLst/>
+          </a:prstGeom>
+        </p:spPr>
+      </p:pic>
+      <p:sp>
+        <p:nvSpPr>
+          <p:cNvPr id="13" name="TextBox 12"/>
+          <p:cNvSpPr txBox="1"/>
+          <p:nvPr/>
+        </p:nvSpPr>
+        <p:spPr>
+          <a:xfrm>
+            <a:off x="685800" y="6053328"/>
+            <a:ext cx="10789920" cy="292608"/>
+          </a:xfrm>
+          <a:prstGeom prst="rect">
+            <a:avLst/>
+          </a:prstGeom>
+          <a:noFill/>
+        </p:spPr>
+        <p:txBody>
+          <a:bodyPr wrap="square" anchor="t" lIns="0" rIns="0" tIns="0" bIns="0">
+            <a:spAutoFit/>
+          </a:bodyPr>
+          <a:lstStyle/>
+          <a:p>
             <a:pPr algn="l">
               <a:lnSpc>
                 <a:spcPct val="106000"/>
@@ -23558,334 +24016,29 @@
               </a:spcAft>
             </a:pPr>
             <a:r>
-              <a:rPr sz="1500" b="1" i="0">
-                <a:solidFill>
-                  <a:srgbClr val="B1456A"/>
-                </a:solidFill>
-                <a:latin typeface="Calibri"/>
-              </a:rPr>
-              <a:t>LA PRUEBA DE EQUIDAD · 05</a:t>
-            </a:r>
-          </a:p>
-        </p:txBody>
-      </p:sp>
-      <p:sp>
-        <p:nvSpPr>
-          <p:cNvPr id="5" name="TextBox 4"/>
-          <p:cNvSpPr txBox="1"/>
-          <p:nvPr/>
-        </p:nvSpPr>
-        <p:spPr>
-          <a:xfrm>
-            <a:off x="685800" y="987552"/>
-            <a:ext cx="10789920" cy="1188720"/>
-          </a:xfrm>
-          <a:prstGeom prst="rect">
-            <a:avLst/>
-          </a:prstGeom>
-          <a:noFill/>
-        </p:spPr>
-        <p:txBody>
-          <a:bodyPr wrap="square" anchor="t" lIns="0" rIns="0" tIns="0" bIns="0">
-            <a:spAutoFit/>
-          </a:bodyPr>
-          <a:lstStyle/>
-          <a:p>
-            <a:pPr algn="l">
-              <a:lnSpc>
-                <a:spcPct val="100000"/>
-              </a:lnSpc>
-              <a:spcBef>
-                <a:spcPts val="0"/>
-              </a:spcBef>
-              <a:spcAft>
-                <a:spcPts val="0"/>
-              </a:spcAft>
-            </a:pPr>
-            <a:r>
-              <a:rPr sz="3600" b="1" i="0">
-                <a:solidFill>
-                  <a:srgbClr val="4E5869"/>
-                </a:solidFill>
-                <a:latin typeface="Calibri"/>
-              </a:rPr>
-              <a:t>¿Dónde se necesita vs. dónde se invierte?</a:t>
-            </a:r>
-          </a:p>
-        </p:txBody>
-      </p:sp>
-      <p:sp>
-        <p:nvSpPr>
-          <p:cNvPr id="6" name="TextBox 5"/>
-          <p:cNvSpPr txBox="1"/>
-          <p:nvPr/>
-        </p:nvSpPr>
-        <p:spPr>
-          <a:xfrm>
-            <a:off x="685800" y="2148840"/>
-            <a:ext cx="10607040" cy="3657600"/>
-          </a:xfrm>
-          <a:prstGeom prst="rect">
-            <a:avLst/>
-          </a:prstGeom>
-          <a:noFill/>
-        </p:spPr>
-        <p:txBody>
-          <a:bodyPr wrap="square" lIns="0" rIns="0" tIns="0" bIns="0">
-            <a:spAutoFit/>
-          </a:bodyPr>
-          <a:lstStyle/>
-          <a:p>
-            <a:pPr>
-              <a:lnSpc>
-                <a:spcPct val="112000"/>
-              </a:lnSpc>
-              <a:spcBef>
-                <a:spcPts val="0"/>
-              </a:spcBef>
-              <a:spcAft>
-                <a:spcPts val="2200"/>
-              </a:spcAft>
-            </a:pPr>
-            <a:r>
-              <a:rPr sz="2000" b="1" i="0">
-                <a:solidFill>
-                  <a:srgbClr val="B8860B"/>
-                </a:solidFill>
-                <a:latin typeface="Calibri"/>
-              </a:rPr>
-              <a:t>▪  </a:t>
-            </a:r>
-            <a:r>
-              <a:rPr sz="2100" b="0" i="0">
-                <a:solidFill>
-                  <a:srgbClr val="2B3038"/>
-                </a:solidFill>
-                <a:latin typeface="Calibri"/>
-              </a:rPr>
-              <a:t>Las 2 mayores inversiones caen en distritos que </a:t>
-            </a:r>
-            <a:r>
-              <a:rPr sz="2100" b="1" i="0">
-                <a:solidFill>
-                  <a:srgbClr val="2F8F9D"/>
-                </a:solidFill>
-                <a:latin typeface="Calibri"/>
-              </a:rPr>
-              <a:t>ya puntúan bien</a:t>
-            </a:r>
-            <a:r>
-              <a:rPr sz="2100" b="0" i="0">
-                <a:solidFill>
-                  <a:srgbClr val="2B3038"/>
-                </a:solidFill>
-                <a:latin typeface="Calibri"/>
-              </a:rPr>
-              <a:t> en verde.</a:t>
-            </a:r>
-          </a:p>
-          <a:p>
-            <a:pPr>
-              <a:lnSpc>
-                <a:spcPct val="112000"/>
-              </a:lnSpc>
-              <a:spcBef>
-                <a:spcPts val="0"/>
-              </a:spcBef>
-              <a:spcAft>
-                <a:spcPts val="2200"/>
-              </a:spcAft>
-            </a:pPr>
-            <a:r>
-              <a:rPr sz="2000" b="1" i="0">
-                <a:solidFill>
-                  <a:srgbClr val="B8860B"/>
-                </a:solidFill>
-                <a:latin typeface="Calibri"/>
-              </a:rPr>
-              <a:t>▪  </a:t>
-            </a:r>
-            <a:r>
-              <a:rPr sz="2100" b="0" i="0">
-                <a:solidFill>
-                  <a:srgbClr val="2B3038"/>
-                </a:solidFill>
-                <a:latin typeface="Calibri"/>
-              </a:rPr>
-              <a:t>Los más necesitados </a:t>
-            </a:r>
-            <a:r>
-              <a:rPr sz="2100" b="1" i="0">
-                <a:solidFill>
-                  <a:srgbClr val="B1456A"/>
-                </a:solidFill>
-                <a:latin typeface="Calibri"/>
-              </a:rPr>
-              <a:t>(Vistalba, Las Compuertas, Industrial)</a:t>
-            </a:r>
-            <a:r>
-              <a:rPr sz="2100" b="0" i="0">
-                <a:solidFill>
-                  <a:srgbClr val="2B3038"/>
-                </a:solidFill>
-                <a:latin typeface="Calibri"/>
-              </a:rPr>
-              <a:t> no reciben obra verde.</a:t>
-            </a:r>
-          </a:p>
-          <a:p>
-            <a:pPr>
-              <a:lnSpc>
-                <a:spcPct val="112000"/>
-              </a:lnSpc>
-              <a:spcBef>
-                <a:spcPts val="0"/>
-              </a:spcBef>
-              <a:spcAft>
-                <a:spcPts val="2200"/>
-              </a:spcAft>
-            </a:pPr>
-            <a:r>
-              <a:rPr sz="2000" b="1" i="0">
-                <a:solidFill>
-                  <a:srgbClr val="B8860B"/>
-                </a:solidFill>
-                <a:latin typeface="Calibri"/>
-              </a:rPr>
-              <a:t>▪  </a:t>
-            </a:r>
-            <a:r>
-              <a:rPr sz="2100" b="0" i="0">
-                <a:solidFill>
-                  <a:srgbClr val="2B3038"/>
-                </a:solidFill>
-                <a:latin typeface="Calibri"/>
-              </a:rPr>
-              <a:t>La palanca: </a:t>
-            </a:r>
-            <a:r>
-              <a:rPr sz="2100" b="1" i="0">
-                <a:solidFill>
-                  <a:srgbClr val="5A8F6B"/>
-                </a:solidFill>
-                <a:latin typeface="Calibri"/>
-              </a:rPr>
-              <a:t>reasignar las microplazas (ARS 1.200 M) a distritos D/E</a:t>
-            </a:r>
-            <a:r>
-              <a:rPr sz="2100" b="0" i="0">
-                <a:solidFill>
-                  <a:srgbClr val="2B3038"/>
-                </a:solidFill>
-                <a:latin typeface="Calibri"/>
-              </a:rPr>
-              <a:t>.</a:t>
-            </a:r>
-          </a:p>
-        </p:txBody>
-      </p:sp>
-      <p:sp>
-        <p:nvSpPr>
-          <p:cNvPr id="7" name="TextBox 6"/>
-          <p:cNvSpPr txBox="1"/>
-          <p:nvPr/>
-        </p:nvSpPr>
-        <p:spPr>
-          <a:xfrm>
-            <a:off x="685800" y="5394960"/>
-            <a:ext cx="10698480" cy="640080"/>
-          </a:xfrm>
-          <a:prstGeom prst="rect">
-            <a:avLst/>
-          </a:prstGeom>
-          <a:noFill/>
-        </p:spPr>
-        <p:txBody>
-          <a:bodyPr wrap="square" anchor="t" lIns="0" rIns="0" tIns="0" bIns="0">
-            <a:spAutoFit/>
-          </a:bodyPr>
-          <a:lstStyle/>
-          <a:p>
-            <a:pPr algn="l">
-              <a:lnSpc>
-                <a:spcPct val="110000"/>
-              </a:lnSpc>
-              <a:spcBef>
-                <a:spcPts val="0"/>
-              </a:spcBef>
-              <a:spcAft>
-                <a:spcPts val="0"/>
-              </a:spcAft>
-            </a:pPr>
-            <a:r>
-              <a:rPr sz="1800" b="1" i="1">
-                <a:solidFill>
-                  <a:srgbClr val="B8860B"/>
-                </a:solidFill>
-                <a:latin typeface="Calibri"/>
-              </a:rPr>
-              <a:t>El ICD no describe: corrige. Alinea la inversión con la necesidad, no con la capacidad.</a:t>
-            </a:r>
-          </a:p>
-        </p:txBody>
-      </p:sp>
-      <p:sp>
-        <p:nvSpPr>
-          <p:cNvPr id="8" name="TextBox 7"/>
-          <p:cNvSpPr txBox="1"/>
-          <p:nvPr/>
-        </p:nvSpPr>
-        <p:spPr>
-          <a:xfrm>
-            <a:off x="685800" y="6327648"/>
-            <a:ext cx="8229600" cy="365760"/>
-          </a:xfrm>
-          <a:prstGeom prst="rect">
-            <a:avLst/>
-          </a:prstGeom>
-          <a:noFill/>
-        </p:spPr>
-        <p:txBody>
-          <a:bodyPr wrap="square" anchor="ctr" lIns="0" rIns="0" tIns="0" bIns="0">
-            <a:spAutoFit/>
-          </a:bodyPr>
-          <a:lstStyle/>
-          <a:p>
-            <a:pPr algn="l">
-              <a:lnSpc>
-                <a:spcPct val="106000"/>
-              </a:lnSpc>
-              <a:spcBef>
-                <a:spcPts val="0"/>
-              </a:spcBef>
-              <a:spcAft>
-                <a:spcPts val="0"/>
-              </a:spcAft>
-            </a:pPr>
-            <a:r>
-              <a:rPr sz="1100" b="0" i="0">
+              <a:rPr sz="1150" b="0" i="1">
                 <a:solidFill>
                   <a:srgbClr val="7A828E"/>
                 </a:solidFill>
                 <a:latin typeface="Calibri"/>
               </a:rPr>
-              <a:t>Luján de Cuyo · Gestión del suelo   ·   </a:t>
-            </a:r>
-            <a:r>
-              <a:rPr sz="1100" b="1" i="0">
+              <a:t>Cada indicador se pondera sobre 11 puntos: Óptimo 1 · Mínimo 0,5 · Crítico 0 · s/d computa 0.  </a:t>
+            </a:r>
+            <a:r>
+              <a:rPr sz="1150" b="0" i="1">
                 <a:solidFill>
                   <a:srgbClr val="6F7D94"/>
                 </a:solidFill>
                 <a:latin typeface="Calibri"/>
               </a:rPr>
-              <a:t>CIPUV–UTDT / Lincoln Institute</a:t>
-            </a:r>
-          </a:p>
-        </p:txBody>
-      </p:sp>
-      <p:sp>
-        <p:nvSpPr>
-          <p:cNvPr id="9" name="TextBox 8"/>
+              <a:t>Fuente: elaboración propia CIPUV–UTDT.</a:t>
+            </a:r>
+          </a:p>
+        </p:txBody>
+      </p:sp>
+      <p:sp>
+        <p:nvSpPr>
+          <p:cNvPr id="14" name="TextBox 13"/>
           <p:cNvSpPr txBox="1"/>
           <p:nvPr/>
         </p:nvSpPr>
@@ -23923,7 +24076,7 @@
                 </a:solidFill>
                 <a:latin typeface="Calibri"/>
               </a:rPr>
-              <a:t>23 / 28</a:t>
+              <a:t>23 / 29</a:t>
             </a:r>
           </a:p>
         </p:txBody>
@@ -24013,7 +24166,7 @@
             <a:avLst/>
           </a:prstGeom>
           <a:solidFill>
-            <a:srgbClr val="B8860B"/>
+            <a:srgbClr val="B1456A"/>
           </a:solidFill>
           <a:ln>
             <a:noFill/>
@@ -24078,11 +24231,11 @@
             <a:r>
               <a:rPr sz="1500" b="1" i="0">
                 <a:solidFill>
-                  <a:srgbClr val="B8860B"/>
-                </a:solidFill>
-                <a:latin typeface="Calibri"/>
-              </a:rPr>
-              <a:t>LOS NÚMEROS REALES · 06</a:t>
+                  <a:srgbClr val="B1456A"/>
+                </a:solidFill>
+                <a:latin typeface="Calibri"/>
+              </a:rPr>
+              <a:t>LA PRUEBA DE EQUIDAD · 05</a:t>
             </a:r>
           </a:p>
         </p:txBody>
@@ -24127,626 +24280,229 @@
                 </a:solidFill>
                 <a:latin typeface="Calibri"/>
               </a:rPr>
-              <a:t>Potencial de recaudación</a:t>
-            </a:r>
-          </a:p>
-        </p:txBody>
-      </p:sp>
-      <p:sp>
-        <p:nvSpPr>
-          <p:cNvPr id="6" name="Rounded Rectangle 5"/>
-          <p:cNvSpPr/>
-          <p:nvPr/>
-        </p:nvSpPr>
-        <p:spPr>
-          <a:xfrm>
-            <a:off x="685800" y="2468880"/>
-            <a:ext cx="3520440" cy="2651760"/>
-          </a:xfrm>
-          <a:prstGeom prst="roundRect">
-            <a:avLst>
-              <a:gd name="adj" fmla="val 6000"/>
-            </a:avLst>
-          </a:prstGeom>
-          <a:solidFill>
-            <a:srgbClr val="FFFFFF"/>
-          </a:solidFill>
-          <a:ln w="12700">
-            <a:solidFill>
-              <a:srgbClr val="E3E6EA"/>
-            </a:solidFill>
-          </a:ln>
-          <a:effectLst/>
-          <a:effectLst>
-            <a:outerShdw blurRad="90000" dist="40000" dir="5400000" rotWithShape="0">
-              <a:srgbClr val="28323E">
-                <a:alpha val="20000"/>
-              </a:srgbClr>
-            </a:outerShdw>
-          </a:effectLst>
-        </p:spPr>
-        <p:style>
-          <a:lnRef idx="1">
-            <a:schemeClr val="accent1"/>
-          </a:lnRef>
-          <a:fillRef idx="3">
-            <a:schemeClr val="accent1"/>
-          </a:fillRef>
-          <a:effectRef idx="2">
-            <a:schemeClr val="accent1"/>
-          </a:effectRef>
-          <a:fontRef idx="minor">
-            <a:schemeClr val="lt1"/>
-          </a:fontRef>
-        </p:style>
-        <p:txBody>
-          <a:bodyPr rtlCol="0" anchor="ctr"/>
-          <a:lstStyle/>
-          <a:p>
-            <a:pPr algn="ctr"/>
-          </a:p>
-        </p:txBody>
-      </p:sp>
-      <p:sp>
-        <p:nvSpPr>
-          <p:cNvPr id="7" name="Rectangle 6"/>
-          <p:cNvSpPr/>
-          <p:nvPr/>
-        </p:nvSpPr>
-        <p:spPr>
-          <a:xfrm>
-            <a:off x="685800" y="2468880"/>
-            <a:ext cx="3520440" cy="76200"/>
-          </a:xfrm>
-          <a:prstGeom prst="rect">
-            <a:avLst/>
-          </a:prstGeom>
-          <a:solidFill>
-            <a:srgbClr val="5A8F6B"/>
-          </a:solidFill>
-          <a:ln>
-            <a:noFill/>
-          </a:ln>
-          <a:effectLst/>
-        </p:spPr>
-        <p:style>
-          <a:lnRef idx="1">
-            <a:schemeClr val="accent1"/>
-          </a:lnRef>
-          <a:fillRef idx="3">
-            <a:schemeClr val="accent1"/>
-          </a:fillRef>
-          <a:effectRef idx="2">
-            <a:schemeClr val="accent1"/>
-          </a:effectRef>
-          <a:fontRef idx="minor">
-            <a:schemeClr val="lt1"/>
-          </a:fontRef>
-        </p:style>
-        <p:txBody>
-          <a:bodyPr rtlCol="0" anchor="ctr"/>
-          <a:lstStyle/>
-          <a:p>
-            <a:pPr algn="ctr"/>
+              <a:t>¿Dónde se necesita vs. dónde se invierte?</a:t>
+            </a:r>
+          </a:p>
+        </p:txBody>
+      </p:sp>
+      <p:sp>
+        <p:nvSpPr>
+          <p:cNvPr id="6" name="TextBox 5"/>
+          <p:cNvSpPr txBox="1"/>
+          <p:nvPr/>
+        </p:nvSpPr>
+        <p:spPr>
+          <a:xfrm>
+            <a:off x="685800" y="2148840"/>
+            <a:ext cx="10607040" cy="3657600"/>
+          </a:xfrm>
+          <a:prstGeom prst="rect">
+            <a:avLst/>
+          </a:prstGeom>
+          <a:noFill/>
+        </p:spPr>
+        <p:txBody>
+          <a:bodyPr wrap="square" lIns="0" rIns="0" tIns="0" bIns="0">
+            <a:spAutoFit/>
+          </a:bodyPr>
+          <a:lstStyle/>
+          <a:p>
+            <a:pPr>
+              <a:lnSpc>
+                <a:spcPct val="112000"/>
+              </a:lnSpc>
+              <a:spcBef>
+                <a:spcPts val="0"/>
+              </a:spcBef>
+              <a:spcAft>
+                <a:spcPts val="2200"/>
+              </a:spcAft>
+            </a:pPr>
+            <a:r>
+              <a:rPr sz="2000" b="1" i="0">
+                <a:solidFill>
+                  <a:srgbClr val="B8860B"/>
+                </a:solidFill>
+                <a:latin typeface="Calibri"/>
+              </a:rPr>
+              <a:t>▪  </a:t>
+            </a:r>
+            <a:r>
+              <a:rPr sz="2100" b="0" i="0">
+                <a:solidFill>
+                  <a:srgbClr val="2B3038"/>
+                </a:solidFill>
+                <a:latin typeface="Calibri"/>
+              </a:rPr>
+              <a:t>Las 2 mayores inversiones caen en distritos que </a:t>
+            </a:r>
+            <a:r>
+              <a:rPr sz="2100" b="1" i="0">
+                <a:solidFill>
+                  <a:srgbClr val="2F8F9D"/>
+                </a:solidFill>
+                <a:latin typeface="Calibri"/>
+              </a:rPr>
+              <a:t>ya puntúan bien</a:t>
+            </a:r>
+            <a:r>
+              <a:rPr sz="2100" b="0" i="0">
+                <a:solidFill>
+                  <a:srgbClr val="2B3038"/>
+                </a:solidFill>
+                <a:latin typeface="Calibri"/>
+              </a:rPr>
+              <a:t> en verde.</a:t>
+            </a:r>
+          </a:p>
+          <a:p>
+            <a:pPr>
+              <a:lnSpc>
+                <a:spcPct val="112000"/>
+              </a:lnSpc>
+              <a:spcBef>
+                <a:spcPts val="0"/>
+              </a:spcBef>
+              <a:spcAft>
+                <a:spcPts val="2200"/>
+              </a:spcAft>
+            </a:pPr>
+            <a:r>
+              <a:rPr sz="2000" b="1" i="0">
+                <a:solidFill>
+                  <a:srgbClr val="B8860B"/>
+                </a:solidFill>
+                <a:latin typeface="Calibri"/>
+              </a:rPr>
+              <a:t>▪  </a:t>
+            </a:r>
+            <a:r>
+              <a:rPr sz="2100" b="0" i="0">
+                <a:solidFill>
+                  <a:srgbClr val="2B3038"/>
+                </a:solidFill>
+                <a:latin typeface="Calibri"/>
+              </a:rPr>
+              <a:t>Los más necesitados </a:t>
+            </a:r>
+            <a:r>
+              <a:rPr sz="2100" b="1" i="0">
+                <a:solidFill>
+                  <a:srgbClr val="B1456A"/>
+                </a:solidFill>
+                <a:latin typeface="Calibri"/>
+              </a:rPr>
+              <a:t>(Vistalba, Las Compuertas, Industrial)</a:t>
+            </a:r>
+            <a:r>
+              <a:rPr sz="2100" b="0" i="0">
+                <a:solidFill>
+                  <a:srgbClr val="2B3038"/>
+                </a:solidFill>
+                <a:latin typeface="Calibri"/>
+              </a:rPr>
+              <a:t> no reciben obra verde.</a:t>
+            </a:r>
+          </a:p>
+          <a:p>
+            <a:pPr>
+              <a:lnSpc>
+                <a:spcPct val="112000"/>
+              </a:lnSpc>
+              <a:spcBef>
+                <a:spcPts val="0"/>
+              </a:spcBef>
+              <a:spcAft>
+                <a:spcPts val="2200"/>
+              </a:spcAft>
+            </a:pPr>
+            <a:r>
+              <a:rPr sz="2000" b="1" i="0">
+                <a:solidFill>
+                  <a:srgbClr val="B8860B"/>
+                </a:solidFill>
+                <a:latin typeface="Calibri"/>
+              </a:rPr>
+              <a:t>▪  </a:t>
+            </a:r>
+            <a:r>
+              <a:rPr sz="2100" b="0" i="0">
+                <a:solidFill>
+                  <a:srgbClr val="2B3038"/>
+                </a:solidFill>
+                <a:latin typeface="Calibri"/>
+              </a:rPr>
+              <a:t>La palanca: </a:t>
+            </a:r>
+            <a:r>
+              <a:rPr sz="2100" b="1" i="0">
+                <a:solidFill>
+                  <a:srgbClr val="5A8F6B"/>
+                </a:solidFill>
+                <a:latin typeface="Calibri"/>
+              </a:rPr>
+              <a:t>reasignar las microplazas (ARS 1.200 M) a distritos D/E</a:t>
+            </a:r>
+            <a:r>
+              <a:rPr sz="2100" b="0" i="0">
+                <a:solidFill>
+                  <a:srgbClr val="2B3038"/>
+                </a:solidFill>
+                <a:latin typeface="Calibri"/>
+              </a:rPr>
+              <a:t>.</a:t>
+            </a:r>
+          </a:p>
+        </p:txBody>
+      </p:sp>
+      <p:sp>
+        <p:nvSpPr>
+          <p:cNvPr id="7" name="TextBox 6"/>
+          <p:cNvSpPr txBox="1"/>
+          <p:nvPr/>
+        </p:nvSpPr>
+        <p:spPr>
+          <a:xfrm>
+            <a:off x="685800" y="5394960"/>
+            <a:ext cx="10698480" cy="640080"/>
+          </a:xfrm>
+          <a:prstGeom prst="rect">
+            <a:avLst/>
+          </a:prstGeom>
+          <a:noFill/>
+        </p:spPr>
+        <p:txBody>
+          <a:bodyPr wrap="square" anchor="t" lIns="0" rIns="0" tIns="0" bIns="0">
+            <a:spAutoFit/>
+          </a:bodyPr>
+          <a:lstStyle/>
+          <a:p>
+            <a:pPr algn="l">
+              <a:lnSpc>
+                <a:spcPct val="110000"/>
+              </a:lnSpc>
+              <a:spcBef>
+                <a:spcPts val="0"/>
+              </a:spcBef>
+              <a:spcAft>
+                <a:spcPts val="0"/>
+              </a:spcAft>
+            </a:pPr>
+            <a:r>
+              <a:rPr sz="1800" b="1" i="1">
+                <a:solidFill>
+                  <a:srgbClr val="B8860B"/>
+                </a:solidFill>
+                <a:latin typeface="Calibri"/>
+              </a:rPr>
+              <a:t>El ICD no describe: corrige. Alinea la inversión con la necesidad, no con la capacidad.</a:t>
+            </a:r>
           </a:p>
         </p:txBody>
       </p:sp>
       <p:sp>
         <p:nvSpPr>
           <p:cNvPr id="8" name="TextBox 7"/>
-          <p:cNvSpPr txBox="1"/>
-          <p:nvPr/>
-        </p:nvSpPr>
-        <p:spPr>
-          <a:xfrm>
-            <a:off x="914400" y="2971800"/>
-            <a:ext cx="3063240" cy="914400"/>
-          </a:xfrm>
-          <a:prstGeom prst="rect">
-            <a:avLst/>
-          </a:prstGeom>
-          <a:noFill/>
-        </p:spPr>
-        <p:txBody>
-          <a:bodyPr wrap="square" anchor="t" lIns="0" rIns="0" tIns="0" bIns="0">
-            <a:spAutoFit/>
-          </a:bodyPr>
-          <a:lstStyle/>
-          <a:p>
-            <a:pPr algn="ctr">
-              <a:lnSpc>
-                <a:spcPct val="106000"/>
-              </a:lnSpc>
-              <a:spcBef>
-                <a:spcPts val="0"/>
-              </a:spcBef>
-              <a:spcAft>
-                <a:spcPts val="0"/>
-              </a:spcAft>
-            </a:pPr>
-            <a:r>
-              <a:rPr sz="4000" b="1" i="0">
-                <a:solidFill>
-                  <a:srgbClr val="5A8F6B"/>
-                </a:solidFill>
-                <a:latin typeface="Calibri"/>
-              </a:rPr>
-              <a:t>~USD 1 M</a:t>
-            </a:r>
-          </a:p>
-        </p:txBody>
-      </p:sp>
-      <p:sp>
-        <p:nvSpPr>
-          <p:cNvPr id="9" name="TextBox 8"/>
-          <p:cNvSpPr txBox="1"/>
-          <p:nvPr/>
-        </p:nvSpPr>
-        <p:spPr>
-          <a:xfrm>
-            <a:off x="960120" y="4023360"/>
-            <a:ext cx="2971800" cy="914400"/>
-          </a:xfrm>
-          <a:prstGeom prst="rect">
-            <a:avLst/>
-          </a:prstGeom>
-          <a:noFill/>
-        </p:spPr>
-        <p:txBody>
-          <a:bodyPr wrap="square" anchor="t" lIns="0" rIns="0" tIns="0" bIns="0">
-            <a:spAutoFit/>
-          </a:bodyPr>
-          <a:lstStyle/>
-          <a:p>
-            <a:pPr algn="ctr">
-              <a:lnSpc>
-                <a:spcPct val="115000"/>
-              </a:lnSpc>
-              <a:spcBef>
-                <a:spcPts val="0"/>
-              </a:spcBef>
-              <a:spcAft>
-                <a:spcPts val="0"/>
-              </a:spcAft>
-            </a:pPr>
-            <a:r>
-              <a:rPr sz="1700" b="0" i="0">
-                <a:solidFill>
-                  <a:srgbClr val="4E5869"/>
-                </a:solidFill>
-                <a:latin typeface="Calibri"/>
-              </a:rPr>
-              <a:t>YA se recauda hoy (2 instrumentos operativos)</a:t>
-            </a:r>
-          </a:p>
-        </p:txBody>
-      </p:sp>
-      <p:sp>
-        <p:nvSpPr>
-          <p:cNvPr id="10" name="Rounded Rectangle 9"/>
-          <p:cNvSpPr/>
-          <p:nvPr/>
-        </p:nvSpPr>
-        <p:spPr>
-          <a:xfrm>
-            <a:off x="4462272" y="2468880"/>
-            <a:ext cx="3520440" cy="2651760"/>
-          </a:xfrm>
-          <a:prstGeom prst="roundRect">
-            <a:avLst>
-              <a:gd name="adj" fmla="val 6000"/>
-            </a:avLst>
-          </a:prstGeom>
-          <a:solidFill>
-            <a:srgbClr val="FFFFFF"/>
-          </a:solidFill>
-          <a:ln w="12700">
-            <a:solidFill>
-              <a:srgbClr val="E3E6EA"/>
-            </a:solidFill>
-          </a:ln>
-          <a:effectLst/>
-          <a:effectLst>
-            <a:outerShdw blurRad="90000" dist="40000" dir="5400000" rotWithShape="0">
-              <a:srgbClr val="28323E">
-                <a:alpha val="20000"/>
-              </a:srgbClr>
-            </a:outerShdw>
-          </a:effectLst>
-        </p:spPr>
-        <p:style>
-          <a:lnRef idx="1">
-            <a:schemeClr val="accent1"/>
-          </a:lnRef>
-          <a:fillRef idx="3">
-            <a:schemeClr val="accent1"/>
-          </a:fillRef>
-          <a:effectRef idx="2">
-            <a:schemeClr val="accent1"/>
-          </a:effectRef>
-          <a:fontRef idx="minor">
-            <a:schemeClr val="lt1"/>
-          </a:fontRef>
-        </p:style>
-        <p:txBody>
-          <a:bodyPr rtlCol="0" anchor="ctr"/>
-          <a:lstStyle/>
-          <a:p>
-            <a:pPr algn="ctr"/>
-          </a:p>
-        </p:txBody>
-      </p:sp>
-      <p:sp>
-        <p:nvSpPr>
-          <p:cNvPr id="11" name="Rectangle 10"/>
-          <p:cNvSpPr/>
-          <p:nvPr/>
-        </p:nvSpPr>
-        <p:spPr>
-          <a:xfrm>
-            <a:off x="4462272" y="2468880"/>
-            <a:ext cx="3520440" cy="76200"/>
-          </a:xfrm>
-          <a:prstGeom prst="rect">
-            <a:avLst/>
-          </a:prstGeom>
-          <a:solidFill>
-            <a:srgbClr val="B8860B"/>
-          </a:solidFill>
-          <a:ln>
-            <a:noFill/>
-          </a:ln>
-          <a:effectLst/>
-        </p:spPr>
-        <p:style>
-          <a:lnRef idx="1">
-            <a:schemeClr val="accent1"/>
-          </a:lnRef>
-          <a:fillRef idx="3">
-            <a:schemeClr val="accent1"/>
-          </a:fillRef>
-          <a:effectRef idx="2">
-            <a:schemeClr val="accent1"/>
-          </a:effectRef>
-          <a:fontRef idx="minor">
-            <a:schemeClr val="lt1"/>
-          </a:fontRef>
-        </p:style>
-        <p:txBody>
-          <a:bodyPr rtlCol="0" anchor="ctr"/>
-          <a:lstStyle/>
-          <a:p>
-            <a:pPr algn="ctr"/>
-          </a:p>
-        </p:txBody>
-      </p:sp>
-      <p:sp>
-        <p:nvSpPr>
-          <p:cNvPr id="12" name="TextBox 11"/>
-          <p:cNvSpPr txBox="1"/>
-          <p:nvPr/>
-        </p:nvSpPr>
-        <p:spPr>
-          <a:xfrm>
-            <a:off x="4690872" y="2971800"/>
-            <a:ext cx="3063240" cy="914400"/>
-          </a:xfrm>
-          <a:prstGeom prst="rect">
-            <a:avLst/>
-          </a:prstGeom>
-          <a:noFill/>
-        </p:spPr>
-        <p:txBody>
-          <a:bodyPr wrap="square" anchor="t" lIns="0" rIns="0" tIns="0" bIns="0">
-            <a:spAutoFit/>
-          </a:bodyPr>
-          <a:lstStyle/>
-          <a:p>
-            <a:pPr algn="ctr">
-              <a:lnSpc>
-                <a:spcPct val="106000"/>
-              </a:lnSpc>
-              <a:spcBef>
-                <a:spcPts val="0"/>
-              </a:spcBef>
-              <a:spcAft>
-                <a:spcPts val="0"/>
-              </a:spcAft>
-            </a:pPr>
-            <a:r>
-              <a:rPr sz="4000" b="1" i="0">
-                <a:solidFill>
-                  <a:srgbClr val="B8860B"/>
-                </a:solidFill>
-                <a:latin typeface="Calibri"/>
-              </a:rPr>
-              <a:t>~USD 3 M</a:t>
-            </a:r>
-          </a:p>
-        </p:txBody>
-      </p:sp>
-      <p:sp>
-        <p:nvSpPr>
-          <p:cNvPr id="13" name="TextBox 12"/>
-          <p:cNvSpPr txBox="1"/>
-          <p:nvPr/>
-        </p:nvSpPr>
-        <p:spPr>
-          <a:xfrm>
-            <a:off x="4736592" y="4023360"/>
-            <a:ext cx="2971800" cy="914400"/>
-          </a:xfrm>
-          <a:prstGeom prst="rect">
-            <a:avLst/>
-          </a:prstGeom>
-          <a:noFill/>
-        </p:spPr>
-        <p:txBody>
-          <a:bodyPr wrap="square" anchor="t" lIns="0" rIns="0" tIns="0" bIns="0">
-            <a:spAutoFit/>
-          </a:bodyPr>
-          <a:lstStyle/>
-          <a:p>
-            <a:pPr algn="ctr">
-              <a:lnSpc>
-                <a:spcPct val="115000"/>
-              </a:lnSpc>
-              <a:spcBef>
-                <a:spcPts val="0"/>
-              </a:spcBef>
-              <a:spcAft>
-                <a:spcPts val="0"/>
-              </a:spcAft>
-            </a:pPr>
-            <a:r>
-              <a:rPr sz="1700" b="0" i="0">
-                <a:solidFill>
-                  <a:srgbClr val="4E5869"/>
-                </a:solidFill>
-                <a:latin typeface="Calibri"/>
-              </a:rPr>
-              <a:t>potencial del paquete completo (base)</a:t>
-            </a:r>
-          </a:p>
-        </p:txBody>
-      </p:sp>
-      <p:sp>
-        <p:nvSpPr>
-          <p:cNvPr id="14" name="Rounded Rectangle 13"/>
-          <p:cNvSpPr/>
-          <p:nvPr/>
-        </p:nvSpPr>
-        <p:spPr>
-          <a:xfrm>
-            <a:off x="8238744" y="2468880"/>
-            <a:ext cx="3520440" cy="2651760"/>
-          </a:xfrm>
-          <a:prstGeom prst="roundRect">
-            <a:avLst>
-              <a:gd name="adj" fmla="val 6000"/>
-            </a:avLst>
-          </a:prstGeom>
-          <a:solidFill>
-            <a:srgbClr val="FFFFFF"/>
-          </a:solidFill>
-          <a:ln w="12700">
-            <a:solidFill>
-              <a:srgbClr val="E3E6EA"/>
-            </a:solidFill>
-          </a:ln>
-          <a:effectLst/>
-          <a:effectLst>
-            <a:outerShdw blurRad="90000" dist="40000" dir="5400000" rotWithShape="0">
-              <a:srgbClr val="28323E">
-                <a:alpha val="20000"/>
-              </a:srgbClr>
-            </a:outerShdw>
-          </a:effectLst>
-        </p:spPr>
-        <p:style>
-          <a:lnRef idx="1">
-            <a:schemeClr val="accent1"/>
-          </a:lnRef>
-          <a:fillRef idx="3">
-            <a:schemeClr val="accent1"/>
-          </a:fillRef>
-          <a:effectRef idx="2">
-            <a:schemeClr val="accent1"/>
-          </a:effectRef>
-          <a:fontRef idx="minor">
-            <a:schemeClr val="lt1"/>
-          </a:fontRef>
-        </p:style>
-        <p:txBody>
-          <a:bodyPr rtlCol="0" anchor="ctr"/>
-          <a:lstStyle/>
-          <a:p>
-            <a:pPr algn="ctr"/>
-          </a:p>
-        </p:txBody>
-      </p:sp>
-      <p:sp>
-        <p:nvSpPr>
-          <p:cNvPr id="15" name="Rectangle 14"/>
-          <p:cNvSpPr/>
-          <p:nvPr/>
-        </p:nvSpPr>
-        <p:spPr>
-          <a:xfrm>
-            <a:off x="8238744" y="2468880"/>
-            <a:ext cx="3520440" cy="76200"/>
-          </a:xfrm>
-          <a:prstGeom prst="rect">
-            <a:avLst/>
-          </a:prstGeom>
-          <a:solidFill>
-            <a:srgbClr val="2F8F9D"/>
-          </a:solidFill>
-          <a:ln>
-            <a:noFill/>
-          </a:ln>
-          <a:effectLst/>
-        </p:spPr>
-        <p:style>
-          <a:lnRef idx="1">
-            <a:schemeClr val="accent1"/>
-          </a:lnRef>
-          <a:fillRef idx="3">
-            <a:schemeClr val="accent1"/>
-          </a:fillRef>
-          <a:effectRef idx="2">
-            <a:schemeClr val="accent1"/>
-          </a:effectRef>
-          <a:fontRef idx="minor">
-            <a:schemeClr val="lt1"/>
-          </a:fontRef>
-        </p:style>
-        <p:txBody>
-          <a:bodyPr rtlCol="0" anchor="ctr"/>
-          <a:lstStyle/>
-          <a:p>
-            <a:pPr algn="ctr"/>
-          </a:p>
-        </p:txBody>
-      </p:sp>
-      <p:sp>
-        <p:nvSpPr>
-          <p:cNvPr id="16" name="TextBox 15"/>
-          <p:cNvSpPr txBox="1"/>
-          <p:nvPr/>
-        </p:nvSpPr>
-        <p:spPr>
-          <a:xfrm>
-            <a:off x="8467344" y="2971800"/>
-            <a:ext cx="3063240" cy="914400"/>
-          </a:xfrm>
-          <a:prstGeom prst="rect">
-            <a:avLst/>
-          </a:prstGeom>
-          <a:noFill/>
-        </p:spPr>
-        <p:txBody>
-          <a:bodyPr wrap="square" anchor="t" lIns="0" rIns="0" tIns="0" bIns="0">
-            <a:spAutoFit/>
-          </a:bodyPr>
-          <a:lstStyle/>
-          <a:p>
-            <a:pPr algn="ctr">
-              <a:lnSpc>
-                <a:spcPct val="106000"/>
-              </a:lnSpc>
-              <a:spcBef>
-                <a:spcPts val="0"/>
-              </a:spcBef>
-              <a:spcAft>
-                <a:spcPts val="0"/>
-              </a:spcAft>
-            </a:pPr>
-            <a:r>
-              <a:rPr sz="4000" b="1" i="0">
-                <a:solidFill>
-                  <a:srgbClr val="2F8F9D"/>
-                </a:solidFill>
-                <a:latin typeface="Calibri"/>
-              </a:rPr>
-              <a:t>USD 56 M</a:t>
-            </a:r>
-          </a:p>
-        </p:txBody>
-      </p:sp>
-      <p:sp>
-        <p:nvSpPr>
-          <p:cNvPr id="17" name="TextBox 16"/>
-          <p:cNvSpPr txBox="1"/>
-          <p:nvPr/>
-        </p:nvSpPr>
-        <p:spPr>
-          <a:xfrm>
-            <a:off x="8513064" y="4023360"/>
-            <a:ext cx="2971800" cy="914400"/>
-          </a:xfrm>
-          <a:prstGeom prst="rect">
-            <a:avLst/>
-          </a:prstGeom>
-          <a:noFill/>
-        </p:spPr>
-        <p:txBody>
-          <a:bodyPr wrap="square" anchor="t" lIns="0" rIns="0" tIns="0" bIns="0">
-            <a:spAutoFit/>
-          </a:bodyPr>
-          <a:lstStyle/>
-          <a:p>
-            <a:pPr algn="ctr">
-              <a:lnSpc>
-                <a:spcPct val="115000"/>
-              </a:lnSpc>
-              <a:spcBef>
-                <a:spcPts val="0"/>
-              </a:spcBef>
-              <a:spcAft>
-                <a:spcPts val="0"/>
-              </a:spcAft>
-            </a:pPr>
-            <a:r>
-              <a:rPr sz="1700" b="0" i="0">
-                <a:solidFill>
-                  <a:srgbClr val="4E5869"/>
-                </a:solidFill>
-                <a:latin typeface="Calibri"/>
-              </a:rPr>
-              <a:t>brecha de espacio verde → la cierra el bono verde</a:t>
-            </a:r>
-          </a:p>
-        </p:txBody>
-      </p:sp>
-      <p:sp>
-        <p:nvSpPr>
-          <p:cNvPr id="18" name="TextBox 17"/>
-          <p:cNvSpPr txBox="1"/>
-          <p:nvPr/>
-        </p:nvSpPr>
-        <p:spPr>
-          <a:xfrm>
-            <a:off x="685800" y="5623560"/>
-            <a:ext cx="10698480" cy="457200"/>
-          </a:xfrm>
-          <a:prstGeom prst="rect">
-            <a:avLst/>
-          </a:prstGeom>
-          <a:noFill/>
-        </p:spPr>
-        <p:txBody>
-          <a:bodyPr wrap="square" anchor="t" lIns="0" rIns="0" tIns="0" bIns="0">
-            <a:spAutoFit/>
-          </a:bodyPr>
-          <a:lstStyle/>
-          <a:p>
-            <a:pPr algn="ctr">
-              <a:lnSpc>
-                <a:spcPct val="106000"/>
-              </a:lnSpc>
-              <a:spcBef>
-                <a:spcPts val="0"/>
-              </a:spcBef>
-              <a:spcAft>
-                <a:spcPts val="0"/>
-              </a:spcAft>
-            </a:pPr>
-            <a:r>
-              <a:rPr sz="1700" b="0" i="1">
-                <a:solidFill>
-                  <a:srgbClr val="7A828E"/>
-                </a:solidFill>
-                <a:latin typeface="Calibri"/>
-              </a:rPr>
-              <a:t>De ~1 a ~3 con el paquete; y del recurso propio, un salto a decenas con el bono verde.</a:t>
-            </a:r>
-          </a:p>
-        </p:txBody>
-      </p:sp>
-      <p:sp>
-        <p:nvSpPr>
-          <p:cNvPr id="19" name="TextBox 18"/>
           <p:cNvSpPr txBox="1"/>
           <p:nvPr/>
         </p:nvSpPr>
@@ -24800,7 +24556,7 @@
       </p:sp>
       <p:sp>
         <p:nvSpPr>
-          <p:cNvPr id="20" name="TextBox 19"/>
+          <p:cNvPr id="9" name="TextBox 8"/>
           <p:cNvSpPr txBox="1"/>
           <p:nvPr/>
         </p:nvSpPr>
@@ -24838,7 +24594,7 @@
                 </a:solidFill>
                 <a:latin typeface="Calibri"/>
               </a:rPr>
-              <a:t>24 / 28</a:t>
+              <a:t>24 / 29</a:t>
             </a:r>
           </a:p>
         </p:txBody>
@@ -24928,7 +24684,7 @@
             <a:avLst/>
           </a:prstGeom>
           <a:solidFill>
-            <a:srgbClr val="B1456A"/>
+            <a:srgbClr val="B8860B"/>
           </a:solidFill>
           <a:ln>
             <a:noFill/>
@@ -24993,11 +24749,11 @@
             <a:r>
               <a:rPr sz="1500" b="1" i="0">
                 <a:solidFill>
-                  <a:srgbClr val="B1456A"/>
-                </a:solidFill>
-                <a:latin typeface="Calibri"/>
-              </a:rPr>
-              <a:t>EQUIDAD · 06</a:t>
+                  <a:srgbClr val="B8860B"/>
+                </a:solidFill>
+                <a:latin typeface="Calibri"/>
+              </a:rPr>
+              <a:t>LOS NÚMEROS REALES · 06</a:t>
             </a:r>
           </a:p>
         </p:txBody>
@@ -25042,7 +24798,7 @@
                 </a:solidFill>
                 <a:latin typeface="Calibri"/>
               </a:rPr>
-              <a:t>¿Quién paga y quién se beneficia?</a:t>
+              <a:t>Potencial de recaudación</a:t>
             </a:r>
           </a:p>
         </p:txBody>
@@ -25055,19 +24811,21 @@
         </p:nvSpPr>
         <p:spPr>
           <a:xfrm>
-            <a:off x="685800" y="2194560"/>
-            <a:ext cx="5212080" cy="2103120"/>
+            <a:off x="685800" y="2468880"/>
+            <a:ext cx="3520440" cy="2651760"/>
           </a:xfrm>
           <a:prstGeom prst="roundRect">
             <a:avLst>
-              <a:gd name="adj" fmla="val 5000"/>
+              <a:gd name="adj" fmla="val 6000"/>
             </a:avLst>
           </a:prstGeom>
           <a:solidFill>
-            <a:srgbClr val="F1E6EA"/>
+            <a:srgbClr val="FFFFFF"/>
           </a:solidFill>
-          <a:ln>
-            <a:noFill/>
+          <a:ln w="12700">
+            <a:solidFill>
+              <a:srgbClr val="E3E6EA"/>
+            </a:solidFill>
           </a:ln>
           <a:effectLst/>
           <a:effectLst>
@@ -25102,115 +24860,161 @@
       </p:sp>
       <p:sp>
         <p:nvSpPr>
-          <p:cNvPr id="7" name="TextBox 6"/>
-          <p:cNvSpPr txBox="1"/>
-          <p:nvPr/>
-        </p:nvSpPr>
-        <p:spPr>
-          <a:xfrm>
-            <a:off x="960120" y="2423160"/>
-            <a:ext cx="4663440" cy="457200"/>
-          </a:xfrm>
-          <a:prstGeom prst="rect">
-            <a:avLst/>
-          </a:prstGeom>
-          <a:noFill/>
-        </p:spPr>
-        <p:txBody>
-          <a:bodyPr wrap="square" anchor="t" lIns="0" rIns="0" tIns="0" bIns="0">
-            <a:spAutoFit/>
-          </a:bodyPr>
-          <a:lstStyle/>
-          <a:p>
-            <a:pPr algn="l">
-              <a:lnSpc>
-                <a:spcPct val="106000"/>
-              </a:lnSpc>
-              <a:spcBef>
-                <a:spcPts val="0"/>
-              </a:spcBef>
-              <a:spcAft>
-                <a:spcPts val="0"/>
-              </a:spcAft>
-            </a:pPr>
-            <a:r>
-              <a:rPr sz="1800" b="1" i="0">
-                <a:solidFill>
-                  <a:srgbClr val="B1456A"/>
-                </a:solidFill>
-                <a:latin typeface="Calibri"/>
-              </a:rPr>
-              <a:t>PAGA</a:t>
-            </a:r>
-          </a:p>
-        </p:txBody>
-      </p:sp>
-      <p:sp>
-        <p:nvSpPr>
-          <p:cNvPr id="8" name="TextBox 7"/>
-          <p:cNvSpPr txBox="1"/>
-          <p:nvPr/>
-        </p:nvSpPr>
-        <p:spPr>
-          <a:xfrm>
-            <a:off x="960120" y="2926080"/>
-            <a:ext cx="4663440" cy="1188720"/>
-          </a:xfrm>
-          <a:prstGeom prst="rect">
-            <a:avLst/>
-          </a:prstGeom>
-          <a:noFill/>
-        </p:spPr>
-        <p:txBody>
-          <a:bodyPr wrap="square" anchor="t" lIns="0" rIns="0" tIns="0" bIns="0">
-            <a:spAutoFit/>
-          </a:bodyPr>
-          <a:lstStyle/>
-          <a:p>
-            <a:pPr algn="l">
-              <a:lnSpc>
-                <a:spcPct val="115000"/>
-              </a:lnSpc>
-              <a:spcBef>
-                <a:spcPts val="0"/>
-              </a:spcBef>
-              <a:spcAft>
-                <a:spcPts val="0"/>
-              </a:spcAft>
-            </a:pPr>
-            <a:r>
-              <a:rPr sz="1900" b="0" i="0">
-                <a:solidFill>
-                  <a:srgbClr val="2B3038"/>
-                </a:solidFill>
-                <a:latin typeface="Calibri"/>
-              </a:rPr>
-              <a:t>Quien captura la plusvalía: desarrolladores y dueños de suelo ocioso (bases progresivas).</a:t>
-            </a:r>
-          </a:p>
-        </p:txBody>
-      </p:sp>
-      <p:sp>
-        <p:nvSpPr>
-          <p:cNvPr id="9" name="Rounded Rectangle 8"/>
+          <p:cNvPr id="7" name="Rectangle 6"/>
           <p:cNvSpPr/>
           <p:nvPr/>
         </p:nvSpPr>
         <p:spPr>
           <a:xfrm>
-            <a:off x="6263640" y="2194560"/>
-            <a:ext cx="5212080" cy="2103120"/>
-          </a:xfrm>
-          <a:prstGeom prst="roundRect">
-            <a:avLst>
-              <a:gd name="adj" fmla="val 5000"/>
-            </a:avLst>
+            <a:off x="685800" y="2468880"/>
+            <a:ext cx="3520440" cy="76200"/>
+          </a:xfrm>
+          <a:prstGeom prst="rect">
+            <a:avLst/>
           </a:prstGeom>
           <a:solidFill>
-            <a:srgbClr val="E7F0EA"/>
+            <a:srgbClr val="5A8F6B"/>
           </a:solidFill>
           <a:ln>
             <a:noFill/>
+          </a:ln>
+          <a:effectLst/>
+        </p:spPr>
+        <p:style>
+          <a:lnRef idx="1">
+            <a:schemeClr val="accent1"/>
+          </a:lnRef>
+          <a:fillRef idx="3">
+            <a:schemeClr val="accent1"/>
+          </a:fillRef>
+          <a:effectRef idx="2">
+            <a:schemeClr val="accent1"/>
+          </a:effectRef>
+          <a:fontRef idx="minor">
+            <a:schemeClr val="lt1"/>
+          </a:fontRef>
+        </p:style>
+        <p:txBody>
+          <a:bodyPr rtlCol="0" anchor="ctr"/>
+          <a:lstStyle/>
+          <a:p>
+            <a:pPr algn="ctr"/>
+          </a:p>
+        </p:txBody>
+      </p:sp>
+      <p:sp>
+        <p:nvSpPr>
+          <p:cNvPr id="8" name="TextBox 7"/>
+          <p:cNvSpPr txBox="1"/>
+          <p:nvPr/>
+        </p:nvSpPr>
+        <p:spPr>
+          <a:xfrm>
+            <a:off x="914400" y="2971800"/>
+            <a:ext cx="3063240" cy="914400"/>
+          </a:xfrm>
+          <a:prstGeom prst="rect">
+            <a:avLst/>
+          </a:prstGeom>
+          <a:noFill/>
+        </p:spPr>
+        <p:txBody>
+          <a:bodyPr wrap="square" anchor="t" lIns="0" rIns="0" tIns="0" bIns="0">
+            <a:spAutoFit/>
+          </a:bodyPr>
+          <a:lstStyle/>
+          <a:p>
+            <a:pPr algn="ctr">
+              <a:lnSpc>
+                <a:spcPct val="106000"/>
+              </a:lnSpc>
+              <a:spcBef>
+                <a:spcPts val="0"/>
+              </a:spcBef>
+              <a:spcAft>
+                <a:spcPts val="0"/>
+              </a:spcAft>
+            </a:pPr>
+            <a:r>
+              <a:rPr sz="4000" b="1" i="0">
+                <a:solidFill>
+                  <a:srgbClr val="5A8F6B"/>
+                </a:solidFill>
+                <a:latin typeface="Calibri"/>
+              </a:rPr>
+              <a:t>~USD 1 M</a:t>
+            </a:r>
+          </a:p>
+        </p:txBody>
+      </p:sp>
+      <p:sp>
+        <p:nvSpPr>
+          <p:cNvPr id="9" name="TextBox 8"/>
+          <p:cNvSpPr txBox="1"/>
+          <p:nvPr/>
+        </p:nvSpPr>
+        <p:spPr>
+          <a:xfrm>
+            <a:off x="960120" y="4023360"/>
+            <a:ext cx="2971800" cy="914400"/>
+          </a:xfrm>
+          <a:prstGeom prst="rect">
+            <a:avLst/>
+          </a:prstGeom>
+          <a:noFill/>
+        </p:spPr>
+        <p:txBody>
+          <a:bodyPr wrap="square" anchor="t" lIns="0" rIns="0" tIns="0" bIns="0">
+            <a:spAutoFit/>
+          </a:bodyPr>
+          <a:lstStyle/>
+          <a:p>
+            <a:pPr algn="ctr">
+              <a:lnSpc>
+                <a:spcPct val="115000"/>
+              </a:lnSpc>
+              <a:spcBef>
+                <a:spcPts val="0"/>
+              </a:spcBef>
+              <a:spcAft>
+                <a:spcPts val="0"/>
+              </a:spcAft>
+            </a:pPr>
+            <a:r>
+              <a:rPr sz="1700" b="0" i="0">
+                <a:solidFill>
+                  <a:srgbClr val="4E5869"/>
+                </a:solidFill>
+                <a:latin typeface="Calibri"/>
+              </a:rPr>
+              <a:t>YA se recauda hoy (2 instrumentos operativos)</a:t>
+            </a:r>
+          </a:p>
+        </p:txBody>
+      </p:sp>
+      <p:sp>
+        <p:nvSpPr>
+          <p:cNvPr id="10" name="Rounded Rectangle 9"/>
+          <p:cNvSpPr/>
+          <p:nvPr/>
+        </p:nvSpPr>
+        <p:spPr>
+          <a:xfrm>
+            <a:off x="4462272" y="2468880"/>
+            <a:ext cx="3520440" cy="2651760"/>
+          </a:xfrm>
+          <a:prstGeom prst="roundRect">
+            <a:avLst>
+              <a:gd name="adj" fmla="val 6000"/>
+            </a:avLst>
+          </a:prstGeom>
+          <a:solidFill>
+            <a:srgbClr val="FFFFFF"/>
+          </a:solidFill>
+          <a:ln w="12700">
+            <a:solidFill>
+              <a:srgbClr val="E3E6EA"/>
+            </a:solidFill>
           </a:ln>
           <a:effectLst/>
           <a:effectLst>
@@ -25245,112 +25049,20 @@
       </p:sp>
       <p:sp>
         <p:nvSpPr>
-          <p:cNvPr id="10" name="TextBox 9"/>
-          <p:cNvSpPr txBox="1"/>
-          <p:nvPr/>
-        </p:nvSpPr>
-        <p:spPr>
-          <a:xfrm>
-            <a:off x="6537960" y="2423160"/>
-            <a:ext cx="4663440" cy="457200"/>
-          </a:xfrm>
-          <a:prstGeom prst="rect">
-            <a:avLst/>
-          </a:prstGeom>
-          <a:noFill/>
-        </p:spPr>
-        <p:txBody>
-          <a:bodyPr wrap="square" anchor="t" lIns="0" rIns="0" tIns="0" bIns="0">
-            <a:spAutoFit/>
-          </a:bodyPr>
-          <a:lstStyle/>
-          <a:p>
-            <a:pPr algn="l">
-              <a:lnSpc>
-                <a:spcPct val="106000"/>
-              </a:lnSpc>
-              <a:spcBef>
-                <a:spcPts val="0"/>
-              </a:spcBef>
-              <a:spcAft>
-                <a:spcPts val="0"/>
-              </a:spcAft>
-            </a:pPr>
-            <a:r>
-              <a:rPr sz="1800" b="1" i="0">
-                <a:solidFill>
-                  <a:srgbClr val="5A8F6B"/>
-                </a:solidFill>
-                <a:latin typeface="Calibri"/>
-              </a:rPr>
-              <a:t>SE BENEFICIA</a:t>
-            </a:r>
-          </a:p>
-        </p:txBody>
-      </p:sp>
-      <p:sp>
-        <p:nvSpPr>
-          <p:cNvPr id="11" name="TextBox 10"/>
-          <p:cNvSpPr txBox="1"/>
-          <p:nvPr/>
-        </p:nvSpPr>
-        <p:spPr>
-          <a:xfrm>
-            <a:off x="6537960" y="2926080"/>
-            <a:ext cx="4663440" cy="1188720"/>
-          </a:xfrm>
-          <a:prstGeom prst="rect">
-            <a:avLst/>
-          </a:prstGeom>
-          <a:noFill/>
-        </p:spPr>
-        <p:txBody>
-          <a:bodyPr wrap="square" anchor="t" lIns="0" rIns="0" tIns="0" bIns="0">
-            <a:spAutoFit/>
-          </a:bodyPr>
-          <a:lstStyle/>
-          <a:p>
-            <a:pPr algn="l">
-              <a:lnSpc>
-                <a:spcPct val="115000"/>
-              </a:lnSpc>
-              <a:spcBef>
-                <a:spcPts val="0"/>
-              </a:spcBef>
-              <a:spcAft>
-                <a:spcPts val="0"/>
-              </a:spcAft>
-            </a:pPr>
-            <a:r>
-              <a:rPr sz="1900" b="0" i="0">
-                <a:solidFill>
-                  <a:srgbClr val="2B3038"/>
-                </a:solidFill>
-                <a:latin typeface="Calibri"/>
-              </a:rPr>
-              <a:t>El distrito con menor acceso a verde, agua y servicios (vía ICD).</a:t>
-            </a:r>
-          </a:p>
-        </p:txBody>
-      </p:sp>
-      <p:sp>
-        <p:nvSpPr>
-          <p:cNvPr id="12" name="Rounded Rectangle 11"/>
+          <p:cNvPr id="11" name="Rectangle 10"/>
           <p:cNvSpPr/>
           <p:nvPr/>
         </p:nvSpPr>
         <p:spPr>
           <a:xfrm>
-            <a:off x="685800" y="4617720"/>
-            <a:ext cx="10789920" cy="1234440"/>
-          </a:xfrm>
-          <a:prstGeom prst="roundRect">
-            <a:avLst>
-              <a:gd name="adj" fmla="val 7000"/>
-            </a:avLst>
+            <a:off x="4462272" y="2468880"/>
+            <a:ext cx="3520440" cy="76200"/>
+          </a:xfrm>
+          <a:prstGeom prst="rect">
+            <a:avLst/>
           </a:prstGeom>
           <a:solidFill>
-            <a:srgbClr val="3A4250"/>
+            <a:srgbClr val="B8860B"/>
           </a:solidFill>
           <a:ln>
             <a:noFill/>
@@ -25381,61 +25093,331 @@
       </p:sp>
       <p:sp>
         <p:nvSpPr>
+          <p:cNvPr id="12" name="TextBox 11"/>
+          <p:cNvSpPr txBox="1"/>
+          <p:nvPr/>
+        </p:nvSpPr>
+        <p:spPr>
+          <a:xfrm>
+            <a:off x="4690872" y="2971800"/>
+            <a:ext cx="3063240" cy="914400"/>
+          </a:xfrm>
+          <a:prstGeom prst="rect">
+            <a:avLst/>
+          </a:prstGeom>
+          <a:noFill/>
+        </p:spPr>
+        <p:txBody>
+          <a:bodyPr wrap="square" anchor="t" lIns="0" rIns="0" tIns="0" bIns="0">
+            <a:spAutoFit/>
+          </a:bodyPr>
+          <a:lstStyle/>
+          <a:p>
+            <a:pPr algn="ctr">
+              <a:lnSpc>
+                <a:spcPct val="106000"/>
+              </a:lnSpc>
+              <a:spcBef>
+                <a:spcPts val="0"/>
+              </a:spcBef>
+              <a:spcAft>
+                <a:spcPts val="0"/>
+              </a:spcAft>
+            </a:pPr>
+            <a:r>
+              <a:rPr sz="4000" b="1" i="0">
+                <a:solidFill>
+                  <a:srgbClr val="B8860B"/>
+                </a:solidFill>
+                <a:latin typeface="Calibri"/>
+              </a:rPr>
+              <a:t>~USD 3 M</a:t>
+            </a:r>
+          </a:p>
+        </p:txBody>
+      </p:sp>
+      <p:sp>
+        <p:nvSpPr>
           <p:cNvPr id="13" name="TextBox 12"/>
           <p:cNvSpPr txBox="1"/>
           <p:nvPr/>
         </p:nvSpPr>
         <p:spPr>
           <a:xfrm>
-            <a:off x="1005840" y="4617720"/>
-            <a:ext cx="10149840" cy="1234440"/>
-          </a:xfrm>
-          <a:prstGeom prst="rect">
-            <a:avLst/>
-          </a:prstGeom>
-          <a:noFill/>
-        </p:spPr>
-        <p:txBody>
-          <a:bodyPr wrap="square" anchor="ctr" lIns="0" rIns="0" tIns="0" bIns="0">
-            <a:spAutoFit/>
-          </a:bodyPr>
-          <a:lstStyle/>
-          <a:p>
-            <a:pPr algn="l">
-              <a:lnSpc>
-                <a:spcPct val="112000"/>
-              </a:lnSpc>
-              <a:spcBef>
-                <a:spcPts val="0"/>
-              </a:spcBef>
-              <a:spcAft>
-                <a:spcPts val="0"/>
-              </a:spcAft>
-            </a:pPr>
-            <a:r>
-              <a:rPr sz="1900" b="0" i="0">
-                <a:solidFill>
-                  <a:srgbClr val="FFFFFF"/>
-                </a:solidFill>
-                <a:latin typeface="Calibri"/>
-              </a:rPr>
-              <a:t>Con suelo inelástico (límite hídrico), la carga recae en el terrateniente → </a:t>
-            </a:r>
-            <a:r>
-              <a:rPr sz="1900" b="1" i="0">
-                <a:solidFill>
-                  <a:srgbClr val="D4C088"/>
-                </a:solidFill>
-                <a:latin typeface="Calibri"/>
-              </a:rPr>
-              <a:t>un caso deliberadamente progresivo.</a:t>
-            </a:r>
-          </a:p>
-        </p:txBody>
-      </p:sp>
-      <p:sp>
-        <p:nvSpPr>
-          <p:cNvPr id="14" name="TextBox 13"/>
+            <a:off x="4736592" y="4023360"/>
+            <a:ext cx="2971800" cy="914400"/>
+          </a:xfrm>
+          <a:prstGeom prst="rect">
+            <a:avLst/>
+          </a:prstGeom>
+          <a:noFill/>
+        </p:spPr>
+        <p:txBody>
+          <a:bodyPr wrap="square" anchor="t" lIns="0" rIns="0" tIns="0" bIns="0">
+            <a:spAutoFit/>
+          </a:bodyPr>
+          <a:lstStyle/>
+          <a:p>
+            <a:pPr algn="ctr">
+              <a:lnSpc>
+                <a:spcPct val="115000"/>
+              </a:lnSpc>
+              <a:spcBef>
+                <a:spcPts val="0"/>
+              </a:spcBef>
+              <a:spcAft>
+                <a:spcPts val="0"/>
+              </a:spcAft>
+            </a:pPr>
+            <a:r>
+              <a:rPr sz="1700" b="0" i="0">
+                <a:solidFill>
+                  <a:srgbClr val="4E5869"/>
+                </a:solidFill>
+                <a:latin typeface="Calibri"/>
+              </a:rPr>
+              <a:t>potencial del paquete completo (base)</a:t>
+            </a:r>
+          </a:p>
+        </p:txBody>
+      </p:sp>
+      <p:sp>
+        <p:nvSpPr>
+          <p:cNvPr id="14" name="Rounded Rectangle 13"/>
+          <p:cNvSpPr/>
+          <p:nvPr/>
+        </p:nvSpPr>
+        <p:spPr>
+          <a:xfrm>
+            <a:off x="8238744" y="2468880"/>
+            <a:ext cx="3520440" cy="2651760"/>
+          </a:xfrm>
+          <a:prstGeom prst="roundRect">
+            <a:avLst>
+              <a:gd name="adj" fmla="val 6000"/>
+            </a:avLst>
+          </a:prstGeom>
+          <a:solidFill>
+            <a:srgbClr val="FFFFFF"/>
+          </a:solidFill>
+          <a:ln w="12700">
+            <a:solidFill>
+              <a:srgbClr val="E3E6EA"/>
+            </a:solidFill>
+          </a:ln>
+          <a:effectLst/>
+          <a:effectLst>
+            <a:outerShdw blurRad="90000" dist="40000" dir="5400000" rotWithShape="0">
+              <a:srgbClr val="28323E">
+                <a:alpha val="20000"/>
+              </a:srgbClr>
+            </a:outerShdw>
+          </a:effectLst>
+        </p:spPr>
+        <p:style>
+          <a:lnRef idx="1">
+            <a:schemeClr val="accent1"/>
+          </a:lnRef>
+          <a:fillRef idx="3">
+            <a:schemeClr val="accent1"/>
+          </a:fillRef>
+          <a:effectRef idx="2">
+            <a:schemeClr val="accent1"/>
+          </a:effectRef>
+          <a:fontRef idx="minor">
+            <a:schemeClr val="lt1"/>
+          </a:fontRef>
+        </p:style>
+        <p:txBody>
+          <a:bodyPr rtlCol="0" anchor="ctr"/>
+          <a:lstStyle/>
+          <a:p>
+            <a:pPr algn="ctr"/>
+          </a:p>
+        </p:txBody>
+      </p:sp>
+      <p:sp>
+        <p:nvSpPr>
+          <p:cNvPr id="15" name="Rectangle 14"/>
+          <p:cNvSpPr/>
+          <p:nvPr/>
+        </p:nvSpPr>
+        <p:spPr>
+          <a:xfrm>
+            <a:off x="8238744" y="2468880"/>
+            <a:ext cx="3520440" cy="76200"/>
+          </a:xfrm>
+          <a:prstGeom prst="rect">
+            <a:avLst/>
+          </a:prstGeom>
+          <a:solidFill>
+            <a:srgbClr val="2F8F9D"/>
+          </a:solidFill>
+          <a:ln>
+            <a:noFill/>
+          </a:ln>
+          <a:effectLst/>
+        </p:spPr>
+        <p:style>
+          <a:lnRef idx="1">
+            <a:schemeClr val="accent1"/>
+          </a:lnRef>
+          <a:fillRef idx="3">
+            <a:schemeClr val="accent1"/>
+          </a:fillRef>
+          <a:effectRef idx="2">
+            <a:schemeClr val="accent1"/>
+          </a:effectRef>
+          <a:fontRef idx="minor">
+            <a:schemeClr val="lt1"/>
+          </a:fontRef>
+        </p:style>
+        <p:txBody>
+          <a:bodyPr rtlCol="0" anchor="ctr"/>
+          <a:lstStyle/>
+          <a:p>
+            <a:pPr algn="ctr"/>
+          </a:p>
+        </p:txBody>
+      </p:sp>
+      <p:sp>
+        <p:nvSpPr>
+          <p:cNvPr id="16" name="TextBox 15"/>
+          <p:cNvSpPr txBox="1"/>
+          <p:nvPr/>
+        </p:nvSpPr>
+        <p:spPr>
+          <a:xfrm>
+            <a:off x="8467344" y="2971800"/>
+            <a:ext cx="3063240" cy="914400"/>
+          </a:xfrm>
+          <a:prstGeom prst="rect">
+            <a:avLst/>
+          </a:prstGeom>
+          <a:noFill/>
+        </p:spPr>
+        <p:txBody>
+          <a:bodyPr wrap="square" anchor="t" lIns="0" rIns="0" tIns="0" bIns="0">
+            <a:spAutoFit/>
+          </a:bodyPr>
+          <a:lstStyle/>
+          <a:p>
+            <a:pPr algn="ctr">
+              <a:lnSpc>
+                <a:spcPct val="106000"/>
+              </a:lnSpc>
+              <a:spcBef>
+                <a:spcPts val="0"/>
+              </a:spcBef>
+              <a:spcAft>
+                <a:spcPts val="0"/>
+              </a:spcAft>
+            </a:pPr>
+            <a:r>
+              <a:rPr sz="4000" b="1" i="0">
+                <a:solidFill>
+                  <a:srgbClr val="2F8F9D"/>
+                </a:solidFill>
+                <a:latin typeface="Calibri"/>
+              </a:rPr>
+              <a:t>USD 56 M</a:t>
+            </a:r>
+          </a:p>
+        </p:txBody>
+      </p:sp>
+      <p:sp>
+        <p:nvSpPr>
+          <p:cNvPr id="17" name="TextBox 16"/>
+          <p:cNvSpPr txBox="1"/>
+          <p:nvPr/>
+        </p:nvSpPr>
+        <p:spPr>
+          <a:xfrm>
+            <a:off x="8513064" y="4023360"/>
+            <a:ext cx="2971800" cy="914400"/>
+          </a:xfrm>
+          <a:prstGeom prst="rect">
+            <a:avLst/>
+          </a:prstGeom>
+          <a:noFill/>
+        </p:spPr>
+        <p:txBody>
+          <a:bodyPr wrap="square" anchor="t" lIns="0" rIns="0" tIns="0" bIns="0">
+            <a:spAutoFit/>
+          </a:bodyPr>
+          <a:lstStyle/>
+          <a:p>
+            <a:pPr algn="ctr">
+              <a:lnSpc>
+                <a:spcPct val="115000"/>
+              </a:lnSpc>
+              <a:spcBef>
+                <a:spcPts val="0"/>
+              </a:spcBef>
+              <a:spcAft>
+                <a:spcPts val="0"/>
+              </a:spcAft>
+            </a:pPr>
+            <a:r>
+              <a:rPr sz="1700" b="0" i="0">
+                <a:solidFill>
+                  <a:srgbClr val="4E5869"/>
+                </a:solidFill>
+                <a:latin typeface="Calibri"/>
+              </a:rPr>
+              <a:t>brecha de espacio verde → la cierra el bono verde</a:t>
+            </a:r>
+          </a:p>
+        </p:txBody>
+      </p:sp>
+      <p:sp>
+        <p:nvSpPr>
+          <p:cNvPr id="18" name="TextBox 17"/>
+          <p:cNvSpPr txBox="1"/>
+          <p:nvPr/>
+        </p:nvSpPr>
+        <p:spPr>
+          <a:xfrm>
+            <a:off x="685800" y="5623560"/>
+            <a:ext cx="10698480" cy="457200"/>
+          </a:xfrm>
+          <a:prstGeom prst="rect">
+            <a:avLst/>
+          </a:prstGeom>
+          <a:noFill/>
+        </p:spPr>
+        <p:txBody>
+          <a:bodyPr wrap="square" anchor="t" lIns="0" rIns="0" tIns="0" bIns="0">
+            <a:spAutoFit/>
+          </a:bodyPr>
+          <a:lstStyle/>
+          <a:p>
+            <a:pPr algn="ctr">
+              <a:lnSpc>
+                <a:spcPct val="106000"/>
+              </a:lnSpc>
+              <a:spcBef>
+                <a:spcPts val="0"/>
+              </a:spcBef>
+              <a:spcAft>
+                <a:spcPts val="0"/>
+              </a:spcAft>
+            </a:pPr>
+            <a:r>
+              <a:rPr sz="1700" b="0" i="1">
+                <a:solidFill>
+                  <a:srgbClr val="7A828E"/>
+                </a:solidFill>
+                <a:latin typeface="Calibri"/>
+              </a:rPr>
+              <a:t>De ~1 a ~3 con el paquete; y del recurso propio, un salto a decenas con el bono verde.</a:t>
+            </a:r>
+          </a:p>
+        </p:txBody>
+      </p:sp>
+      <p:sp>
+        <p:nvSpPr>
+          <p:cNvPr id="19" name="TextBox 18"/>
           <p:cNvSpPr txBox="1"/>
           <p:nvPr/>
         </p:nvSpPr>
@@ -25489,7 +25471,7 @@
       </p:sp>
       <p:sp>
         <p:nvSpPr>
-          <p:cNvPr id="15" name="TextBox 14"/>
+          <p:cNvPr id="20" name="TextBox 19"/>
           <p:cNvSpPr txBox="1"/>
           <p:nvPr/>
         </p:nvSpPr>
@@ -25527,7 +25509,7 @@
                 </a:solidFill>
                 <a:latin typeface="Calibri"/>
               </a:rPr>
-              <a:t>25 / 28</a:t>
+              <a:t>25 / 29</a:t>
             </a:r>
           </a:p>
         </p:txBody>
@@ -25617,7 +25599,7 @@
             <a:avLst/>
           </a:prstGeom>
           <a:solidFill>
-            <a:srgbClr val="5A8F6B"/>
+            <a:srgbClr val="B1456A"/>
           </a:solidFill>
           <a:ln>
             <a:noFill/>
@@ -25682,11 +25664,11 @@
             <a:r>
               <a:rPr sz="1500" b="1" i="0">
                 <a:solidFill>
-                  <a:srgbClr val="5A8F6B"/>
-                </a:solidFill>
-                <a:latin typeface="Calibri"/>
-              </a:rPr>
-              <a:t>NO SÓLO ADAPTACIÓN · 06</a:t>
+                  <a:srgbClr val="B1456A"/>
+                </a:solidFill>
+                <a:latin typeface="Calibri"/>
+              </a:rPr>
+              <a:t>EQUIDAD · 06</a:t>
             </a:r>
           </a:p>
         </p:txBody>
@@ -25731,43 +25713,366 @@
                 </a:solidFill>
                 <a:latin typeface="Calibri"/>
               </a:rPr>
-              <a:t>Co-beneficios </a:t>
-            </a:r>
-            <a:r>
-              <a:rPr sz="3600" b="1" i="0">
+              <a:t>¿Quién paga y quién se beneficia?</a:t>
+            </a:r>
+          </a:p>
+        </p:txBody>
+      </p:sp>
+      <p:sp>
+        <p:nvSpPr>
+          <p:cNvPr id="6" name="Rounded Rectangle 5"/>
+          <p:cNvSpPr/>
+          <p:nvPr/>
+        </p:nvSpPr>
+        <p:spPr>
+          <a:xfrm>
+            <a:off x="685800" y="2194560"/>
+            <a:ext cx="5212080" cy="2103120"/>
+          </a:xfrm>
+          <a:prstGeom prst="roundRect">
+            <a:avLst>
+              <a:gd name="adj" fmla="val 5000"/>
+            </a:avLst>
+          </a:prstGeom>
+          <a:solidFill>
+            <a:srgbClr val="F1E6EA"/>
+          </a:solidFill>
+          <a:ln>
+            <a:noFill/>
+          </a:ln>
+          <a:effectLst/>
+          <a:effectLst>
+            <a:outerShdw blurRad="90000" dist="40000" dir="5400000" rotWithShape="0">
+              <a:srgbClr val="28323E">
+                <a:alpha val="20000"/>
+              </a:srgbClr>
+            </a:outerShdw>
+          </a:effectLst>
+        </p:spPr>
+        <p:style>
+          <a:lnRef idx="1">
+            <a:schemeClr val="accent1"/>
+          </a:lnRef>
+          <a:fillRef idx="3">
+            <a:schemeClr val="accent1"/>
+          </a:fillRef>
+          <a:effectRef idx="2">
+            <a:schemeClr val="accent1"/>
+          </a:effectRef>
+          <a:fontRef idx="minor">
+            <a:schemeClr val="lt1"/>
+          </a:fontRef>
+        </p:style>
+        <p:txBody>
+          <a:bodyPr rtlCol="0" anchor="ctr"/>
+          <a:lstStyle/>
+          <a:p>
+            <a:pPr algn="ctr"/>
+          </a:p>
+        </p:txBody>
+      </p:sp>
+      <p:sp>
+        <p:nvSpPr>
+          <p:cNvPr id="7" name="TextBox 6"/>
+          <p:cNvSpPr txBox="1"/>
+          <p:nvPr/>
+        </p:nvSpPr>
+        <p:spPr>
+          <a:xfrm>
+            <a:off x="960120" y="2423160"/>
+            <a:ext cx="4663440" cy="457200"/>
+          </a:xfrm>
+          <a:prstGeom prst="rect">
+            <a:avLst/>
+          </a:prstGeom>
+          <a:noFill/>
+        </p:spPr>
+        <p:txBody>
+          <a:bodyPr wrap="square" anchor="t" lIns="0" rIns="0" tIns="0" bIns="0">
+            <a:spAutoFit/>
+          </a:bodyPr>
+          <a:lstStyle/>
+          <a:p>
+            <a:pPr algn="l">
+              <a:lnSpc>
+                <a:spcPct val="106000"/>
+              </a:lnSpc>
+              <a:spcBef>
+                <a:spcPts val="0"/>
+              </a:spcBef>
+              <a:spcAft>
+                <a:spcPts val="0"/>
+              </a:spcAft>
+            </a:pPr>
+            <a:r>
+              <a:rPr sz="1800" b="1" i="0">
+                <a:solidFill>
+                  <a:srgbClr val="B1456A"/>
+                </a:solidFill>
+                <a:latin typeface="Calibri"/>
+              </a:rPr>
+              <a:t>PAGA</a:t>
+            </a:r>
+          </a:p>
+        </p:txBody>
+      </p:sp>
+      <p:sp>
+        <p:nvSpPr>
+          <p:cNvPr id="8" name="TextBox 7"/>
+          <p:cNvSpPr txBox="1"/>
+          <p:nvPr/>
+        </p:nvSpPr>
+        <p:spPr>
+          <a:xfrm>
+            <a:off x="960120" y="2926080"/>
+            <a:ext cx="4663440" cy="1188720"/>
+          </a:xfrm>
+          <a:prstGeom prst="rect">
+            <a:avLst/>
+          </a:prstGeom>
+          <a:noFill/>
+        </p:spPr>
+        <p:txBody>
+          <a:bodyPr wrap="square" anchor="t" lIns="0" rIns="0" tIns="0" bIns="0">
+            <a:spAutoFit/>
+          </a:bodyPr>
+          <a:lstStyle/>
+          <a:p>
+            <a:pPr algn="l">
+              <a:lnSpc>
+                <a:spcPct val="115000"/>
+              </a:lnSpc>
+              <a:spcBef>
+                <a:spcPts val="0"/>
+              </a:spcBef>
+              <a:spcAft>
+                <a:spcPts val="0"/>
+              </a:spcAft>
+            </a:pPr>
+            <a:r>
+              <a:rPr sz="1900" b="0" i="0">
+                <a:solidFill>
+                  <a:srgbClr val="2B3038"/>
+                </a:solidFill>
+                <a:latin typeface="Calibri"/>
+              </a:rPr>
+              <a:t>Quien captura la plusvalía: desarrolladores y dueños de suelo ocioso (bases progresivas).</a:t>
+            </a:r>
+          </a:p>
+        </p:txBody>
+      </p:sp>
+      <p:sp>
+        <p:nvSpPr>
+          <p:cNvPr id="9" name="Rounded Rectangle 8"/>
+          <p:cNvSpPr/>
+          <p:nvPr/>
+        </p:nvSpPr>
+        <p:spPr>
+          <a:xfrm>
+            <a:off x="6263640" y="2194560"/>
+            <a:ext cx="5212080" cy="2103120"/>
+          </a:xfrm>
+          <a:prstGeom prst="roundRect">
+            <a:avLst>
+              <a:gd name="adj" fmla="val 5000"/>
+            </a:avLst>
+          </a:prstGeom>
+          <a:solidFill>
+            <a:srgbClr val="E7F0EA"/>
+          </a:solidFill>
+          <a:ln>
+            <a:noFill/>
+          </a:ln>
+          <a:effectLst/>
+          <a:effectLst>
+            <a:outerShdw blurRad="90000" dist="40000" dir="5400000" rotWithShape="0">
+              <a:srgbClr val="28323E">
+                <a:alpha val="20000"/>
+              </a:srgbClr>
+            </a:outerShdw>
+          </a:effectLst>
+        </p:spPr>
+        <p:style>
+          <a:lnRef idx="1">
+            <a:schemeClr val="accent1"/>
+          </a:lnRef>
+          <a:fillRef idx="3">
+            <a:schemeClr val="accent1"/>
+          </a:fillRef>
+          <a:effectRef idx="2">
+            <a:schemeClr val="accent1"/>
+          </a:effectRef>
+          <a:fontRef idx="minor">
+            <a:schemeClr val="lt1"/>
+          </a:fontRef>
+        </p:style>
+        <p:txBody>
+          <a:bodyPr rtlCol="0" anchor="ctr"/>
+          <a:lstStyle/>
+          <a:p>
+            <a:pPr algn="ctr"/>
+          </a:p>
+        </p:txBody>
+      </p:sp>
+      <p:sp>
+        <p:nvSpPr>
+          <p:cNvPr id="10" name="TextBox 9"/>
+          <p:cNvSpPr txBox="1"/>
+          <p:nvPr/>
+        </p:nvSpPr>
+        <p:spPr>
+          <a:xfrm>
+            <a:off x="6537960" y="2423160"/>
+            <a:ext cx="4663440" cy="457200"/>
+          </a:xfrm>
+          <a:prstGeom prst="rect">
+            <a:avLst/>
+          </a:prstGeom>
+          <a:noFill/>
+        </p:spPr>
+        <p:txBody>
+          <a:bodyPr wrap="square" anchor="t" lIns="0" rIns="0" tIns="0" bIns="0">
+            <a:spAutoFit/>
+          </a:bodyPr>
+          <a:lstStyle/>
+          <a:p>
+            <a:pPr algn="l">
+              <a:lnSpc>
+                <a:spcPct val="106000"/>
+              </a:lnSpc>
+              <a:spcBef>
+                <a:spcPts val="0"/>
+              </a:spcBef>
+              <a:spcAft>
+                <a:spcPts val="0"/>
+              </a:spcAft>
+            </a:pPr>
+            <a:r>
+              <a:rPr sz="1800" b="1" i="0">
                 <a:solidFill>
                   <a:srgbClr val="5A8F6B"/>
                 </a:solidFill>
                 <a:latin typeface="Calibri"/>
               </a:rPr>
-              <a:t>low-carbon</a:t>
-            </a:r>
-          </a:p>
-        </p:txBody>
-      </p:sp>
-      <p:sp>
-        <p:nvSpPr>
-          <p:cNvPr id="6" name="TextBox 5"/>
-          <p:cNvSpPr txBox="1"/>
-          <p:nvPr/>
-        </p:nvSpPr>
-        <p:spPr>
-          <a:xfrm>
-            <a:off x="685800" y="2148840"/>
-            <a:ext cx="10607040" cy="3657600"/>
-          </a:xfrm>
-          <a:prstGeom prst="rect">
-            <a:avLst/>
-          </a:prstGeom>
-          <a:noFill/>
-        </p:spPr>
-        <p:txBody>
-          <a:bodyPr wrap="square" lIns="0" rIns="0" tIns="0" bIns="0">
-            <a:spAutoFit/>
-          </a:bodyPr>
-          <a:lstStyle/>
-          <a:p>
-            <a:pPr>
+              <a:t>SE BENEFICIA</a:t>
+            </a:r>
+          </a:p>
+        </p:txBody>
+      </p:sp>
+      <p:sp>
+        <p:nvSpPr>
+          <p:cNvPr id="11" name="TextBox 10"/>
+          <p:cNvSpPr txBox="1"/>
+          <p:nvPr/>
+        </p:nvSpPr>
+        <p:spPr>
+          <a:xfrm>
+            <a:off x="6537960" y="2926080"/>
+            <a:ext cx="4663440" cy="1188720"/>
+          </a:xfrm>
+          <a:prstGeom prst="rect">
+            <a:avLst/>
+          </a:prstGeom>
+          <a:noFill/>
+        </p:spPr>
+        <p:txBody>
+          <a:bodyPr wrap="square" anchor="t" lIns="0" rIns="0" tIns="0" bIns="0">
+            <a:spAutoFit/>
+          </a:bodyPr>
+          <a:lstStyle/>
+          <a:p>
+            <a:pPr algn="l">
+              <a:lnSpc>
+                <a:spcPct val="115000"/>
+              </a:lnSpc>
+              <a:spcBef>
+                <a:spcPts val="0"/>
+              </a:spcBef>
+              <a:spcAft>
+                <a:spcPts val="0"/>
+              </a:spcAft>
+            </a:pPr>
+            <a:r>
+              <a:rPr sz="1900" b="0" i="0">
+                <a:solidFill>
+                  <a:srgbClr val="2B3038"/>
+                </a:solidFill>
+                <a:latin typeface="Calibri"/>
+              </a:rPr>
+              <a:t>El distrito con menor acceso a verde, agua y servicios (vía ICD).</a:t>
+            </a:r>
+          </a:p>
+        </p:txBody>
+      </p:sp>
+      <p:sp>
+        <p:nvSpPr>
+          <p:cNvPr id="12" name="Rounded Rectangle 11"/>
+          <p:cNvSpPr/>
+          <p:nvPr/>
+        </p:nvSpPr>
+        <p:spPr>
+          <a:xfrm>
+            <a:off x="685800" y="4617720"/>
+            <a:ext cx="10789920" cy="1234440"/>
+          </a:xfrm>
+          <a:prstGeom prst="roundRect">
+            <a:avLst>
+              <a:gd name="adj" fmla="val 7000"/>
+            </a:avLst>
+          </a:prstGeom>
+          <a:solidFill>
+            <a:srgbClr val="3A4250"/>
+          </a:solidFill>
+          <a:ln>
+            <a:noFill/>
+          </a:ln>
+          <a:effectLst/>
+        </p:spPr>
+        <p:style>
+          <a:lnRef idx="1">
+            <a:schemeClr val="accent1"/>
+          </a:lnRef>
+          <a:fillRef idx="3">
+            <a:schemeClr val="accent1"/>
+          </a:fillRef>
+          <a:effectRef idx="2">
+            <a:schemeClr val="accent1"/>
+          </a:effectRef>
+          <a:fontRef idx="minor">
+            <a:schemeClr val="lt1"/>
+          </a:fontRef>
+        </p:style>
+        <p:txBody>
+          <a:bodyPr rtlCol="0" anchor="ctr"/>
+          <a:lstStyle/>
+          <a:p>
+            <a:pPr algn="ctr"/>
+          </a:p>
+        </p:txBody>
+      </p:sp>
+      <p:sp>
+        <p:nvSpPr>
+          <p:cNvPr id="13" name="TextBox 12"/>
+          <p:cNvSpPr txBox="1"/>
+          <p:nvPr/>
+        </p:nvSpPr>
+        <p:spPr>
+          <a:xfrm>
+            <a:off x="1005840" y="4617720"/>
+            <a:ext cx="10149840" cy="1234440"/>
+          </a:xfrm>
+          <a:prstGeom prst="rect">
+            <a:avLst/>
+          </a:prstGeom>
+          <a:noFill/>
+        </p:spPr>
+        <p:txBody>
+          <a:bodyPr wrap="square" anchor="ctr" lIns="0" rIns="0" tIns="0" bIns="0">
+            <a:spAutoFit/>
+          </a:bodyPr>
+          <a:lstStyle/>
+          <a:p>
+            <a:pPr algn="l">
               <a:lnSpc>
                 <a:spcPct val="112000"/>
               </a:lnSpc>
@@ -25775,167 +26080,33 @@
                 <a:spcPts val="0"/>
               </a:spcBef>
               <a:spcAft>
-                <a:spcPts val="2200"/>
-              </a:spcAft>
-            </a:pPr>
-            <a:r>
-              <a:rPr sz="2000" b="1" i="0">
-                <a:solidFill>
-                  <a:srgbClr val="B8860B"/>
-                </a:solidFill>
-                <a:latin typeface="Calibri"/>
-              </a:rPr>
-              <a:t>▪  </a:t>
-            </a:r>
-            <a:r>
-              <a:rPr sz="2100" b="0" i="0">
-                <a:solidFill>
-                  <a:srgbClr val="2B3038"/>
-                </a:solidFill>
-                <a:latin typeface="Calibri"/>
-              </a:rPr>
-              <a:t>Premian el desarrollo compacto y orientado al transporte (TOD): </a:t>
-            </a:r>
-            <a:r>
-              <a:rPr sz="2100" b="1" i="0">
-                <a:solidFill>
-                  <a:srgbClr val="5A8F6B"/>
-                </a:solidFill>
-                <a:latin typeface="Calibri"/>
-              </a:rPr>
-              <a:t>el metrotranvía concentra edificabilidad.</a:t>
-            </a:r>
-          </a:p>
-          <a:p>
-            <a:pPr>
-              <a:lnSpc>
-                <a:spcPct val="112000"/>
-              </a:lnSpc>
-              <a:spcBef>
-                <a:spcPts val="0"/>
-              </a:spcBef>
-              <a:spcAft>
-                <a:spcPts val="2200"/>
-              </a:spcAft>
-            </a:pPr>
-            <a:r>
-              <a:rPr sz="2000" b="1" i="0">
-                <a:solidFill>
-                  <a:srgbClr val="B8860B"/>
-                </a:solidFill>
-                <a:latin typeface="Calibri"/>
-              </a:rPr>
-              <a:t>▪  </a:t>
-            </a:r>
-            <a:r>
-              <a:rPr sz="2100" b="0" i="0">
-                <a:solidFill>
-                  <a:srgbClr val="2B3038"/>
-                </a:solidFill>
-                <a:latin typeface="Calibri"/>
-              </a:rPr>
-              <a:t>Menos viajes en auto: </a:t>
-            </a:r>
-            <a:r>
-              <a:rPr sz="2100" b="1" i="0">
-                <a:solidFill>
-                  <a:srgbClr val="2F8F9D"/>
-                </a:solidFill>
-                <a:latin typeface="Calibri"/>
-              </a:rPr>
-              <a:t>menor consumo energético e hídrico per cápita.</a:t>
-            </a:r>
-          </a:p>
-          <a:p>
-            <a:pPr>
-              <a:lnSpc>
-                <a:spcPct val="112000"/>
-              </a:lnSpc>
-              <a:spcBef>
-                <a:spcPts val="0"/>
-              </a:spcBef>
-              <a:spcAft>
-                <a:spcPts val="2200"/>
-              </a:spcAft>
-            </a:pPr>
-            <a:r>
-              <a:rPr sz="2000" b="1" i="0">
-                <a:solidFill>
-                  <a:srgbClr val="B8860B"/>
-                </a:solidFill>
-                <a:latin typeface="Calibri"/>
-              </a:rPr>
-              <a:t>▪  </a:t>
-            </a:r>
-            <a:r>
-              <a:rPr sz="2100" b="0" i="0">
-                <a:solidFill>
-                  <a:srgbClr val="2B3038"/>
-                </a:solidFill>
-                <a:latin typeface="Calibri"/>
-              </a:rPr>
-              <a:t>Se evita convertir suelo agrícola y de pedemonte: </a:t>
-            </a:r>
-            <a:r>
-              <a:rPr sz="2100" b="1" i="0">
-                <a:solidFill>
-                  <a:srgbClr val="B8860B"/>
-                </a:solidFill>
-                <a:latin typeface="Calibri"/>
-              </a:rPr>
-              <a:t>carbono + recarga preservados.</a:t>
-            </a:r>
-          </a:p>
-        </p:txBody>
-      </p:sp>
-      <p:sp>
-        <p:nvSpPr>
-          <p:cNvPr id="7" name="TextBox 6"/>
-          <p:cNvSpPr txBox="1"/>
-          <p:nvPr/>
-        </p:nvSpPr>
-        <p:spPr>
-          <a:xfrm>
-            <a:off x="685800" y="5394960"/>
-            <a:ext cx="10698480" cy="640080"/>
-          </a:xfrm>
-          <a:prstGeom prst="rect">
-            <a:avLst/>
-          </a:prstGeom>
-          <a:noFill/>
-        </p:spPr>
-        <p:txBody>
-          <a:bodyPr wrap="square" anchor="t" lIns="0" rIns="0" tIns="0" bIns="0">
-            <a:spAutoFit/>
-          </a:bodyPr>
-          <a:lstStyle/>
-          <a:p>
-            <a:pPr algn="l">
-              <a:lnSpc>
-                <a:spcPct val="110000"/>
-              </a:lnSpc>
-              <a:spcBef>
-                <a:spcPts val="0"/>
-              </a:spcBef>
-              <a:spcAft>
-                <a:spcPts val="0"/>
-              </a:spcAft>
-            </a:pPr>
-            <a:r>
-              <a:rPr sz="1900" b="1" i="1">
-                <a:solidFill>
-                  <a:srgbClr val="B8860B"/>
-                </a:solidFill>
-                <a:latin typeface="Calibri"/>
-              </a:rPr>
-              <a:t>Adaptación y mitigación: la misma palanca, accionada una sola vez.</a:t>
-            </a:r>
-          </a:p>
-        </p:txBody>
-      </p:sp>
-      <p:sp>
-        <p:nvSpPr>
-          <p:cNvPr id="8" name="TextBox 7"/>
+                <a:spcPts val="0"/>
+              </a:spcAft>
+            </a:pPr>
+            <a:r>
+              <a:rPr sz="1900" b="0" i="0">
+                <a:solidFill>
+                  <a:srgbClr val="FFFFFF"/>
+                </a:solidFill>
+                <a:latin typeface="Calibri"/>
+              </a:rPr>
+              <a:t>Con suelo inelástico (límite hídrico), la carga recae en el terrateniente → </a:t>
+            </a:r>
+            <a:r>
+              <a:rPr sz="1900" b="1" i="0">
+                <a:solidFill>
+                  <a:srgbClr val="D4C088"/>
+                </a:solidFill>
+                <a:latin typeface="Calibri"/>
+              </a:rPr>
+              <a:t>un caso deliberadamente progresivo.</a:t>
+            </a:r>
+          </a:p>
+        </p:txBody>
+      </p:sp>
+      <p:sp>
+        <p:nvSpPr>
+          <p:cNvPr id="14" name="TextBox 13"/>
           <p:cNvSpPr txBox="1"/>
           <p:nvPr/>
         </p:nvSpPr>
@@ -25989,7 +26160,7 @@
       </p:sp>
       <p:sp>
         <p:nvSpPr>
-          <p:cNvPr id="9" name="TextBox 8"/>
+          <p:cNvPr id="15" name="TextBox 14"/>
           <p:cNvSpPr txBox="1"/>
           <p:nvPr/>
         </p:nvSpPr>
@@ -26027,7 +26198,7 @@
                 </a:solidFill>
                 <a:latin typeface="Calibri"/>
               </a:rPr>
-              <a:t>26 / 28</a:t>
+              <a:t>26 / 29</a:t>
             </a:r>
           </a:p>
         </p:txBody>
@@ -26041,6 +26212,506 @@
 </file>
 
 <file path=ppt/slides/slide27.xml><?xml version="1.0" encoding="utf-8"?>
+<p:sld xmlns:a="http://schemas.openxmlformats.org/drawingml/2006/main" xmlns:p="http://schemas.openxmlformats.org/presentationml/2006/main" xmlns:r="http://schemas.openxmlformats.org/officeDocument/2006/relationships">
+  <p:cSld>
+    <p:bg>
+      <p:bgPr>
+        <a:solidFill>
+          <a:srgbClr val="F7F8FA"/>
+        </a:solidFill>
+        <a:effectLst/>
+      </p:bgPr>
+    </p:bg>
+    <p:spTree>
+      <p:nvGrpSpPr>
+        <p:cNvPr id="1" name=""/>
+        <p:cNvGrpSpPr/>
+        <p:nvPr/>
+      </p:nvGrpSpPr>
+      <p:grpSpPr/>
+      <p:sp>
+        <p:nvSpPr>
+          <p:cNvPr id="2" name="Rectangle 1"/>
+          <p:cNvSpPr/>
+          <p:nvPr/>
+        </p:nvSpPr>
+        <p:spPr>
+          <a:xfrm>
+            <a:off x="0" y="0"/>
+            <a:ext cx="12191695" cy="88900"/>
+          </a:xfrm>
+          <a:prstGeom prst="rect">
+            <a:avLst/>
+          </a:prstGeom>
+          <a:solidFill>
+            <a:srgbClr val="B8860B"/>
+          </a:solidFill>
+          <a:ln>
+            <a:noFill/>
+          </a:ln>
+          <a:effectLst/>
+        </p:spPr>
+        <p:style>
+          <a:lnRef idx="1">
+            <a:schemeClr val="accent1"/>
+          </a:lnRef>
+          <a:fillRef idx="3">
+            <a:schemeClr val="accent1"/>
+          </a:fillRef>
+          <a:effectRef idx="2">
+            <a:schemeClr val="accent1"/>
+          </a:effectRef>
+          <a:fontRef idx="minor">
+            <a:schemeClr val="lt1"/>
+          </a:fontRef>
+        </p:style>
+        <p:txBody>
+          <a:bodyPr rtlCol="0" anchor="ctr"/>
+          <a:lstStyle/>
+          <a:p>
+            <a:pPr algn="ctr"/>
+          </a:p>
+        </p:txBody>
+      </p:sp>
+      <p:sp>
+        <p:nvSpPr>
+          <p:cNvPr id="3" name="Rectangle 2"/>
+          <p:cNvSpPr/>
+          <p:nvPr/>
+        </p:nvSpPr>
+        <p:spPr>
+          <a:xfrm>
+            <a:off x="685800" y="590928"/>
+            <a:ext cx="63500" cy="274320"/>
+          </a:xfrm>
+          <a:prstGeom prst="rect">
+            <a:avLst/>
+          </a:prstGeom>
+          <a:solidFill>
+            <a:srgbClr val="5A8F6B"/>
+          </a:solidFill>
+          <a:ln>
+            <a:noFill/>
+          </a:ln>
+          <a:effectLst/>
+        </p:spPr>
+        <p:style>
+          <a:lnRef idx="1">
+            <a:schemeClr val="accent1"/>
+          </a:lnRef>
+          <a:fillRef idx="3">
+            <a:schemeClr val="accent1"/>
+          </a:fillRef>
+          <a:effectRef idx="2">
+            <a:schemeClr val="accent1"/>
+          </a:effectRef>
+          <a:fontRef idx="minor">
+            <a:schemeClr val="lt1"/>
+          </a:fontRef>
+        </p:style>
+        <p:txBody>
+          <a:bodyPr rtlCol="0" anchor="ctr"/>
+          <a:lstStyle/>
+          <a:p>
+            <a:pPr algn="ctr"/>
+          </a:p>
+        </p:txBody>
+      </p:sp>
+      <p:sp>
+        <p:nvSpPr>
+          <p:cNvPr id="4" name="TextBox 3"/>
+          <p:cNvSpPr txBox="1"/>
+          <p:nvPr/>
+        </p:nvSpPr>
+        <p:spPr>
+          <a:xfrm>
+            <a:off x="832104" y="566928"/>
+            <a:ext cx="10058400" cy="329184"/>
+          </a:xfrm>
+          <a:prstGeom prst="rect">
+            <a:avLst/>
+          </a:prstGeom>
+          <a:noFill/>
+        </p:spPr>
+        <p:txBody>
+          <a:bodyPr wrap="square" anchor="ctr" lIns="0" rIns="0" tIns="0" bIns="0">
+            <a:spAutoFit/>
+          </a:bodyPr>
+          <a:lstStyle/>
+          <a:p>
+            <a:pPr algn="l">
+              <a:lnSpc>
+                <a:spcPct val="106000"/>
+              </a:lnSpc>
+              <a:spcBef>
+                <a:spcPts val="0"/>
+              </a:spcBef>
+              <a:spcAft>
+                <a:spcPts val="0"/>
+              </a:spcAft>
+            </a:pPr>
+            <a:r>
+              <a:rPr sz="1500" b="1" i="0">
+                <a:solidFill>
+                  <a:srgbClr val="5A8F6B"/>
+                </a:solidFill>
+                <a:latin typeface="Calibri"/>
+              </a:rPr>
+              <a:t>NO SÓLO ADAPTACIÓN · 06</a:t>
+            </a:r>
+          </a:p>
+        </p:txBody>
+      </p:sp>
+      <p:sp>
+        <p:nvSpPr>
+          <p:cNvPr id="5" name="TextBox 4"/>
+          <p:cNvSpPr txBox="1"/>
+          <p:nvPr/>
+        </p:nvSpPr>
+        <p:spPr>
+          <a:xfrm>
+            <a:off x="685800" y="987552"/>
+            <a:ext cx="10789920" cy="1188720"/>
+          </a:xfrm>
+          <a:prstGeom prst="rect">
+            <a:avLst/>
+          </a:prstGeom>
+          <a:noFill/>
+        </p:spPr>
+        <p:txBody>
+          <a:bodyPr wrap="square" anchor="t" lIns="0" rIns="0" tIns="0" bIns="0">
+            <a:spAutoFit/>
+          </a:bodyPr>
+          <a:lstStyle/>
+          <a:p>
+            <a:pPr algn="l">
+              <a:lnSpc>
+                <a:spcPct val="100000"/>
+              </a:lnSpc>
+              <a:spcBef>
+                <a:spcPts val="0"/>
+              </a:spcBef>
+              <a:spcAft>
+                <a:spcPts val="0"/>
+              </a:spcAft>
+            </a:pPr>
+            <a:r>
+              <a:rPr sz="3600" b="1" i="0">
+                <a:solidFill>
+                  <a:srgbClr val="4E5869"/>
+                </a:solidFill>
+                <a:latin typeface="Calibri"/>
+              </a:rPr>
+              <a:t>Co-beneficios </a:t>
+            </a:r>
+            <a:r>
+              <a:rPr sz="3600" b="1" i="0">
+                <a:solidFill>
+                  <a:srgbClr val="5A8F6B"/>
+                </a:solidFill>
+                <a:latin typeface="Calibri"/>
+              </a:rPr>
+              <a:t>low-carbon</a:t>
+            </a:r>
+          </a:p>
+        </p:txBody>
+      </p:sp>
+      <p:sp>
+        <p:nvSpPr>
+          <p:cNvPr id="6" name="TextBox 5"/>
+          <p:cNvSpPr txBox="1"/>
+          <p:nvPr/>
+        </p:nvSpPr>
+        <p:spPr>
+          <a:xfrm>
+            <a:off x="685800" y="2148840"/>
+            <a:ext cx="10607040" cy="3657600"/>
+          </a:xfrm>
+          <a:prstGeom prst="rect">
+            <a:avLst/>
+          </a:prstGeom>
+          <a:noFill/>
+        </p:spPr>
+        <p:txBody>
+          <a:bodyPr wrap="square" lIns="0" rIns="0" tIns="0" bIns="0">
+            <a:spAutoFit/>
+          </a:bodyPr>
+          <a:lstStyle/>
+          <a:p>
+            <a:pPr>
+              <a:lnSpc>
+                <a:spcPct val="112000"/>
+              </a:lnSpc>
+              <a:spcBef>
+                <a:spcPts val="0"/>
+              </a:spcBef>
+              <a:spcAft>
+                <a:spcPts val="2200"/>
+              </a:spcAft>
+            </a:pPr>
+            <a:r>
+              <a:rPr sz="2000" b="1" i="0">
+                <a:solidFill>
+                  <a:srgbClr val="B8860B"/>
+                </a:solidFill>
+                <a:latin typeface="Calibri"/>
+              </a:rPr>
+              <a:t>▪  </a:t>
+            </a:r>
+            <a:r>
+              <a:rPr sz="2100" b="0" i="0">
+                <a:solidFill>
+                  <a:srgbClr val="2B3038"/>
+                </a:solidFill>
+                <a:latin typeface="Calibri"/>
+              </a:rPr>
+              <a:t>Premian el desarrollo compacto y orientado al transporte (TOD): </a:t>
+            </a:r>
+            <a:r>
+              <a:rPr sz="2100" b="1" i="0">
+                <a:solidFill>
+                  <a:srgbClr val="5A8F6B"/>
+                </a:solidFill>
+                <a:latin typeface="Calibri"/>
+              </a:rPr>
+              <a:t>el metrotranvía concentra edificabilidad.</a:t>
+            </a:r>
+          </a:p>
+          <a:p>
+            <a:pPr>
+              <a:lnSpc>
+                <a:spcPct val="112000"/>
+              </a:lnSpc>
+              <a:spcBef>
+                <a:spcPts val="0"/>
+              </a:spcBef>
+              <a:spcAft>
+                <a:spcPts val="2200"/>
+              </a:spcAft>
+            </a:pPr>
+            <a:r>
+              <a:rPr sz="2000" b="1" i="0">
+                <a:solidFill>
+                  <a:srgbClr val="B8860B"/>
+                </a:solidFill>
+                <a:latin typeface="Calibri"/>
+              </a:rPr>
+              <a:t>▪  </a:t>
+            </a:r>
+            <a:r>
+              <a:rPr sz="2100" b="0" i="0">
+                <a:solidFill>
+                  <a:srgbClr val="2B3038"/>
+                </a:solidFill>
+                <a:latin typeface="Calibri"/>
+              </a:rPr>
+              <a:t>Menos viajes en auto: </a:t>
+            </a:r>
+            <a:r>
+              <a:rPr sz="2100" b="1" i="0">
+                <a:solidFill>
+                  <a:srgbClr val="2F8F9D"/>
+                </a:solidFill>
+                <a:latin typeface="Calibri"/>
+              </a:rPr>
+              <a:t>menor consumo energético e hídrico per cápita.</a:t>
+            </a:r>
+          </a:p>
+          <a:p>
+            <a:pPr>
+              <a:lnSpc>
+                <a:spcPct val="112000"/>
+              </a:lnSpc>
+              <a:spcBef>
+                <a:spcPts val="0"/>
+              </a:spcBef>
+              <a:spcAft>
+                <a:spcPts val="2200"/>
+              </a:spcAft>
+            </a:pPr>
+            <a:r>
+              <a:rPr sz="2000" b="1" i="0">
+                <a:solidFill>
+                  <a:srgbClr val="B8860B"/>
+                </a:solidFill>
+                <a:latin typeface="Calibri"/>
+              </a:rPr>
+              <a:t>▪  </a:t>
+            </a:r>
+            <a:r>
+              <a:rPr sz="2100" b="0" i="0">
+                <a:solidFill>
+                  <a:srgbClr val="2B3038"/>
+                </a:solidFill>
+                <a:latin typeface="Calibri"/>
+              </a:rPr>
+              <a:t>Se evita convertir suelo agrícola y de pedemonte: </a:t>
+            </a:r>
+            <a:r>
+              <a:rPr sz="2100" b="1" i="0">
+                <a:solidFill>
+                  <a:srgbClr val="B8860B"/>
+                </a:solidFill>
+                <a:latin typeface="Calibri"/>
+              </a:rPr>
+              <a:t>carbono + recarga preservados.</a:t>
+            </a:r>
+          </a:p>
+        </p:txBody>
+      </p:sp>
+      <p:sp>
+        <p:nvSpPr>
+          <p:cNvPr id="7" name="TextBox 6"/>
+          <p:cNvSpPr txBox="1"/>
+          <p:nvPr/>
+        </p:nvSpPr>
+        <p:spPr>
+          <a:xfrm>
+            <a:off x="685800" y="5394960"/>
+            <a:ext cx="10698480" cy="640080"/>
+          </a:xfrm>
+          <a:prstGeom prst="rect">
+            <a:avLst/>
+          </a:prstGeom>
+          <a:noFill/>
+        </p:spPr>
+        <p:txBody>
+          <a:bodyPr wrap="square" anchor="t" lIns="0" rIns="0" tIns="0" bIns="0">
+            <a:spAutoFit/>
+          </a:bodyPr>
+          <a:lstStyle/>
+          <a:p>
+            <a:pPr algn="l">
+              <a:lnSpc>
+                <a:spcPct val="110000"/>
+              </a:lnSpc>
+              <a:spcBef>
+                <a:spcPts val="0"/>
+              </a:spcBef>
+              <a:spcAft>
+                <a:spcPts val="0"/>
+              </a:spcAft>
+            </a:pPr>
+            <a:r>
+              <a:rPr sz="1900" b="1" i="1">
+                <a:solidFill>
+                  <a:srgbClr val="B8860B"/>
+                </a:solidFill>
+                <a:latin typeface="Calibri"/>
+              </a:rPr>
+              <a:t>Adaptación y mitigación: la misma palanca, accionada una sola vez.</a:t>
+            </a:r>
+          </a:p>
+        </p:txBody>
+      </p:sp>
+      <p:sp>
+        <p:nvSpPr>
+          <p:cNvPr id="8" name="TextBox 7"/>
+          <p:cNvSpPr txBox="1"/>
+          <p:nvPr/>
+        </p:nvSpPr>
+        <p:spPr>
+          <a:xfrm>
+            <a:off x="685800" y="6327648"/>
+            <a:ext cx="8229600" cy="365760"/>
+          </a:xfrm>
+          <a:prstGeom prst="rect">
+            <a:avLst/>
+          </a:prstGeom>
+          <a:noFill/>
+        </p:spPr>
+        <p:txBody>
+          <a:bodyPr wrap="square" anchor="ctr" lIns="0" rIns="0" tIns="0" bIns="0">
+            <a:spAutoFit/>
+          </a:bodyPr>
+          <a:lstStyle/>
+          <a:p>
+            <a:pPr algn="l">
+              <a:lnSpc>
+                <a:spcPct val="106000"/>
+              </a:lnSpc>
+              <a:spcBef>
+                <a:spcPts val="0"/>
+              </a:spcBef>
+              <a:spcAft>
+                <a:spcPts val="0"/>
+              </a:spcAft>
+            </a:pPr>
+            <a:r>
+              <a:rPr sz="1100" b="0" i="0">
+                <a:solidFill>
+                  <a:srgbClr val="7A828E"/>
+                </a:solidFill>
+                <a:latin typeface="Calibri"/>
+              </a:rPr>
+              <a:t>Luján de Cuyo · Gestión del suelo   ·   </a:t>
+            </a:r>
+            <a:r>
+              <a:rPr sz="1100" b="1" i="0">
+                <a:solidFill>
+                  <a:srgbClr val="6F7D94"/>
+                </a:solidFill>
+                <a:latin typeface="Calibri"/>
+              </a:rPr>
+              <a:t>CIPUV–UTDT / Lincoln Institute</a:t>
+            </a:r>
+          </a:p>
+        </p:txBody>
+      </p:sp>
+      <p:sp>
+        <p:nvSpPr>
+          <p:cNvPr id="9" name="TextBox 8"/>
+          <p:cNvSpPr txBox="1"/>
+          <p:nvPr/>
+        </p:nvSpPr>
+        <p:spPr>
+          <a:xfrm>
+            <a:off x="11155680" y="6327648"/>
+            <a:ext cx="822960" cy="365760"/>
+          </a:xfrm>
+          <a:prstGeom prst="rect">
+            <a:avLst/>
+          </a:prstGeom>
+          <a:noFill/>
+        </p:spPr>
+        <p:txBody>
+          <a:bodyPr wrap="square" anchor="ctr" lIns="0" rIns="0" tIns="0" bIns="0">
+            <a:spAutoFit/>
+          </a:bodyPr>
+          <a:lstStyle/>
+          <a:p>
+            <a:pPr algn="r">
+              <a:lnSpc>
+                <a:spcPct val="106000"/>
+              </a:lnSpc>
+              <a:spcBef>
+                <a:spcPts val="0"/>
+              </a:spcBef>
+              <a:spcAft>
+                <a:spcPts val="0"/>
+              </a:spcAft>
+            </a:pPr>
+            <a:r>
+              <a:rPr sz="1200" b="0" i="0">
+                <a:solidFill>
+                  <a:srgbClr val="7A828E"/>
+                </a:solidFill>
+                <a:latin typeface="Calibri"/>
+              </a:rPr>
+              <a:t>27 / 29</a:t>
+            </a:r>
+          </a:p>
+        </p:txBody>
+      </p:sp>
+    </p:spTree>
+  </p:cSld>
+  <p:clrMapOvr>
+    <a:masterClrMapping/>
+  </p:clrMapOvr>
+</p:sld>
+</file>
+
+<file path=ppt/slides/slide28.xml><?xml version="1.0" encoding="utf-8"?>
 <p:sld xmlns:a="http://schemas.openxmlformats.org/drawingml/2006/main" xmlns:p="http://schemas.openxmlformats.org/presentationml/2006/main" xmlns:r="http://schemas.openxmlformats.org/officeDocument/2006/relationships">
   <p:cSld>
     <p:bg>
@@ -26870,7 +27541,7 @@
 </p:sld>
 </file>
 
-<file path=ppt/slides/slide28.xml><?xml version="1.0" encoding="utf-8"?>
+<file path=ppt/slides/slide29.xml><?xml version="1.0" encoding="utf-8"?>
 <p:sld xmlns:a="http://schemas.openxmlformats.org/drawingml/2006/main" xmlns:p="http://schemas.openxmlformats.org/presentationml/2006/main" xmlns:r="http://schemas.openxmlformats.org/officeDocument/2006/relationships">
   <p:cSld>
     <p:bg>
@@ -28043,7 +28714,7 @@
                 </a:solidFill>
                 <a:latin typeface="Calibri"/>
               </a:rPr>
-              <a:t>28 / 28</a:t>
+              <a:t>29 / 29</a:t>
             </a:r>
           </a:p>
         </p:txBody>
@@ -29274,7 +29945,7 @@
                 </a:solidFill>
                 <a:latin typeface="Calibri"/>
               </a:rPr>
-              <a:t>03 / 28</a:t>
+              <a:t>03 / 29</a:t>
             </a:r>
           </a:p>
         </p:txBody>
@@ -29895,7 +30566,7 @@
                 </a:solidFill>
                 <a:latin typeface="Calibri"/>
               </a:rPr>
-              <a:t>04 / 28</a:t>
+              <a:t>04 / 29</a:t>
             </a:r>
           </a:p>
         </p:txBody>
@@ -30594,7 +31265,7 @@
                 </a:solidFill>
                 <a:latin typeface="Calibri"/>
               </a:rPr>
-              <a:t>05 / 28</a:t>
+              <a:t>05 / 29</a:t>
             </a:r>
           </a:p>
         </p:txBody>
@@ -31283,7 +31954,7 @@
                 </a:solidFill>
                 <a:latin typeface="Calibri"/>
               </a:rPr>
-              <a:t>06 / 28</a:t>
+              <a:t>06 / 29</a:t>
             </a:r>
           </a:p>
         </p:txBody>
@@ -31792,7 +32463,7 @@
                 </a:solidFill>
                 <a:latin typeface="Calibri"/>
               </a:rPr>
-              <a:t>07 / 28</a:t>
+              <a:t>07 / 29</a:t>
             </a:r>
           </a:p>
         </p:txBody>
@@ -32432,7 +33103,7 @@
                 </a:solidFill>
                 <a:latin typeface="Calibri"/>
               </a:rPr>
-              <a:t>08 / 28</a:t>
+              <a:t>08 / 29</a:t>
             </a:r>
           </a:p>
         </p:txBody>
@@ -34148,7 +34819,7 @@
                 </a:solidFill>
                 <a:latin typeface="Calibri"/>
               </a:rPr>
-              <a:t>09 / 28</a:t>
+              <a:t>09 / 29</a:t>
             </a:r>
           </a:p>
         </p:txBody>

</xml_diff>

<commit_message>
Fix ranking slide: color tiers and priority-encoded bars
Corrige dos errores en "Dónde va primero la inversión":
- Colores no coincidían con los tramos de la Tabla Síntesis. Umbral correcto:
  verde ≥5 (líderes 6–7), amarillo 3–4,5 (intermedio), rojo ≤2,5 (déficit).
  Mayor Drummond y Vistalba (4,5) pasan a amarillo; El Carrizal (2,5) a rojo.
- La barra contradecía el título: ahora la barra codifica la prioridad
  (11 − puntaje), Industrial encabeza con la barra más larga y Ciudad queda
  al final. El número sigue siendo el puntaje ICD real.

Aplicado en PPTX y HTML (deck de 31 slides).

Co-Authored-By: Claude Opus 4.8 <noreply@anthropic.com>
Claude-Session: https://claude.ai/code/session_01QZiauNhtTVEiLX1MmVDGUu
</commit_message>
<xml_diff>
--- a/presentations/lujan-de-cuyo-gestion-suelo.pptx
+++ b/presentations/lujan-de-cuyo-gestion-suelo.pptx
@@ -1652,7 +1652,7 @@
           <a:lstStyle/>
           <a:p>
             <a:r>
-              <a:t>El resultado en una imagen: Ciudad y La Puntilla, ya consolidadas, puntúan alto; los distritos del oeste y el periurbano (Industrial, Vertientes, Cacheuta) puntúan bajo y son, por diseño, los primeros destinatarios de la inversión. Puntaje sobre 11 puntos.</a:t>
+              <a:t>Lectura correcta: la barra es la prioridad (mayor brecha = va primero), por eso Industrial encabeza y Ciudad queda al final. El número es el puntaje ICD de la Tabla Síntesis. Colores por tramo: verde líderes (6–7), amarillo intermedio (3–4,5), rojo déficit (≤2,5).</a:t>
             </a:r>
           </a:p>
         </p:txBody>
@@ -23032,7 +23032,7 @@
         <p:spPr>
           <a:xfrm>
             <a:off x="685800" y="1874519"/>
-            <a:ext cx="2103120" cy="246888"/>
+            <a:ext cx="2286000" cy="246888"/>
           </a:xfrm>
           <a:prstGeom prst="rect">
             <a:avLst/>
@@ -23063,7 +23063,7 @@
                 </a:solidFill>
                 <a:latin typeface="Calibri"/>
               </a:rPr>
-              <a:t>Ciudad</a:t>
+              <a:t>Industrial</a:t>
             </a:r>
           </a:p>
         </p:txBody>
@@ -23076,8 +23076,1776 @@
         </p:nvSpPr>
         <p:spPr>
           <a:xfrm>
-            <a:off x="2880360" y="1889519"/>
-            <a:ext cx="7589520" cy="216888"/>
+            <a:off x="3063240" y="1889519"/>
+            <a:ext cx="7223760" cy="216888"/>
+          </a:xfrm>
+          <a:prstGeom prst="roundRect">
+            <a:avLst>
+              <a:gd name="adj" fmla="val 35000"/>
+            </a:avLst>
+          </a:prstGeom>
+          <a:solidFill>
+            <a:srgbClr val="B1456A"/>
+          </a:solidFill>
+          <a:ln>
+            <a:noFill/>
+          </a:ln>
+          <a:effectLst/>
+        </p:spPr>
+        <p:style>
+          <a:lnRef idx="1">
+            <a:schemeClr val="accent1"/>
+          </a:lnRef>
+          <a:fillRef idx="3">
+            <a:schemeClr val="accent1"/>
+          </a:fillRef>
+          <a:effectRef idx="2">
+            <a:schemeClr val="accent1"/>
+          </a:effectRef>
+          <a:fontRef idx="minor">
+            <a:schemeClr val="lt1"/>
+          </a:fontRef>
+        </p:style>
+        <p:txBody>
+          <a:bodyPr rtlCol="0" anchor="ctr"/>
+          <a:lstStyle/>
+          <a:p>
+            <a:pPr algn="ctr"/>
+          </a:p>
+        </p:txBody>
+      </p:sp>
+      <p:sp>
+        <p:nvSpPr>
+          <p:cNvPr id="8" name="TextBox 7"/>
+          <p:cNvSpPr txBox="1"/>
+          <p:nvPr/>
+        </p:nvSpPr>
+        <p:spPr>
+          <a:xfrm>
+            <a:off x="10360152" y="1874519"/>
+            <a:ext cx="868680" cy="246888"/>
+          </a:xfrm>
+          <a:prstGeom prst="rect">
+            <a:avLst/>
+          </a:prstGeom>
+          <a:noFill/>
+        </p:spPr>
+        <p:txBody>
+          <a:bodyPr wrap="square" anchor="ctr" lIns="0" rIns="0" tIns="0" bIns="0">
+            <a:spAutoFit/>
+          </a:bodyPr>
+          <a:lstStyle/>
+          <a:p>
+            <a:pPr algn="l">
+              <a:lnSpc>
+                <a:spcPct val="106000"/>
+              </a:lnSpc>
+              <a:spcBef>
+                <a:spcPts val="0"/>
+              </a:spcBef>
+              <a:spcAft>
+                <a:spcPts val="0"/>
+              </a:spcAft>
+            </a:pPr>
+            <a:r>
+              <a:rPr sz="1250" b="1" i="0">
+                <a:solidFill>
+                  <a:srgbClr val="B1456A"/>
+                </a:solidFill>
+                <a:latin typeface="Calibri"/>
+              </a:rPr>
+              <a:t>1</a:t>
+            </a:r>
+          </a:p>
+        </p:txBody>
+      </p:sp>
+      <p:sp>
+        <p:nvSpPr>
+          <p:cNvPr id="9" name="TextBox 8"/>
+          <p:cNvSpPr txBox="1"/>
+          <p:nvPr/>
+        </p:nvSpPr>
+        <p:spPr>
+          <a:xfrm>
+            <a:off x="685800" y="2162555"/>
+            <a:ext cx="2286000" cy="246888"/>
+          </a:xfrm>
+          <a:prstGeom prst="rect">
+            <a:avLst/>
+          </a:prstGeom>
+          <a:noFill/>
+        </p:spPr>
+        <p:txBody>
+          <a:bodyPr wrap="square" anchor="ctr" lIns="0" rIns="0" tIns="0" bIns="0">
+            <a:spAutoFit/>
+          </a:bodyPr>
+          <a:lstStyle/>
+          <a:p>
+            <a:pPr algn="r">
+              <a:lnSpc>
+                <a:spcPct val="106000"/>
+              </a:lnSpc>
+              <a:spcBef>
+                <a:spcPts val="0"/>
+              </a:spcBef>
+              <a:spcAft>
+                <a:spcPts val="0"/>
+              </a:spcAft>
+            </a:pPr>
+            <a:r>
+              <a:rPr sz="1250" b="1" i="0">
+                <a:solidFill>
+                  <a:srgbClr val="2B3038"/>
+                </a:solidFill>
+                <a:latin typeface="Calibri"/>
+              </a:rPr>
+              <a:t>Vertientes de Pedemonte</a:t>
+            </a:r>
+          </a:p>
+        </p:txBody>
+      </p:sp>
+      <p:sp>
+        <p:nvSpPr>
+          <p:cNvPr id="10" name="Rounded Rectangle 9"/>
+          <p:cNvSpPr/>
+          <p:nvPr/>
+        </p:nvSpPr>
+        <p:spPr>
+          <a:xfrm>
+            <a:off x="3063240" y="2177555"/>
+            <a:ext cx="6862572" cy="216888"/>
+          </a:xfrm>
+          <a:prstGeom prst="roundRect">
+            <a:avLst>
+              <a:gd name="adj" fmla="val 35000"/>
+            </a:avLst>
+          </a:prstGeom>
+          <a:solidFill>
+            <a:srgbClr val="B1456A"/>
+          </a:solidFill>
+          <a:ln>
+            <a:noFill/>
+          </a:ln>
+          <a:effectLst/>
+        </p:spPr>
+        <p:style>
+          <a:lnRef idx="1">
+            <a:schemeClr val="accent1"/>
+          </a:lnRef>
+          <a:fillRef idx="3">
+            <a:schemeClr val="accent1"/>
+          </a:fillRef>
+          <a:effectRef idx="2">
+            <a:schemeClr val="accent1"/>
+          </a:effectRef>
+          <a:fontRef idx="minor">
+            <a:schemeClr val="lt1"/>
+          </a:fontRef>
+        </p:style>
+        <p:txBody>
+          <a:bodyPr rtlCol="0" anchor="ctr"/>
+          <a:lstStyle/>
+          <a:p>
+            <a:pPr algn="ctr"/>
+          </a:p>
+        </p:txBody>
+      </p:sp>
+      <p:sp>
+        <p:nvSpPr>
+          <p:cNvPr id="11" name="TextBox 10"/>
+          <p:cNvSpPr txBox="1"/>
+          <p:nvPr/>
+        </p:nvSpPr>
+        <p:spPr>
+          <a:xfrm>
+            <a:off x="9998964" y="2162555"/>
+            <a:ext cx="868680" cy="246888"/>
+          </a:xfrm>
+          <a:prstGeom prst="rect">
+            <a:avLst/>
+          </a:prstGeom>
+          <a:noFill/>
+        </p:spPr>
+        <p:txBody>
+          <a:bodyPr wrap="square" anchor="ctr" lIns="0" rIns="0" tIns="0" bIns="0">
+            <a:spAutoFit/>
+          </a:bodyPr>
+          <a:lstStyle/>
+          <a:p>
+            <a:pPr algn="l">
+              <a:lnSpc>
+                <a:spcPct val="106000"/>
+              </a:lnSpc>
+              <a:spcBef>
+                <a:spcPts val="0"/>
+              </a:spcBef>
+              <a:spcAft>
+                <a:spcPts val="0"/>
+              </a:spcAft>
+            </a:pPr>
+            <a:r>
+              <a:rPr sz="1250" b="1" i="0">
+                <a:solidFill>
+                  <a:srgbClr val="B1456A"/>
+                </a:solidFill>
+                <a:latin typeface="Calibri"/>
+              </a:rPr>
+              <a:t>1.5</a:t>
+            </a:r>
+          </a:p>
+        </p:txBody>
+      </p:sp>
+      <p:sp>
+        <p:nvSpPr>
+          <p:cNvPr id="12" name="TextBox 11"/>
+          <p:cNvSpPr txBox="1"/>
+          <p:nvPr/>
+        </p:nvSpPr>
+        <p:spPr>
+          <a:xfrm>
+            <a:off x="685800" y="2450591"/>
+            <a:ext cx="2286000" cy="246888"/>
+          </a:xfrm>
+          <a:prstGeom prst="rect">
+            <a:avLst/>
+          </a:prstGeom>
+          <a:noFill/>
+        </p:spPr>
+        <p:txBody>
+          <a:bodyPr wrap="square" anchor="ctr" lIns="0" rIns="0" tIns="0" bIns="0">
+            <a:spAutoFit/>
+          </a:bodyPr>
+          <a:lstStyle/>
+          <a:p>
+            <a:pPr algn="r">
+              <a:lnSpc>
+                <a:spcPct val="106000"/>
+              </a:lnSpc>
+              <a:spcBef>
+                <a:spcPts val="0"/>
+              </a:spcBef>
+              <a:spcAft>
+                <a:spcPts val="0"/>
+              </a:spcAft>
+            </a:pPr>
+            <a:r>
+              <a:rPr sz="1250" b="1" i="0">
+                <a:solidFill>
+                  <a:srgbClr val="2B3038"/>
+                </a:solidFill>
+                <a:latin typeface="Calibri"/>
+              </a:rPr>
+              <a:t>Cacheuta</a:t>
+            </a:r>
+          </a:p>
+        </p:txBody>
+      </p:sp>
+      <p:sp>
+        <p:nvSpPr>
+          <p:cNvPr id="13" name="Rounded Rectangle 12"/>
+          <p:cNvSpPr/>
+          <p:nvPr/>
+        </p:nvSpPr>
+        <p:spPr>
+          <a:xfrm>
+            <a:off x="3063240" y="2465591"/>
+            <a:ext cx="6501384" cy="216888"/>
+          </a:xfrm>
+          <a:prstGeom prst="roundRect">
+            <a:avLst>
+              <a:gd name="adj" fmla="val 35000"/>
+            </a:avLst>
+          </a:prstGeom>
+          <a:solidFill>
+            <a:srgbClr val="B1456A"/>
+          </a:solidFill>
+          <a:ln>
+            <a:noFill/>
+          </a:ln>
+          <a:effectLst/>
+        </p:spPr>
+        <p:style>
+          <a:lnRef idx="1">
+            <a:schemeClr val="accent1"/>
+          </a:lnRef>
+          <a:fillRef idx="3">
+            <a:schemeClr val="accent1"/>
+          </a:fillRef>
+          <a:effectRef idx="2">
+            <a:schemeClr val="accent1"/>
+          </a:effectRef>
+          <a:fontRef idx="minor">
+            <a:schemeClr val="lt1"/>
+          </a:fontRef>
+        </p:style>
+        <p:txBody>
+          <a:bodyPr rtlCol="0" anchor="ctr"/>
+          <a:lstStyle/>
+          <a:p>
+            <a:pPr algn="ctr"/>
+          </a:p>
+        </p:txBody>
+      </p:sp>
+      <p:sp>
+        <p:nvSpPr>
+          <p:cNvPr id="14" name="TextBox 13"/>
+          <p:cNvSpPr txBox="1"/>
+          <p:nvPr/>
+        </p:nvSpPr>
+        <p:spPr>
+          <a:xfrm>
+            <a:off x="9637776" y="2450591"/>
+            <a:ext cx="868680" cy="246888"/>
+          </a:xfrm>
+          <a:prstGeom prst="rect">
+            <a:avLst/>
+          </a:prstGeom>
+          <a:noFill/>
+        </p:spPr>
+        <p:txBody>
+          <a:bodyPr wrap="square" anchor="ctr" lIns="0" rIns="0" tIns="0" bIns="0">
+            <a:spAutoFit/>
+          </a:bodyPr>
+          <a:lstStyle/>
+          <a:p>
+            <a:pPr algn="l">
+              <a:lnSpc>
+                <a:spcPct val="106000"/>
+              </a:lnSpc>
+              <a:spcBef>
+                <a:spcPts val="0"/>
+              </a:spcBef>
+              <a:spcAft>
+                <a:spcPts val="0"/>
+              </a:spcAft>
+            </a:pPr>
+            <a:r>
+              <a:rPr sz="1250" b="1" i="0">
+                <a:solidFill>
+                  <a:srgbClr val="B1456A"/>
+                </a:solidFill>
+                <a:latin typeface="Calibri"/>
+              </a:rPr>
+              <a:t>2</a:t>
+            </a:r>
+          </a:p>
+        </p:txBody>
+      </p:sp>
+      <p:sp>
+        <p:nvSpPr>
+          <p:cNvPr id="15" name="TextBox 14"/>
+          <p:cNvSpPr txBox="1"/>
+          <p:nvPr/>
+        </p:nvSpPr>
+        <p:spPr>
+          <a:xfrm>
+            <a:off x="685800" y="2738627"/>
+            <a:ext cx="2286000" cy="246888"/>
+          </a:xfrm>
+          <a:prstGeom prst="rect">
+            <a:avLst/>
+          </a:prstGeom>
+          <a:noFill/>
+        </p:spPr>
+        <p:txBody>
+          <a:bodyPr wrap="square" anchor="ctr" lIns="0" rIns="0" tIns="0" bIns="0">
+            <a:spAutoFit/>
+          </a:bodyPr>
+          <a:lstStyle/>
+          <a:p>
+            <a:pPr algn="r">
+              <a:lnSpc>
+                <a:spcPct val="106000"/>
+              </a:lnSpc>
+              <a:spcBef>
+                <a:spcPts val="0"/>
+              </a:spcBef>
+              <a:spcAft>
+                <a:spcPts val="0"/>
+              </a:spcAft>
+            </a:pPr>
+            <a:r>
+              <a:rPr sz="1250" b="1" i="0">
+                <a:solidFill>
+                  <a:srgbClr val="2B3038"/>
+                </a:solidFill>
+                <a:latin typeface="Calibri"/>
+              </a:rPr>
+              <a:t>El Carrizal</a:t>
+            </a:r>
+          </a:p>
+        </p:txBody>
+      </p:sp>
+      <p:sp>
+        <p:nvSpPr>
+          <p:cNvPr id="16" name="Rounded Rectangle 15"/>
+          <p:cNvSpPr/>
+          <p:nvPr/>
+        </p:nvSpPr>
+        <p:spPr>
+          <a:xfrm>
+            <a:off x="3063240" y="2753627"/>
+            <a:ext cx="6140196" cy="216888"/>
+          </a:xfrm>
+          <a:prstGeom prst="roundRect">
+            <a:avLst>
+              <a:gd name="adj" fmla="val 35000"/>
+            </a:avLst>
+          </a:prstGeom>
+          <a:solidFill>
+            <a:srgbClr val="B1456A"/>
+          </a:solidFill>
+          <a:ln>
+            <a:noFill/>
+          </a:ln>
+          <a:effectLst/>
+        </p:spPr>
+        <p:style>
+          <a:lnRef idx="1">
+            <a:schemeClr val="accent1"/>
+          </a:lnRef>
+          <a:fillRef idx="3">
+            <a:schemeClr val="accent1"/>
+          </a:fillRef>
+          <a:effectRef idx="2">
+            <a:schemeClr val="accent1"/>
+          </a:effectRef>
+          <a:fontRef idx="minor">
+            <a:schemeClr val="lt1"/>
+          </a:fontRef>
+        </p:style>
+        <p:txBody>
+          <a:bodyPr rtlCol="0" anchor="ctr"/>
+          <a:lstStyle/>
+          <a:p>
+            <a:pPr algn="ctr"/>
+          </a:p>
+        </p:txBody>
+      </p:sp>
+      <p:sp>
+        <p:nvSpPr>
+          <p:cNvPr id="17" name="TextBox 16"/>
+          <p:cNvSpPr txBox="1"/>
+          <p:nvPr/>
+        </p:nvSpPr>
+        <p:spPr>
+          <a:xfrm>
+            <a:off x="9276588" y="2738627"/>
+            <a:ext cx="868680" cy="246888"/>
+          </a:xfrm>
+          <a:prstGeom prst="rect">
+            <a:avLst/>
+          </a:prstGeom>
+          <a:noFill/>
+        </p:spPr>
+        <p:txBody>
+          <a:bodyPr wrap="square" anchor="ctr" lIns="0" rIns="0" tIns="0" bIns="0">
+            <a:spAutoFit/>
+          </a:bodyPr>
+          <a:lstStyle/>
+          <a:p>
+            <a:pPr algn="l">
+              <a:lnSpc>
+                <a:spcPct val="106000"/>
+              </a:lnSpc>
+              <a:spcBef>
+                <a:spcPts val="0"/>
+              </a:spcBef>
+              <a:spcAft>
+                <a:spcPts val="0"/>
+              </a:spcAft>
+            </a:pPr>
+            <a:r>
+              <a:rPr sz="1250" b="1" i="0">
+                <a:solidFill>
+                  <a:srgbClr val="B1456A"/>
+                </a:solidFill>
+                <a:latin typeface="Calibri"/>
+              </a:rPr>
+              <a:t>2.5</a:t>
+            </a:r>
+          </a:p>
+        </p:txBody>
+      </p:sp>
+      <p:sp>
+        <p:nvSpPr>
+          <p:cNvPr id="18" name="TextBox 17"/>
+          <p:cNvSpPr txBox="1"/>
+          <p:nvPr/>
+        </p:nvSpPr>
+        <p:spPr>
+          <a:xfrm>
+            <a:off x="685800" y="3026663"/>
+            <a:ext cx="2286000" cy="246888"/>
+          </a:xfrm>
+          <a:prstGeom prst="rect">
+            <a:avLst/>
+          </a:prstGeom>
+          <a:noFill/>
+        </p:spPr>
+        <p:txBody>
+          <a:bodyPr wrap="square" anchor="ctr" lIns="0" rIns="0" tIns="0" bIns="0">
+            <a:spAutoFit/>
+          </a:bodyPr>
+          <a:lstStyle/>
+          <a:p>
+            <a:pPr algn="r">
+              <a:lnSpc>
+                <a:spcPct val="106000"/>
+              </a:lnSpc>
+              <a:spcBef>
+                <a:spcPts val="0"/>
+              </a:spcBef>
+              <a:spcAft>
+                <a:spcPts val="0"/>
+              </a:spcAft>
+            </a:pPr>
+            <a:r>
+              <a:rPr sz="1250" b="1" i="0">
+                <a:solidFill>
+                  <a:srgbClr val="2B3038"/>
+                </a:solidFill>
+                <a:latin typeface="Calibri"/>
+              </a:rPr>
+              <a:t>Las Compuertas</a:t>
+            </a:r>
+          </a:p>
+        </p:txBody>
+      </p:sp>
+      <p:sp>
+        <p:nvSpPr>
+          <p:cNvPr id="19" name="Rounded Rectangle 18"/>
+          <p:cNvSpPr/>
+          <p:nvPr/>
+        </p:nvSpPr>
+        <p:spPr>
+          <a:xfrm>
+            <a:off x="3063240" y="3041663"/>
+            <a:ext cx="5779008" cy="216888"/>
+          </a:xfrm>
+          <a:prstGeom prst="roundRect">
+            <a:avLst>
+              <a:gd name="adj" fmla="val 35000"/>
+            </a:avLst>
+          </a:prstGeom>
+          <a:solidFill>
+            <a:srgbClr val="B8860B"/>
+          </a:solidFill>
+          <a:ln>
+            <a:noFill/>
+          </a:ln>
+          <a:effectLst/>
+        </p:spPr>
+        <p:style>
+          <a:lnRef idx="1">
+            <a:schemeClr val="accent1"/>
+          </a:lnRef>
+          <a:fillRef idx="3">
+            <a:schemeClr val="accent1"/>
+          </a:fillRef>
+          <a:effectRef idx="2">
+            <a:schemeClr val="accent1"/>
+          </a:effectRef>
+          <a:fontRef idx="minor">
+            <a:schemeClr val="lt1"/>
+          </a:fontRef>
+        </p:style>
+        <p:txBody>
+          <a:bodyPr rtlCol="0" anchor="ctr"/>
+          <a:lstStyle/>
+          <a:p>
+            <a:pPr algn="ctr"/>
+          </a:p>
+        </p:txBody>
+      </p:sp>
+      <p:sp>
+        <p:nvSpPr>
+          <p:cNvPr id="20" name="TextBox 19"/>
+          <p:cNvSpPr txBox="1"/>
+          <p:nvPr/>
+        </p:nvSpPr>
+        <p:spPr>
+          <a:xfrm>
+            <a:off x="8915400" y="3026663"/>
+            <a:ext cx="868680" cy="246888"/>
+          </a:xfrm>
+          <a:prstGeom prst="rect">
+            <a:avLst/>
+          </a:prstGeom>
+          <a:noFill/>
+        </p:spPr>
+        <p:txBody>
+          <a:bodyPr wrap="square" anchor="ctr" lIns="0" rIns="0" tIns="0" bIns="0">
+            <a:spAutoFit/>
+          </a:bodyPr>
+          <a:lstStyle/>
+          <a:p>
+            <a:pPr algn="l">
+              <a:lnSpc>
+                <a:spcPct val="106000"/>
+              </a:lnSpc>
+              <a:spcBef>
+                <a:spcPts val="0"/>
+              </a:spcBef>
+              <a:spcAft>
+                <a:spcPts val="0"/>
+              </a:spcAft>
+            </a:pPr>
+            <a:r>
+              <a:rPr sz="1250" b="1" i="0">
+                <a:solidFill>
+                  <a:srgbClr val="B8860B"/>
+                </a:solidFill>
+                <a:latin typeface="Calibri"/>
+              </a:rPr>
+              <a:t>3</a:t>
+            </a:r>
+          </a:p>
+        </p:txBody>
+      </p:sp>
+      <p:sp>
+        <p:nvSpPr>
+          <p:cNvPr id="21" name="TextBox 20"/>
+          <p:cNvSpPr txBox="1"/>
+          <p:nvPr/>
+        </p:nvSpPr>
+        <p:spPr>
+          <a:xfrm>
+            <a:off x="685800" y="3314699"/>
+            <a:ext cx="2286000" cy="246888"/>
+          </a:xfrm>
+          <a:prstGeom prst="rect">
+            <a:avLst/>
+          </a:prstGeom>
+          <a:noFill/>
+        </p:spPr>
+        <p:txBody>
+          <a:bodyPr wrap="square" anchor="ctr" lIns="0" rIns="0" tIns="0" bIns="0">
+            <a:spAutoFit/>
+          </a:bodyPr>
+          <a:lstStyle/>
+          <a:p>
+            <a:pPr algn="r">
+              <a:lnSpc>
+                <a:spcPct val="106000"/>
+              </a:lnSpc>
+              <a:spcBef>
+                <a:spcPts val="0"/>
+              </a:spcBef>
+              <a:spcAft>
+                <a:spcPts val="0"/>
+              </a:spcAft>
+            </a:pPr>
+            <a:r>
+              <a:rPr sz="1250" b="1" i="0">
+                <a:solidFill>
+                  <a:srgbClr val="2B3038"/>
+                </a:solidFill>
+                <a:latin typeface="Calibri"/>
+              </a:rPr>
+              <a:t>Perdriel</a:t>
+            </a:r>
+          </a:p>
+        </p:txBody>
+      </p:sp>
+      <p:sp>
+        <p:nvSpPr>
+          <p:cNvPr id="22" name="Rounded Rectangle 21"/>
+          <p:cNvSpPr/>
+          <p:nvPr/>
+        </p:nvSpPr>
+        <p:spPr>
+          <a:xfrm>
+            <a:off x="3063240" y="3329699"/>
+            <a:ext cx="5779008" cy="216888"/>
+          </a:xfrm>
+          <a:prstGeom prst="roundRect">
+            <a:avLst>
+              <a:gd name="adj" fmla="val 35000"/>
+            </a:avLst>
+          </a:prstGeom>
+          <a:solidFill>
+            <a:srgbClr val="B8860B"/>
+          </a:solidFill>
+          <a:ln>
+            <a:noFill/>
+          </a:ln>
+          <a:effectLst/>
+        </p:spPr>
+        <p:style>
+          <a:lnRef idx="1">
+            <a:schemeClr val="accent1"/>
+          </a:lnRef>
+          <a:fillRef idx="3">
+            <a:schemeClr val="accent1"/>
+          </a:fillRef>
+          <a:effectRef idx="2">
+            <a:schemeClr val="accent1"/>
+          </a:effectRef>
+          <a:fontRef idx="minor">
+            <a:schemeClr val="lt1"/>
+          </a:fontRef>
+        </p:style>
+        <p:txBody>
+          <a:bodyPr rtlCol="0" anchor="ctr"/>
+          <a:lstStyle/>
+          <a:p>
+            <a:pPr algn="ctr"/>
+          </a:p>
+        </p:txBody>
+      </p:sp>
+      <p:sp>
+        <p:nvSpPr>
+          <p:cNvPr id="23" name="TextBox 22"/>
+          <p:cNvSpPr txBox="1"/>
+          <p:nvPr/>
+        </p:nvSpPr>
+        <p:spPr>
+          <a:xfrm>
+            <a:off x="8915400" y="3314699"/>
+            <a:ext cx="868680" cy="246888"/>
+          </a:xfrm>
+          <a:prstGeom prst="rect">
+            <a:avLst/>
+          </a:prstGeom>
+          <a:noFill/>
+        </p:spPr>
+        <p:txBody>
+          <a:bodyPr wrap="square" anchor="ctr" lIns="0" rIns="0" tIns="0" bIns="0">
+            <a:spAutoFit/>
+          </a:bodyPr>
+          <a:lstStyle/>
+          <a:p>
+            <a:pPr algn="l">
+              <a:lnSpc>
+                <a:spcPct val="106000"/>
+              </a:lnSpc>
+              <a:spcBef>
+                <a:spcPts val="0"/>
+              </a:spcBef>
+              <a:spcAft>
+                <a:spcPts val="0"/>
+              </a:spcAft>
+            </a:pPr>
+            <a:r>
+              <a:rPr sz="1250" b="1" i="0">
+                <a:solidFill>
+                  <a:srgbClr val="B8860B"/>
+                </a:solidFill>
+                <a:latin typeface="Calibri"/>
+              </a:rPr>
+              <a:t>3</a:t>
+            </a:r>
+          </a:p>
+        </p:txBody>
+      </p:sp>
+      <p:sp>
+        <p:nvSpPr>
+          <p:cNvPr id="24" name="TextBox 23"/>
+          <p:cNvSpPr txBox="1"/>
+          <p:nvPr/>
+        </p:nvSpPr>
+        <p:spPr>
+          <a:xfrm>
+            <a:off x="685800" y="3602735"/>
+            <a:ext cx="2286000" cy="246888"/>
+          </a:xfrm>
+          <a:prstGeom prst="rect">
+            <a:avLst/>
+          </a:prstGeom>
+          <a:noFill/>
+        </p:spPr>
+        <p:txBody>
+          <a:bodyPr wrap="square" anchor="ctr" lIns="0" rIns="0" tIns="0" bIns="0">
+            <a:spAutoFit/>
+          </a:bodyPr>
+          <a:lstStyle/>
+          <a:p>
+            <a:pPr algn="r">
+              <a:lnSpc>
+                <a:spcPct val="106000"/>
+              </a:lnSpc>
+              <a:spcBef>
+                <a:spcPts val="0"/>
+              </a:spcBef>
+              <a:spcAft>
+                <a:spcPts val="0"/>
+              </a:spcAft>
+            </a:pPr>
+            <a:r>
+              <a:rPr sz="1250" b="1" i="0">
+                <a:solidFill>
+                  <a:srgbClr val="2B3038"/>
+                </a:solidFill>
+                <a:latin typeface="Calibri"/>
+              </a:rPr>
+              <a:t>Potrerillos</a:t>
+            </a:r>
+          </a:p>
+        </p:txBody>
+      </p:sp>
+      <p:sp>
+        <p:nvSpPr>
+          <p:cNvPr id="25" name="Rounded Rectangle 24"/>
+          <p:cNvSpPr/>
+          <p:nvPr/>
+        </p:nvSpPr>
+        <p:spPr>
+          <a:xfrm>
+            <a:off x="3063240" y="3617735"/>
+            <a:ext cx="5779008" cy="216888"/>
+          </a:xfrm>
+          <a:prstGeom prst="roundRect">
+            <a:avLst>
+              <a:gd name="adj" fmla="val 35000"/>
+            </a:avLst>
+          </a:prstGeom>
+          <a:solidFill>
+            <a:srgbClr val="B8860B"/>
+          </a:solidFill>
+          <a:ln>
+            <a:noFill/>
+          </a:ln>
+          <a:effectLst/>
+        </p:spPr>
+        <p:style>
+          <a:lnRef idx="1">
+            <a:schemeClr val="accent1"/>
+          </a:lnRef>
+          <a:fillRef idx="3">
+            <a:schemeClr val="accent1"/>
+          </a:fillRef>
+          <a:effectRef idx="2">
+            <a:schemeClr val="accent1"/>
+          </a:effectRef>
+          <a:fontRef idx="minor">
+            <a:schemeClr val="lt1"/>
+          </a:fontRef>
+        </p:style>
+        <p:txBody>
+          <a:bodyPr rtlCol="0" anchor="ctr"/>
+          <a:lstStyle/>
+          <a:p>
+            <a:pPr algn="ctr"/>
+          </a:p>
+        </p:txBody>
+      </p:sp>
+      <p:sp>
+        <p:nvSpPr>
+          <p:cNvPr id="26" name="TextBox 25"/>
+          <p:cNvSpPr txBox="1"/>
+          <p:nvPr/>
+        </p:nvSpPr>
+        <p:spPr>
+          <a:xfrm>
+            <a:off x="8915400" y="3602735"/>
+            <a:ext cx="868680" cy="246888"/>
+          </a:xfrm>
+          <a:prstGeom prst="rect">
+            <a:avLst/>
+          </a:prstGeom>
+          <a:noFill/>
+        </p:spPr>
+        <p:txBody>
+          <a:bodyPr wrap="square" anchor="ctr" lIns="0" rIns="0" tIns="0" bIns="0">
+            <a:spAutoFit/>
+          </a:bodyPr>
+          <a:lstStyle/>
+          <a:p>
+            <a:pPr algn="l">
+              <a:lnSpc>
+                <a:spcPct val="106000"/>
+              </a:lnSpc>
+              <a:spcBef>
+                <a:spcPts val="0"/>
+              </a:spcBef>
+              <a:spcAft>
+                <a:spcPts val="0"/>
+              </a:spcAft>
+            </a:pPr>
+            <a:r>
+              <a:rPr sz="1250" b="1" i="0">
+                <a:solidFill>
+                  <a:srgbClr val="B8860B"/>
+                </a:solidFill>
+                <a:latin typeface="Calibri"/>
+              </a:rPr>
+              <a:t>3</a:t>
+            </a:r>
+          </a:p>
+        </p:txBody>
+      </p:sp>
+      <p:sp>
+        <p:nvSpPr>
+          <p:cNvPr id="27" name="TextBox 26"/>
+          <p:cNvSpPr txBox="1"/>
+          <p:nvPr/>
+        </p:nvSpPr>
+        <p:spPr>
+          <a:xfrm>
+            <a:off x="685800" y="3890771"/>
+            <a:ext cx="2286000" cy="246888"/>
+          </a:xfrm>
+          <a:prstGeom prst="rect">
+            <a:avLst/>
+          </a:prstGeom>
+          <a:noFill/>
+        </p:spPr>
+        <p:txBody>
+          <a:bodyPr wrap="square" anchor="ctr" lIns="0" rIns="0" tIns="0" bIns="0">
+            <a:spAutoFit/>
+          </a:bodyPr>
+          <a:lstStyle/>
+          <a:p>
+            <a:pPr algn="r">
+              <a:lnSpc>
+                <a:spcPct val="106000"/>
+              </a:lnSpc>
+              <a:spcBef>
+                <a:spcPts val="0"/>
+              </a:spcBef>
+              <a:spcAft>
+                <a:spcPts val="0"/>
+              </a:spcAft>
+            </a:pPr>
+            <a:r>
+              <a:rPr sz="1250" b="1" i="0">
+                <a:solidFill>
+                  <a:srgbClr val="2B3038"/>
+                </a:solidFill>
+                <a:latin typeface="Calibri"/>
+              </a:rPr>
+              <a:t>Carrodilla</a:t>
+            </a:r>
+          </a:p>
+        </p:txBody>
+      </p:sp>
+      <p:sp>
+        <p:nvSpPr>
+          <p:cNvPr id="28" name="Rounded Rectangle 27"/>
+          <p:cNvSpPr/>
+          <p:nvPr/>
+        </p:nvSpPr>
+        <p:spPr>
+          <a:xfrm>
+            <a:off x="3063240" y="3905771"/>
+            <a:ext cx="5417820" cy="216888"/>
+          </a:xfrm>
+          <a:prstGeom prst="roundRect">
+            <a:avLst>
+              <a:gd name="adj" fmla="val 35000"/>
+            </a:avLst>
+          </a:prstGeom>
+          <a:solidFill>
+            <a:srgbClr val="B8860B"/>
+          </a:solidFill>
+          <a:ln>
+            <a:noFill/>
+          </a:ln>
+          <a:effectLst/>
+        </p:spPr>
+        <p:style>
+          <a:lnRef idx="1">
+            <a:schemeClr val="accent1"/>
+          </a:lnRef>
+          <a:fillRef idx="3">
+            <a:schemeClr val="accent1"/>
+          </a:fillRef>
+          <a:effectRef idx="2">
+            <a:schemeClr val="accent1"/>
+          </a:effectRef>
+          <a:fontRef idx="minor">
+            <a:schemeClr val="lt1"/>
+          </a:fontRef>
+        </p:style>
+        <p:txBody>
+          <a:bodyPr rtlCol="0" anchor="ctr"/>
+          <a:lstStyle/>
+          <a:p>
+            <a:pPr algn="ctr"/>
+          </a:p>
+        </p:txBody>
+      </p:sp>
+      <p:sp>
+        <p:nvSpPr>
+          <p:cNvPr id="29" name="TextBox 28"/>
+          <p:cNvSpPr txBox="1"/>
+          <p:nvPr/>
+        </p:nvSpPr>
+        <p:spPr>
+          <a:xfrm>
+            <a:off x="8554212" y="3890771"/>
+            <a:ext cx="868680" cy="246888"/>
+          </a:xfrm>
+          <a:prstGeom prst="rect">
+            <a:avLst/>
+          </a:prstGeom>
+          <a:noFill/>
+        </p:spPr>
+        <p:txBody>
+          <a:bodyPr wrap="square" anchor="ctr" lIns="0" rIns="0" tIns="0" bIns="0">
+            <a:spAutoFit/>
+          </a:bodyPr>
+          <a:lstStyle/>
+          <a:p>
+            <a:pPr algn="l">
+              <a:lnSpc>
+                <a:spcPct val="106000"/>
+              </a:lnSpc>
+              <a:spcBef>
+                <a:spcPts val="0"/>
+              </a:spcBef>
+              <a:spcAft>
+                <a:spcPts val="0"/>
+              </a:spcAft>
+            </a:pPr>
+            <a:r>
+              <a:rPr sz="1250" b="1" i="0">
+                <a:solidFill>
+                  <a:srgbClr val="B8860B"/>
+                </a:solidFill>
+                <a:latin typeface="Calibri"/>
+              </a:rPr>
+              <a:t>3.5</a:t>
+            </a:r>
+          </a:p>
+        </p:txBody>
+      </p:sp>
+      <p:sp>
+        <p:nvSpPr>
+          <p:cNvPr id="30" name="TextBox 29"/>
+          <p:cNvSpPr txBox="1"/>
+          <p:nvPr/>
+        </p:nvSpPr>
+        <p:spPr>
+          <a:xfrm>
+            <a:off x="685800" y="4178807"/>
+            <a:ext cx="2286000" cy="246888"/>
+          </a:xfrm>
+          <a:prstGeom prst="rect">
+            <a:avLst/>
+          </a:prstGeom>
+          <a:noFill/>
+        </p:spPr>
+        <p:txBody>
+          <a:bodyPr wrap="square" anchor="ctr" lIns="0" rIns="0" tIns="0" bIns="0">
+            <a:spAutoFit/>
+          </a:bodyPr>
+          <a:lstStyle/>
+          <a:p>
+            <a:pPr algn="r">
+              <a:lnSpc>
+                <a:spcPct val="106000"/>
+              </a:lnSpc>
+              <a:spcBef>
+                <a:spcPts val="0"/>
+              </a:spcBef>
+              <a:spcAft>
+                <a:spcPts val="0"/>
+              </a:spcAft>
+            </a:pPr>
+            <a:r>
+              <a:rPr sz="1250" b="1" i="0">
+                <a:solidFill>
+                  <a:srgbClr val="2B3038"/>
+                </a:solidFill>
+                <a:latin typeface="Calibri"/>
+              </a:rPr>
+              <a:t>Agrelo</a:t>
+            </a:r>
+          </a:p>
+        </p:txBody>
+      </p:sp>
+      <p:sp>
+        <p:nvSpPr>
+          <p:cNvPr id="31" name="Rounded Rectangle 30"/>
+          <p:cNvSpPr/>
+          <p:nvPr/>
+        </p:nvSpPr>
+        <p:spPr>
+          <a:xfrm>
+            <a:off x="3063240" y="4193807"/>
+            <a:ext cx="5417820" cy="216888"/>
+          </a:xfrm>
+          <a:prstGeom prst="roundRect">
+            <a:avLst>
+              <a:gd name="adj" fmla="val 35000"/>
+            </a:avLst>
+          </a:prstGeom>
+          <a:solidFill>
+            <a:srgbClr val="B8860B"/>
+          </a:solidFill>
+          <a:ln>
+            <a:noFill/>
+          </a:ln>
+          <a:effectLst/>
+        </p:spPr>
+        <p:style>
+          <a:lnRef idx="1">
+            <a:schemeClr val="accent1"/>
+          </a:lnRef>
+          <a:fillRef idx="3">
+            <a:schemeClr val="accent1"/>
+          </a:fillRef>
+          <a:effectRef idx="2">
+            <a:schemeClr val="accent1"/>
+          </a:effectRef>
+          <a:fontRef idx="minor">
+            <a:schemeClr val="lt1"/>
+          </a:fontRef>
+        </p:style>
+        <p:txBody>
+          <a:bodyPr rtlCol="0" anchor="ctr"/>
+          <a:lstStyle/>
+          <a:p>
+            <a:pPr algn="ctr"/>
+          </a:p>
+        </p:txBody>
+      </p:sp>
+      <p:sp>
+        <p:nvSpPr>
+          <p:cNvPr id="32" name="TextBox 31"/>
+          <p:cNvSpPr txBox="1"/>
+          <p:nvPr/>
+        </p:nvSpPr>
+        <p:spPr>
+          <a:xfrm>
+            <a:off x="8554212" y="4178807"/>
+            <a:ext cx="868680" cy="246888"/>
+          </a:xfrm>
+          <a:prstGeom prst="rect">
+            <a:avLst/>
+          </a:prstGeom>
+          <a:noFill/>
+        </p:spPr>
+        <p:txBody>
+          <a:bodyPr wrap="square" anchor="ctr" lIns="0" rIns="0" tIns="0" bIns="0">
+            <a:spAutoFit/>
+          </a:bodyPr>
+          <a:lstStyle/>
+          <a:p>
+            <a:pPr algn="l">
+              <a:lnSpc>
+                <a:spcPct val="106000"/>
+              </a:lnSpc>
+              <a:spcBef>
+                <a:spcPts val="0"/>
+              </a:spcBef>
+              <a:spcAft>
+                <a:spcPts val="0"/>
+              </a:spcAft>
+            </a:pPr>
+            <a:r>
+              <a:rPr sz="1250" b="1" i="0">
+                <a:solidFill>
+                  <a:srgbClr val="B8860B"/>
+                </a:solidFill>
+                <a:latin typeface="Calibri"/>
+              </a:rPr>
+              <a:t>3.5</a:t>
+            </a:r>
+          </a:p>
+        </p:txBody>
+      </p:sp>
+      <p:sp>
+        <p:nvSpPr>
+          <p:cNvPr id="33" name="TextBox 32"/>
+          <p:cNvSpPr txBox="1"/>
+          <p:nvPr/>
+        </p:nvSpPr>
+        <p:spPr>
+          <a:xfrm>
+            <a:off x="685800" y="4466843"/>
+            <a:ext cx="2286000" cy="246888"/>
+          </a:xfrm>
+          <a:prstGeom prst="rect">
+            <a:avLst/>
+          </a:prstGeom>
+          <a:noFill/>
+        </p:spPr>
+        <p:txBody>
+          <a:bodyPr wrap="square" anchor="ctr" lIns="0" rIns="0" tIns="0" bIns="0">
+            <a:spAutoFit/>
+          </a:bodyPr>
+          <a:lstStyle/>
+          <a:p>
+            <a:pPr algn="r">
+              <a:lnSpc>
+                <a:spcPct val="106000"/>
+              </a:lnSpc>
+              <a:spcBef>
+                <a:spcPts val="0"/>
+              </a:spcBef>
+              <a:spcAft>
+                <a:spcPts val="0"/>
+              </a:spcAft>
+            </a:pPr>
+            <a:r>
+              <a:rPr sz="1250" b="1" i="0">
+                <a:solidFill>
+                  <a:srgbClr val="2B3038"/>
+                </a:solidFill>
+                <a:latin typeface="Calibri"/>
+              </a:rPr>
+              <a:t>Ugarteche</a:t>
+            </a:r>
+          </a:p>
+        </p:txBody>
+      </p:sp>
+      <p:sp>
+        <p:nvSpPr>
+          <p:cNvPr id="34" name="Rounded Rectangle 33"/>
+          <p:cNvSpPr/>
+          <p:nvPr/>
+        </p:nvSpPr>
+        <p:spPr>
+          <a:xfrm>
+            <a:off x="3063240" y="4481843"/>
+            <a:ext cx="5417820" cy="216888"/>
+          </a:xfrm>
+          <a:prstGeom prst="roundRect">
+            <a:avLst>
+              <a:gd name="adj" fmla="val 35000"/>
+            </a:avLst>
+          </a:prstGeom>
+          <a:solidFill>
+            <a:srgbClr val="B8860B"/>
+          </a:solidFill>
+          <a:ln>
+            <a:noFill/>
+          </a:ln>
+          <a:effectLst/>
+        </p:spPr>
+        <p:style>
+          <a:lnRef idx="1">
+            <a:schemeClr val="accent1"/>
+          </a:lnRef>
+          <a:fillRef idx="3">
+            <a:schemeClr val="accent1"/>
+          </a:fillRef>
+          <a:effectRef idx="2">
+            <a:schemeClr val="accent1"/>
+          </a:effectRef>
+          <a:fontRef idx="minor">
+            <a:schemeClr val="lt1"/>
+          </a:fontRef>
+        </p:style>
+        <p:txBody>
+          <a:bodyPr rtlCol="0" anchor="ctr"/>
+          <a:lstStyle/>
+          <a:p>
+            <a:pPr algn="ctr"/>
+          </a:p>
+        </p:txBody>
+      </p:sp>
+      <p:sp>
+        <p:nvSpPr>
+          <p:cNvPr id="35" name="TextBox 34"/>
+          <p:cNvSpPr txBox="1"/>
+          <p:nvPr/>
+        </p:nvSpPr>
+        <p:spPr>
+          <a:xfrm>
+            <a:off x="8554212" y="4466843"/>
+            <a:ext cx="868680" cy="246888"/>
+          </a:xfrm>
+          <a:prstGeom prst="rect">
+            <a:avLst/>
+          </a:prstGeom>
+          <a:noFill/>
+        </p:spPr>
+        <p:txBody>
+          <a:bodyPr wrap="square" anchor="ctr" lIns="0" rIns="0" tIns="0" bIns="0">
+            <a:spAutoFit/>
+          </a:bodyPr>
+          <a:lstStyle/>
+          <a:p>
+            <a:pPr algn="l">
+              <a:lnSpc>
+                <a:spcPct val="106000"/>
+              </a:lnSpc>
+              <a:spcBef>
+                <a:spcPts val="0"/>
+              </a:spcBef>
+              <a:spcAft>
+                <a:spcPts val="0"/>
+              </a:spcAft>
+            </a:pPr>
+            <a:r>
+              <a:rPr sz="1250" b="1" i="0">
+                <a:solidFill>
+                  <a:srgbClr val="B8860B"/>
+                </a:solidFill>
+                <a:latin typeface="Calibri"/>
+              </a:rPr>
+              <a:t>3.5</a:t>
+            </a:r>
+          </a:p>
+        </p:txBody>
+      </p:sp>
+      <p:sp>
+        <p:nvSpPr>
+          <p:cNvPr id="36" name="TextBox 35"/>
+          <p:cNvSpPr txBox="1"/>
+          <p:nvPr/>
+        </p:nvSpPr>
+        <p:spPr>
+          <a:xfrm>
+            <a:off x="685800" y="4754879"/>
+            <a:ext cx="2286000" cy="246888"/>
+          </a:xfrm>
+          <a:prstGeom prst="rect">
+            <a:avLst/>
+          </a:prstGeom>
+          <a:noFill/>
+        </p:spPr>
+        <p:txBody>
+          <a:bodyPr wrap="square" anchor="ctr" lIns="0" rIns="0" tIns="0" bIns="0">
+            <a:spAutoFit/>
+          </a:bodyPr>
+          <a:lstStyle/>
+          <a:p>
+            <a:pPr algn="r">
+              <a:lnSpc>
+                <a:spcPct val="106000"/>
+              </a:lnSpc>
+              <a:spcBef>
+                <a:spcPts val="0"/>
+              </a:spcBef>
+              <a:spcAft>
+                <a:spcPts val="0"/>
+              </a:spcAft>
+            </a:pPr>
+            <a:r>
+              <a:rPr sz="1250" b="1" i="0">
+                <a:solidFill>
+                  <a:srgbClr val="2B3038"/>
+                </a:solidFill>
+                <a:latin typeface="Calibri"/>
+              </a:rPr>
+              <a:t>Chacras de Coria</a:t>
+            </a:r>
+          </a:p>
+        </p:txBody>
+      </p:sp>
+      <p:sp>
+        <p:nvSpPr>
+          <p:cNvPr id="37" name="Rounded Rectangle 36"/>
+          <p:cNvSpPr/>
+          <p:nvPr/>
+        </p:nvSpPr>
+        <p:spPr>
+          <a:xfrm>
+            <a:off x="3063240" y="4769879"/>
+            <a:ext cx="5056632" cy="216888"/>
+          </a:xfrm>
+          <a:prstGeom prst="roundRect">
+            <a:avLst>
+              <a:gd name="adj" fmla="val 35000"/>
+            </a:avLst>
+          </a:prstGeom>
+          <a:solidFill>
+            <a:srgbClr val="B8860B"/>
+          </a:solidFill>
+          <a:ln>
+            <a:noFill/>
+          </a:ln>
+          <a:effectLst/>
+        </p:spPr>
+        <p:style>
+          <a:lnRef idx="1">
+            <a:schemeClr val="accent1"/>
+          </a:lnRef>
+          <a:fillRef idx="3">
+            <a:schemeClr val="accent1"/>
+          </a:fillRef>
+          <a:effectRef idx="2">
+            <a:schemeClr val="accent1"/>
+          </a:effectRef>
+          <a:fontRef idx="minor">
+            <a:schemeClr val="lt1"/>
+          </a:fontRef>
+        </p:style>
+        <p:txBody>
+          <a:bodyPr rtlCol="0" anchor="ctr"/>
+          <a:lstStyle/>
+          <a:p>
+            <a:pPr algn="ctr"/>
+          </a:p>
+        </p:txBody>
+      </p:sp>
+      <p:sp>
+        <p:nvSpPr>
+          <p:cNvPr id="38" name="TextBox 37"/>
+          <p:cNvSpPr txBox="1"/>
+          <p:nvPr/>
+        </p:nvSpPr>
+        <p:spPr>
+          <a:xfrm>
+            <a:off x="8193024" y="4754879"/>
+            <a:ext cx="868680" cy="246888"/>
+          </a:xfrm>
+          <a:prstGeom prst="rect">
+            <a:avLst/>
+          </a:prstGeom>
+          <a:noFill/>
+        </p:spPr>
+        <p:txBody>
+          <a:bodyPr wrap="square" anchor="ctr" lIns="0" rIns="0" tIns="0" bIns="0">
+            <a:spAutoFit/>
+          </a:bodyPr>
+          <a:lstStyle/>
+          <a:p>
+            <a:pPr algn="l">
+              <a:lnSpc>
+                <a:spcPct val="106000"/>
+              </a:lnSpc>
+              <a:spcBef>
+                <a:spcPts val="0"/>
+              </a:spcBef>
+              <a:spcAft>
+                <a:spcPts val="0"/>
+              </a:spcAft>
+            </a:pPr>
+            <a:r>
+              <a:rPr sz="1250" b="1" i="0">
+                <a:solidFill>
+                  <a:srgbClr val="B8860B"/>
+                </a:solidFill>
+                <a:latin typeface="Calibri"/>
+              </a:rPr>
+              <a:t>4</a:t>
+            </a:r>
+          </a:p>
+        </p:txBody>
+      </p:sp>
+      <p:sp>
+        <p:nvSpPr>
+          <p:cNvPr id="39" name="TextBox 38"/>
+          <p:cNvSpPr txBox="1"/>
+          <p:nvPr/>
+        </p:nvSpPr>
+        <p:spPr>
+          <a:xfrm>
+            <a:off x="685800" y="5042915"/>
+            <a:ext cx="2286000" cy="246888"/>
+          </a:xfrm>
+          <a:prstGeom prst="rect">
+            <a:avLst/>
+          </a:prstGeom>
+          <a:noFill/>
+        </p:spPr>
+        <p:txBody>
+          <a:bodyPr wrap="square" anchor="ctr" lIns="0" rIns="0" tIns="0" bIns="0">
+            <a:spAutoFit/>
+          </a:bodyPr>
+          <a:lstStyle/>
+          <a:p>
+            <a:pPr algn="r">
+              <a:lnSpc>
+                <a:spcPct val="106000"/>
+              </a:lnSpc>
+              <a:spcBef>
+                <a:spcPts val="0"/>
+              </a:spcBef>
+              <a:spcAft>
+                <a:spcPts val="0"/>
+              </a:spcAft>
+            </a:pPr>
+            <a:r>
+              <a:rPr sz="1250" b="1" i="0">
+                <a:solidFill>
+                  <a:srgbClr val="2B3038"/>
+                </a:solidFill>
+                <a:latin typeface="Calibri"/>
+              </a:rPr>
+              <a:t>Vistalba</a:t>
+            </a:r>
+          </a:p>
+        </p:txBody>
+      </p:sp>
+      <p:sp>
+        <p:nvSpPr>
+          <p:cNvPr id="40" name="Rounded Rectangle 39"/>
+          <p:cNvSpPr/>
+          <p:nvPr/>
+        </p:nvSpPr>
+        <p:spPr>
+          <a:xfrm>
+            <a:off x="3063240" y="5057915"/>
+            <a:ext cx="4695444" cy="216888"/>
+          </a:xfrm>
+          <a:prstGeom prst="roundRect">
+            <a:avLst>
+              <a:gd name="adj" fmla="val 35000"/>
+            </a:avLst>
+          </a:prstGeom>
+          <a:solidFill>
+            <a:srgbClr val="B8860B"/>
+          </a:solidFill>
+          <a:ln>
+            <a:noFill/>
+          </a:ln>
+          <a:effectLst/>
+        </p:spPr>
+        <p:style>
+          <a:lnRef idx="1">
+            <a:schemeClr val="accent1"/>
+          </a:lnRef>
+          <a:fillRef idx="3">
+            <a:schemeClr val="accent1"/>
+          </a:fillRef>
+          <a:effectRef idx="2">
+            <a:schemeClr val="accent1"/>
+          </a:effectRef>
+          <a:fontRef idx="minor">
+            <a:schemeClr val="lt1"/>
+          </a:fontRef>
+        </p:style>
+        <p:txBody>
+          <a:bodyPr rtlCol="0" anchor="ctr"/>
+          <a:lstStyle/>
+          <a:p>
+            <a:pPr algn="ctr"/>
+          </a:p>
+        </p:txBody>
+      </p:sp>
+      <p:sp>
+        <p:nvSpPr>
+          <p:cNvPr id="41" name="TextBox 40"/>
+          <p:cNvSpPr txBox="1"/>
+          <p:nvPr/>
+        </p:nvSpPr>
+        <p:spPr>
+          <a:xfrm>
+            <a:off x="7831836" y="5042915"/>
+            <a:ext cx="868680" cy="246888"/>
+          </a:xfrm>
+          <a:prstGeom prst="rect">
+            <a:avLst/>
+          </a:prstGeom>
+          <a:noFill/>
+        </p:spPr>
+        <p:txBody>
+          <a:bodyPr wrap="square" anchor="ctr" lIns="0" rIns="0" tIns="0" bIns="0">
+            <a:spAutoFit/>
+          </a:bodyPr>
+          <a:lstStyle/>
+          <a:p>
+            <a:pPr algn="l">
+              <a:lnSpc>
+                <a:spcPct val="106000"/>
+              </a:lnSpc>
+              <a:spcBef>
+                <a:spcPts val="0"/>
+              </a:spcBef>
+              <a:spcAft>
+                <a:spcPts val="0"/>
+              </a:spcAft>
+            </a:pPr>
+            <a:r>
+              <a:rPr sz="1250" b="1" i="0">
+                <a:solidFill>
+                  <a:srgbClr val="B8860B"/>
+                </a:solidFill>
+                <a:latin typeface="Calibri"/>
+              </a:rPr>
+              <a:t>4.5</a:t>
+            </a:r>
+          </a:p>
+        </p:txBody>
+      </p:sp>
+      <p:sp>
+        <p:nvSpPr>
+          <p:cNvPr id="42" name="TextBox 41"/>
+          <p:cNvSpPr txBox="1"/>
+          <p:nvPr/>
+        </p:nvSpPr>
+        <p:spPr>
+          <a:xfrm>
+            <a:off x="685800" y="5330951"/>
+            <a:ext cx="2286000" cy="246888"/>
+          </a:xfrm>
+          <a:prstGeom prst="rect">
+            <a:avLst/>
+          </a:prstGeom>
+          <a:noFill/>
+        </p:spPr>
+        <p:txBody>
+          <a:bodyPr wrap="square" anchor="ctr" lIns="0" rIns="0" tIns="0" bIns="0">
+            <a:spAutoFit/>
+          </a:bodyPr>
+          <a:lstStyle/>
+          <a:p>
+            <a:pPr algn="r">
+              <a:lnSpc>
+                <a:spcPct val="106000"/>
+              </a:lnSpc>
+              <a:spcBef>
+                <a:spcPts val="0"/>
+              </a:spcBef>
+              <a:spcAft>
+                <a:spcPts val="0"/>
+              </a:spcAft>
+            </a:pPr>
+            <a:r>
+              <a:rPr sz="1250" b="1" i="0">
+                <a:solidFill>
+                  <a:srgbClr val="2B3038"/>
+                </a:solidFill>
+                <a:latin typeface="Calibri"/>
+              </a:rPr>
+              <a:t>Mayor Drummond</a:t>
+            </a:r>
+          </a:p>
+        </p:txBody>
+      </p:sp>
+      <p:sp>
+        <p:nvSpPr>
+          <p:cNvPr id="43" name="Rounded Rectangle 42"/>
+          <p:cNvSpPr/>
+          <p:nvPr/>
+        </p:nvSpPr>
+        <p:spPr>
+          <a:xfrm>
+            <a:off x="3063240" y="5345951"/>
+            <a:ext cx="4695444" cy="216888"/>
+          </a:xfrm>
+          <a:prstGeom prst="roundRect">
+            <a:avLst>
+              <a:gd name="adj" fmla="val 35000"/>
+            </a:avLst>
+          </a:prstGeom>
+          <a:solidFill>
+            <a:srgbClr val="B8860B"/>
+          </a:solidFill>
+          <a:ln>
+            <a:noFill/>
+          </a:ln>
+          <a:effectLst/>
+        </p:spPr>
+        <p:style>
+          <a:lnRef idx="1">
+            <a:schemeClr val="accent1"/>
+          </a:lnRef>
+          <a:fillRef idx="3">
+            <a:schemeClr val="accent1"/>
+          </a:fillRef>
+          <a:effectRef idx="2">
+            <a:schemeClr val="accent1"/>
+          </a:effectRef>
+          <a:fontRef idx="minor">
+            <a:schemeClr val="lt1"/>
+          </a:fontRef>
+        </p:style>
+        <p:txBody>
+          <a:bodyPr rtlCol="0" anchor="ctr"/>
+          <a:lstStyle/>
+          <a:p>
+            <a:pPr algn="ctr"/>
+          </a:p>
+        </p:txBody>
+      </p:sp>
+      <p:sp>
+        <p:nvSpPr>
+          <p:cNvPr id="44" name="TextBox 43"/>
+          <p:cNvSpPr txBox="1"/>
+          <p:nvPr/>
+        </p:nvSpPr>
+        <p:spPr>
+          <a:xfrm>
+            <a:off x="7831836" y="5330951"/>
+            <a:ext cx="868680" cy="246888"/>
+          </a:xfrm>
+          <a:prstGeom prst="rect">
+            <a:avLst/>
+          </a:prstGeom>
+          <a:noFill/>
+        </p:spPr>
+        <p:txBody>
+          <a:bodyPr wrap="square" anchor="ctr" lIns="0" rIns="0" tIns="0" bIns="0">
+            <a:spAutoFit/>
+          </a:bodyPr>
+          <a:lstStyle/>
+          <a:p>
+            <a:pPr algn="l">
+              <a:lnSpc>
+                <a:spcPct val="106000"/>
+              </a:lnSpc>
+              <a:spcBef>
+                <a:spcPts val="0"/>
+              </a:spcBef>
+              <a:spcAft>
+                <a:spcPts val="0"/>
+              </a:spcAft>
+            </a:pPr>
+            <a:r>
+              <a:rPr sz="1250" b="1" i="0">
+                <a:solidFill>
+                  <a:srgbClr val="B8860B"/>
+                </a:solidFill>
+                <a:latin typeface="Calibri"/>
+              </a:rPr>
+              <a:t>4.5</a:t>
+            </a:r>
+          </a:p>
+        </p:txBody>
+      </p:sp>
+      <p:sp>
+        <p:nvSpPr>
+          <p:cNvPr id="45" name="TextBox 44"/>
+          <p:cNvSpPr txBox="1"/>
+          <p:nvPr/>
+        </p:nvSpPr>
+        <p:spPr>
+          <a:xfrm>
+            <a:off x="685800" y="5618987"/>
+            <a:ext cx="2286000" cy="246888"/>
+          </a:xfrm>
+          <a:prstGeom prst="rect">
+            <a:avLst/>
+          </a:prstGeom>
+          <a:noFill/>
+        </p:spPr>
+        <p:txBody>
+          <a:bodyPr wrap="square" anchor="ctr" lIns="0" rIns="0" tIns="0" bIns="0">
+            <a:spAutoFit/>
+          </a:bodyPr>
+          <a:lstStyle/>
+          <a:p>
+            <a:pPr algn="r">
+              <a:lnSpc>
+                <a:spcPct val="106000"/>
+              </a:lnSpc>
+              <a:spcBef>
+                <a:spcPts val="0"/>
+              </a:spcBef>
+              <a:spcAft>
+                <a:spcPts val="0"/>
+              </a:spcAft>
+            </a:pPr>
+            <a:r>
+              <a:rPr sz="1250" b="1" i="0">
+                <a:solidFill>
+                  <a:srgbClr val="2B3038"/>
+                </a:solidFill>
+                <a:latin typeface="Calibri"/>
+              </a:rPr>
+              <a:t>La Puntilla</a:t>
+            </a:r>
+          </a:p>
+        </p:txBody>
+      </p:sp>
+      <p:sp>
+        <p:nvSpPr>
+          <p:cNvPr id="46" name="Rounded Rectangle 45"/>
+          <p:cNvSpPr/>
+          <p:nvPr/>
+        </p:nvSpPr>
+        <p:spPr>
+          <a:xfrm>
+            <a:off x="3063240" y="5633987"/>
+            <a:ext cx="3611880" cy="216888"/>
           </a:xfrm>
           <a:prstGeom prst="roundRect">
             <a:avLst>
@@ -23116,14 +24884,14 @@
       </p:sp>
       <p:sp>
         <p:nvSpPr>
-          <p:cNvPr id="8" name="TextBox 7"/>
-          <p:cNvSpPr txBox="1"/>
-          <p:nvPr/>
-        </p:nvSpPr>
-        <p:spPr>
-          <a:xfrm>
-            <a:off x="10543032" y="1874519"/>
-            <a:ext cx="822960" cy="246888"/>
+          <p:cNvPr id="47" name="TextBox 46"/>
+          <p:cNvSpPr txBox="1"/>
+          <p:nvPr/>
+        </p:nvSpPr>
+        <p:spPr>
+          <a:xfrm>
+            <a:off x="6748272" y="5618987"/>
+            <a:ext cx="868680" cy="246888"/>
           </a:xfrm>
           <a:prstGeom prst="rect">
             <a:avLst/>
@@ -23154,21 +24922,21 @@
                 </a:solidFill>
                 <a:latin typeface="Calibri"/>
               </a:rPr>
-              <a:t>7</a:t>
-            </a:r>
-          </a:p>
-        </p:txBody>
-      </p:sp>
-      <p:sp>
-        <p:nvSpPr>
-          <p:cNvPr id="9" name="TextBox 8"/>
-          <p:cNvSpPr txBox="1"/>
-          <p:nvPr/>
-        </p:nvSpPr>
-        <p:spPr>
-          <a:xfrm>
-            <a:off x="685800" y="2162555"/>
-            <a:ext cx="2103120" cy="246888"/>
+              <a:t>6</a:t>
+            </a:r>
+          </a:p>
+        </p:txBody>
+      </p:sp>
+      <p:sp>
+        <p:nvSpPr>
+          <p:cNvPr id="48" name="TextBox 47"/>
+          <p:cNvSpPr txBox="1"/>
+          <p:nvPr/>
+        </p:nvSpPr>
+        <p:spPr>
+          <a:xfrm>
+            <a:off x="685800" y="5907023"/>
+            <a:ext cx="2286000" cy="246888"/>
           </a:xfrm>
           <a:prstGeom prst="rect">
             <a:avLst/>
@@ -23199,21 +24967,21 @@
                 </a:solidFill>
                 <a:latin typeface="Calibri"/>
               </a:rPr>
-              <a:t>La Puntilla</a:t>
-            </a:r>
-          </a:p>
-        </p:txBody>
-      </p:sp>
-      <p:sp>
-        <p:nvSpPr>
-          <p:cNvPr id="10" name="Rounded Rectangle 9"/>
+              <a:t>Ciudad</a:t>
+            </a:r>
+          </a:p>
+        </p:txBody>
+      </p:sp>
+      <p:sp>
+        <p:nvSpPr>
+          <p:cNvPr id="49" name="Rounded Rectangle 48"/>
           <p:cNvSpPr/>
           <p:nvPr/>
         </p:nvSpPr>
         <p:spPr>
           <a:xfrm>
-            <a:off x="2880360" y="2177555"/>
-            <a:ext cx="6505302" cy="216888"/>
+            <a:off x="3063240" y="5922023"/>
+            <a:ext cx="2889504" cy="216888"/>
           </a:xfrm>
           <a:prstGeom prst="roundRect">
             <a:avLst>
@@ -23252,14 +25020,14 @@
       </p:sp>
       <p:sp>
         <p:nvSpPr>
-          <p:cNvPr id="11" name="TextBox 10"/>
-          <p:cNvSpPr txBox="1"/>
-          <p:nvPr/>
-        </p:nvSpPr>
-        <p:spPr>
-          <a:xfrm>
-            <a:off x="9458814" y="2162555"/>
-            <a:ext cx="822960" cy="246888"/>
+          <p:cNvPr id="50" name="TextBox 49"/>
+          <p:cNvSpPr txBox="1"/>
+          <p:nvPr/>
+        </p:nvSpPr>
+        <p:spPr>
+          <a:xfrm>
+            <a:off x="6025896" y="5907023"/>
+            <a:ext cx="868680" cy="246888"/>
           </a:xfrm>
           <a:prstGeom prst="rect">
             <a:avLst/>
@@ -23290,1831 +25058,21 @@
                 </a:solidFill>
                 <a:latin typeface="Calibri"/>
               </a:rPr>
-              <a:t>6</a:t>
-            </a:r>
-          </a:p>
-        </p:txBody>
-      </p:sp>
-      <p:sp>
-        <p:nvSpPr>
-          <p:cNvPr id="12" name="TextBox 11"/>
-          <p:cNvSpPr txBox="1"/>
-          <p:nvPr/>
-        </p:nvSpPr>
-        <p:spPr>
-          <a:xfrm>
-            <a:off x="685800" y="2450591"/>
-            <a:ext cx="2103120" cy="246888"/>
-          </a:xfrm>
-          <a:prstGeom prst="rect">
-            <a:avLst/>
-          </a:prstGeom>
-          <a:noFill/>
-        </p:spPr>
-        <p:txBody>
-          <a:bodyPr wrap="square" anchor="ctr" lIns="0" rIns="0" tIns="0" bIns="0">
-            <a:spAutoFit/>
-          </a:bodyPr>
-          <a:lstStyle/>
-          <a:p>
-            <a:pPr algn="r">
-              <a:lnSpc>
-                <a:spcPct val="106000"/>
-              </a:lnSpc>
-              <a:spcBef>
-                <a:spcPts val="0"/>
-              </a:spcBef>
-              <a:spcAft>
-                <a:spcPts val="0"/>
-              </a:spcAft>
-            </a:pPr>
-            <a:r>
-              <a:rPr sz="1250" b="1" i="0">
-                <a:solidFill>
-                  <a:srgbClr val="2B3038"/>
-                </a:solidFill>
-                <a:latin typeface="Calibri"/>
-              </a:rPr>
-              <a:t>Mayor Drummond</a:t>
-            </a:r>
-          </a:p>
-        </p:txBody>
-      </p:sp>
-      <p:sp>
-        <p:nvSpPr>
-          <p:cNvPr id="13" name="Rounded Rectangle 12"/>
+              <a:t>7</a:t>
+            </a:r>
+          </a:p>
+        </p:txBody>
+      </p:sp>
+      <p:sp>
+        <p:nvSpPr>
+          <p:cNvPr id="51" name="Rounded Rectangle 50"/>
           <p:cNvSpPr/>
           <p:nvPr/>
         </p:nvSpPr>
         <p:spPr>
           <a:xfrm>
-            <a:off x="2880360" y="2465591"/>
-            <a:ext cx="4878977" cy="216888"/>
-          </a:xfrm>
-          <a:prstGeom prst="roundRect">
-            <a:avLst>
-              <a:gd name="adj" fmla="val 35000"/>
-            </a:avLst>
-          </a:prstGeom>
-          <a:solidFill>
-            <a:srgbClr val="5A8F6B"/>
-          </a:solidFill>
-          <a:ln>
-            <a:noFill/>
-          </a:ln>
-          <a:effectLst/>
-        </p:spPr>
-        <p:style>
-          <a:lnRef idx="1">
-            <a:schemeClr val="accent1"/>
-          </a:lnRef>
-          <a:fillRef idx="3">
-            <a:schemeClr val="accent1"/>
-          </a:fillRef>
-          <a:effectRef idx="2">
-            <a:schemeClr val="accent1"/>
-          </a:effectRef>
-          <a:fontRef idx="minor">
-            <a:schemeClr val="lt1"/>
-          </a:fontRef>
-        </p:style>
-        <p:txBody>
-          <a:bodyPr rtlCol="0" anchor="ctr"/>
-          <a:lstStyle/>
-          <a:p>
-            <a:pPr algn="ctr"/>
-          </a:p>
-        </p:txBody>
-      </p:sp>
-      <p:sp>
-        <p:nvSpPr>
-          <p:cNvPr id="14" name="TextBox 13"/>
-          <p:cNvSpPr txBox="1"/>
-          <p:nvPr/>
-        </p:nvSpPr>
-        <p:spPr>
-          <a:xfrm>
-            <a:off x="7832489" y="2450591"/>
-            <a:ext cx="822960" cy="246888"/>
-          </a:xfrm>
-          <a:prstGeom prst="rect">
-            <a:avLst/>
-          </a:prstGeom>
-          <a:noFill/>
-        </p:spPr>
-        <p:txBody>
-          <a:bodyPr wrap="square" anchor="ctr" lIns="0" rIns="0" tIns="0" bIns="0">
-            <a:spAutoFit/>
-          </a:bodyPr>
-          <a:lstStyle/>
-          <a:p>
-            <a:pPr algn="l">
-              <a:lnSpc>
-                <a:spcPct val="106000"/>
-              </a:lnSpc>
-              <a:spcBef>
-                <a:spcPts val="0"/>
-              </a:spcBef>
-              <a:spcAft>
-                <a:spcPts val="0"/>
-              </a:spcAft>
-            </a:pPr>
-            <a:r>
-              <a:rPr sz="1250" b="1" i="0">
-                <a:solidFill>
-                  <a:srgbClr val="5A8F6B"/>
-                </a:solidFill>
-                <a:latin typeface="Calibri"/>
-              </a:rPr>
-              <a:t>4.5</a:t>
-            </a:r>
-          </a:p>
-        </p:txBody>
-      </p:sp>
-      <p:sp>
-        <p:nvSpPr>
-          <p:cNvPr id="15" name="TextBox 14"/>
-          <p:cNvSpPr txBox="1"/>
-          <p:nvPr/>
-        </p:nvSpPr>
-        <p:spPr>
-          <a:xfrm>
-            <a:off x="685800" y="2738627"/>
-            <a:ext cx="2103120" cy="246888"/>
-          </a:xfrm>
-          <a:prstGeom prst="rect">
-            <a:avLst/>
-          </a:prstGeom>
-          <a:noFill/>
-        </p:spPr>
-        <p:txBody>
-          <a:bodyPr wrap="square" anchor="ctr" lIns="0" rIns="0" tIns="0" bIns="0">
-            <a:spAutoFit/>
-          </a:bodyPr>
-          <a:lstStyle/>
-          <a:p>
-            <a:pPr algn="r">
-              <a:lnSpc>
-                <a:spcPct val="106000"/>
-              </a:lnSpc>
-              <a:spcBef>
-                <a:spcPts val="0"/>
-              </a:spcBef>
-              <a:spcAft>
-                <a:spcPts val="0"/>
-              </a:spcAft>
-            </a:pPr>
-            <a:r>
-              <a:rPr sz="1250" b="1" i="0">
-                <a:solidFill>
-                  <a:srgbClr val="2B3038"/>
-                </a:solidFill>
-                <a:latin typeface="Calibri"/>
-              </a:rPr>
-              <a:t>Vistalba</a:t>
-            </a:r>
-          </a:p>
-        </p:txBody>
-      </p:sp>
-      <p:sp>
-        <p:nvSpPr>
-          <p:cNvPr id="16" name="Rounded Rectangle 15"/>
-          <p:cNvSpPr/>
-          <p:nvPr/>
-        </p:nvSpPr>
-        <p:spPr>
-          <a:xfrm>
-            <a:off x="2880360" y="2753627"/>
-            <a:ext cx="4878977" cy="216888"/>
-          </a:xfrm>
-          <a:prstGeom prst="roundRect">
-            <a:avLst>
-              <a:gd name="adj" fmla="val 35000"/>
-            </a:avLst>
-          </a:prstGeom>
-          <a:solidFill>
-            <a:srgbClr val="5A8F6B"/>
-          </a:solidFill>
-          <a:ln>
-            <a:noFill/>
-          </a:ln>
-          <a:effectLst/>
-        </p:spPr>
-        <p:style>
-          <a:lnRef idx="1">
-            <a:schemeClr val="accent1"/>
-          </a:lnRef>
-          <a:fillRef idx="3">
-            <a:schemeClr val="accent1"/>
-          </a:fillRef>
-          <a:effectRef idx="2">
-            <a:schemeClr val="accent1"/>
-          </a:effectRef>
-          <a:fontRef idx="minor">
-            <a:schemeClr val="lt1"/>
-          </a:fontRef>
-        </p:style>
-        <p:txBody>
-          <a:bodyPr rtlCol="0" anchor="ctr"/>
-          <a:lstStyle/>
-          <a:p>
-            <a:pPr algn="ctr"/>
-          </a:p>
-        </p:txBody>
-      </p:sp>
-      <p:sp>
-        <p:nvSpPr>
-          <p:cNvPr id="17" name="TextBox 16"/>
-          <p:cNvSpPr txBox="1"/>
-          <p:nvPr/>
-        </p:nvSpPr>
-        <p:spPr>
-          <a:xfrm>
-            <a:off x="7832489" y="2738627"/>
-            <a:ext cx="822960" cy="246888"/>
-          </a:xfrm>
-          <a:prstGeom prst="rect">
-            <a:avLst/>
-          </a:prstGeom>
-          <a:noFill/>
-        </p:spPr>
-        <p:txBody>
-          <a:bodyPr wrap="square" anchor="ctr" lIns="0" rIns="0" tIns="0" bIns="0">
-            <a:spAutoFit/>
-          </a:bodyPr>
-          <a:lstStyle/>
-          <a:p>
-            <a:pPr algn="l">
-              <a:lnSpc>
-                <a:spcPct val="106000"/>
-              </a:lnSpc>
-              <a:spcBef>
-                <a:spcPts val="0"/>
-              </a:spcBef>
-              <a:spcAft>
-                <a:spcPts val="0"/>
-              </a:spcAft>
-            </a:pPr>
-            <a:r>
-              <a:rPr sz="1250" b="1" i="0">
-                <a:solidFill>
-                  <a:srgbClr val="5A8F6B"/>
-                </a:solidFill>
-                <a:latin typeface="Calibri"/>
-              </a:rPr>
-              <a:t>4.5</a:t>
-            </a:r>
-          </a:p>
-        </p:txBody>
-      </p:sp>
-      <p:sp>
-        <p:nvSpPr>
-          <p:cNvPr id="18" name="TextBox 17"/>
-          <p:cNvSpPr txBox="1"/>
-          <p:nvPr/>
-        </p:nvSpPr>
-        <p:spPr>
-          <a:xfrm>
-            <a:off x="685800" y="3026663"/>
-            <a:ext cx="2103120" cy="246888"/>
-          </a:xfrm>
-          <a:prstGeom prst="rect">
-            <a:avLst/>
-          </a:prstGeom>
-          <a:noFill/>
-        </p:spPr>
-        <p:txBody>
-          <a:bodyPr wrap="square" anchor="ctr" lIns="0" rIns="0" tIns="0" bIns="0">
-            <a:spAutoFit/>
-          </a:bodyPr>
-          <a:lstStyle/>
-          <a:p>
-            <a:pPr algn="r">
-              <a:lnSpc>
-                <a:spcPct val="106000"/>
-              </a:lnSpc>
-              <a:spcBef>
-                <a:spcPts val="0"/>
-              </a:spcBef>
-              <a:spcAft>
-                <a:spcPts val="0"/>
-              </a:spcAft>
-            </a:pPr>
-            <a:r>
-              <a:rPr sz="1250" b="1" i="0">
-                <a:solidFill>
-                  <a:srgbClr val="2B3038"/>
-                </a:solidFill>
-                <a:latin typeface="Calibri"/>
-              </a:rPr>
-              <a:t>Chacras de Coria</a:t>
-            </a:r>
-          </a:p>
-        </p:txBody>
-      </p:sp>
-      <p:sp>
-        <p:nvSpPr>
-          <p:cNvPr id="19" name="Rounded Rectangle 18"/>
-          <p:cNvSpPr/>
-          <p:nvPr/>
-        </p:nvSpPr>
-        <p:spPr>
-          <a:xfrm>
-            <a:off x="2880360" y="3041663"/>
-            <a:ext cx="4336868" cy="216888"/>
-          </a:xfrm>
-          <a:prstGeom prst="roundRect">
-            <a:avLst>
-              <a:gd name="adj" fmla="val 35000"/>
-            </a:avLst>
-          </a:prstGeom>
-          <a:solidFill>
-            <a:srgbClr val="5A8F6B"/>
-          </a:solidFill>
-          <a:ln>
-            <a:noFill/>
-          </a:ln>
-          <a:effectLst/>
-        </p:spPr>
-        <p:style>
-          <a:lnRef idx="1">
-            <a:schemeClr val="accent1"/>
-          </a:lnRef>
-          <a:fillRef idx="3">
-            <a:schemeClr val="accent1"/>
-          </a:fillRef>
-          <a:effectRef idx="2">
-            <a:schemeClr val="accent1"/>
-          </a:effectRef>
-          <a:fontRef idx="minor">
-            <a:schemeClr val="lt1"/>
-          </a:fontRef>
-        </p:style>
-        <p:txBody>
-          <a:bodyPr rtlCol="0" anchor="ctr"/>
-          <a:lstStyle/>
-          <a:p>
-            <a:pPr algn="ctr"/>
-          </a:p>
-        </p:txBody>
-      </p:sp>
-      <p:sp>
-        <p:nvSpPr>
-          <p:cNvPr id="20" name="TextBox 19"/>
-          <p:cNvSpPr txBox="1"/>
-          <p:nvPr/>
-        </p:nvSpPr>
-        <p:spPr>
-          <a:xfrm>
-            <a:off x="7290380" y="3026663"/>
-            <a:ext cx="822960" cy="246888"/>
-          </a:xfrm>
-          <a:prstGeom prst="rect">
-            <a:avLst/>
-          </a:prstGeom>
-          <a:noFill/>
-        </p:spPr>
-        <p:txBody>
-          <a:bodyPr wrap="square" anchor="ctr" lIns="0" rIns="0" tIns="0" bIns="0">
-            <a:spAutoFit/>
-          </a:bodyPr>
-          <a:lstStyle/>
-          <a:p>
-            <a:pPr algn="l">
-              <a:lnSpc>
-                <a:spcPct val="106000"/>
-              </a:lnSpc>
-              <a:spcBef>
-                <a:spcPts val="0"/>
-              </a:spcBef>
-              <a:spcAft>
-                <a:spcPts val="0"/>
-              </a:spcAft>
-            </a:pPr>
-            <a:r>
-              <a:rPr sz="1250" b="1" i="0">
-                <a:solidFill>
-                  <a:srgbClr val="5A8F6B"/>
-                </a:solidFill>
-                <a:latin typeface="Calibri"/>
-              </a:rPr>
-              <a:t>4</a:t>
-            </a:r>
-          </a:p>
-        </p:txBody>
-      </p:sp>
-      <p:sp>
-        <p:nvSpPr>
-          <p:cNvPr id="21" name="TextBox 20"/>
-          <p:cNvSpPr txBox="1"/>
-          <p:nvPr/>
-        </p:nvSpPr>
-        <p:spPr>
-          <a:xfrm>
-            <a:off x="685800" y="3314699"/>
-            <a:ext cx="2103120" cy="246888"/>
-          </a:xfrm>
-          <a:prstGeom prst="rect">
-            <a:avLst/>
-          </a:prstGeom>
-          <a:noFill/>
-        </p:spPr>
-        <p:txBody>
-          <a:bodyPr wrap="square" anchor="ctr" lIns="0" rIns="0" tIns="0" bIns="0">
-            <a:spAutoFit/>
-          </a:bodyPr>
-          <a:lstStyle/>
-          <a:p>
-            <a:pPr algn="r">
-              <a:lnSpc>
-                <a:spcPct val="106000"/>
-              </a:lnSpc>
-              <a:spcBef>
-                <a:spcPts val="0"/>
-              </a:spcBef>
-              <a:spcAft>
-                <a:spcPts val="0"/>
-              </a:spcAft>
-            </a:pPr>
-            <a:r>
-              <a:rPr sz="1250" b="1" i="0">
-                <a:solidFill>
-                  <a:srgbClr val="2B3038"/>
-                </a:solidFill>
-                <a:latin typeface="Calibri"/>
-              </a:rPr>
-              <a:t>Carrodilla</a:t>
-            </a:r>
-          </a:p>
-        </p:txBody>
-      </p:sp>
-      <p:sp>
-        <p:nvSpPr>
-          <p:cNvPr id="22" name="Rounded Rectangle 21"/>
-          <p:cNvSpPr/>
-          <p:nvPr/>
-        </p:nvSpPr>
-        <p:spPr>
-          <a:xfrm>
-            <a:off x="2880360" y="3329699"/>
-            <a:ext cx="3794760" cy="216888"/>
-          </a:xfrm>
-          <a:prstGeom prst="roundRect">
-            <a:avLst>
-              <a:gd name="adj" fmla="val 35000"/>
-            </a:avLst>
-          </a:prstGeom>
-          <a:solidFill>
-            <a:srgbClr val="B8860B"/>
-          </a:solidFill>
-          <a:ln>
-            <a:noFill/>
-          </a:ln>
-          <a:effectLst/>
-        </p:spPr>
-        <p:style>
-          <a:lnRef idx="1">
-            <a:schemeClr val="accent1"/>
-          </a:lnRef>
-          <a:fillRef idx="3">
-            <a:schemeClr val="accent1"/>
-          </a:fillRef>
-          <a:effectRef idx="2">
-            <a:schemeClr val="accent1"/>
-          </a:effectRef>
-          <a:fontRef idx="minor">
-            <a:schemeClr val="lt1"/>
-          </a:fontRef>
-        </p:style>
-        <p:txBody>
-          <a:bodyPr rtlCol="0" anchor="ctr"/>
-          <a:lstStyle/>
-          <a:p>
-            <a:pPr algn="ctr"/>
-          </a:p>
-        </p:txBody>
-      </p:sp>
-      <p:sp>
-        <p:nvSpPr>
-          <p:cNvPr id="23" name="TextBox 22"/>
-          <p:cNvSpPr txBox="1"/>
-          <p:nvPr/>
-        </p:nvSpPr>
-        <p:spPr>
-          <a:xfrm>
-            <a:off x="6748272" y="3314699"/>
-            <a:ext cx="822960" cy="246888"/>
-          </a:xfrm>
-          <a:prstGeom prst="rect">
-            <a:avLst/>
-          </a:prstGeom>
-          <a:noFill/>
-        </p:spPr>
-        <p:txBody>
-          <a:bodyPr wrap="square" anchor="ctr" lIns="0" rIns="0" tIns="0" bIns="0">
-            <a:spAutoFit/>
-          </a:bodyPr>
-          <a:lstStyle/>
-          <a:p>
-            <a:pPr algn="l">
-              <a:lnSpc>
-                <a:spcPct val="106000"/>
-              </a:lnSpc>
-              <a:spcBef>
-                <a:spcPts val="0"/>
-              </a:spcBef>
-              <a:spcAft>
-                <a:spcPts val="0"/>
-              </a:spcAft>
-            </a:pPr>
-            <a:r>
-              <a:rPr sz="1250" b="1" i="0">
-                <a:solidFill>
-                  <a:srgbClr val="B8860B"/>
-                </a:solidFill>
-                <a:latin typeface="Calibri"/>
-              </a:rPr>
-              <a:t>3.5</a:t>
-            </a:r>
-          </a:p>
-        </p:txBody>
-      </p:sp>
-      <p:sp>
-        <p:nvSpPr>
-          <p:cNvPr id="24" name="TextBox 23"/>
-          <p:cNvSpPr txBox="1"/>
-          <p:nvPr/>
-        </p:nvSpPr>
-        <p:spPr>
-          <a:xfrm>
-            <a:off x="685800" y="3602735"/>
-            <a:ext cx="2103120" cy="246888"/>
-          </a:xfrm>
-          <a:prstGeom prst="rect">
-            <a:avLst/>
-          </a:prstGeom>
-          <a:noFill/>
-        </p:spPr>
-        <p:txBody>
-          <a:bodyPr wrap="square" anchor="ctr" lIns="0" rIns="0" tIns="0" bIns="0">
-            <a:spAutoFit/>
-          </a:bodyPr>
-          <a:lstStyle/>
-          <a:p>
-            <a:pPr algn="r">
-              <a:lnSpc>
-                <a:spcPct val="106000"/>
-              </a:lnSpc>
-              <a:spcBef>
-                <a:spcPts val="0"/>
-              </a:spcBef>
-              <a:spcAft>
-                <a:spcPts val="0"/>
-              </a:spcAft>
-            </a:pPr>
-            <a:r>
-              <a:rPr sz="1250" b="1" i="0">
-                <a:solidFill>
-                  <a:srgbClr val="2B3038"/>
-                </a:solidFill>
-                <a:latin typeface="Calibri"/>
-              </a:rPr>
-              <a:t>Agrelo</a:t>
-            </a:r>
-          </a:p>
-        </p:txBody>
-      </p:sp>
-      <p:sp>
-        <p:nvSpPr>
-          <p:cNvPr id="25" name="Rounded Rectangle 24"/>
-          <p:cNvSpPr/>
-          <p:nvPr/>
-        </p:nvSpPr>
-        <p:spPr>
-          <a:xfrm>
-            <a:off x="2880360" y="3617735"/>
-            <a:ext cx="3794760" cy="216888"/>
-          </a:xfrm>
-          <a:prstGeom prst="roundRect">
-            <a:avLst>
-              <a:gd name="adj" fmla="val 35000"/>
-            </a:avLst>
-          </a:prstGeom>
-          <a:solidFill>
-            <a:srgbClr val="B8860B"/>
-          </a:solidFill>
-          <a:ln>
-            <a:noFill/>
-          </a:ln>
-          <a:effectLst/>
-        </p:spPr>
-        <p:style>
-          <a:lnRef idx="1">
-            <a:schemeClr val="accent1"/>
-          </a:lnRef>
-          <a:fillRef idx="3">
-            <a:schemeClr val="accent1"/>
-          </a:fillRef>
-          <a:effectRef idx="2">
-            <a:schemeClr val="accent1"/>
-          </a:effectRef>
-          <a:fontRef idx="minor">
-            <a:schemeClr val="lt1"/>
-          </a:fontRef>
-        </p:style>
-        <p:txBody>
-          <a:bodyPr rtlCol="0" anchor="ctr"/>
-          <a:lstStyle/>
-          <a:p>
-            <a:pPr algn="ctr"/>
-          </a:p>
-        </p:txBody>
-      </p:sp>
-      <p:sp>
-        <p:nvSpPr>
-          <p:cNvPr id="26" name="TextBox 25"/>
-          <p:cNvSpPr txBox="1"/>
-          <p:nvPr/>
-        </p:nvSpPr>
-        <p:spPr>
-          <a:xfrm>
-            <a:off x="6748272" y="3602735"/>
-            <a:ext cx="822960" cy="246888"/>
-          </a:xfrm>
-          <a:prstGeom prst="rect">
-            <a:avLst/>
-          </a:prstGeom>
-          <a:noFill/>
-        </p:spPr>
-        <p:txBody>
-          <a:bodyPr wrap="square" anchor="ctr" lIns="0" rIns="0" tIns="0" bIns="0">
-            <a:spAutoFit/>
-          </a:bodyPr>
-          <a:lstStyle/>
-          <a:p>
-            <a:pPr algn="l">
-              <a:lnSpc>
-                <a:spcPct val="106000"/>
-              </a:lnSpc>
-              <a:spcBef>
-                <a:spcPts val="0"/>
-              </a:spcBef>
-              <a:spcAft>
-                <a:spcPts val="0"/>
-              </a:spcAft>
-            </a:pPr>
-            <a:r>
-              <a:rPr sz="1250" b="1" i="0">
-                <a:solidFill>
-                  <a:srgbClr val="B8860B"/>
-                </a:solidFill>
-                <a:latin typeface="Calibri"/>
-              </a:rPr>
-              <a:t>3.5</a:t>
-            </a:r>
-          </a:p>
-        </p:txBody>
-      </p:sp>
-      <p:sp>
-        <p:nvSpPr>
-          <p:cNvPr id="27" name="TextBox 26"/>
-          <p:cNvSpPr txBox="1"/>
-          <p:nvPr/>
-        </p:nvSpPr>
-        <p:spPr>
-          <a:xfrm>
-            <a:off x="685800" y="3890771"/>
-            <a:ext cx="2103120" cy="246888"/>
-          </a:xfrm>
-          <a:prstGeom prst="rect">
-            <a:avLst/>
-          </a:prstGeom>
-          <a:noFill/>
-        </p:spPr>
-        <p:txBody>
-          <a:bodyPr wrap="square" anchor="ctr" lIns="0" rIns="0" tIns="0" bIns="0">
-            <a:spAutoFit/>
-          </a:bodyPr>
-          <a:lstStyle/>
-          <a:p>
-            <a:pPr algn="r">
-              <a:lnSpc>
-                <a:spcPct val="106000"/>
-              </a:lnSpc>
-              <a:spcBef>
-                <a:spcPts val="0"/>
-              </a:spcBef>
-              <a:spcAft>
-                <a:spcPts val="0"/>
-              </a:spcAft>
-            </a:pPr>
-            <a:r>
-              <a:rPr sz="1250" b="1" i="0">
-                <a:solidFill>
-                  <a:srgbClr val="2B3038"/>
-                </a:solidFill>
-                <a:latin typeface="Calibri"/>
-              </a:rPr>
-              <a:t>Ugarteche</a:t>
-            </a:r>
-          </a:p>
-        </p:txBody>
-      </p:sp>
-      <p:sp>
-        <p:nvSpPr>
-          <p:cNvPr id="28" name="Rounded Rectangle 27"/>
-          <p:cNvSpPr/>
-          <p:nvPr/>
-        </p:nvSpPr>
-        <p:spPr>
-          <a:xfrm>
-            <a:off x="2880360" y="3905771"/>
-            <a:ext cx="3794760" cy="216888"/>
-          </a:xfrm>
-          <a:prstGeom prst="roundRect">
-            <a:avLst>
-              <a:gd name="adj" fmla="val 35000"/>
-            </a:avLst>
-          </a:prstGeom>
-          <a:solidFill>
-            <a:srgbClr val="B8860B"/>
-          </a:solidFill>
-          <a:ln>
-            <a:noFill/>
-          </a:ln>
-          <a:effectLst/>
-        </p:spPr>
-        <p:style>
-          <a:lnRef idx="1">
-            <a:schemeClr val="accent1"/>
-          </a:lnRef>
-          <a:fillRef idx="3">
-            <a:schemeClr val="accent1"/>
-          </a:fillRef>
-          <a:effectRef idx="2">
-            <a:schemeClr val="accent1"/>
-          </a:effectRef>
-          <a:fontRef idx="minor">
-            <a:schemeClr val="lt1"/>
-          </a:fontRef>
-        </p:style>
-        <p:txBody>
-          <a:bodyPr rtlCol="0" anchor="ctr"/>
-          <a:lstStyle/>
-          <a:p>
-            <a:pPr algn="ctr"/>
-          </a:p>
-        </p:txBody>
-      </p:sp>
-      <p:sp>
-        <p:nvSpPr>
-          <p:cNvPr id="29" name="TextBox 28"/>
-          <p:cNvSpPr txBox="1"/>
-          <p:nvPr/>
-        </p:nvSpPr>
-        <p:spPr>
-          <a:xfrm>
-            <a:off x="6748272" y="3890771"/>
-            <a:ext cx="822960" cy="246888"/>
-          </a:xfrm>
-          <a:prstGeom prst="rect">
-            <a:avLst/>
-          </a:prstGeom>
-          <a:noFill/>
-        </p:spPr>
-        <p:txBody>
-          <a:bodyPr wrap="square" anchor="ctr" lIns="0" rIns="0" tIns="0" bIns="0">
-            <a:spAutoFit/>
-          </a:bodyPr>
-          <a:lstStyle/>
-          <a:p>
-            <a:pPr algn="l">
-              <a:lnSpc>
-                <a:spcPct val="106000"/>
-              </a:lnSpc>
-              <a:spcBef>
-                <a:spcPts val="0"/>
-              </a:spcBef>
-              <a:spcAft>
-                <a:spcPts val="0"/>
-              </a:spcAft>
-            </a:pPr>
-            <a:r>
-              <a:rPr sz="1250" b="1" i="0">
-                <a:solidFill>
-                  <a:srgbClr val="B8860B"/>
-                </a:solidFill>
-                <a:latin typeface="Calibri"/>
-              </a:rPr>
-              <a:t>3.5</a:t>
-            </a:r>
-          </a:p>
-        </p:txBody>
-      </p:sp>
-      <p:sp>
-        <p:nvSpPr>
-          <p:cNvPr id="30" name="TextBox 29"/>
-          <p:cNvSpPr txBox="1"/>
-          <p:nvPr/>
-        </p:nvSpPr>
-        <p:spPr>
-          <a:xfrm>
-            <a:off x="685800" y="4178807"/>
-            <a:ext cx="2103120" cy="246888"/>
-          </a:xfrm>
-          <a:prstGeom prst="rect">
-            <a:avLst/>
-          </a:prstGeom>
-          <a:noFill/>
-        </p:spPr>
-        <p:txBody>
-          <a:bodyPr wrap="square" anchor="ctr" lIns="0" rIns="0" tIns="0" bIns="0">
-            <a:spAutoFit/>
-          </a:bodyPr>
-          <a:lstStyle/>
-          <a:p>
-            <a:pPr algn="r">
-              <a:lnSpc>
-                <a:spcPct val="106000"/>
-              </a:lnSpc>
-              <a:spcBef>
-                <a:spcPts val="0"/>
-              </a:spcBef>
-              <a:spcAft>
-                <a:spcPts val="0"/>
-              </a:spcAft>
-            </a:pPr>
-            <a:r>
-              <a:rPr sz="1250" b="1" i="0">
-                <a:solidFill>
-                  <a:srgbClr val="2B3038"/>
-                </a:solidFill>
-                <a:latin typeface="Calibri"/>
-              </a:rPr>
-              <a:t>Las Compuertas</a:t>
-            </a:r>
-          </a:p>
-        </p:txBody>
-      </p:sp>
-      <p:sp>
-        <p:nvSpPr>
-          <p:cNvPr id="31" name="Rounded Rectangle 30"/>
-          <p:cNvSpPr/>
-          <p:nvPr/>
-        </p:nvSpPr>
-        <p:spPr>
-          <a:xfrm>
-            <a:off x="2880360" y="4193807"/>
-            <a:ext cx="3252651" cy="216888"/>
-          </a:xfrm>
-          <a:prstGeom prst="roundRect">
-            <a:avLst>
-              <a:gd name="adj" fmla="val 35000"/>
-            </a:avLst>
-          </a:prstGeom>
-          <a:solidFill>
-            <a:srgbClr val="B8860B"/>
-          </a:solidFill>
-          <a:ln>
-            <a:noFill/>
-          </a:ln>
-          <a:effectLst/>
-        </p:spPr>
-        <p:style>
-          <a:lnRef idx="1">
-            <a:schemeClr val="accent1"/>
-          </a:lnRef>
-          <a:fillRef idx="3">
-            <a:schemeClr val="accent1"/>
-          </a:fillRef>
-          <a:effectRef idx="2">
-            <a:schemeClr val="accent1"/>
-          </a:effectRef>
-          <a:fontRef idx="minor">
-            <a:schemeClr val="lt1"/>
-          </a:fontRef>
-        </p:style>
-        <p:txBody>
-          <a:bodyPr rtlCol="0" anchor="ctr"/>
-          <a:lstStyle/>
-          <a:p>
-            <a:pPr algn="ctr"/>
-          </a:p>
-        </p:txBody>
-      </p:sp>
-      <p:sp>
-        <p:nvSpPr>
-          <p:cNvPr id="32" name="TextBox 31"/>
-          <p:cNvSpPr txBox="1"/>
-          <p:nvPr/>
-        </p:nvSpPr>
-        <p:spPr>
-          <a:xfrm>
-            <a:off x="6206163" y="4178807"/>
-            <a:ext cx="822960" cy="246888"/>
-          </a:xfrm>
-          <a:prstGeom prst="rect">
-            <a:avLst/>
-          </a:prstGeom>
-          <a:noFill/>
-        </p:spPr>
-        <p:txBody>
-          <a:bodyPr wrap="square" anchor="ctr" lIns="0" rIns="0" tIns="0" bIns="0">
-            <a:spAutoFit/>
-          </a:bodyPr>
-          <a:lstStyle/>
-          <a:p>
-            <a:pPr algn="l">
-              <a:lnSpc>
-                <a:spcPct val="106000"/>
-              </a:lnSpc>
-              <a:spcBef>
-                <a:spcPts val="0"/>
-              </a:spcBef>
-              <a:spcAft>
-                <a:spcPts val="0"/>
-              </a:spcAft>
-            </a:pPr>
-            <a:r>
-              <a:rPr sz="1250" b="1" i="0">
-                <a:solidFill>
-                  <a:srgbClr val="B8860B"/>
-                </a:solidFill>
-                <a:latin typeface="Calibri"/>
-              </a:rPr>
-              <a:t>3</a:t>
-            </a:r>
-          </a:p>
-        </p:txBody>
-      </p:sp>
-      <p:sp>
-        <p:nvSpPr>
-          <p:cNvPr id="33" name="TextBox 32"/>
-          <p:cNvSpPr txBox="1"/>
-          <p:nvPr/>
-        </p:nvSpPr>
-        <p:spPr>
-          <a:xfrm>
-            <a:off x="685800" y="4466843"/>
-            <a:ext cx="2103120" cy="246888"/>
-          </a:xfrm>
-          <a:prstGeom prst="rect">
-            <a:avLst/>
-          </a:prstGeom>
-          <a:noFill/>
-        </p:spPr>
-        <p:txBody>
-          <a:bodyPr wrap="square" anchor="ctr" lIns="0" rIns="0" tIns="0" bIns="0">
-            <a:spAutoFit/>
-          </a:bodyPr>
-          <a:lstStyle/>
-          <a:p>
-            <a:pPr algn="r">
-              <a:lnSpc>
-                <a:spcPct val="106000"/>
-              </a:lnSpc>
-              <a:spcBef>
-                <a:spcPts val="0"/>
-              </a:spcBef>
-              <a:spcAft>
-                <a:spcPts val="0"/>
-              </a:spcAft>
-            </a:pPr>
-            <a:r>
-              <a:rPr sz="1250" b="1" i="0">
-                <a:solidFill>
-                  <a:srgbClr val="2B3038"/>
-                </a:solidFill>
-                <a:latin typeface="Calibri"/>
-              </a:rPr>
-              <a:t>Perdriel</a:t>
-            </a:r>
-          </a:p>
-        </p:txBody>
-      </p:sp>
-      <p:sp>
-        <p:nvSpPr>
-          <p:cNvPr id="34" name="Rounded Rectangle 33"/>
-          <p:cNvSpPr/>
-          <p:nvPr/>
-        </p:nvSpPr>
-        <p:spPr>
-          <a:xfrm>
-            <a:off x="2880360" y="4481843"/>
-            <a:ext cx="3252651" cy="216888"/>
-          </a:xfrm>
-          <a:prstGeom prst="roundRect">
-            <a:avLst>
-              <a:gd name="adj" fmla="val 35000"/>
-            </a:avLst>
-          </a:prstGeom>
-          <a:solidFill>
-            <a:srgbClr val="B8860B"/>
-          </a:solidFill>
-          <a:ln>
-            <a:noFill/>
-          </a:ln>
-          <a:effectLst/>
-        </p:spPr>
-        <p:style>
-          <a:lnRef idx="1">
-            <a:schemeClr val="accent1"/>
-          </a:lnRef>
-          <a:fillRef idx="3">
-            <a:schemeClr val="accent1"/>
-          </a:fillRef>
-          <a:effectRef idx="2">
-            <a:schemeClr val="accent1"/>
-          </a:effectRef>
-          <a:fontRef idx="minor">
-            <a:schemeClr val="lt1"/>
-          </a:fontRef>
-        </p:style>
-        <p:txBody>
-          <a:bodyPr rtlCol="0" anchor="ctr"/>
-          <a:lstStyle/>
-          <a:p>
-            <a:pPr algn="ctr"/>
-          </a:p>
-        </p:txBody>
-      </p:sp>
-      <p:sp>
-        <p:nvSpPr>
-          <p:cNvPr id="35" name="TextBox 34"/>
-          <p:cNvSpPr txBox="1"/>
-          <p:nvPr/>
-        </p:nvSpPr>
-        <p:spPr>
-          <a:xfrm>
-            <a:off x="6206163" y="4466843"/>
-            <a:ext cx="822960" cy="246888"/>
-          </a:xfrm>
-          <a:prstGeom prst="rect">
-            <a:avLst/>
-          </a:prstGeom>
-          <a:noFill/>
-        </p:spPr>
-        <p:txBody>
-          <a:bodyPr wrap="square" anchor="ctr" lIns="0" rIns="0" tIns="0" bIns="0">
-            <a:spAutoFit/>
-          </a:bodyPr>
-          <a:lstStyle/>
-          <a:p>
-            <a:pPr algn="l">
-              <a:lnSpc>
-                <a:spcPct val="106000"/>
-              </a:lnSpc>
-              <a:spcBef>
-                <a:spcPts val="0"/>
-              </a:spcBef>
-              <a:spcAft>
-                <a:spcPts val="0"/>
-              </a:spcAft>
-            </a:pPr>
-            <a:r>
-              <a:rPr sz="1250" b="1" i="0">
-                <a:solidFill>
-                  <a:srgbClr val="B8860B"/>
-                </a:solidFill>
-                <a:latin typeface="Calibri"/>
-              </a:rPr>
-              <a:t>3</a:t>
-            </a:r>
-          </a:p>
-        </p:txBody>
-      </p:sp>
-      <p:sp>
-        <p:nvSpPr>
-          <p:cNvPr id="36" name="TextBox 35"/>
-          <p:cNvSpPr txBox="1"/>
-          <p:nvPr/>
-        </p:nvSpPr>
-        <p:spPr>
-          <a:xfrm>
-            <a:off x="685800" y="4754879"/>
-            <a:ext cx="2103120" cy="246888"/>
-          </a:xfrm>
-          <a:prstGeom prst="rect">
-            <a:avLst/>
-          </a:prstGeom>
-          <a:noFill/>
-        </p:spPr>
-        <p:txBody>
-          <a:bodyPr wrap="square" anchor="ctr" lIns="0" rIns="0" tIns="0" bIns="0">
-            <a:spAutoFit/>
-          </a:bodyPr>
-          <a:lstStyle/>
-          <a:p>
-            <a:pPr algn="r">
-              <a:lnSpc>
-                <a:spcPct val="106000"/>
-              </a:lnSpc>
-              <a:spcBef>
-                <a:spcPts val="0"/>
-              </a:spcBef>
-              <a:spcAft>
-                <a:spcPts val="0"/>
-              </a:spcAft>
-            </a:pPr>
-            <a:r>
-              <a:rPr sz="1250" b="1" i="0">
-                <a:solidFill>
-                  <a:srgbClr val="2B3038"/>
-                </a:solidFill>
-                <a:latin typeface="Calibri"/>
-              </a:rPr>
-              <a:t>Potrerillos</a:t>
-            </a:r>
-          </a:p>
-        </p:txBody>
-      </p:sp>
-      <p:sp>
-        <p:nvSpPr>
-          <p:cNvPr id="37" name="Rounded Rectangle 36"/>
-          <p:cNvSpPr/>
-          <p:nvPr/>
-        </p:nvSpPr>
-        <p:spPr>
-          <a:xfrm>
-            <a:off x="2880360" y="4769879"/>
-            <a:ext cx="3252651" cy="216888"/>
-          </a:xfrm>
-          <a:prstGeom prst="roundRect">
-            <a:avLst>
-              <a:gd name="adj" fmla="val 35000"/>
-            </a:avLst>
-          </a:prstGeom>
-          <a:solidFill>
-            <a:srgbClr val="B8860B"/>
-          </a:solidFill>
-          <a:ln>
-            <a:noFill/>
-          </a:ln>
-          <a:effectLst/>
-        </p:spPr>
-        <p:style>
-          <a:lnRef idx="1">
-            <a:schemeClr val="accent1"/>
-          </a:lnRef>
-          <a:fillRef idx="3">
-            <a:schemeClr val="accent1"/>
-          </a:fillRef>
-          <a:effectRef idx="2">
-            <a:schemeClr val="accent1"/>
-          </a:effectRef>
-          <a:fontRef idx="minor">
-            <a:schemeClr val="lt1"/>
-          </a:fontRef>
-        </p:style>
-        <p:txBody>
-          <a:bodyPr rtlCol="0" anchor="ctr"/>
-          <a:lstStyle/>
-          <a:p>
-            <a:pPr algn="ctr"/>
-          </a:p>
-        </p:txBody>
-      </p:sp>
-      <p:sp>
-        <p:nvSpPr>
-          <p:cNvPr id="38" name="TextBox 37"/>
-          <p:cNvSpPr txBox="1"/>
-          <p:nvPr/>
-        </p:nvSpPr>
-        <p:spPr>
-          <a:xfrm>
-            <a:off x="6206163" y="4754879"/>
-            <a:ext cx="822960" cy="246888"/>
-          </a:xfrm>
-          <a:prstGeom prst="rect">
-            <a:avLst/>
-          </a:prstGeom>
-          <a:noFill/>
-        </p:spPr>
-        <p:txBody>
-          <a:bodyPr wrap="square" anchor="ctr" lIns="0" rIns="0" tIns="0" bIns="0">
-            <a:spAutoFit/>
-          </a:bodyPr>
-          <a:lstStyle/>
-          <a:p>
-            <a:pPr algn="l">
-              <a:lnSpc>
-                <a:spcPct val="106000"/>
-              </a:lnSpc>
-              <a:spcBef>
-                <a:spcPts val="0"/>
-              </a:spcBef>
-              <a:spcAft>
-                <a:spcPts val="0"/>
-              </a:spcAft>
-            </a:pPr>
-            <a:r>
-              <a:rPr sz="1250" b="1" i="0">
-                <a:solidFill>
-                  <a:srgbClr val="B8860B"/>
-                </a:solidFill>
-                <a:latin typeface="Calibri"/>
-              </a:rPr>
-              <a:t>3</a:t>
-            </a:r>
-          </a:p>
-        </p:txBody>
-      </p:sp>
-      <p:sp>
-        <p:nvSpPr>
-          <p:cNvPr id="39" name="TextBox 38"/>
-          <p:cNvSpPr txBox="1"/>
-          <p:nvPr/>
-        </p:nvSpPr>
-        <p:spPr>
-          <a:xfrm>
-            <a:off x="685800" y="5042915"/>
-            <a:ext cx="2103120" cy="246888"/>
-          </a:xfrm>
-          <a:prstGeom prst="rect">
-            <a:avLst/>
-          </a:prstGeom>
-          <a:noFill/>
-        </p:spPr>
-        <p:txBody>
-          <a:bodyPr wrap="square" anchor="ctr" lIns="0" rIns="0" tIns="0" bIns="0">
-            <a:spAutoFit/>
-          </a:bodyPr>
-          <a:lstStyle/>
-          <a:p>
-            <a:pPr algn="r">
-              <a:lnSpc>
-                <a:spcPct val="106000"/>
-              </a:lnSpc>
-              <a:spcBef>
-                <a:spcPts val="0"/>
-              </a:spcBef>
-              <a:spcAft>
-                <a:spcPts val="0"/>
-              </a:spcAft>
-            </a:pPr>
-            <a:r>
-              <a:rPr sz="1250" b="1" i="0">
-                <a:solidFill>
-                  <a:srgbClr val="2B3038"/>
-                </a:solidFill>
-                <a:latin typeface="Calibri"/>
-              </a:rPr>
-              <a:t>El Carrizal</a:t>
-            </a:r>
-          </a:p>
-        </p:txBody>
-      </p:sp>
-      <p:sp>
-        <p:nvSpPr>
-          <p:cNvPr id="40" name="Rounded Rectangle 39"/>
-          <p:cNvSpPr/>
-          <p:nvPr/>
-        </p:nvSpPr>
-        <p:spPr>
-          <a:xfrm>
-            <a:off x="2880360" y="5057915"/>
-            <a:ext cx="2710542" cy="216888"/>
-          </a:xfrm>
-          <a:prstGeom prst="roundRect">
-            <a:avLst>
-              <a:gd name="adj" fmla="val 35000"/>
-            </a:avLst>
-          </a:prstGeom>
-          <a:solidFill>
-            <a:srgbClr val="B8860B"/>
-          </a:solidFill>
-          <a:ln>
-            <a:noFill/>
-          </a:ln>
-          <a:effectLst/>
-        </p:spPr>
-        <p:style>
-          <a:lnRef idx="1">
-            <a:schemeClr val="accent1"/>
-          </a:lnRef>
-          <a:fillRef idx="3">
-            <a:schemeClr val="accent1"/>
-          </a:fillRef>
-          <a:effectRef idx="2">
-            <a:schemeClr val="accent1"/>
-          </a:effectRef>
-          <a:fontRef idx="minor">
-            <a:schemeClr val="lt1"/>
-          </a:fontRef>
-        </p:style>
-        <p:txBody>
-          <a:bodyPr rtlCol="0" anchor="ctr"/>
-          <a:lstStyle/>
-          <a:p>
-            <a:pPr algn="ctr"/>
-          </a:p>
-        </p:txBody>
-      </p:sp>
-      <p:sp>
-        <p:nvSpPr>
-          <p:cNvPr id="41" name="TextBox 40"/>
-          <p:cNvSpPr txBox="1"/>
-          <p:nvPr/>
-        </p:nvSpPr>
-        <p:spPr>
-          <a:xfrm>
-            <a:off x="5664054" y="5042915"/>
-            <a:ext cx="822960" cy="246888"/>
-          </a:xfrm>
-          <a:prstGeom prst="rect">
-            <a:avLst/>
-          </a:prstGeom>
-          <a:noFill/>
-        </p:spPr>
-        <p:txBody>
-          <a:bodyPr wrap="square" anchor="ctr" lIns="0" rIns="0" tIns="0" bIns="0">
-            <a:spAutoFit/>
-          </a:bodyPr>
-          <a:lstStyle/>
-          <a:p>
-            <a:pPr algn="l">
-              <a:lnSpc>
-                <a:spcPct val="106000"/>
-              </a:lnSpc>
-              <a:spcBef>
-                <a:spcPts val="0"/>
-              </a:spcBef>
-              <a:spcAft>
-                <a:spcPts val="0"/>
-              </a:spcAft>
-            </a:pPr>
-            <a:r>
-              <a:rPr sz="1250" b="1" i="0">
-                <a:solidFill>
-                  <a:srgbClr val="B8860B"/>
-                </a:solidFill>
-                <a:latin typeface="Calibri"/>
-              </a:rPr>
-              <a:t>2.5</a:t>
-            </a:r>
-          </a:p>
-        </p:txBody>
-      </p:sp>
-      <p:sp>
-        <p:nvSpPr>
-          <p:cNvPr id="42" name="TextBox 41"/>
-          <p:cNvSpPr txBox="1"/>
-          <p:nvPr/>
-        </p:nvSpPr>
-        <p:spPr>
-          <a:xfrm>
-            <a:off x="685800" y="5330951"/>
-            <a:ext cx="2103120" cy="246888"/>
-          </a:xfrm>
-          <a:prstGeom prst="rect">
-            <a:avLst/>
-          </a:prstGeom>
-          <a:noFill/>
-        </p:spPr>
-        <p:txBody>
-          <a:bodyPr wrap="square" anchor="ctr" lIns="0" rIns="0" tIns="0" bIns="0">
-            <a:spAutoFit/>
-          </a:bodyPr>
-          <a:lstStyle/>
-          <a:p>
-            <a:pPr algn="r">
-              <a:lnSpc>
-                <a:spcPct val="106000"/>
-              </a:lnSpc>
-              <a:spcBef>
-                <a:spcPts val="0"/>
-              </a:spcBef>
-              <a:spcAft>
-                <a:spcPts val="0"/>
-              </a:spcAft>
-            </a:pPr>
-            <a:r>
-              <a:rPr sz="1250" b="1" i="0">
-                <a:solidFill>
-                  <a:srgbClr val="2B3038"/>
-                </a:solidFill>
-                <a:latin typeface="Calibri"/>
-              </a:rPr>
-              <a:t>Cacheuta</a:t>
-            </a:r>
-          </a:p>
-        </p:txBody>
-      </p:sp>
-      <p:sp>
-        <p:nvSpPr>
-          <p:cNvPr id="43" name="Rounded Rectangle 42"/>
-          <p:cNvSpPr/>
-          <p:nvPr/>
-        </p:nvSpPr>
-        <p:spPr>
-          <a:xfrm>
-            <a:off x="2880360" y="5345951"/>
-            <a:ext cx="2168434" cy="216888"/>
-          </a:xfrm>
-          <a:prstGeom prst="roundRect">
-            <a:avLst>
-              <a:gd name="adj" fmla="val 35000"/>
-            </a:avLst>
-          </a:prstGeom>
-          <a:solidFill>
-            <a:srgbClr val="B1456A"/>
-          </a:solidFill>
-          <a:ln>
-            <a:noFill/>
-          </a:ln>
-          <a:effectLst/>
-        </p:spPr>
-        <p:style>
-          <a:lnRef idx="1">
-            <a:schemeClr val="accent1"/>
-          </a:lnRef>
-          <a:fillRef idx="3">
-            <a:schemeClr val="accent1"/>
-          </a:fillRef>
-          <a:effectRef idx="2">
-            <a:schemeClr val="accent1"/>
-          </a:effectRef>
-          <a:fontRef idx="minor">
-            <a:schemeClr val="lt1"/>
-          </a:fontRef>
-        </p:style>
-        <p:txBody>
-          <a:bodyPr rtlCol="0" anchor="ctr"/>
-          <a:lstStyle/>
-          <a:p>
-            <a:pPr algn="ctr"/>
-          </a:p>
-        </p:txBody>
-      </p:sp>
-      <p:sp>
-        <p:nvSpPr>
-          <p:cNvPr id="44" name="TextBox 43"/>
-          <p:cNvSpPr txBox="1"/>
-          <p:nvPr/>
-        </p:nvSpPr>
-        <p:spPr>
-          <a:xfrm>
-            <a:off x="5121946" y="5330951"/>
-            <a:ext cx="822960" cy="246888"/>
-          </a:xfrm>
-          <a:prstGeom prst="rect">
-            <a:avLst/>
-          </a:prstGeom>
-          <a:noFill/>
-        </p:spPr>
-        <p:txBody>
-          <a:bodyPr wrap="square" anchor="ctr" lIns="0" rIns="0" tIns="0" bIns="0">
-            <a:spAutoFit/>
-          </a:bodyPr>
-          <a:lstStyle/>
-          <a:p>
-            <a:pPr algn="l">
-              <a:lnSpc>
-                <a:spcPct val="106000"/>
-              </a:lnSpc>
-              <a:spcBef>
-                <a:spcPts val="0"/>
-              </a:spcBef>
-              <a:spcAft>
-                <a:spcPts val="0"/>
-              </a:spcAft>
-            </a:pPr>
-            <a:r>
-              <a:rPr sz="1250" b="1" i="0">
-                <a:solidFill>
-                  <a:srgbClr val="B1456A"/>
-                </a:solidFill>
-                <a:latin typeface="Calibri"/>
-              </a:rPr>
-              <a:t>2</a:t>
-            </a:r>
-          </a:p>
-        </p:txBody>
-      </p:sp>
-      <p:sp>
-        <p:nvSpPr>
-          <p:cNvPr id="45" name="TextBox 44"/>
-          <p:cNvSpPr txBox="1"/>
-          <p:nvPr/>
-        </p:nvSpPr>
-        <p:spPr>
-          <a:xfrm>
-            <a:off x="685800" y="5618987"/>
-            <a:ext cx="2103120" cy="246888"/>
-          </a:xfrm>
-          <a:prstGeom prst="rect">
-            <a:avLst/>
-          </a:prstGeom>
-          <a:noFill/>
-        </p:spPr>
-        <p:txBody>
-          <a:bodyPr wrap="square" anchor="ctr" lIns="0" rIns="0" tIns="0" bIns="0">
-            <a:spAutoFit/>
-          </a:bodyPr>
-          <a:lstStyle/>
-          <a:p>
-            <a:pPr algn="r">
-              <a:lnSpc>
-                <a:spcPct val="106000"/>
-              </a:lnSpc>
-              <a:spcBef>
-                <a:spcPts val="0"/>
-              </a:spcBef>
-              <a:spcAft>
-                <a:spcPts val="0"/>
-              </a:spcAft>
-            </a:pPr>
-            <a:r>
-              <a:rPr sz="1250" b="1" i="0">
-                <a:solidFill>
-                  <a:srgbClr val="2B3038"/>
-                </a:solidFill>
-                <a:latin typeface="Calibri"/>
-              </a:rPr>
-              <a:t>Vertientes de Pedemonte</a:t>
-            </a:r>
-          </a:p>
-        </p:txBody>
-      </p:sp>
-      <p:sp>
-        <p:nvSpPr>
-          <p:cNvPr id="46" name="Rounded Rectangle 45"/>
-          <p:cNvSpPr/>
-          <p:nvPr/>
-        </p:nvSpPr>
-        <p:spPr>
-          <a:xfrm>
-            <a:off x="2880360" y="5633987"/>
-            <a:ext cx="1626325" cy="216888"/>
-          </a:xfrm>
-          <a:prstGeom prst="roundRect">
-            <a:avLst>
-              <a:gd name="adj" fmla="val 35000"/>
-            </a:avLst>
-          </a:prstGeom>
-          <a:solidFill>
-            <a:srgbClr val="B1456A"/>
-          </a:solidFill>
-          <a:ln>
-            <a:noFill/>
-          </a:ln>
-          <a:effectLst/>
-        </p:spPr>
-        <p:style>
-          <a:lnRef idx="1">
-            <a:schemeClr val="accent1"/>
-          </a:lnRef>
-          <a:fillRef idx="3">
-            <a:schemeClr val="accent1"/>
-          </a:fillRef>
-          <a:effectRef idx="2">
-            <a:schemeClr val="accent1"/>
-          </a:effectRef>
-          <a:fontRef idx="minor">
-            <a:schemeClr val="lt1"/>
-          </a:fontRef>
-        </p:style>
-        <p:txBody>
-          <a:bodyPr rtlCol="0" anchor="ctr"/>
-          <a:lstStyle/>
-          <a:p>
-            <a:pPr algn="ctr"/>
-          </a:p>
-        </p:txBody>
-      </p:sp>
-      <p:sp>
-        <p:nvSpPr>
-          <p:cNvPr id="47" name="TextBox 46"/>
-          <p:cNvSpPr txBox="1"/>
-          <p:nvPr/>
-        </p:nvSpPr>
-        <p:spPr>
-          <a:xfrm>
-            <a:off x="4579837" y="5618987"/>
-            <a:ext cx="822960" cy="246888"/>
-          </a:xfrm>
-          <a:prstGeom prst="rect">
-            <a:avLst/>
-          </a:prstGeom>
-          <a:noFill/>
-        </p:spPr>
-        <p:txBody>
-          <a:bodyPr wrap="square" anchor="ctr" lIns="0" rIns="0" tIns="0" bIns="0">
-            <a:spAutoFit/>
-          </a:bodyPr>
-          <a:lstStyle/>
-          <a:p>
-            <a:pPr algn="l">
-              <a:lnSpc>
-                <a:spcPct val="106000"/>
-              </a:lnSpc>
-              <a:spcBef>
-                <a:spcPts val="0"/>
-              </a:spcBef>
-              <a:spcAft>
-                <a:spcPts val="0"/>
-              </a:spcAft>
-            </a:pPr>
-            <a:r>
-              <a:rPr sz="1250" b="1" i="0">
-                <a:solidFill>
-                  <a:srgbClr val="B1456A"/>
-                </a:solidFill>
-                <a:latin typeface="Calibri"/>
-              </a:rPr>
-              <a:t>1.5</a:t>
-            </a:r>
-          </a:p>
-        </p:txBody>
-      </p:sp>
-      <p:sp>
-        <p:nvSpPr>
-          <p:cNvPr id="48" name="TextBox 47"/>
-          <p:cNvSpPr txBox="1"/>
-          <p:nvPr/>
-        </p:nvSpPr>
-        <p:spPr>
-          <a:xfrm>
-            <a:off x="685800" y="5907023"/>
-            <a:ext cx="2103120" cy="246888"/>
-          </a:xfrm>
-          <a:prstGeom prst="rect">
-            <a:avLst/>
-          </a:prstGeom>
-          <a:noFill/>
-        </p:spPr>
-        <p:txBody>
-          <a:bodyPr wrap="square" anchor="ctr" lIns="0" rIns="0" tIns="0" bIns="0">
-            <a:spAutoFit/>
-          </a:bodyPr>
-          <a:lstStyle/>
-          <a:p>
-            <a:pPr algn="r">
-              <a:lnSpc>
-                <a:spcPct val="106000"/>
-              </a:lnSpc>
-              <a:spcBef>
-                <a:spcPts val="0"/>
-              </a:spcBef>
-              <a:spcAft>
-                <a:spcPts val="0"/>
-              </a:spcAft>
-            </a:pPr>
-            <a:r>
-              <a:rPr sz="1250" b="1" i="0">
-                <a:solidFill>
-                  <a:srgbClr val="2B3038"/>
-                </a:solidFill>
-                <a:latin typeface="Calibri"/>
-              </a:rPr>
-              <a:t>Industrial</a:t>
-            </a:r>
-          </a:p>
-        </p:txBody>
-      </p:sp>
-      <p:sp>
-        <p:nvSpPr>
-          <p:cNvPr id="49" name="Rounded Rectangle 48"/>
-          <p:cNvSpPr/>
-          <p:nvPr/>
-        </p:nvSpPr>
-        <p:spPr>
-          <a:xfrm>
-            <a:off x="2880360" y="5922023"/>
-            <a:ext cx="1084217" cy="216888"/>
-          </a:xfrm>
-          <a:prstGeom prst="roundRect">
-            <a:avLst>
-              <a:gd name="adj" fmla="val 35000"/>
-            </a:avLst>
-          </a:prstGeom>
-          <a:solidFill>
-            <a:srgbClr val="B1456A"/>
-          </a:solidFill>
-          <a:ln>
-            <a:noFill/>
-          </a:ln>
-          <a:effectLst/>
-        </p:spPr>
-        <p:style>
-          <a:lnRef idx="1">
-            <a:schemeClr val="accent1"/>
-          </a:lnRef>
-          <a:fillRef idx="3">
-            <a:schemeClr val="accent1"/>
-          </a:fillRef>
-          <a:effectRef idx="2">
-            <a:schemeClr val="accent1"/>
-          </a:effectRef>
-          <a:fontRef idx="minor">
-            <a:schemeClr val="lt1"/>
-          </a:fontRef>
-        </p:style>
-        <p:txBody>
-          <a:bodyPr rtlCol="0" anchor="ctr"/>
-          <a:lstStyle/>
-          <a:p>
-            <a:pPr algn="ctr"/>
-          </a:p>
-        </p:txBody>
-      </p:sp>
-      <p:sp>
-        <p:nvSpPr>
-          <p:cNvPr id="50" name="TextBox 49"/>
-          <p:cNvSpPr txBox="1"/>
-          <p:nvPr/>
-        </p:nvSpPr>
-        <p:spPr>
-          <a:xfrm>
-            <a:off x="4037729" y="5907023"/>
-            <a:ext cx="822960" cy="246888"/>
-          </a:xfrm>
-          <a:prstGeom prst="rect">
-            <a:avLst/>
-          </a:prstGeom>
-          <a:noFill/>
-        </p:spPr>
-        <p:txBody>
-          <a:bodyPr wrap="square" anchor="ctr" lIns="0" rIns="0" tIns="0" bIns="0">
-            <a:spAutoFit/>
-          </a:bodyPr>
-          <a:lstStyle/>
-          <a:p>
-            <a:pPr algn="l">
-              <a:lnSpc>
-                <a:spcPct val="106000"/>
-              </a:lnSpc>
-              <a:spcBef>
-                <a:spcPts val="0"/>
-              </a:spcBef>
-              <a:spcAft>
-                <a:spcPts val="0"/>
-              </a:spcAft>
-            </a:pPr>
-            <a:r>
-              <a:rPr sz="1250" b="1" i="0">
-                <a:solidFill>
-                  <a:srgbClr val="B1456A"/>
-                </a:solidFill>
-                <a:latin typeface="Calibri"/>
-              </a:rPr>
-              <a:t>1</a:t>
-            </a:r>
-          </a:p>
-        </p:txBody>
-      </p:sp>
-      <p:sp>
-        <p:nvSpPr>
-          <p:cNvPr id="51" name="Rectangle 50"/>
-          <p:cNvSpPr/>
-          <p:nvPr/>
-        </p:nvSpPr>
-        <p:spPr>
-          <a:xfrm>
-            <a:off x="10698480" y="1874519"/>
-            <a:ext cx="1280160" cy="4572000"/>
-          </a:xfrm>
-          <a:prstGeom prst="rect">
-            <a:avLst/>
-          </a:prstGeom>
-          <a:noFill/>
-          <a:ln>
-            <a:noFill/>
-          </a:ln>
-          <a:effectLst/>
-        </p:spPr>
-        <p:style>
-          <a:lnRef idx="1">
-            <a:schemeClr val="accent1"/>
-          </a:lnRef>
-          <a:fillRef idx="3">
-            <a:schemeClr val="accent1"/>
-          </a:fillRef>
-          <a:effectRef idx="2">
-            <a:schemeClr val="accent1"/>
-          </a:effectRef>
-          <a:fontRef idx="minor">
-            <a:schemeClr val="lt1"/>
-          </a:fontRef>
-        </p:style>
-        <p:txBody>
-          <a:bodyPr rtlCol="0" anchor="ctr"/>
-          <a:lstStyle/>
-          <a:p>
-            <a:pPr algn="ctr"/>
-          </a:p>
-        </p:txBody>
-      </p:sp>
-      <p:sp>
-        <p:nvSpPr>
-          <p:cNvPr id="52" name="Rounded Rectangle 51"/>
-          <p:cNvSpPr/>
-          <p:nvPr/>
-        </p:nvSpPr>
-        <p:spPr>
-          <a:xfrm>
-            <a:off x="10652760" y="1965960"/>
-            <a:ext cx="1325880" cy="1965960"/>
+            <a:off x="10561320" y="1965960"/>
+            <a:ext cx="1463040" cy="2148840"/>
           </a:xfrm>
           <a:prstGeom prst="roundRect">
             <a:avLst>
@@ -25153,14 +25111,125 @@
       </p:sp>
       <p:sp>
         <p:nvSpPr>
+          <p:cNvPr id="52" name="TextBox 51"/>
+          <p:cNvSpPr txBox="1"/>
+          <p:nvPr/>
+        </p:nvSpPr>
+        <p:spPr>
+          <a:xfrm>
+            <a:off x="10716768" y="2148840"/>
+            <a:ext cx="1234440" cy="1920240"/>
+          </a:xfrm>
+          <a:prstGeom prst="rect">
+            <a:avLst/>
+          </a:prstGeom>
+          <a:noFill/>
+        </p:spPr>
+        <p:txBody>
+          <a:bodyPr wrap="square" anchor="t" lIns="0" rIns="0" tIns="0" bIns="0">
+            <a:spAutoFit/>
+          </a:bodyPr>
+          <a:lstStyle/>
+          <a:p>
+            <a:pPr algn="l">
+              <a:lnSpc>
+                <a:spcPct val="115000"/>
+              </a:lnSpc>
+              <a:spcBef>
+                <a:spcPts val="0"/>
+              </a:spcBef>
+              <a:spcAft>
+                <a:spcPts val="800"/>
+              </a:spcAft>
+            </a:pPr>
+            <a:r>
+              <a:rPr sz="1150" b="1" i="0">
+                <a:solidFill>
+                  <a:srgbClr val="4E5869"/>
+                </a:solidFill>
+                <a:latin typeface="Calibri"/>
+              </a:rPr>
+              <a:t>n = puntaje ICD /11</a:t>
+            </a:r>
+          </a:p>
+          <a:p>
+            <a:pPr algn="l">
+              <a:lnSpc>
+                <a:spcPct val="115000"/>
+              </a:lnSpc>
+              <a:spcBef>
+                <a:spcPts val="0"/>
+              </a:spcBef>
+              <a:spcAft>
+                <a:spcPts val="800"/>
+              </a:spcAft>
+            </a:pPr>
+            <a:r>
+              <a:rPr sz="1200" b="1" i="0">
+                <a:solidFill>
+                  <a:srgbClr val="5A8F6B"/>
+                </a:solidFill>
+                <a:latin typeface="Calibri"/>
+              </a:rPr>
+              <a:t>≥5  lidera</a:t>
+            </a:r>
+          </a:p>
+          <a:p>
+            <a:pPr algn="l">
+              <a:lnSpc>
+                <a:spcPct val="115000"/>
+              </a:lnSpc>
+              <a:spcBef>
+                <a:spcPts val="0"/>
+              </a:spcBef>
+              <a:spcAft>
+                <a:spcPts val="800"/>
+              </a:spcAft>
+            </a:pPr>
+            <a:r>
+              <a:rPr sz="1200" b="1" i="0">
+                <a:solidFill>
+                  <a:srgbClr val="B8860B"/>
+                </a:solidFill>
+                <a:latin typeface="Calibri"/>
+              </a:rPr>
+              <a:t>3–4,5  medio</a:t>
+            </a:r>
+          </a:p>
+          <a:p>
+            <a:pPr algn="l">
+              <a:lnSpc>
+                <a:spcPct val="115000"/>
+              </a:lnSpc>
+              <a:spcBef>
+                <a:spcPts val="0"/>
+              </a:spcBef>
+              <a:spcAft>
+                <a:spcPts val="800"/>
+              </a:spcAft>
+            </a:pPr>
+            <a:r>
+              <a:rPr sz="1200" b="1" i="0">
+                <a:solidFill>
+                  <a:srgbClr val="B1456A"/>
+                </a:solidFill>
+                <a:latin typeface="Calibri"/>
+              </a:rPr>
+              <a:t>≤2,5  déficit</a:t>
+            </a:r>
+          </a:p>
+        </p:txBody>
+      </p:sp>
+      <p:sp>
+        <p:nvSpPr>
           <p:cNvPr id="53" name="TextBox 52"/>
           <p:cNvSpPr txBox="1"/>
           <p:nvPr/>
         </p:nvSpPr>
         <p:spPr>
           <a:xfrm>
-            <a:off x="10789920" y="2148840"/>
-            <a:ext cx="1097280" cy="1828800"/>
+            <a:off x="8686800" y="4480560"/>
+            <a:ext cx="3291840" cy="1828800"/>
           </a:xfrm>
           <a:prstGeom prst="rect">
             <a:avLst/>
@@ -25175,7 +25244,7 @@
           <a:p>
             <a:pPr algn="l">
               <a:lnSpc>
-                <a:spcPct val="110000"/>
+                <a:spcPct val="115000"/>
               </a:lnSpc>
               <a:spcBef>
                 <a:spcPts val="0"/>
@@ -25185,79 +25254,75 @@
               </a:spcAft>
             </a:pPr>
             <a:r>
-              <a:rPr sz="1200" b="1" i="0">
+              <a:rPr sz="1500" b="0" i="0">
+                <a:solidFill>
+                  <a:srgbClr val="2B3038"/>
+                </a:solidFill>
+                <a:latin typeface="Calibri"/>
+              </a:rPr>
+              <a:t>Barra = </a:t>
+            </a:r>
+            <a:r>
+              <a:rPr sz="1500" b="1" i="0">
+                <a:solidFill>
+                  <a:srgbClr val="B1456A"/>
+                </a:solidFill>
+                <a:latin typeface="Calibri"/>
+              </a:rPr>
+              <a:t>prioridad</a:t>
+            </a:r>
+            <a:r>
+              <a:rPr sz="1500" b="0" i="0">
+                <a:solidFill>
+                  <a:srgbClr val="2B3038"/>
+                </a:solidFill>
+                <a:latin typeface="Calibri"/>
+              </a:rPr>
+              <a:t> (mayor brecha, primero).</a:t>
+            </a:r>
+          </a:p>
+          <a:p>
+            <a:pPr algn="l">
+              <a:lnSpc>
+                <a:spcPct val="115000"/>
+              </a:lnSpc>
+              <a:spcBef>
+                <a:spcPts val="0"/>
+              </a:spcBef>
+              <a:spcAft>
+                <a:spcPts val="800"/>
+              </a:spcAft>
+            </a:pPr>
+            <a:r>
+              <a:rPr sz="600" b="0" i="0">
+                <a:solidFill>
+                  <a:srgbClr val="2B3038"/>
+                </a:solidFill>
+                <a:latin typeface="Calibri"/>
+              </a:rPr>
+              <a:t/>
+            </a:r>
+          </a:p>
+          <a:p>
+            <a:pPr algn="l">
+              <a:lnSpc>
+                <a:spcPct val="115000"/>
+              </a:lnSpc>
+              <a:spcBef>
+                <a:spcPts val="0"/>
+              </a:spcBef>
+              <a:spcAft>
+                <a:spcPts val="800"/>
+              </a:spcAft>
+            </a:pPr>
+            <a:r>
+              <a:rPr sz="1400" b="0" i="1">
                 <a:solidFill>
                   <a:srgbClr val="4E5869"/>
                 </a:solidFill>
                 <a:latin typeface="Calibri"/>
               </a:rPr>
-              <a:t>Puntaje /11</a:t>
-            </a:r>
-          </a:p>
-          <a:p>
-            <a:pPr algn="l">
-              <a:lnSpc>
-                <a:spcPct val="110000"/>
-              </a:lnSpc>
-              <a:spcBef>
-                <a:spcPts val="0"/>
-              </a:spcBef>
-              <a:spcAft>
-                <a:spcPts val="800"/>
-              </a:spcAft>
-            </a:pPr>
-            <a:r>
-              <a:rPr sz="1200" b="1" i="0">
-                <a:solidFill>
-                  <a:srgbClr val="5A8F6B"/>
-                </a:solidFill>
-                <a:latin typeface="Calibri"/>
-              </a:rPr>
-              <a:t>≥4  bien</a:t>
-            </a:r>
-          </a:p>
-          <a:p>
-            <a:pPr algn="l">
-              <a:lnSpc>
-                <a:spcPct val="110000"/>
-              </a:lnSpc>
-              <a:spcBef>
-                <a:spcPts val="0"/>
-              </a:spcBef>
-              <a:spcAft>
-                <a:spcPts val="800"/>
-              </a:spcAft>
-            </a:pPr>
-            <a:r>
-              <a:rPr sz="1200" b="1" i="0">
-                <a:solidFill>
-                  <a:srgbClr val="B8860B"/>
-                </a:solidFill>
-                <a:latin typeface="Calibri"/>
-              </a:rPr>
-              <a:t>2,5–3,9</a:t>
-            </a:r>
-          </a:p>
-          <a:p>
-            <a:pPr algn="l">
-              <a:lnSpc>
-                <a:spcPct val="110000"/>
-              </a:lnSpc>
-              <a:spcBef>
-                <a:spcPts val="0"/>
-              </a:spcBef>
-              <a:spcAft>
-                <a:spcPts val="800"/>
-              </a:spcAft>
-            </a:pPr>
-            <a:r>
-              <a:rPr sz="1200" b="1" i="0">
-                <a:solidFill>
-                  <a:srgbClr val="B1456A"/>
-                </a:solidFill>
-                <a:latin typeface="Calibri"/>
-              </a:rPr>
-              <a:t>&lt;2,5  déficit</a:t>
+              <a:t>El índice manda el dinero a Industrial, Vertientes y Cacheuta —no a Ciudad.</a:t>
             </a:r>
           </a:p>
         </p:txBody>
@@ -25265,113 +25330,6 @@
       <p:sp>
         <p:nvSpPr>
           <p:cNvPr id="54" name="TextBox 53"/>
-          <p:cNvSpPr txBox="1"/>
-          <p:nvPr/>
-        </p:nvSpPr>
-        <p:spPr>
-          <a:xfrm>
-            <a:off x="8732520" y="4297680"/>
-            <a:ext cx="3108960" cy="1828800"/>
-          </a:xfrm>
-          <a:prstGeom prst="rect">
-            <a:avLst/>
-          </a:prstGeom>
-          <a:noFill/>
-        </p:spPr>
-        <p:txBody>
-          <a:bodyPr wrap="square" anchor="t" lIns="0" rIns="0" tIns="0" bIns="0">
-            <a:spAutoFit/>
-          </a:bodyPr>
-          <a:lstStyle/>
-          <a:p>
-            <a:pPr algn="l">
-              <a:lnSpc>
-                <a:spcPct val="115000"/>
-              </a:lnSpc>
-              <a:spcBef>
-                <a:spcPts val="0"/>
-              </a:spcBef>
-              <a:spcAft>
-                <a:spcPts val="800"/>
-              </a:spcAft>
-            </a:pPr>
-            <a:r>
-              <a:rPr sz="1500" b="0" i="0">
-                <a:solidFill>
-                  <a:srgbClr val="2B3038"/>
-                </a:solidFill>
-                <a:latin typeface="Calibri"/>
-              </a:rPr>
-              <a:t>Menor puntaje = </a:t>
-            </a:r>
-            <a:r>
-              <a:rPr sz="1500" b="1" i="0">
-                <a:solidFill>
-                  <a:srgbClr val="B1456A"/>
-                </a:solidFill>
-                <a:latin typeface="Calibri"/>
-              </a:rPr>
-              <a:t>mayor prioridad</a:t>
-            </a:r>
-            <a:r>
-              <a:rPr sz="1500" b="0" i="0">
-                <a:solidFill>
-                  <a:srgbClr val="2B3038"/>
-                </a:solidFill>
-                <a:latin typeface="Calibri"/>
-              </a:rPr>
-              <a:t> de inversión.</a:t>
-            </a:r>
-          </a:p>
-          <a:p>
-            <a:pPr algn="l">
-              <a:lnSpc>
-                <a:spcPct val="115000"/>
-              </a:lnSpc>
-              <a:spcBef>
-                <a:spcPts val="0"/>
-              </a:spcBef>
-              <a:spcAft>
-                <a:spcPts val="800"/>
-              </a:spcAft>
-            </a:pPr>
-            <a:r>
-              <a:rPr sz="600" b="0" i="0">
-                <a:solidFill>
-                  <a:srgbClr val="2B3038"/>
-                </a:solidFill>
-                <a:latin typeface="Calibri"/>
-              </a:rPr>
-              <a:t/>
-            </a:r>
-          </a:p>
-          <a:p>
-            <a:pPr algn="l">
-              <a:lnSpc>
-                <a:spcPct val="115000"/>
-              </a:lnSpc>
-              <a:spcBef>
-                <a:spcPts val="0"/>
-              </a:spcBef>
-              <a:spcAft>
-                <a:spcPts val="800"/>
-              </a:spcAft>
-            </a:pPr>
-            <a:r>
-              <a:rPr sz="1400" b="0" i="1">
-                <a:solidFill>
-                  <a:srgbClr val="4E5869"/>
-                </a:solidFill>
-                <a:latin typeface="Calibri"/>
-              </a:rPr>
-              <a:t>El índice manda el dinero a Industrial, Vertientes y Cacheuta —no a Ciudad.</a:t>
-            </a:r>
-          </a:p>
-        </p:txBody>
-      </p:sp>
-      <p:sp>
-        <p:nvSpPr>
-          <p:cNvPr id="55" name="TextBox 54"/>
           <p:cNvSpPr txBox="1"/>
           <p:nvPr/>
         </p:nvSpPr>
@@ -25425,7 +25383,7 @@
       </p:sp>
       <p:sp>
         <p:nvSpPr>
-          <p:cNvPr id="56" name="TextBox 55"/>
+          <p:cNvPr id="55" name="TextBox 54"/>
           <p:cNvSpPr txBox="1"/>
           <p:nvPr/>
         </p:nvSpPr>

</xml_diff>

<commit_message>
Ranking slide: replicate the synthesis table exactly
El gráfico ahora refleja la Tabla Síntesis: mismo orden (Ciudad 7 arriba →
Industrial 1 abajo), barra proporcional al puntaje ICD y los tres tramos de
color idénticos (verde 6–7, amarillo 3–4,5, rojo ≤2,5). Título y leyenda
alineados con el puntaje (antes invertía la barra a "prioridad", lo que
confundía).

Aplicado en PPTX y HTML.

Co-Authored-By: Claude Opus 4.8 <noreply@anthropic.com>
Claude-Session: https://claude.ai/code/session_01QZiauNhtTVEiLX1MmVDGUu
</commit_message>
<xml_diff>
--- a/presentations/lujan-de-cuyo-gestion-suelo.pptx
+++ b/presentations/lujan-de-cuyo-gestion-suelo.pptx
@@ -1652,7 +1652,7 @@
           <a:lstStyle/>
           <a:p>
             <a:r>
-              <a:t>Lectura correcta: la barra es la prioridad (mayor brecha = va primero), por eso Industrial encabeza y Ciudad queda al final. El número es el puntaje ICD de la Tabla Síntesis. Colores por tramo: verde líderes (6–7), amarillo intermedio (3–4,5), rojo déficit (≤2,5).</a:t>
+              <a:t>Mismo orden y colores que la Tabla Síntesis: Ciudad (7) y La Puntilla (6) lideran (verde); el tramo intermedio 3–4,5 en amarillo; el déficit ≤2,5 (El Carrizal, Cacheuta, Vertientes, Industrial) en rojo. Menor puntaje = mayor prioridad de inversión.</a:t>
             </a:r>
           </a:p>
         </p:txBody>
@@ -22973,7 +22973,7 @@
                 </a:solidFill>
                 <a:latin typeface="Calibri"/>
               </a:rPr>
-              <a:t>MAPA DE PRIORIDADES · 05</a:t>
+              <a:t>EL DIAGNÓSTICO · 05</a:t>
             </a:r>
           </a:p>
         </p:txBody>
@@ -23018,7 +23018,7 @@
                 </a:solidFill>
                 <a:latin typeface="Calibri"/>
               </a:rPr>
-              <a:t>Dónde va primero la inversión</a:t>
+              <a:t>Puntaje de infraestructura por distrito</a:t>
             </a:r>
           </a:p>
         </p:txBody>
@@ -23063,7 +23063,7 @@
                 </a:solidFill>
                 <a:latin typeface="Calibri"/>
               </a:rPr>
-              <a:t>Industrial</a:t>
+              <a:t>Ciudad</a:t>
             </a:r>
           </a:p>
         </p:txBody>
@@ -23078,6 +23078,1502 @@
           <a:xfrm>
             <a:off x="3063240" y="1889519"/>
             <a:ext cx="7223760" cy="216888"/>
+          </a:xfrm>
+          <a:prstGeom prst="roundRect">
+            <a:avLst>
+              <a:gd name="adj" fmla="val 35000"/>
+            </a:avLst>
+          </a:prstGeom>
+          <a:solidFill>
+            <a:srgbClr val="5A8F6B"/>
+          </a:solidFill>
+          <a:ln>
+            <a:noFill/>
+          </a:ln>
+          <a:effectLst/>
+        </p:spPr>
+        <p:style>
+          <a:lnRef idx="1">
+            <a:schemeClr val="accent1"/>
+          </a:lnRef>
+          <a:fillRef idx="3">
+            <a:schemeClr val="accent1"/>
+          </a:fillRef>
+          <a:effectRef idx="2">
+            <a:schemeClr val="accent1"/>
+          </a:effectRef>
+          <a:fontRef idx="minor">
+            <a:schemeClr val="lt1"/>
+          </a:fontRef>
+        </p:style>
+        <p:txBody>
+          <a:bodyPr rtlCol="0" anchor="ctr"/>
+          <a:lstStyle/>
+          <a:p>
+            <a:pPr algn="ctr"/>
+          </a:p>
+        </p:txBody>
+      </p:sp>
+      <p:sp>
+        <p:nvSpPr>
+          <p:cNvPr id="8" name="TextBox 7"/>
+          <p:cNvSpPr txBox="1"/>
+          <p:nvPr/>
+        </p:nvSpPr>
+        <p:spPr>
+          <a:xfrm>
+            <a:off x="10360152" y="1874519"/>
+            <a:ext cx="868680" cy="246888"/>
+          </a:xfrm>
+          <a:prstGeom prst="rect">
+            <a:avLst/>
+          </a:prstGeom>
+          <a:noFill/>
+        </p:spPr>
+        <p:txBody>
+          <a:bodyPr wrap="square" anchor="ctr" lIns="0" rIns="0" tIns="0" bIns="0">
+            <a:spAutoFit/>
+          </a:bodyPr>
+          <a:lstStyle/>
+          <a:p>
+            <a:pPr algn="l">
+              <a:lnSpc>
+                <a:spcPct val="106000"/>
+              </a:lnSpc>
+              <a:spcBef>
+                <a:spcPts val="0"/>
+              </a:spcBef>
+              <a:spcAft>
+                <a:spcPts val="0"/>
+              </a:spcAft>
+            </a:pPr>
+            <a:r>
+              <a:rPr sz="1250" b="1" i="0">
+                <a:solidFill>
+                  <a:srgbClr val="5A8F6B"/>
+                </a:solidFill>
+                <a:latin typeface="Calibri"/>
+              </a:rPr>
+              <a:t>7</a:t>
+            </a:r>
+          </a:p>
+        </p:txBody>
+      </p:sp>
+      <p:sp>
+        <p:nvSpPr>
+          <p:cNvPr id="9" name="TextBox 8"/>
+          <p:cNvSpPr txBox="1"/>
+          <p:nvPr/>
+        </p:nvSpPr>
+        <p:spPr>
+          <a:xfrm>
+            <a:off x="685800" y="2162555"/>
+            <a:ext cx="2286000" cy="246888"/>
+          </a:xfrm>
+          <a:prstGeom prst="rect">
+            <a:avLst/>
+          </a:prstGeom>
+          <a:noFill/>
+        </p:spPr>
+        <p:txBody>
+          <a:bodyPr wrap="square" anchor="ctr" lIns="0" rIns="0" tIns="0" bIns="0">
+            <a:spAutoFit/>
+          </a:bodyPr>
+          <a:lstStyle/>
+          <a:p>
+            <a:pPr algn="r">
+              <a:lnSpc>
+                <a:spcPct val="106000"/>
+              </a:lnSpc>
+              <a:spcBef>
+                <a:spcPts val="0"/>
+              </a:spcBef>
+              <a:spcAft>
+                <a:spcPts val="0"/>
+              </a:spcAft>
+            </a:pPr>
+            <a:r>
+              <a:rPr sz="1250" b="1" i="0">
+                <a:solidFill>
+                  <a:srgbClr val="2B3038"/>
+                </a:solidFill>
+                <a:latin typeface="Calibri"/>
+              </a:rPr>
+              <a:t>La Puntilla</a:t>
+            </a:r>
+          </a:p>
+        </p:txBody>
+      </p:sp>
+      <p:sp>
+        <p:nvSpPr>
+          <p:cNvPr id="10" name="Rounded Rectangle 9"/>
+          <p:cNvSpPr/>
+          <p:nvPr/>
+        </p:nvSpPr>
+        <p:spPr>
+          <a:xfrm>
+            <a:off x="3063240" y="2177555"/>
+            <a:ext cx="6191794" cy="216888"/>
+          </a:xfrm>
+          <a:prstGeom prst="roundRect">
+            <a:avLst>
+              <a:gd name="adj" fmla="val 35000"/>
+            </a:avLst>
+          </a:prstGeom>
+          <a:solidFill>
+            <a:srgbClr val="5A8F6B"/>
+          </a:solidFill>
+          <a:ln>
+            <a:noFill/>
+          </a:ln>
+          <a:effectLst/>
+        </p:spPr>
+        <p:style>
+          <a:lnRef idx="1">
+            <a:schemeClr val="accent1"/>
+          </a:lnRef>
+          <a:fillRef idx="3">
+            <a:schemeClr val="accent1"/>
+          </a:fillRef>
+          <a:effectRef idx="2">
+            <a:schemeClr val="accent1"/>
+          </a:effectRef>
+          <a:fontRef idx="minor">
+            <a:schemeClr val="lt1"/>
+          </a:fontRef>
+        </p:style>
+        <p:txBody>
+          <a:bodyPr rtlCol="0" anchor="ctr"/>
+          <a:lstStyle/>
+          <a:p>
+            <a:pPr algn="ctr"/>
+          </a:p>
+        </p:txBody>
+      </p:sp>
+      <p:sp>
+        <p:nvSpPr>
+          <p:cNvPr id="11" name="TextBox 10"/>
+          <p:cNvSpPr txBox="1"/>
+          <p:nvPr/>
+        </p:nvSpPr>
+        <p:spPr>
+          <a:xfrm>
+            <a:off x="9328186" y="2162555"/>
+            <a:ext cx="868680" cy="246888"/>
+          </a:xfrm>
+          <a:prstGeom prst="rect">
+            <a:avLst/>
+          </a:prstGeom>
+          <a:noFill/>
+        </p:spPr>
+        <p:txBody>
+          <a:bodyPr wrap="square" anchor="ctr" lIns="0" rIns="0" tIns="0" bIns="0">
+            <a:spAutoFit/>
+          </a:bodyPr>
+          <a:lstStyle/>
+          <a:p>
+            <a:pPr algn="l">
+              <a:lnSpc>
+                <a:spcPct val="106000"/>
+              </a:lnSpc>
+              <a:spcBef>
+                <a:spcPts val="0"/>
+              </a:spcBef>
+              <a:spcAft>
+                <a:spcPts val="0"/>
+              </a:spcAft>
+            </a:pPr>
+            <a:r>
+              <a:rPr sz="1250" b="1" i="0">
+                <a:solidFill>
+                  <a:srgbClr val="5A8F6B"/>
+                </a:solidFill>
+                <a:latin typeface="Calibri"/>
+              </a:rPr>
+              <a:t>6</a:t>
+            </a:r>
+          </a:p>
+        </p:txBody>
+      </p:sp>
+      <p:sp>
+        <p:nvSpPr>
+          <p:cNvPr id="12" name="TextBox 11"/>
+          <p:cNvSpPr txBox="1"/>
+          <p:nvPr/>
+        </p:nvSpPr>
+        <p:spPr>
+          <a:xfrm>
+            <a:off x="685800" y="2450591"/>
+            <a:ext cx="2286000" cy="246888"/>
+          </a:xfrm>
+          <a:prstGeom prst="rect">
+            <a:avLst/>
+          </a:prstGeom>
+          <a:noFill/>
+        </p:spPr>
+        <p:txBody>
+          <a:bodyPr wrap="square" anchor="ctr" lIns="0" rIns="0" tIns="0" bIns="0">
+            <a:spAutoFit/>
+          </a:bodyPr>
+          <a:lstStyle/>
+          <a:p>
+            <a:pPr algn="r">
+              <a:lnSpc>
+                <a:spcPct val="106000"/>
+              </a:lnSpc>
+              <a:spcBef>
+                <a:spcPts val="0"/>
+              </a:spcBef>
+              <a:spcAft>
+                <a:spcPts val="0"/>
+              </a:spcAft>
+            </a:pPr>
+            <a:r>
+              <a:rPr sz="1250" b="1" i="0">
+                <a:solidFill>
+                  <a:srgbClr val="2B3038"/>
+                </a:solidFill>
+                <a:latin typeface="Calibri"/>
+              </a:rPr>
+              <a:t>Mayor Drummond</a:t>
+            </a:r>
+          </a:p>
+        </p:txBody>
+      </p:sp>
+      <p:sp>
+        <p:nvSpPr>
+          <p:cNvPr id="13" name="Rounded Rectangle 12"/>
+          <p:cNvSpPr/>
+          <p:nvPr/>
+        </p:nvSpPr>
+        <p:spPr>
+          <a:xfrm>
+            <a:off x="3063240" y="2465591"/>
+            <a:ext cx="4643845" cy="216888"/>
+          </a:xfrm>
+          <a:prstGeom prst="roundRect">
+            <a:avLst>
+              <a:gd name="adj" fmla="val 35000"/>
+            </a:avLst>
+          </a:prstGeom>
+          <a:solidFill>
+            <a:srgbClr val="B8860B"/>
+          </a:solidFill>
+          <a:ln>
+            <a:noFill/>
+          </a:ln>
+          <a:effectLst/>
+        </p:spPr>
+        <p:style>
+          <a:lnRef idx="1">
+            <a:schemeClr val="accent1"/>
+          </a:lnRef>
+          <a:fillRef idx="3">
+            <a:schemeClr val="accent1"/>
+          </a:fillRef>
+          <a:effectRef idx="2">
+            <a:schemeClr val="accent1"/>
+          </a:effectRef>
+          <a:fontRef idx="minor">
+            <a:schemeClr val="lt1"/>
+          </a:fontRef>
+        </p:style>
+        <p:txBody>
+          <a:bodyPr rtlCol="0" anchor="ctr"/>
+          <a:lstStyle/>
+          <a:p>
+            <a:pPr algn="ctr"/>
+          </a:p>
+        </p:txBody>
+      </p:sp>
+      <p:sp>
+        <p:nvSpPr>
+          <p:cNvPr id="14" name="TextBox 13"/>
+          <p:cNvSpPr txBox="1"/>
+          <p:nvPr/>
+        </p:nvSpPr>
+        <p:spPr>
+          <a:xfrm>
+            <a:off x="7780237" y="2450591"/>
+            <a:ext cx="868680" cy="246888"/>
+          </a:xfrm>
+          <a:prstGeom prst="rect">
+            <a:avLst/>
+          </a:prstGeom>
+          <a:noFill/>
+        </p:spPr>
+        <p:txBody>
+          <a:bodyPr wrap="square" anchor="ctr" lIns="0" rIns="0" tIns="0" bIns="0">
+            <a:spAutoFit/>
+          </a:bodyPr>
+          <a:lstStyle/>
+          <a:p>
+            <a:pPr algn="l">
+              <a:lnSpc>
+                <a:spcPct val="106000"/>
+              </a:lnSpc>
+              <a:spcBef>
+                <a:spcPts val="0"/>
+              </a:spcBef>
+              <a:spcAft>
+                <a:spcPts val="0"/>
+              </a:spcAft>
+            </a:pPr>
+            <a:r>
+              <a:rPr sz="1250" b="1" i="0">
+                <a:solidFill>
+                  <a:srgbClr val="B8860B"/>
+                </a:solidFill>
+                <a:latin typeface="Calibri"/>
+              </a:rPr>
+              <a:t>4.5</a:t>
+            </a:r>
+          </a:p>
+        </p:txBody>
+      </p:sp>
+      <p:sp>
+        <p:nvSpPr>
+          <p:cNvPr id="15" name="TextBox 14"/>
+          <p:cNvSpPr txBox="1"/>
+          <p:nvPr/>
+        </p:nvSpPr>
+        <p:spPr>
+          <a:xfrm>
+            <a:off x="685800" y="2738627"/>
+            <a:ext cx="2286000" cy="246888"/>
+          </a:xfrm>
+          <a:prstGeom prst="rect">
+            <a:avLst/>
+          </a:prstGeom>
+          <a:noFill/>
+        </p:spPr>
+        <p:txBody>
+          <a:bodyPr wrap="square" anchor="ctr" lIns="0" rIns="0" tIns="0" bIns="0">
+            <a:spAutoFit/>
+          </a:bodyPr>
+          <a:lstStyle/>
+          <a:p>
+            <a:pPr algn="r">
+              <a:lnSpc>
+                <a:spcPct val="106000"/>
+              </a:lnSpc>
+              <a:spcBef>
+                <a:spcPts val="0"/>
+              </a:spcBef>
+              <a:spcAft>
+                <a:spcPts val="0"/>
+              </a:spcAft>
+            </a:pPr>
+            <a:r>
+              <a:rPr sz="1250" b="1" i="0">
+                <a:solidFill>
+                  <a:srgbClr val="2B3038"/>
+                </a:solidFill>
+                <a:latin typeface="Calibri"/>
+              </a:rPr>
+              <a:t>Vistalba</a:t>
+            </a:r>
+          </a:p>
+        </p:txBody>
+      </p:sp>
+      <p:sp>
+        <p:nvSpPr>
+          <p:cNvPr id="16" name="Rounded Rectangle 15"/>
+          <p:cNvSpPr/>
+          <p:nvPr/>
+        </p:nvSpPr>
+        <p:spPr>
+          <a:xfrm>
+            <a:off x="3063240" y="2753627"/>
+            <a:ext cx="4643845" cy="216888"/>
+          </a:xfrm>
+          <a:prstGeom prst="roundRect">
+            <a:avLst>
+              <a:gd name="adj" fmla="val 35000"/>
+            </a:avLst>
+          </a:prstGeom>
+          <a:solidFill>
+            <a:srgbClr val="B8860B"/>
+          </a:solidFill>
+          <a:ln>
+            <a:noFill/>
+          </a:ln>
+          <a:effectLst/>
+        </p:spPr>
+        <p:style>
+          <a:lnRef idx="1">
+            <a:schemeClr val="accent1"/>
+          </a:lnRef>
+          <a:fillRef idx="3">
+            <a:schemeClr val="accent1"/>
+          </a:fillRef>
+          <a:effectRef idx="2">
+            <a:schemeClr val="accent1"/>
+          </a:effectRef>
+          <a:fontRef idx="minor">
+            <a:schemeClr val="lt1"/>
+          </a:fontRef>
+        </p:style>
+        <p:txBody>
+          <a:bodyPr rtlCol="0" anchor="ctr"/>
+          <a:lstStyle/>
+          <a:p>
+            <a:pPr algn="ctr"/>
+          </a:p>
+        </p:txBody>
+      </p:sp>
+      <p:sp>
+        <p:nvSpPr>
+          <p:cNvPr id="17" name="TextBox 16"/>
+          <p:cNvSpPr txBox="1"/>
+          <p:nvPr/>
+        </p:nvSpPr>
+        <p:spPr>
+          <a:xfrm>
+            <a:off x="7780237" y="2738627"/>
+            <a:ext cx="868680" cy="246888"/>
+          </a:xfrm>
+          <a:prstGeom prst="rect">
+            <a:avLst/>
+          </a:prstGeom>
+          <a:noFill/>
+        </p:spPr>
+        <p:txBody>
+          <a:bodyPr wrap="square" anchor="ctr" lIns="0" rIns="0" tIns="0" bIns="0">
+            <a:spAutoFit/>
+          </a:bodyPr>
+          <a:lstStyle/>
+          <a:p>
+            <a:pPr algn="l">
+              <a:lnSpc>
+                <a:spcPct val="106000"/>
+              </a:lnSpc>
+              <a:spcBef>
+                <a:spcPts val="0"/>
+              </a:spcBef>
+              <a:spcAft>
+                <a:spcPts val="0"/>
+              </a:spcAft>
+            </a:pPr>
+            <a:r>
+              <a:rPr sz="1250" b="1" i="0">
+                <a:solidFill>
+                  <a:srgbClr val="B8860B"/>
+                </a:solidFill>
+                <a:latin typeface="Calibri"/>
+              </a:rPr>
+              <a:t>4.5</a:t>
+            </a:r>
+          </a:p>
+        </p:txBody>
+      </p:sp>
+      <p:sp>
+        <p:nvSpPr>
+          <p:cNvPr id="18" name="TextBox 17"/>
+          <p:cNvSpPr txBox="1"/>
+          <p:nvPr/>
+        </p:nvSpPr>
+        <p:spPr>
+          <a:xfrm>
+            <a:off x="685800" y="3026663"/>
+            <a:ext cx="2286000" cy="246888"/>
+          </a:xfrm>
+          <a:prstGeom prst="rect">
+            <a:avLst/>
+          </a:prstGeom>
+          <a:noFill/>
+        </p:spPr>
+        <p:txBody>
+          <a:bodyPr wrap="square" anchor="ctr" lIns="0" rIns="0" tIns="0" bIns="0">
+            <a:spAutoFit/>
+          </a:bodyPr>
+          <a:lstStyle/>
+          <a:p>
+            <a:pPr algn="r">
+              <a:lnSpc>
+                <a:spcPct val="106000"/>
+              </a:lnSpc>
+              <a:spcBef>
+                <a:spcPts val="0"/>
+              </a:spcBef>
+              <a:spcAft>
+                <a:spcPts val="0"/>
+              </a:spcAft>
+            </a:pPr>
+            <a:r>
+              <a:rPr sz="1250" b="1" i="0">
+                <a:solidFill>
+                  <a:srgbClr val="2B3038"/>
+                </a:solidFill>
+                <a:latin typeface="Calibri"/>
+              </a:rPr>
+              <a:t>Chacras de Coria</a:t>
+            </a:r>
+          </a:p>
+        </p:txBody>
+      </p:sp>
+      <p:sp>
+        <p:nvSpPr>
+          <p:cNvPr id="19" name="Rounded Rectangle 18"/>
+          <p:cNvSpPr/>
+          <p:nvPr/>
+        </p:nvSpPr>
+        <p:spPr>
+          <a:xfrm>
+            <a:off x="3063240" y="3041663"/>
+            <a:ext cx="4127862" cy="216888"/>
+          </a:xfrm>
+          <a:prstGeom prst="roundRect">
+            <a:avLst>
+              <a:gd name="adj" fmla="val 35000"/>
+            </a:avLst>
+          </a:prstGeom>
+          <a:solidFill>
+            <a:srgbClr val="B8860B"/>
+          </a:solidFill>
+          <a:ln>
+            <a:noFill/>
+          </a:ln>
+          <a:effectLst/>
+        </p:spPr>
+        <p:style>
+          <a:lnRef idx="1">
+            <a:schemeClr val="accent1"/>
+          </a:lnRef>
+          <a:fillRef idx="3">
+            <a:schemeClr val="accent1"/>
+          </a:fillRef>
+          <a:effectRef idx="2">
+            <a:schemeClr val="accent1"/>
+          </a:effectRef>
+          <a:fontRef idx="minor">
+            <a:schemeClr val="lt1"/>
+          </a:fontRef>
+        </p:style>
+        <p:txBody>
+          <a:bodyPr rtlCol="0" anchor="ctr"/>
+          <a:lstStyle/>
+          <a:p>
+            <a:pPr algn="ctr"/>
+          </a:p>
+        </p:txBody>
+      </p:sp>
+      <p:sp>
+        <p:nvSpPr>
+          <p:cNvPr id="20" name="TextBox 19"/>
+          <p:cNvSpPr txBox="1"/>
+          <p:nvPr/>
+        </p:nvSpPr>
+        <p:spPr>
+          <a:xfrm>
+            <a:off x="7264254" y="3026663"/>
+            <a:ext cx="868680" cy="246888"/>
+          </a:xfrm>
+          <a:prstGeom prst="rect">
+            <a:avLst/>
+          </a:prstGeom>
+          <a:noFill/>
+        </p:spPr>
+        <p:txBody>
+          <a:bodyPr wrap="square" anchor="ctr" lIns="0" rIns="0" tIns="0" bIns="0">
+            <a:spAutoFit/>
+          </a:bodyPr>
+          <a:lstStyle/>
+          <a:p>
+            <a:pPr algn="l">
+              <a:lnSpc>
+                <a:spcPct val="106000"/>
+              </a:lnSpc>
+              <a:spcBef>
+                <a:spcPts val="0"/>
+              </a:spcBef>
+              <a:spcAft>
+                <a:spcPts val="0"/>
+              </a:spcAft>
+            </a:pPr>
+            <a:r>
+              <a:rPr sz="1250" b="1" i="0">
+                <a:solidFill>
+                  <a:srgbClr val="B8860B"/>
+                </a:solidFill>
+                <a:latin typeface="Calibri"/>
+              </a:rPr>
+              <a:t>4</a:t>
+            </a:r>
+          </a:p>
+        </p:txBody>
+      </p:sp>
+      <p:sp>
+        <p:nvSpPr>
+          <p:cNvPr id="21" name="TextBox 20"/>
+          <p:cNvSpPr txBox="1"/>
+          <p:nvPr/>
+        </p:nvSpPr>
+        <p:spPr>
+          <a:xfrm>
+            <a:off x="685800" y="3314699"/>
+            <a:ext cx="2286000" cy="246888"/>
+          </a:xfrm>
+          <a:prstGeom prst="rect">
+            <a:avLst/>
+          </a:prstGeom>
+          <a:noFill/>
+        </p:spPr>
+        <p:txBody>
+          <a:bodyPr wrap="square" anchor="ctr" lIns="0" rIns="0" tIns="0" bIns="0">
+            <a:spAutoFit/>
+          </a:bodyPr>
+          <a:lstStyle/>
+          <a:p>
+            <a:pPr algn="r">
+              <a:lnSpc>
+                <a:spcPct val="106000"/>
+              </a:lnSpc>
+              <a:spcBef>
+                <a:spcPts val="0"/>
+              </a:spcBef>
+              <a:spcAft>
+                <a:spcPts val="0"/>
+              </a:spcAft>
+            </a:pPr>
+            <a:r>
+              <a:rPr sz="1250" b="1" i="0">
+                <a:solidFill>
+                  <a:srgbClr val="2B3038"/>
+                </a:solidFill>
+                <a:latin typeface="Calibri"/>
+              </a:rPr>
+              <a:t>Carrodilla</a:t>
+            </a:r>
+          </a:p>
+        </p:txBody>
+      </p:sp>
+      <p:sp>
+        <p:nvSpPr>
+          <p:cNvPr id="22" name="Rounded Rectangle 21"/>
+          <p:cNvSpPr/>
+          <p:nvPr/>
+        </p:nvSpPr>
+        <p:spPr>
+          <a:xfrm>
+            <a:off x="3063240" y="3329699"/>
+            <a:ext cx="3611880" cy="216888"/>
+          </a:xfrm>
+          <a:prstGeom prst="roundRect">
+            <a:avLst>
+              <a:gd name="adj" fmla="val 35000"/>
+            </a:avLst>
+          </a:prstGeom>
+          <a:solidFill>
+            <a:srgbClr val="B8860B"/>
+          </a:solidFill>
+          <a:ln>
+            <a:noFill/>
+          </a:ln>
+          <a:effectLst/>
+        </p:spPr>
+        <p:style>
+          <a:lnRef idx="1">
+            <a:schemeClr val="accent1"/>
+          </a:lnRef>
+          <a:fillRef idx="3">
+            <a:schemeClr val="accent1"/>
+          </a:fillRef>
+          <a:effectRef idx="2">
+            <a:schemeClr val="accent1"/>
+          </a:effectRef>
+          <a:fontRef idx="minor">
+            <a:schemeClr val="lt1"/>
+          </a:fontRef>
+        </p:style>
+        <p:txBody>
+          <a:bodyPr rtlCol="0" anchor="ctr"/>
+          <a:lstStyle/>
+          <a:p>
+            <a:pPr algn="ctr"/>
+          </a:p>
+        </p:txBody>
+      </p:sp>
+      <p:sp>
+        <p:nvSpPr>
+          <p:cNvPr id="23" name="TextBox 22"/>
+          <p:cNvSpPr txBox="1"/>
+          <p:nvPr/>
+        </p:nvSpPr>
+        <p:spPr>
+          <a:xfrm>
+            <a:off x="6748272" y="3314699"/>
+            <a:ext cx="868680" cy="246888"/>
+          </a:xfrm>
+          <a:prstGeom prst="rect">
+            <a:avLst/>
+          </a:prstGeom>
+          <a:noFill/>
+        </p:spPr>
+        <p:txBody>
+          <a:bodyPr wrap="square" anchor="ctr" lIns="0" rIns="0" tIns="0" bIns="0">
+            <a:spAutoFit/>
+          </a:bodyPr>
+          <a:lstStyle/>
+          <a:p>
+            <a:pPr algn="l">
+              <a:lnSpc>
+                <a:spcPct val="106000"/>
+              </a:lnSpc>
+              <a:spcBef>
+                <a:spcPts val="0"/>
+              </a:spcBef>
+              <a:spcAft>
+                <a:spcPts val="0"/>
+              </a:spcAft>
+            </a:pPr>
+            <a:r>
+              <a:rPr sz="1250" b="1" i="0">
+                <a:solidFill>
+                  <a:srgbClr val="B8860B"/>
+                </a:solidFill>
+                <a:latin typeface="Calibri"/>
+              </a:rPr>
+              <a:t>3.5</a:t>
+            </a:r>
+          </a:p>
+        </p:txBody>
+      </p:sp>
+      <p:sp>
+        <p:nvSpPr>
+          <p:cNvPr id="24" name="TextBox 23"/>
+          <p:cNvSpPr txBox="1"/>
+          <p:nvPr/>
+        </p:nvSpPr>
+        <p:spPr>
+          <a:xfrm>
+            <a:off x="685800" y="3602735"/>
+            <a:ext cx="2286000" cy="246888"/>
+          </a:xfrm>
+          <a:prstGeom prst="rect">
+            <a:avLst/>
+          </a:prstGeom>
+          <a:noFill/>
+        </p:spPr>
+        <p:txBody>
+          <a:bodyPr wrap="square" anchor="ctr" lIns="0" rIns="0" tIns="0" bIns="0">
+            <a:spAutoFit/>
+          </a:bodyPr>
+          <a:lstStyle/>
+          <a:p>
+            <a:pPr algn="r">
+              <a:lnSpc>
+                <a:spcPct val="106000"/>
+              </a:lnSpc>
+              <a:spcBef>
+                <a:spcPts val="0"/>
+              </a:spcBef>
+              <a:spcAft>
+                <a:spcPts val="0"/>
+              </a:spcAft>
+            </a:pPr>
+            <a:r>
+              <a:rPr sz="1250" b="1" i="0">
+                <a:solidFill>
+                  <a:srgbClr val="2B3038"/>
+                </a:solidFill>
+                <a:latin typeface="Calibri"/>
+              </a:rPr>
+              <a:t>Agrelo</a:t>
+            </a:r>
+          </a:p>
+        </p:txBody>
+      </p:sp>
+      <p:sp>
+        <p:nvSpPr>
+          <p:cNvPr id="25" name="Rounded Rectangle 24"/>
+          <p:cNvSpPr/>
+          <p:nvPr/>
+        </p:nvSpPr>
+        <p:spPr>
+          <a:xfrm>
+            <a:off x="3063240" y="3617735"/>
+            <a:ext cx="3611880" cy="216888"/>
+          </a:xfrm>
+          <a:prstGeom prst="roundRect">
+            <a:avLst>
+              <a:gd name="adj" fmla="val 35000"/>
+            </a:avLst>
+          </a:prstGeom>
+          <a:solidFill>
+            <a:srgbClr val="B8860B"/>
+          </a:solidFill>
+          <a:ln>
+            <a:noFill/>
+          </a:ln>
+          <a:effectLst/>
+        </p:spPr>
+        <p:style>
+          <a:lnRef idx="1">
+            <a:schemeClr val="accent1"/>
+          </a:lnRef>
+          <a:fillRef idx="3">
+            <a:schemeClr val="accent1"/>
+          </a:fillRef>
+          <a:effectRef idx="2">
+            <a:schemeClr val="accent1"/>
+          </a:effectRef>
+          <a:fontRef idx="minor">
+            <a:schemeClr val="lt1"/>
+          </a:fontRef>
+        </p:style>
+        <p:txBody>
+          <a:bodyPr rtlCol="0" anchor="ctr"/>
+          <a:lstStyle/>
+          <a:p>
+            <a:pPr algn="ctr"/>
+          </a:p>
+        </p:txBody>
+      </p:sp>
+      <p:sp>
+        <p:nvSpPr>
+          <p:cNvPr id="26" name="TextBox 25"/>
+          <p:cNvSpPr txBox="1"/>
+          <p:nvPr/>
+        </p:nvSpPr>
+        <p:spPr>
+          <a:xfrm>
+            <a:off x="6748272" y="3602735"/>
+            <a:ext cx="868680" cy="246888"/>
+          </a:xfrm>
+          <a:prstGeom prst="rect">
+            <a:avLst/>
+          </a:prstGeom>
+          <a:noFill/>
+        </p:spPr>
+        <p:txBody>
+          <a:bodyPr wrap="square" anchor="ctr" lIns="0" rIns="0" tIns="0" bIns="0">
+            <a:spAutoFit/>
+          </a:bodyPr>
+          <a:lstStyle/>
+          <a:p>
+            <a:pPr algn="l">
+              <a:lnSpc>
+                <a:spcPct val="106000"/>
+              </a:lnSpc>
+              <a:spcBef>
+                <a:spcPts val="0"/>
+              </a:spcBef>
+              <a:spcAft>
+                <a:spcPts val="0"/>
+              </a:spcAft>
+            </a:pPr>
+            <a:r>
+              <a:rPr sz="1250" b="1" i="0">
+                <a:solidFill>
+                  <a:srgbClr val="B8860B"/>
+                </a:solidFill>
+                <a:latin typeface="Calibri"/>
+              </a:rPr>
+              <a:t>3.5</a:t>
+            </a:r>
+          </a:p>
+        </p:txBody>
+      </p:sp>
+      <p:sp>
+        <p:nvSpPr>
+          <p:cNvPr id="27" name="TextBox 26"/>
+          <p:cNvSpPr txBox="1"/>
+          <p:nvPr/>
+        </p:nvSpPr>
+        <p:spPr>
+          <a:xfrm>
+            <a:off x="685800" y="3890771"/>
+            <a:ext cx="2286000" cy="246888"/>
+          </a:xfrm>
+          <a:prstGeom prst="rect">
+            <a:avLst/>
+          </a:prstGeom>
+          <a:noFill/>
+        </p:spPr>
+        <p:txBody>
+          <a:bodyPr wrap="square" anchor="ctr" lIns="0" rIns="0" tIns="0" bIns="0">
+            <a:spAutoFit/>
+          </a:bodyPr>
+          <a:lstStyle/>
+          <a:p>
+            <a:pPr algn="r">
+              <a:lnSpc>
+                <a:spcPct val="106000"/>
+              </a:lnSpc>
+              <a:spcBef>
+                <a:spcPts val="0"/>
+              </a:spcBef>
+              <a:spcAft>
+                <a:spcPts val="0"/>
+              </a:spcAft>
+            </a:pPr>
+            <a:r>
+              <a:rPr sz="1250" b="1" i="0">
+                <a:solidFill>
+                  <a:srgbClr val="2B3038"/>
+                </a:solidFill>
+                <a:latin typeface="Calibri"/>
+              </a:rPr>
+              <a:t>Ugarteche</a:t>
+            </a:r>
+          </a:p>
+        </p:txBody>
+      </p:sp>
+      <p:sp>
+        <p:nvSpPr>
+          <p:cNvPr id="28" name="Rounded Rectangle 27"/>
+          <p:cNvSpPr/>
+          <p:nvPr/>
+        </p:nvSpPr>
+        <p:spPr>
+          <a:xfrm>
+            <a:off x="3063240" y="3905771"/>
+            <a:ext cx="3611880" cy="216888"/>
+          </a:xfrm>
+          <a:prstGeom prst="roundRect">
+            <a:avLst>
+              <a:gd name="adj" fmla="val 35000"/>
+            </a:avLst>
+          </a:prstGeom>
+          <a:solidFill>
+            <a:srgbClr val="B8860B"/>
+          </a:solidFill>
+          <a:ln>
+            <a:noFill/>
+          </a:ln>
+          <a:effectLst/>
+        </p:spPr>
+        <p:style>
+          <a:lnRef idx="1">
+            <a:schemeClr val="accent1"/>
+          </a:lnRef>
+          <a:fillRef idx="3">
+            <a:schemeClr val="accent1"/>
+          </a:fillRef>
+          <a:effectRef idx="2">
+            <a:schemeClr val="accent1"/>
+          </a:effectRef>
+          <a:fontRef idx="minor">
+            <a:schemeClr val="lt1"/>
+          </a:fontRef>
+        </p:style>
+        <p:txBody>
+          <a:bodyPr rtlCol="0" anchor="ctr"/>
+          <a:lstStyle/>
+          <a:p>
+            <a:pPr algn="ctr"/>
+          </a:p>
+        </p:txBody>
+      </p:sp>
+      <p:sp>
+        <p:nvSpPr>
+          <p:cNvPr id="29" name="TextBox 28"/>
+          <p:cNvSpPr txBox="1"/>
+          <p:nvPr/>
+        </p:nvSpPr>
+        <p:spPr>
+          <a:xfrm>
+            <a:off x="6748272" y="3890771"/>
+            <a:ext cx="868680" cy="246888"/>
+          </a:xfrm>
+          <a:prstGeom prst="rect">
+            <a:avLst/>
+          </a:prstGeom>
+          <a:noFill/>
+        </p:spPr>
+        <p:txBody>
+          <a:bodyPr wrap="square" anchor="ctr" lIns="0" rIns="0" tIns="0" bIns="0">
+            <a:spAutoFit/>
+          </a:bodyPr>
+          <a:lstStyle/>
+          <a:p>
+            <a:pPr algn="l">
+              <a:lnSpc>
+                <a:spcPct val="106000"/>
+              </a:lnSpc>
+              <a:spcBef>
+                <a:spcPts val="0"/>
+              </a:spcBef>
+              <a:spcAft>
+                <a:spcPts val="0"/>
+              </a:spcAft>
+            </a:pPr>
+            <a:r>
+              <a:rPr sz="1250" b="1" i="0">
+                <a:solidFill>
+                  <a:srgbClr val="B8860B"/>
+                </a:solidFill>
+                <a:latin typeface="Calibri"/>
+              </a:rPr>
+              <a:t>3.5</a:t>
+            </a:r>
+          </a:p>
+        </p:txBody>
+      </p:sp>
+      <p:sp>
+        <p:nvSpPr>
+          <p:cNvPr id="30" name="TextBox 29"/>
+          <p:cNvSpPr txBox="1"/>
+          <p:nvPr/>
+        </p:nvSpPr>
+        <p:spPr>
+          <a:xfrm>
+            <a:off x="685800" y="4178807"/>
+            <a:ext cx="2286000" cy="246888"/>
+          </a:xfrm>
+          <a:prstGeom prst="rect">
+            <a:avLst/>
+          </a:prstGeom>
+          <a:noFill/>
+        </p:spPr>
+        <p:txBody>
+          <a:bodyPr wrap="square" anchor="ctr" lIns="0" rIns="0" tIns="0" bIns="0">
+            <a:spAutoFit/>
+          </a:bodyPr>
+          <a:lstStyle/>
+          <a:p>
+            <a:pPr algn="r">
+              <a:lnSpc>
+                <a:spcPct val="106000"/>
+              </a:lnSpc>
+              <a:spcBef>
+                <a:spcPts val="0"/>
+              </a:spcBef>
+              <a:spcAft>
+                <a:spcPts val="0"/>
+              </a:spcAft>
+            </a:pPr>
+            <a:r>
+              <a:rPr sz="1250" b="1" i="0">
+                <a:solidFill>
+                  <a:srgbClr val="2B3038"/>
+                </a:solidFill>
+                <a:latin typeface="Calibri"/>
+              </a:rPr>
+              <a:t>Las Compuertas</a:t>
+            </a:r>
+          </a:p>
+        </p:txBody>
+      </p:sp>
+      <p:sp>
+        <p:nvSpPr>
+          <p:cNvPr id="31" name="Rounded Rectangle 30"/>
+          <p:cNvSpPr/>
+          <p:nvPr/>
+        </p:nvSpPr>
+        <p:spPr>
+          <a:xfrm>
+            <a:off x="3063240" y="4193807"/>
+            <a:ext cx="3095897" cy="216888"/>
+          </a:xfrm>
+          <a:prstGeom prst="roundRect">
+            <a:avLst>
+              <a:gd name="adj" fmla="val 35000"/>
+            </a:avLst>
+          </a:prstGeom>
+          <a:solidFill>
+            <a:srgbClr val="B8860B"/>
+          </a:solidFill>
+          <a:ln>
+            <a:noFill/>
+          </a:ln>
+          <a:effectLst/>
+        </p:spPr>
+        <p:style>
+          <a:lnRef idx="1">
+            <a:schemeClr val="accent1"/>
+          </a:lnRef>
+          <a:fillRef idx="3">
+            <a:schemeClr val="accent1"/>
+          </a:fillRef>
+          <a:effectRef idx="2">
+            <a:schemeClr val="accent1"/>
+          </a:effectRef>
+          <a:fontRef idx="minor">
+            <a:schemeClr val="lt1"/>
+          </a:fontRef>
+        </p:style>
+        <p:txBody>
+          <a:bodyPr rtlCol="0" anchor="ctr"/>
+          <a:lstStyle/>
+          <a:p>
+            <a:pPr algn="ctr"/>
+          </a:p>
+        </p:txBody>
+      </p:sp>
+      <p:sp>
+        <p:nvSpPr>
+          <p:cNvPr id="32" name="TextBox 31"/>
+          <p:cNvSpPr txBox="1"/>
+          <p:nvPr/>
+        </p:nvSpPr>
+        <p:spPr>
+          <a:xfrm>
+            <a:off x="6232289" y="4178807"/>
+            <a:ext cx="868680" cy="246888"/>
+          </a:xfrm>
+          <a:prstGeom prst="rect">
+            <a:avLst/>
+          </a:prstGeom>
+          <a:noFill/>
+        </p:spPr>
+        <p:txBody>
+          <a:bodyPr wrap="square" anchor="ctr" lIns="0" rIns="0" tIns="0" bIns="0">
+            <a:spAutoFit/>
+          </a:bodyPr>
+          <a:lstStyle/>
+          <a:p>
+            <a:pPr algn="l">
+              <a:lnSpc>
+                <a:spcPct val="106000"/>
+              </a:lnSpc>
+              <a:spcBef>
+                <a:spcPts val="0"/>
+              </a:spcBef>
+              <a:spcAft>
+                <a:spcPts val="0"/>
+              </a:spcAft>
+            </a:pPr>
+            <a:r>
+              <a:rPr sz="1250" b="1" i="0">
+                <a:solidFill>
+                  <a:srgbClr val="B8860B"/>
+                </a:solidFill>
+                <a:latin typeface="Calibri"/>
+              </a:rPr>
+              <a:t>3</a:t>
+            </a:r>
+          </a:p>
+        </p:txBody>
+      </p:sp>
+      <p:sp>
+        <p:nvSpPr>
+          <p:cNvPr id="33" name="TextBox 32"/>
+          <p:cNvSpPr txBox="1"/>
+          <p:nvPr/>
+        </p:nvSpPr>
+        <p:spPr>
+          <a:xfrm>
+            <a:off x="685800" y="4466843"/>
+            <a:ext cx="2286000" cy="246888"/>
+          </a:xfrm>
+          <a:prstGeom prst="rect">
+            <a:avLst/>
+          </a:prstGeom>
+          <a:noFill/>
+        </p:spPr>
+        <p:txBody>
+          <a:bodyPr wrap="square" anchor="ctr" lIns="0" rIns="0" tIns="0" bIns="0">
+            <a:spAutoFit/>
+          </a:bodyPr>
+          <a:lstStyle/>
+          <a:p>
+            <a:pPr algn="r">
+              <a:lnSpc>
+                <a:spcPct val="106000"/>
+              </a:lnSpc>
+              <a:spcBef>
+                <a:spcPts val="0"/>
+              </a:spcBef>
+              <a:spcAft>
+                <a:spcPts val="0"/>
+              </a:spcAft>
+            </a:pPr>
+            <a:r>
+              <a:rPr sz="1250" b="1" i="0">
+                <a:solidFill>
+                  <a:srgbClr val="2B3038"/>
+                </a:solidFill>
+                <a:latin typeface="Calibri"/>
+              </a:rPr>
+              <a:t>Perdriel</a:t>
+            </a:r>
+          </a:p>
+        </p:txBody>
+      </p:sp>
+      <p:sp>
+        <p:nvSpPr>
+          <p:cNvPr id="34" name="Rounded Rectangle 33"/>
+          <p:cNvSpPr/>
+          <p:nvPr/>
+        </p:nvSpPr>
+        <p:spPr>
+          <a:xfrm>
+            <a:off x="3063240" y="4481843"/>
+            <a:ext cx="3095897" cy="216888"/>
+          </a:xfrm>
+          <a:prstGeom prst="roundRect">
+            <a:avLst>
+              <a:gd name="adj" fmla="val 35000"/>
+            </a:avLst>
+          </a:prstGeom>
+          <a:solidFill>
+            <a:srgbClr val="B8860B"/>
+          </a:solidFill>
+          <a:ln>
+            <a:noFill/>
+          </a:ln>
+          <a:effectLst/>
+        </p:spPr>
+        <p:style>
+          <a:lnRef idx="1">
+            <a:schemeClr val="accent1"/>
+          </a:lnRef>
+          <a:fillRef idx="3">
+            <a:schemeClr val="accent1"/>
+          </a:fillRef>
+          <a:effectRef idx="2">
+            <a:schemeClr val="accent1"/>
+          </a:effectRef>
+          <a:fontRef idx="minor">
+            <a:schemeClr val="lt1"/>
+          </a:fontRef>
+        </p:style>
+        <p:txBody>
+          <a:bodyPr rtlCol="0" anchor="ctr"/>
+          <a:lstStyle/>
+          <a:p>
+            <a:pPr algn="ctr"/>
+          </a:p>
+        </p:txBody>
+      </p:sp>
+      <p:sp>
+        <p:nvSpPr>
+          <p:cNvPr id="35" name="TextBox 34"/>
+          <p:cNvSpPr txBox="1"/>
+          <p:nvPr/>
+        </p:nvSpPr>
+        <p:spPr>
+          <a:xfrm>
+            <a:off x="6232289" y="4466843"/>
+            <a:ext cx="868680" cy="246888"/>
+          </a:xfrm>
+          <a:prstGeom prst="rect">
+            <a:avLst/>
+          </a:prstGeom>
+          <a:noFill/>
+        </p:spPr>
+        <p:txBody>
+          <a:bodyPr wrap="square" anchor="ctr" lIns="0" rIns="0" tIns="0" bIns="0">
+            <a:spAutoFit/>
+          </a:bodyPr>
+          <a:lstStyle/>
+          <a:p>
+            <a:pPr algn="l">
+              <a:lnSpc>
+                <a:spcPct val="106000"/>
+              </a:lnSpc>
+              <a:spcBef>
+                <a:spcPts val="0"/>
+              </a:spcBef>
+              <a:spcAft>
+                <a:spcPts val="0"/>
+              </a:spcAft>
+            </a:pPr>
+            <a:r>
+              <a:rPr sz="1250" b="1" i="0">
+                <a:solidFill>
+                  <a:srgbClr val="B8860B"/>
+                </a:solidFill>
+                <a:latin typeface="Calibri"/>
+              </a:rPr>
+              <a:t>3</a:t>
+            </a:r>
+          </a:p>
+        </p:txBody>
+      </p:sp>
+      <p:sp>
+        <p:nvSpPr>
+          <p:cNvPr id="36" name="TextBox 35"/>
+          <p:cNvSpPr txBox="1"/>
+          <p:nvPr/>
+        </p:nvSpPr>
+        <p:spPr>
+          <a:xfrm>
+            <a:off x="685800" y="4754879"/>
+            <a:ext cx="2286000" cy="246888"/>
+          </a:xfrm>
+          <a:prstGeom prst="rect">
+            <a:avLst/>
+          </a:prstGeom>
+          <a:noFill/>
+        </p:spPr>
+        <p:txBody>
+          <a:bodyPr wrap="square" anchor="ctr" lIns="0" rIns="0" tIns="0" bIns="0">
+            <a:spAutoFit/>
+          </a:bodyPr>
+          <a:lstStyle/>
+          <a:p>
+            <a:pPr algn="r">
+              <a:lnSpc>
+                <a:spcPct val="106000"/>
+              </a:lnSpc>
+              <a:spcBef>
+                <a:spcPts val="0"/>
+              </a:spcBef>
+              <a:spcAft>
+                <a:spcPts val="0"/>
+              </a:spcAft>
+            </a:pPr>
+            <a:r>
+              <a:rPr sz="1250" b="1" i="0">
+                <a:solidFill>
+                  <a:srgbClr val="2B3038"/>
+                </a:solidFill>
+                <a:latin typeface="Calibri"/>
+              </a:rPr>
+              <a:t>Potrerillos</a:t>
+            </a:r>
+          </a:p>
+        </p:txBody>
+      </p:sp>
+      <p:sp>
+        <p:nvSpPr>
+          <p:cNvPr id="37" name="Rounded Rectangle 36"/>
+          <p:cNvSpPr/>
+          <p:nvPr/>
+        </p:nvSpPr>
+        <p:spPr>
+          <a:xfrm>
+            <a:off x="3063240" y="4769879"/>
+            <a:ext cx="3095897" cy="216888"/>
+          </a:xfrm>
+          <a:prstGeom prst="roundRect">
+            <a:avLst>
+              <a:gd name="adj" fmla="val 35000"/>
+            </a:avLst>
+          </a:prstGeom>
+          <a:solidFill>
+            <a:srgbClr val="B8860B"/>
+          </a:solidFill>
+          <a:ln>
+            <a:noFill/>
+          </a:ln>
+          <a:effectLst/>
+        </p:spPr>
+        <p:style>
+          <a:lnRef idx="1">
+            <a:schemeClr val="accent1"/>
+          </a:lnRef>
+          <a:fillRef idx="3">
+            <a:schemeClr val="accent1"/>
+          </a:fillRef>
+          <a:effectRef idx="2">
+            <a:schemeClr val="accent1"/>
+          </a:effectRef>
+          <a:fontRef idx="minor">
+            <a:schemeClr val="lt1"/>
+          </a:fontRef>
+        </p:style>
+        <p:txBody>
+          <a:bodyPr rtlCol="0" anchor="ctr"/>
+          <a:lstStyle/>
+          <a:p>
+            <a:pPr algn="ctr"/>
+          </a:p>
+        </p:txBody>
+      </p:sp>
+      <p:sp>
+        <p:nvSpPr>
+          <p:cNvPr id="38" name="TextBox 37"/>
+          <p:cNvSpPr txBox="1"/>
+          <p:nvPr/>
+        </p:nvSpPr>
+        <p:spPr>
+          <a:xfrm>
+            <a:off x="6232289" y="4754879"/>
+            <a:ext cx="868680" cy="246888"/>
+          </a:xfrm>
+          <a:prstGeom prst="rect">
+            <a:avLst/>
+          </a:prstGeom>
+          <a:noFill/>
+        </p:spPr>
+        <p:txBody>
+          <a:bodyPr wrap="square" anchor="ctr" lIns="0" rIns="0" tIns="0" bIns="0">
+            <a:spAutoFit/>
+          </a:bodyPr>
+          <a:lstStyle/>
+          <a:p>
+            <a:pPr algn="l">
+              <a:lnSpc>
+                <a:spcPct val="106000"/>
+              </a:lnSpc>
+              <a:spcBef>
+                <a:spcPts val="0"/>
+              </a:spcBef>
+              <a:spcAft>
+                <a:spcPts val="0"/>
+              </a:spcAft>
+            </a:pPr>
+            <a:r>
+              <a:rPr sz="1250" b="1" i="0">
+                <a:solidFill>
+                  <a:srgbClr val="B8860B"/>
+                </a:solidFill>
+                <a:latin typeface="Calibri"/>
+              </a:rPr>
+              <a:t>3</a:t>
+            </a:r>
+          </a:p>
+        </p:txBody>
+      </p:sp>
+      <p:sp>
+        <p:nvSpPr>
+          <p:cNvPr id="39" name="TextBox 38"/>
+          <p:cNvSpPr txBox="1"/>
+          <p:nvPr/>
+        </p:nvSpPr>
+        <p:spPr>
+          <a:xfrm>
+            <a:off x="685800" y="5042915"/>
+            <a:ext cx="2286000" cy="246888"/>
+          </a:xfrm>
+          <a:prstGeom prst="rect">
+            <a:avLst/>
+          </a:prstGeom>
+          <a:noFill/>
+        </p:spPr>
+        <p:txBody>
+          <a:bodyPr wrap="square" anchor="ctr" lIns="0" rIns="0" tIns="0" bIns="0">
+            <a:spAutoFit/>
+          </a:bodyPr>
+          <a:lstStyle/>
+          <a:p>
+            <a:pPr algn="r">
+              <a:lnSpc>
+                <a:spcPct val="106000"/>
+              </a:lnSpc>
+              <a:spcBef>
+                <a:spcPts val="0"/>
+              </a:spcBef>
+              <a:spcAft>
+                <a:spcPts val="0"/>
+              </a:spcAft>
+            </a:pPr>
+            <a:r>
+              <a:rPr sz="1250" b="1" i="0">
+                <a:solidFill>
+                  <a:srgbClr val="2B3038"/>
+                </a:solidFill>
+                <a:latin typeface="Calibri"/>
+              </a:rPr>
+              <a:t>El Carrizal</a:t>
+            </a:r>
+          </a:p>
+        </p:txBody>
+      </p:sp>
+      <p:sp>
+        <p:nvSpPr>
+          <p:cNvPr id="40" name="Rounded Rectangle 39"/>
+          <p:cNvSpPr/>
+          <p:nvPr/>
+        </p:nvSpPr>
+        <p:spPr>
+          <a:xfrm>
+            <a:off x="3063240" y="5057915"/>
+            <a:ext cx="2579914" cy="216888"/>
           </a:xfrm>
           <a:prstGeom prst="roundRect">
             <a:avLst>
@@ -23116,13 +24612,13 @@
       </p:sp>
       <p:sp>
         <p:nvSpPr>
-          <p:cNvPr id="8" name="TextBox 7"/>
-          <p:cNvSpPr txBox="1"/>
-          <p:nvPr/>
-        </p:nvSpPr>
-        <p:spPr>
-          <a:xfrm>
-            <a:off x="10360152" y="1874519"/>
+          <p:cNvPr id="41" name="TextBox 40"/>
+          <p:cNvSpPr txBox="1"/>
+          <p:nvPr/>
+        </p:nvSpPr>
+        <p:spPr>
+          <a:xfrm>
+            <a:off x="5716306" y="5042915"/>
             <a:ext cx="868680" cy="246888"/>
           </a:xfrm>
           <a:prstGeom prst="rect">
@@ -23154,20 +24650,20 @@
                 </a:solidFill>
                 <a:latin typeface="Calibri"/>
               </a:rPr>
-              <a:t>1</a:t>
-            </a:r>
-          </a:p>
-        </p:txBody>
-      </p:sp>
-      <p:sp>
-        <p:nvSpPr>
-          <p:cNvPr id="9" name="TextBox 8"/>
-          <p:cNvSpPr txBox="1"/>
-          <p:nvPr/>
-        </p:nvSpPr>
-        <p:spPr>
-          <a:xfrm>
-            <a:off x="685800" y="2162555"/>
+              <a:t>2.5</a:t>
+            </a:r>
+          </a:p>
+        </p:txBody>
+      </p:sp>
+      <p:sp>
+        <p:nvSpPr>
+          <p:cNvPr id="42" name="TextBox 41"/>
+          <p:cNvSpPr txBox="1"/>
+          <p:nvPr/>
+        </p:nvSpPr>
+        <p:spPr>
+          <a:xfrm>
+            <a:off x="685800" y="5330951"/>
             <a:ext cx="2286000" cy="246888"/>
           </a:xfrm>
           <a:prstGeom prst="rect">
@@ -23199,21 +24695,21 @@
                 </a:solidFill>
                 <a:latin typeface="Calibri"/>
               </a:rPr>
-              <a:t>Vertientes de Pedemonte</a:t>
-            </a:r>
-          </a:p>
-        </p:txBody>
-      </p:sp>
-      <p:sp>
-        <p:nvSpPr>
-          <p:cNvPr id="10" name="Rounded Rectangle 9"/>
+              <a:t>Cacheuta</a:t>
+            </a:r>
+          </a:p>
+        </p:txBody>
+      </p:sp>
+      <p:sp>
+        <p:nvSpPr>
+          <p:cNvPr id="43" name="Rounded Rectangle 42"/>
           <p:cNvSpPr/>
           <p:nvPr/>
         </p:nvSpPr>
         <p:spPr>
           <a:xfrm>
-            <a:off x="3063240" y="2177555"/>
-            <a:ext cx="6862572" cy="216888"/>
+            <a:off x="3063240" y="5345951"/>
+            <a:ext cx="2063931" cy="216888"/>
           </a:xfrm>
           <a:prstGeom prst="roundRect">
             <a:avLst>
@@ -23252,13 +24748,13 @@
       </p:sp>
       <p:sp>
         <p:nvSpPr>
-          <p:cNvPr id="11" name="TextBox 10"/>
-          <p:cNvSpPr txBox="1"/>
-          <p:nvPr/>
-        </p:nvSpPr>
-        <p:spPr>
-          <a:xfrm>
-            <a:off x="9998964" y="2162555"/>
+          <p:cNvPr id="44" name="TextBox 43"/>
+          <p:cNvSpPr txBox="1"/>
+          <p:nvPr/>
+        </p:nvSpPr>
+        <p:spPr>
+          <a:xfrm>
+            <a:off x="5200323" y="5330951"/>
             <a:ext cx="868680" cy="246888"/>
           </a:xfrm>
           <a:prstGeom prst="rect">
@@ -23290,20 +24786,20 @@
                 </a:solidFill>
                 <a:latin typeface="Calibri"/>
               </a:rPr>
-              <a:t>1.5</a:t>
-            </a:r>
-          </a:p>
-        </p:txBody>
-      </p:sp>
-      <p:sp>
-        <p:nvSpPr>
-          <p:cNvPr id="12" name="TextBox 11"/>
-          <p:cNvSpPr txBox="1"/>
-          <p:nvPr/>
-        </p:nvSpPr>
-        <p:spPr>
-          <a:xfrm>
-            <a:off x="685800" y="2450591"/>
+              <a:t>2</a:t>
+            </a:r>
+          </a:p>
+        </p:txBody>
+      </p:sp>
+      <p:sp>
+        <p:nvSpPr>
+          <p:cNvPr id="45" name="TextBox 44"/>
+          <p:cNvSpPr txBox="1"/>
+          <p:nvPr/>
+        </p:nvSpPr>
+        <p:spPr>
+          <a:xfrm>
+            <a:off x="685800" y="5618987"/>
             <a:ext cx="2286000" cy="246888"/>
           </a:xfrm>
           <a:prstGeom prst="rect">
@@ -23335,21 +24831,21 @@
                 </a:solidFill>
                 <a:latin typeface="Calibri"/>
               </a:rPr>
-              <a:t>Cacheuta</a:t>
-            </a:r>
-          </a:p>
-        </p:txBody>
-      </p:sp>
-      <p:sp>
-        <p:nvSpPr>
-          <p:cNvPr id="13" name="Rounded Rectangle 12"/>
+              <a:t>Vertientes de Pedemonte</a:t>
+            </a:r>
+          </a:p>
+        </p:txBody>
+      </p:sp>
+      <p:sp>
+        <p:nvSpPr>
+          <p:cNvPr id="46" name="Rounded Rectangle 45"/>
           <p:cNvSpPr/>
           <p:nvPr/>
         </p:nvSpPr>
         <p:spPr>
           <a:xfrm>
-            <a:off x="3063240" y="2465591"/>
-            <a:ext cx="6501384" cy="216888"/>
+            <a:off x="3063240" y="5633987"/>
+            <a:ext cx="1547948" cy="216888"/>
           </a:xfrm>
           <a:prstGeom prst="roundRect">
             <a:avLst>
@@ -23388,13 +24884,13 @@
       </p:sp>
       <p:sp>
         <p:nvSpPr>
-          <p:cNvPr id="14" name="TextBox 13"/>
-          <p:cNvSpPr txBox="1"/>
-          <p:nvPr/>
-        </p:nvSpPr>
-        <p:spPr>
-          <a:xfrm>
-            <a:off x="9637776" y="2450591"/>
+          <p:cNvPr id="47" name="TextBox 46"/>
+          <p:cNvSpPr txBox="1"/>
+          <p:nvPr/>
+        </p:nvSpPr>
+        <p:spPr>
+          <a:xfrm>
+            <a:off x="4684340" y="5618987"/>
             <a:ext cx="868680" cy="246888"/>
           </a:xfrm>
           <a:prstGeom prst="rect">
@@ -23426,20 +24922,20 @@
                 </a:solidFill>
                 <a:latin typeface="Calibri"/>
               </a:rPr>
-              <a:t>2</a:t>
-            </a:r>
-          </a:p>
-        </p:txBody>
-      </p:sp>
-      <p:sp>
-        <p:nvSpPr>
-          <p:cNvPr id="15" name="TextBox 14"/>
-          <p:cNvSpPr txBox="1"/>
-          <p:nvPr/>
-        </p:nvSpPr>
-        <p:spPr>
-          <a:xfrm>
-            <a:off x="685800" y="2738627"/>
+              <a:t>1.5</a:t>
+            </a:r>
+          </a:p>
+        </p:txBody>
+      </p:sp>
+      <p:sp>
+        <p:nvSpPr>
+          <p:cNvPr id="48" name="TextBox 47"/>
+          <p:cNvSpPr txBox="1"/>
+          <p:nvPr/>
+        </p:nvSpPr>
+        <p:spPr>
+          <a:xfrm>
+            <a:off x="685800" y="5907023"/>
             <a:ext cx="2286000" cy="246888"/>
           </a:xfrm>
           <a:prstGeom prst="rect">
@@ -23471,21 +24967,21 @@
                 </a:solidFill>
                 <a:latin typeface="Calibri"/>
               </a:rPr>
-              <a:t>El Carrizal</a:t>
-            </a:r>
-          </a:p>
-        </p:txBody>
-      </p:sp>
-      <p:sp>
-        <p:nvSpPr>
-          <p:cNvPr id="16" name="Rounded Rectangle 15"/>
+              <a:t>Industrial</a:t>
+            </a:r>
+          </a:p>
+        </p:txBody>
+      </p:sp>
+      <p:sp>
+        <p:nvSpPr>
+          <p:cNvPr id="49" name="Rounded Rectangle 48"/>
           <p:cNvSpPr/>
           <p:nvPr/>
         </p:nvSpPr>
         <p:spPr>
           <a:xfrm>
-            <a:off x="3063240" y="2753627"/>
-            <a:ext cx="6140196" cy="216888"/>
+            <a:off x="3063240" y="5922023"/>
+            <a:ext cx="1031965" cy="216888"/>
           </a:xfrm>
           <a:prstGeom prst="roundRect">
             <a:avLst>
@@ -23524,13 +25020,13 @@
       </p:sp>
       <p:sp>
         <p:nvSpPr>
-          <p:cNvPr id="17" name="TextBox 16"/>
-          <p:cNvSpPr txBox="1"/>
-          <p:nvPr/>
-        </p:nvSpPr>
-        <p:spPr>
-          <a:xfrm>
-            <a:off x="9276588" y="2738627"/>
+          <p:cNvPr id="50" name="TextBox 49"/>
+          <p:cNvSpPr txBox="1"/>
+          <p:nvPr/>
+        </p:nvSpPr>
+        <p:spPr>
+          <a:xfrm>
+            <a:off x="4168357" y="5907023"/>
             <a:ext cx="868680" cy="246888"/>
           </a:xfrm>
           <a:prstGeom prst="rect">
@@ -23562,1503 +25058,7 @@
                 </a:solidFill>
                 <a:latin typeface="Calibri"/>
               </a:rPr>
-              <a:t>2.5</a:t>
-            </a:r>
-          </a:p>
-        </p:txBody>
-      </p:sp>
-      <p:sp>
-        <p:nvSpPr>
-          <p:cNvPr id="18" name="TextBox 17"/>
-          <p:cNvSpPr txBox="1"/>
-          <p:nvPr/>
-        </p:nvSpPr>
-        <p:spPr>
-          <a:xfrm>
-            <a:off x="685800" y="3026663"/>
-            <a:ext cx="2286000" cy="246888"/>
-          </a:xfrm>
-          <a:prstGeom prst="rect">
-            <a:avLst/>
-          </a:prstGeom>
-          <a:noFill/>
-        </p:spPr>
-        <p:txBody>
-          <a:bodyPr wrap="square" anchor="ctr" lIns="0" rIns="0" tIns="0" bIns="0">
-            <a:spAutoFit/>
-          </a:bodyPr>
-          <a:lstStyle/>
-          <a:p>
-            <a:pPr algn="r">
-              <a:lnSpc>
-                <a:spcPct val="106000"/>
-              </a:lnSpc>
-              <a:spcBef>
-                <a:spcPts val="0"/>
-              </a:spcBef>
-              <a:spcAft>
-                <a:spcPts val="0"/>
-              </a:spcAft>
-            </a:pPr>
-            <a:r>
-              <a:rPr sz="1250" b="1" i="0">
-                <a:solidFill>
-                  <a:srgbClr val="2B3038"/>
-                </a:solidFill>
-                <a:latin typeface="Calibri"/>
-              </a:rPr>
-              <a:t>Las Compuertas</a:t>
-            </a:r>
-          </a:p>
-        </p:txBody>
-      </p:sp>
-      <p:sp>
-        <p:nvSpPr>
-          <p:cNvPr id="19" name="Rounded Rectangle 18"/>
-          <p:cNvSpPr/>
-          <p:nvPr/>
-        </p:nvSpPr>
-        <p:spPr>
-          <a:xfrm>
-            <a:off x="3063240" y="3041663"/>
-            <a:ext cx="5779008" cy="216888"/>
-          </a:xfrm>
-          <a:prstGeom prst="roundRect">
-            <a:avLst>
-              <a:gd name="adj" fmla="val 35000"/>
-            </a:avLst>
-          </a:prstGeom>
-          <a:solidFill>
-            <a:srgbClr val="B8860B"/>
-          </a:solidFill>
-          <a:ln>
-            <a:noFill/>
-          </a:ln>
-          <a:effectLst/>
-        </p:spPr>
-        <p:style>
-          <a:lnRef idx="1">
-            <a:schemeClr val="accent1"/>
-          </a:lnRef>
-          <a:fillRef idx="3">
-            <a:schemeClr val="accent1"/>
-          </a:fillRef>
-          <a:effectRef idx="2">
-            <a:schemeClr val="accent1"/>
-          </a:effectRef>
-          <a:fontRef idx="minor">
-            <a:schemeClr val="lt1"/>
-          </a:fontRef>
-        </p:style>
-        <p:txBody>
-          <a:bodyPr rtlCol="0" anchor="ctr"/>
-          <a:lstStyle/>
-          <a:p>
-            <a:pPr algn="ctr"/>
-          </a:p>
-        </p:txBody>
-      </p:sp>
-      <p:sp>
-        <p:nvSpPr>
-          <p:cNvPr id="20" name="TextBox 19"/>
-          <p:cNvSpPr txBox="1"/>
-          <p:nvPr/>
-        </p:nvSpPr>
-        <p:spPr>
-          <a:xfrm>
-            <a:off x="8915400" y="3026663"/>
-            <a:ext cx="868680" cy="246888"/>
-          </a:xfrm>
-          <a:prstGeom prst="rect">
-            <a:avLst/>
-          </a:prstGeom>
-          <a:noFill/>
-        </p:spPr>
-        <p:txBody>
-          <a:bodyPr wrap="square" anchor="ctr" lIns="0" rIns="0" tIns="0" bIns="0">
-            <a:spAutoFit/>
-          </a:bodyPr>
-          <a:lstStyle/>
-          <a:p>
-            <a:pPr algn="l">
-              <a:lnSpc>
-                <a:spcPct val="106000"/>
-              </a:lnSpc>
-              <a:spcBef>
-                <a:spcPts val="0"/>
-              </a:spcBef>
-              <a:spcAft>
-                <a:spcPts val="0"/>
-              </a:spcAft>
-            </a:pPr>
-            <a:r>
-              <a:rPr sz="1250" b="1" i="0">
-                <a:solidFill>
-                  <a:srgbClr val="B8860B"/>
-                </a:solidFill>
-                <a:latin typeface="Calibri"/>
-              </a:rPr>
-              <a:t>3</a:t>
-            </a:r>
-          </a:p>
-        </p:txBody>
-      </p:sp>
-      <p:sp>
-        <p:nvSpPr>
-          <p:cNvPr id="21" name="TextBox 20"/>
-          <p:cNvSpPr txBox="1"/>
-          <p:nvPr/>
-        </p:nvSpPr>
-        <p:spPr>
-          <a:xfrm>
-            <a:off x="685800" y="3314699"/>
-            <a:ext cx="2286000" cy="246888"/>
-          </a:xfrm>
-          <a:prstGeom prst="rect">
-            <a:avLst/>
-          </a:prstGeom>
-          <a:noFill/>
-        </p:spPr>
-        <p:txBody>
-          <a:bodyPr wrap="square" anchor="ctr" lIns="0" rIns="0" tIns="0" bIns="0">
-            <a:spAutoFit/>
-          </a:bodyPr>
-          <a:lstStyle/>
-          <a:p>
-            <a:pPr algn="r">
-              <a:lnSpc>
-                <a:spcPct val="106000"/>
-              </a:lnSpc>
-              <a:spcBef>
-                <a:spcPts val="0"/>
-              </a:spcBef>
-              <a:spcAft>
-                <a:spcPts val="0"/>
-              </a:spcAft>
-            </a:pPr>
-            <a:r>
-              <a:rPr sz="1250" b="1" i="0">
-                <a:solidFill>
-                  <a:srgbClr val="2B3038"/>
-                </a:solidFill>
-                <a:latin typeface="Calibri"/>
-              </a:rPr>
-              <a:t>Perdriel</a:t>
-            </a:r>
-          </a:p>
-        </p:txBody>
-      </p:sp>
-      <p:sp>
-        <p:nvSpPr>
-          <p:cNvPr id="22" name="Rounded Rectangle 21"/>
-          <p:cNvSpPr/>
-          <p:nvPr/>
-        </p:nvSpPr>
-        <p:spPr>
-          <a:xfrm>
-            <a:off x="3063240" y="3329699"/>
-            <a:ext cx="5779008" cy="216888"/>
-          </a:xfrm>
-          <a:prstGeom prst="roundRect">
-            <a:avLst>
-              <a:gd name="adj" fmla="val 35000"/>
-            </a:avLst>
-          </a:prstGeom>
-          <a:solidFill>
-            <a:srgbClr val="B8860B"/>
-          </a:solidFill>
-          <a:ln>
-            <a:noFill/>
-          </a:ln>
-          <a:effectLst/>
-        </p:spPr>
-        <p:style>
-          <a:lnRef idx="1">
-            <a:schemeClr val="accent1"/>
-          </a:lnRef>
-          <a:fillRef idx="3">
-            <a:schemeClr val="accent1"/>
-          </a:fillRef>
-          <a:effectRef idx="2">
-            <a:schemeClr val="accent1"/>
-          </a:effectRef>
-          <a:fontRef idx="minor">
-            <a:schemeClr val="lt1"/>
-          </a:fontRef>
-        </p:style>
-        <p:txBody>
-          <a:bodyPr rtlCol="0" anchor="ctr"/>
-          <a:lstStyle/>
-          <a:p>
-            <a:pPr algn="ctr"/>
-          </a:p>
-        </p:txBody>
-      </p:sp>
-      <p:sp>
-        <p:nvSpPr>
-          <p:cNvPr id="23" name="TextBox 22"/>
-          <p:cNvSpPr txBox="1"/>
-          <p:nvPr/>
-        </p:nvSpPr>
-        <p:spPr>
-          <a:xfrm>
-            <a:off x="8915400" y="3314699"/>
-            <a:ext cx="868680" cy="246888"/>
-          </a:xfrm>
-          <a:prstGeom prst="rect">
-            <a:avLst/>
-          </a:prstGeom>
-          <a:noFill/>
-        </p:spPr>
-        <p:txBody>
-          <a:bodyPr wrap="square" anchor="ctr" lIns="0" rIns="0" tIns="0" bIns="0">
-            <a:spAutoFit/>
-          </a:bodyPr>
-          <a:lstStyle/>
-          <a:p>
-            <a:pPr algn="l">
-              <a:lnSpc>
-                <a:spcPct val="106000"/>
-              </a:lnSpc>
-              <a:spcBef>
-                <a:spcPts val="0"/>
-              </a:spcBef>
-              <a:spcAft>
-                <a:spcPts val="0"/>
-              </a:spcAft>
-            </a:pPr>
-            <a:r>
-              <a:rPr sz="1250" b="1" i="0">
-                <a:solidFill>
-                  <a:srgbClr val="B8860B"/>
-                </a:solidFill>
-                <a:latin typeface="Calibri"/>
-              </a:rPr>
-              <a:t>3</a:t>
-            </a:r>
-          </a:p>
-        </p:txBody>
-      </p:sp>
-      <p:sp>
-        <p:nvSpPr>
-          <p:cNvPr id="24" name="TextBox 23"/>
-          <p:cNvSpPr txBox="1"/>
-          <p:nvPr/>
-        </p:nvSpPr>
-        <p:spPr>
-          <a:xfrm>
-            <a:off x="685800" y="3602735"/>
-            <a:ext cx="2286000" cy="246888"/>
-          </a:xfrm>
-          <a:prstGeom prst="rect">
-            <a:avLst/>
-          </a:prstGeom>
-          <a:noFill/>
-        </p:spPr>
-        <p:txBody>
-          <a:bodyPr wrap="square" anchor="ctr" lIns="0" rIns="0" tIns="0" bIns="0">
-            <a:spAutoFit/>
-          </a:bodyPr>
-          <a:lstStyle/>
-          <a:p>
-            <a:pPr algn="r">
-              <a:lnSpc>
-                <a:spcPct val="106000"/>
-              </a:lnSpc>
-              <a:spcBef>
-                <a:spcPts val="0"/>
-              </a:spcBef>
-              <a:spcAft>
-                <a:spcPts val="0"/>
-              </a:spcAft>
-            </a:pPr>
-            <a:r>
-              <a:rPr sz="1250" b="1" i="0">
-                <a:solidFill>
-                  <a:srgbClr val="2B3038"/>
-                </a:solidFill>
-                <a:latin typeface="Calibri"/>
-              </a:rPr>
-              <a:t>Potrerillos</a:t>
-            </a:r>
-          </a:p>
-        </p:txBody>
-      </p:sp>
-      <p:sp>
-        <p:nvSpPr>
-          <p:cNvPr id="25" name="Rounded Rectangle 24"/>
-          <p:cNvSpPr/>
-          <p:nvPr/>
-        </p:nvSpPr>
-        <p:spPr>
-          <a:xfrm>
-            <a:off x="3063240" y="3617735"/>
-            <a:ext cx="5779008" cy="216888"/>
-          </a:xfrm>
-          <a:prstGeom prst="roundRect">
-            <a:avLst>
-              <a:gd name="adj" fmla="val 35000"/>
-            </a:avLst>
-          </a:prstGeom>
-          <a:solidFill>
-            <a:srgbClr val="B8860B"/>
-          </a:solidFill>
-          <a:ln>
-            <a:noFill/>
-          </a:ln>
-          <a:effectLst/>
-        </p:spPr>
-        <p:style>
-          <a:lnRef idx="1">
-            <a:schemeClr val="accent1"/>
-          </a:lnRef>
-          <a:fillRef idx="3">
-            <a:schemeClr val="accent1"/>
-          </a:fillRef>
-          <a:effectRef idx="2">
-            <a:schemeClr val="accent1"/>
-          </a:effectRef>
-          <a:fontRef idx="minor">
-            <a:schemeClr val="lt1"/>
-          </a:fontRef>
-        </p:style>
-        <p:txBody>
-          <a:bodyPr rtlCol="0" anchor="ctr"/>
-          <a:lstStyle/>
-          <a:p>
-            <a:pPr algn="ctr"/>
-          </a:p>
-        </p:txBody>
-      </p:sp>
-      <p:sp>
-        <p:nvSpPr>
-          <p:cNvPr id="26" name="TextBox 25"/>
-          <p:cNvSpPr txBox="1"/>
-          <p:nvPr/>
-        </p:nvSpPr>
-        <p:spPr>
-          <a:xfrm>
-            <a:off x="8915400" y="3602735"/>
-            <a:ext cx="868680" cy="246888"/>
-          </a:xfrm>
-          <a:prstGeom prst="rect">
-            <a:avLst/>
-          </a:prstGeom>
-          <a:noFill/>
-        </p:spPr>
-        <p:txBody>
-          <a:bodyPr wrap="square" anchor="ctr" lIns="0" rIns="0" tIns="0" bIns="0">
-            <a:spAutoFit/>
-          </a:bodyPr>
-          <a:lstStyle/>
-          <a:p>
-            <a:pPr algn="l">
-              <a:lnSpc>
-                <a:spcPct val="106000"/>
-              </a:lnSpc>
-              <a:spcBef>
-                <a:spcPts val="0"/>
-              </a:spcBef>
-              <a:spcAft>
-                <a:spcPts val="0"/>
-              </a:spcAft>
-            </a:pPr>
-            <a:r>
-              <a:rPr sz="1250" b="1" i="0">
-                <a:solidFill>
-                  <a:srgbClr val="B8860B"/>
-                </a:solidFill>
-                <a:latin typeface="Calibri"/>
-              </a:rPr>
-              <a:t>3</a:t>
-            </a:r>
-          </a:p>
-        </p:txBody>
-      </p:sp>
-      <p:sp>
-        <p:nvSpPr>
-          <p:cNvPr id="27" name="TextBox 26"/>
-          <p:cNvSpPr txBox="1"/>
-          <p:nvPr/>
-        </p:nvSpPr>
-        <p:spPr>
-          <a:xfrm>
-            <a:off x="685800" y="3890771"/>
-            <a:ext cx="2286000" cy="246888"/>
-          </a:xfrm>
-          <a:prstGeom prst="rect">
-            <a:avLst/>
-          </a:prstGeom>
-          <a:noFill/>
-        </p:spPr>
-        <p:txBody>
-          <a:bodyPr wrap="square" anchor="ctr" lIns="0" rIns="0" tIns="0" bIns="0">
-            <a:spAutoFit/>
-          </a:bodyPr>
-          <a:lstStyle/>
-          <a:p>
-            <a:pPr algn="r">
-              <a:lnSpc>
-                <a:spcPct val="106000"/>
-              </a:lnSpc>
-              <a:spcBef>
-                <a:spcPts val="0"/>
-              </a:spcBef>
-              <a:spcAft>
-                <a:spcPts val="0"/>
-              </a:spcAft>
-            </a:pPr>
-            <a:r>
-              <a:rPr sz="1250" b="1" i="0">
-                <a:solidFill>
-                  <a:srgbClr val="2B3038"/>
-                </a:solidFill>
-                <a:latin typeface="Calibri"/>
-              </a:rPr>
-              <a:t>Carrodilla</a:t>
-            </a:r>
-          </a:p>
-        </p:txBody>
-      </p:sp>
-      <p:sp>
-        <p:nvSpPr>
-          <p:cNvPr id="28" name="Rounded Rectangle 27"/>
-          <p:cNvSpPr/>
-          <p:nvPr/>
-        </p:nvSpPr>
-        <p:spPr>
-          <a:xfrm>
-            <a:off x="3063240" y="3905771"/>
-            <a:ext cx="5417820" cy="216888"/>
-          </a:xfrm>
-          <a:prstGeom prst="roundRect">
-            <a:avLst>
-              <a:gd name="adj" fmla="val 35000"/>
-            </a:avLst>
-          </a:prstGeom>
-          <a:solidFill>
-            <a:srgbClr val="B8860B"/>
-          </a:solidFill>
-          <a:ln>
-            <a:noFill/>
-          </a:ln>
-          <a:effectLst/>
-        </p:spPr>
-        <p:style>
-          <a:lnRef idx="1">
-            <a:schemeClr val="accent1"/>
-          </a:lnRef>
-          <a:fillRef idx="3">
-            <a:schemeClr val="accent1"/>
-          </a:fillRef>
-          <a:effectRef idx="2">
-            <a:schemeClr val="accent1"/>
-          </a:effectRef>
-          <a:fontRef idx="minor">
-            <a:schemeClr val="lt1"/>
-          </a:fontRef>
-        </p:style>
-        <p:txBody>
-          <a:bodyPr rtlCol="0" anchor="ctr"/>
-          <a:lstStyle/>
-          <a:p>
-            <a:pPr algn="ctr"/>
-          </a:p>
-        </p:txBody>
-      </p:sp>
-      <p:sp>
-        <p:nvSpPr>
-          <p:cNvPr id="29" name="TextBox 28"/>
-          <p:cNvSpPr txBox="1"/>
-          <p:nvPr/>
-        </p:nvSpPr>
-        <p:spPr>
-          <a:xfrm>
-            <a:off x="8554212" y="3890771"/>
-            <a:ext cx="868680" cy="246888"/>
-          </a:xfrm>
-          <a:prstGeom prst="rect">
-            <a:avLst/>
-          </a:prstGeom>
-          <a:noFill/>
-        </p:spPr>
-        <p:txBody>
-          <a:bodyPr wrap="square" anchor="ctr" lIns="0" rIns="0" tIns="0" bIns="0">
-            <a:spAutoFit/>
-          </a:bodyPr>
-          <a:lstStyle/>
-          <a:p>
-            <a:pPr algn="l">
-              <a:lnSpc>
-                <a:spcPct val="106000"/>
-              </a:lnSpc>
-              <a:spcBef>
-                <a:spcPts val="0"/>
-              </a:spcBef>
-              <a:spcAft>
-                <a:spcPts val="0"/>
-              </a:spcAft>
-            </a:pPr>
-            <a:r>
-              <a:rPr sz="1250" b="1" i="0">
-                <a:solidFill>
-                  <a:srgbClr val="B8860B"/>
-                </a:solidFill>
-                <a:latin typeface="Calibri"/>
-              </a:rPr>
-              <a:t>3.5</a:t>
-            </a:r>
-          </a:p>
-        </p:txBody>
-      </p:sp>
-      <p:sp>
-        <p:nvSpPr>
-          <p:cNvPr id="30" name="TextBox 29"/>
-          <p:cNvSpPr txBox="1"/>
-          <p:nvPr/>
-        </p:nvSpPr>
-        <p:spPr>
-          <a:xfrm>
-            <a:off x="685800" y="4178807"/>
-            <a:ext cx="2286000" cy="246888"/>
-          </a:xfrm>
-          <a:prstGeom prst="rect">
-            <a:avLst/>
-          </a:prstGeom>
-          <a:noFill/>
-        </p:spPr>
-        <p:txBody>
-          <a:bodyPr wrap="square" anchor="ctr" lIns="0" rIns="0" tIns="0" bIns="0">
-            <a:spAutoFit/>
-          </a:bodyPr>
-          <a:lstStyle/>
-          <a:p>
-            <a:pPr algn="r">
-              <a:lnSpc>
-                <a:spcPct val="106000"/>
-              </a:lnSpc>
-              <a:spcBef>
-                <a:spcPts val="0"/>
-              </a:spcBef>
-              <a:spcAft>
-                <a:spcPts val="0"/>
-              </a:spcAft>
-            </a:pPr>
-            <a:r>
-              <a:rPr sz="1250" b="1" i="0">
-                <a:solidFill>
-                  <a:srgbClr val="2B3038"/>
-                </a:solidFill>
-                <a:latin typeface="Calibri"/>
-              </a:rPr>
-              <a:t>Agrelo</a:t>
-            </a:r>
-          </a:p>
-        </p:txBody>
-      </p:sp>
-      <p:sp>
-        <p:nvSpPr>
-          <p:cNvPr id="31" name="Rounded Rectangle 30"/>
-          <p:cNvSpPr/>
-          <p:nvPr/>
-        </p:nvSpPr>
-        <p:spPr>
-          <a:xfrm>
-            <a:off x="3063240" y="4193807"/>
-            <a:ext cx="5417820" cy="216888"/>
-          </a:xfrm>
-          <a:prstGeom prst="roundRect">
-            <a:avLst>
-              <a:gd name="adj" fmla="val 35000"/>
-            </a:avLst>
-          </a:prstGeom>
-          <a:solidFill>
-            <a:srgbClr val="B8860B"/>
-          </a:solidFill>
-          <a:ln>
-            <a:noFill/>
-          </a:ln>
-          <a:effectLst/>
-        </p:spPr>
-        <p:style>
-          <a:lnRef idx="1">
-            <a:schemeClr val="accent1"/>
-          </a:lnRef>
-          <a:fillRef idx="3">
-            <a:schemeClr val="accent1"/>
-          </a:fillRef>
-          <a:effectRef idx="2">
-            <a:schemeClr val="accent1"/>
-          </a:effectRef>
-          <a:fontRef idx="minor">
-            <a:schemeClr val="lt1"/>
-          </a:fontRef>
-        </p:style>
-        <p:txBody>
-          <a:bodyPr rtlCol="0" anchor="ctr"/>
-          <a:lstStyle/>
-          <a:p>
-            <a:pPr algn="ctr"/>
-          </a:p>
-        </p:txBody>
-      </p:sp>
-      <p:sp>
-        <p:nvSpPr>
-          <p:cNvPr id="32" name="TextBox 31"/>
-          <p:cNvSpPr txBox="1"/>
-          <p:nvPr/>
-        </p:nvSpPr>
-        <p:spPr>
-          <a:xfrm>
-            <a:off x="8554212" y="4178807"/>
-            <a:ext cx="868680" cy="246888"/>
-          </a:xfrm>
-          <a:prstGeom prst="rect">
-            <a:avLst/>
-          </a:prstGeom>
-          <a:noFill/>
-        </p:spPr>
-        <p:txBody>
-          <a:bodyPr wrap="square" anchor="ctr" lIns="0" rIns="0" tIns="0" bIns="0">
-            <a:spAutoFit/>
-          </a:bodyPr>
-          <a:lstStyle/>
-          <a:p>
-            <a:pPr algn="l">
-              <a:lnSpc>
-                <a:spcPct val="106000"/>
-              </a:lnSpc>
-              <a:spcBef>
-                <a:spcPts val="0"/>
-              </a:spcBef>
-              <a:spcAft>
-                <a:spcPts val="0"/>
-              </a:spcAft>
-            </a:pPr>
-            <a:r>
-              <a:rPr sz="1250" b="1" i="0">
-                <a:solidFill>
-                  <a:srgbClr val="B8860B"/>
-                </a:solidFill>
-                <a:latin typeface="Calibri"/>
-              </a:rPr>
-              <a:t>3.5</a:t>
-            </a:r>
-          </a:p>
-        </p:txBody>
-      </p:sp>
-      <p:sp>
-        <p:nvSpPr>
-          <p:cNvPr id="33" name="TextBox 32"/>
-          <p:cNvSpPr txBox="1"/>
-          <p:nvPr/>
-        </p:nvSpPr>
-        <p:spPr>
-          <a:xfrm>
-            <a:off x="685800" y="4466843"/>
-            <a:ext cx="2286000" cy="246888"/>
-          </a:xfrm>
-          <a:prstGeom prst="rect">
-            <a:avLst/>
-          </a:prstGeom>
-          <a:noFill/>
-        </p:spPr>
-        <p:txBody>
-          <a:bodyPr wrap="square" anchor="ctr" lIns="0" rIns="0" tIns="0" bIns="0">
-            <a:spAutoFit/>
-          </a:bodyPr>
-          <a:lstStyle/>
-          <a:p>
-            <a:pPr algn="r">
-              <a:lnSpc>
-                <a:spcPct val="106000"/>
-              </a:lnSpc>
-              <a:spcBef>
-                <a:spcPts val="0"/>
-              </a:spcBef>
-              <a:spcAft>
-                <a:spcPts val="0"/>
-              </a:spcAft>
-            </a:pPr>
-            <a:r>
-              <a:rPr sz="1250" b="1" i="0">
-                <a:solidFill>
-                  <a:srgbClr val="2B3038"/>
-                </a:solidFill>
-                <a:latin typeface="Calibri"/>
-              </a:rPr>
-              <a:t>Ugarteche</a:t>
-            </a:r>
-          </a:p>
-        </p:txBody>
-      </p:sp>
-      <p:sp>
-        <p:nvSpPr>
-          <p:cNvPr id="34" name="Rounded Rectangle 33"/>
-          <p:cNvSpPr/>
-          <p:nvPr/>
-        </p:nvSpPr>
-        <p:spPr>
-          <a:xfrm>
-            <a:off x="3063240" y="4481843"/>
-            <a:ext cx="5417820" cy="216888"/>
-          </a:xfrm>
-          <a:prstGeom prst="roundRect">
-            <a:avLst>
-              <a:gd name="adj" fmla="val 35000"/>
-            </a:avLst>
-          </a:prstGeom>
-          <a:solidFill>
-            <a:srgbClr val="B8860B"/>
-          </a:solidFill>
-          <a:ln>
-            <a:noFill/>
-          </a:ln>
-          <a:effectLst/>
-        </p:spPr>
-        <p:style>
-          <a:lnRef idx="1">
-            <a:schemeClr val="accent1"/>
-          </a:lnRef>
-          <a:fillRef idx="3">
-            <a:schemeClr val="accent1"/>
-          </a:fillRef>
-          <a:effectRef idx="2">
-            <a:schemeClr val="accent1"/>
-          </a:effectRef>
-          <a:fontRef idx="minor">
-            <a:schemeClr val="lt1"/>
-          </a:fontRef>
-        </p:style>
-        <p:txBody>
-          <a:bodyPr rtlCol="0" anchor="ctr"/>
-          <a:lstStyle/>
-          <a:p>
-            <a:pPr algn="ctr"/>
-          </a:p>
-        </p:txBody>
-      </p:sp>
-      <p:sp>
-        <p:nvSpPr>
-          <p:cNvPr id="35" name="TextBox 34"/>
-          <p:cNvSpPr txBox="1"/>
-          <p:nvPr/>
-        </p:nvSpPr>
-        <p:spPr>
-          <a:xfrm>
-            <a:off x="8554212" y="4466843"/>
-            <a:ext cx="868680" cy="246888"/>
-          </a:xfrm>
-          <a:prstGeom prst="rect">
-            <a:avLst/>
-          </a:prstGeom>
-          <a:noFill/>
-        </p:spPr>
-        <p:txBody>
-          <a:bodyPr wrap="square" anchor="ctr" lIns="0" rIns="0" tIns="0" bIns="0">
-            <a:spAutoFit/>
-          </a:bodyPr>
-          <a:lstStyle/>
-          <a:p>
-            <a:pPr algn="l">
-              <a:lnSpc>
-                <a:spcPct val="106000"/>
-              </a:lnSpc>
-              <a:spcBef>
-                <a:spcPts val="0"/>
-              </a:spcBef>
-              <a:spcAft>
-                <a:spcPts val="0"/>
-              </a:spcAft>
-            </a:pPr>
-            <a:r>
-              <a:rPr sz="1250" b="1" i="0">
-                <a:solidFill>
-                  <a:srgbClr val="B8860B"/>
-                </a:solidFill>
-                <a:latin typeface="Calibri"/>
-              </a:rPr>
-              <a:t>3.5</a:t>
-            </a:r>
-          </a:p>
-        </p:txBody>
-      </p:sp>
-      <p:sp>
-        <p:nvSpPr>
-          <p:cNvPr id="36" name="TextBox 35"/>
-          <p:cNvSpPr txBox="1"/>
-          <p:nvPr/>
-        </p:nvSpPr>
-        <p:spPr>
-          <a:xfrm>
-            <a:off x="685800" y="4754879"/>
-            <a:ext cx="2286000" cy="246888"/>
-          </a:xfrm>
-          <a:prstGeom prst="rect">
-            <a:avLst/>
-          </a:prstGeom>
-          <a:noFill/>
-        </p:spPr>
-        <p:txBody>
-          <a:bodyPr wrap="square" anchor="ctr" lIns="0" rIns="0" tIns="0" bIns="0">
-            <a:spAutoFit/>
-          </a:bodyPr>
-          <a:lstStyle/>
-          <a:p>
-            <a:pPr algn="r">
-              <a:lnSpc>
-                <a:spcPct val="106000"/>
-              </a:lnSpc>
-              <a:spcBef>
-                <a:spcPts val="0"/>
-              </a:spcBef>
-              <a:spcAft>
-                <a:spcPts val="0"/>
-              </a:spcAft>
-            </a:pPr>
-            <a:r>
-              <a:rPr sz="1250" b="1" i="0">
-                <a:solidFill>
-                  <a:srgbClr val="2B3038"/>
-                </a:solidFill>
-                <a:latin typeface="Calibri"/>
-              </a:rPr>
-              <a:t>Chacras de Coria</a:t>
-            </a:r>
-          </a:p>
-        </p:txBody>
-      </p:sp>
-      <p:sp>
-        <p:nvSpPr>
-          <p:cNvPr id="37" name="Rounded Rectangle 36"/>
-          <p:cNvSpPr/>
-          <p:nvPr/>
-        </p:nvSpPr>
-        <p:spPr>
-          <a:xfrm>
-            <a:off x="3063240" y="4769879"/>
-            <a:ext cx="5056632" cy="216888"/>
-          </a:xfrm>
-          <a:prstGeom prst="roundRect">
-            <a:avLst>
-              <a:gd name="adj" fmla="val 35000"/>
-            </a:avLst>
-          </a:prstGeom>
-          <a:solidFill>
-            <a:srgbClr val="B8860B"/>
-          </a:solidFill>
-          <a:ln>
-            <a:noFill/>
-          </a:ln>
-          <a:effectLst/>
-        </p:spPr>
-        <p:style>
-          <a:lnRef idx="1">
-            <a:schemeClr val="accent1"/>
-          </a:lnRef>
-          <a:fillRef idx="3">
-            <a:schemeClr val="accent1"/>
-          </a:fillRef>
-          <a:effectRef idx="2">
-            <a:schemeClr val="accent1"/>
-          </a:effectRef>
-          <a:fontRef idx="minor">
-            <a:schemeClr val="lt1"/>
-          </a:fontRef>
-        </p:style>
-        <p:txBody>
-          <a:bodyPr rtlCol="0" anchor="ctr"/>
-          <a:lstStyle/>
-          <a:p>
-            <a:pPr algn="ctr"/>
-          </a:p>
-        </p:txBody>
-      </p:sp>
-      <p:sp>
-        <p:nvSpPr>
-          <p:cNvPr id="38" name="TextBox 37"/>
-          <p:cNvSpPr txBox="1"/>
-          <p:nvPr/>
-        </p:nvSpPr>
-        <p:spPr>
-          <a:xfrm>
-            <a:off x="8193024" y="4754879"/>
-            <a:ext cx="868680" cy="246888"/>
-          </a:xfrm>
-          <a:prstGeom prst="rect">
-            <a:avLst/>
-          </a:prstGeom>
-          <a:noFill/>
-        </p:spPr>
-        <p:txBody>
-          <a:bodyPr wrap="square" anchor="ctr" lIns="0" rIns="0" tIns="0" bIns="0">
-            <a:spAutoFit/>
-          </a:bodyPr>
-          <a:lstStyle/>
-          <a:p>
-            <a:pPr algn="l">
-              <a:lnSpc>
-                <a:spcPct val="106000"/>
-              </a:lnSpc>
-              <a:spcBef>
-                <a:spcPts val="0"/>
-              </a:spcBef>
-              <a:spcAft>
-                <a:spcPts val="0"/>
-              </a:spcAft>
-            </a:pPr>
-            <a:r>
-              <a:rPr sz="1250" b="1" i="0">
-                <a:solidFill>
-                  <a:srgbClr val="B8860B"/>
-                </a:solidFill>
-                <a:latin typeface="Calibri"/>
-              </a:rPr>
-              <a:t>4</a:t>
-            </a:r>
-          </a:p>
-        </p:txBody>
-      </p:sp>
-      <p:sp>
-        <p:nvSpPr>
-          <p:cNvPr id="39" name="TextBox 38"/>
-          <p:cNvSpPr txBox="1"/>
-          <p:nvPr/>
-        </p:nvSpPr>
-        <p:spPr>
-          <a:xfrm>
-            <a:off x="685800" y="5042915"/>
-            <a:ext cx="2286000" cy="246888"/>
-          </a:xfrm>
-          <a:prstGeom prst="rect">
-            <a:avLst/>
-          </a:prstGeom>
-          <a:noFill/>
-        </p:spPr>
-        <p:txBody>
-          <a:bodyPr wrap="square" anchor="ctr" lIns="0" rIns="0" tIns="0" bIns="0">
-            <a:spAutoFit/>
-          </a:bodyPr>
-          <a:lstStyle/>
-          <a:p>
-            <a:pPr algn="r">
-              <a:lnSpc>
-                <a:spcPct val="106000"/>
-              </a:lnSpc>
-              <a:spcBef>
-                <a:spcPts val="0"/>
-              </a:spcBef>
-              <a:spcAft>
-                <a:spcPts val="0"/>
-              </a:spcAft>
-            </a:pPr>
-            <a:r>
-              <a:rPr sz="1250" b="1" i="0">
-                <a:solidFill>
-                  <a:srgbClr val="2B3038"/>
-                </a:solidFill>
-                <a:latin typeface="Calibri"/>
-              </a:rPr>
-              <a:t>Vistalba</a:t>
-            </a:r>
-          </a:p>
-        </p:txBody>
-      </p:sp>
-      <p:sp>
-        <p:nvSpPr>
-          <p:cNvPr id="40" name="Rounded Rectangle 39"/>
-          <p:cNvSpPr/>
-          <p:nvPr/>
-        </p:nvSpPr>
-        <p:spPr>
-          <a:xfrm>
-            <a:off x="3063240" y="5057915"/>
-            <a:ext cx="4695444" cy="216888"/>
-          </a:xfrm>
-          <a:prstGeom prst="roundRect">
-            <a:avLst>
-              <a:gd name="adj" fmla="val 35000"/>
-            </a:avLst>
-          </a:prstGeom>
-          <a:solidFill>
-            <a:srgbClr val="B8860B"/>
-          </a:solidFill>
-          <a:ln>
-            <a:noFill/>
-          </a:ln>
-          <a:effectLst/>
-        </p:spPr>
-        <p:style>
-          <a:lnRef idx="1">
-            <a:schemeClr val="accent1"/>
-          </a:lnRef>
-          <a:fillRef idx="3">
-            <a:schemeClr val="accent1"/>
-          </a:fillRef>
-          <a:effectRef idx="2">
-            <a:schemeClr val="accent1"/>
-          </a:effectRef>
-          <a:fontRef idx="minor">
-            <a:schemeClr val="lt1"/>
-          </a:fontRef>
-        </p:style>
-        <p:txBody>
-          <a:bodyPr rtlCol="0" anchor="ctr"/>
-          <a:lstStyle/>
-          <a:p>
-            <a:pPr algn="ctr"/>
-          </a:p>
-        </p:txBody>
-      </p:sp>
-      <p:sp>
-        <p:nvSpPr>
-          <p:cNvPr id="41" name="TextBox 40"/>
-          <p:cNvSpPr txBox="1"/>
-          <p:nvPr/>
-        </p:nvSpPr>
-        <p:spPr>
-          <a:xfrm>
-            <a:off x="7831836" y="5042915"/>
-            <a:ext cx="868680" cy="246888"/>
-          </a:xfrm>
-          <a:prstGeom prst="rect">
-            <a:avLst/>
-          </a:prstGeom>
-          <a:noFill/>
-        </p:spPr>
-        <p:txBody>
-          <a:bodyPr wrap="square" anchor="ctr" lIns="0" rIns="0" tIns="0" bIns="0">
-            <a:spAutoFit/>
-          </a:bodyPr>
-          <a:lstStyle/>
-          <a:p>
-            <a:pPr algn="l">
-              <a:lnSpc>
-                <a:spcPct val="106000"/>
-              </a:lnSpc>
-              <a:spcBef>
-                <a:spcPts val="0"/>
-              </a:spcBef>
-              <a:spcAft>
-                <a:spcPts val="0"/>
-              </a:spcAft>
-            </a:pPr>
-            <a:r>
-              <a:rPr sz="1250" b="1" i="0">
-                <a:solidFill>
-                  <a:srgbClr val="B8860B"/>
-                </a:solidFill>
-                <a:latin typeface="Calibri"/>
-              </a:rPr>
-              <a:t>4.5</a:t>
-            </a:r>
-          </a:p>
-        </p:txBody>
-      </p:sp>
-      <p:sp>
-        <p:nvSpPr>
-          <p:cNvPr id="42" name="TextBox 41"/>
-          <p:cNvSpPr txBox="1"/>
-          <p:nvPr/>
-        </p:nvSpPr>
-        <p:spPr>
-          <a:xfrm>
-            <a:off x="685800" y="5330951"/>
-            <a:ext cx="2286000" cy="246888"/>
-          </a:xfrm>
-          <a:prstGeom prst="rect">
-            <a:avLst/>
-          </a:prstGeom>
-          <a:noFill/>
-        </p:spPr>
-        <p:txBody>
-          <a:bodyPr wrap="square" anchor="ctr" lIns="0" rIns="0" tIns="0" bIns="0">
-            <a:spAutoFit/>
-          </a:bodyPr>
-          <a:lstStyle/>
-          <a:p>
-            <a:pPr algn="r">
-              <a:lnSpc>
-                <a:spcPct val="106000"/>
-              </a:lnSpc>
-              <a:spcBef>
-                <a:spcPts val="0"/>
-              </a:spcBef>
-              <a:spcAft>
-                <a:spcPts val="0"/>
-              </a:spcAft>
-            </a:pPr>
-            <a:r>
-              <a:rPr sz="1250" b="1" i="0">
-                <a:solidFill>
-                  <a:srgbClr val="2B3038"/>
-                </a:solidFill>
-                <a:latin typeface="Calibri"/>
-              </a:rPr>
-              <a:t>Mayor Drummond</a:t>
-            </a:r>
-          </a:p>
-        </p:txBody>
-      </p:sp>
-      <p:sp>
-        <p:nvSpPr>
-          <p:cNvPr id="43" name="Rounded Rectangle 42"/>
-          <p:cNvSpPr/>
-          <p:nvPr/>
-        </p:nvSpPr>
-        <p:spPr>
-          <a:xfrm>
-            <a:off x="3063240" y="5345951"/>
-            <a:ext cx="4695444" cy="216888"/>
-          </a:xfrm>
-          <a:prstGeom prst="roundRect">
-            <a:avLst>
-              <a:gd name="adj" fmla="val 35000"/>
-            </a:avLst>
-          </a:prstGeom>
-          <a:solidFill>
-            <a:srgbClr val="B8860B"/>
-          </a:solidFill>
-          <a:ln>
-            <a:noFill/>
-          </a:ln>
-          <a:effectLst/>
-        </p:spPr>
-        <p:style>
-          <a:lnRef idx="1">
-            <a:schemeClr val="accent1"/>
-          </a:lnRef>
-          <a:fillRef idx="3">
-            <a:schemeClr val="accent1"/>
-          </a:fillRef>
-          <a:effectRef idx="2">
-            <a:schemeClr val="accent1"/>
-          </a:effectRef>
-          <a:fontRef idx="minor">
-            <a:schemeClr val="lt1"/>
-          </a:fontRef>
-        </p:style>
-        <p:txBody>
-          <a:bodyPr rtlCol="0" anchor="ctr"/>
-          <a:lstStyle/>
-          <a:p>
-            <a:pPr algn="ctr"/>
-          </a:p>
-        </p:txBody>
-      </p:sp>
-      <p:sp>
-        <p:nvSpPr>
-          <p:cNvPr id="44" name="TextBox 43"/>
-          <p:cNvSpPr txBox="1"/>
-          <p:nvPr/>
-        </p:nvSpPr>
-        <p:spPr>
-          <a:xfrm>
-            <a:off x="7831836" y="5330951"/>
-            <a:ext cx="868680" cy="246888"/>
-          </a:xfrm>
-          <a:prstGeom prst="rect">
-            <a:avLst/>
-          </a:prstGeom>
-          <a:noFill/>
-        </p:spPr>
-        <p:txBody>
-          <a:bodyPr wrap="square" anchor="ctr" lIns="0" rIns="0" tIns="0" bIns="0">
-            <a:spAutoFit/>
-          </a:bodyPr>
-          <a:lstStyle/>
-          <a:p>
-            <a:pPr algn="l">
-              <a:lnSpc>
-                <a:spcPct val="106000"/>
-              </a:lnSpc>
-              <a:spcBef>
-                <a:spcPts val="0"/>
-              </a:spcBef>
-              <a:spcAft>
-                <a:spcPts val="0"/>
-              </a:spcAft>
-            </a:pPr>
-            <a:r>
-              <a:rPr sz="1250" b="1" i="0">
-                <a:solidFill>
-                  <a:srgbClr val="B8860B"/>
-                </a:solidFill>
-                <a:latin typeface="Calibri"/>
-              </a:rPr>
-              <a:t>4.5</a:t>
-            </a:r>
-          </a:p>
-        </p:txBody>
-      </p:sp>
-      <p:sp>
-        <p:nvSpPr>
-          <p:cNvPr id="45" name="TextBox 44"/>
-          <p:cNvSpPr txBox="1"/>
-          <p:nvPr/>
-        </p:nvSpPr>
-        <p:spPr>
-          <a:xfrm>
-            <a:off x="685800" y="5618987"/>
-            <a:ext cx="2286000" cy="246888"/>
-          </a:xfrm>
-          <a:prstGeom prst="rect">
-            <a:avLst/>
-          </a:prstGeom>
-          <a:noFill/>
-        </p:spPr>
-        <p:txBody>
-          <a:bodyPr wrap="square" anchor="ctr" lIns="0" rIns="0" tIns="0" bIns="0">
-            <a:spAutoFit/>
-          </a:bodyPr>
-          <a:lstStyle/>
-          <a:p>
-            <a:pPr algn="r">
-              <a:lnSpc>
-                <a:spcPct val="106000"/>
-              </a:lnSpc>
-              <a:spcBef>
-                <a:spcPts val="0"/>
-              </a:spcBef>
-              <a:spcAft>
-                <a:spcPts val="0"/>
-              </a:spcAft>
-            </a:pPr>
-            <a:r>
-              <a:rPr sz="1250" b="1" i="0">
-                <a:solidFill>
-                  <a:srgbClr val="2B3038"/>
-                </a:solidFill>
-                <a:latin typeface="Calibri"/>
-              </a:rPr>
-              <a:t>La Puntilla</a:t>
-            </a:r>
-          </a:p>
-        </p:txBody>
-      </p:sp>
-      <p:sp>
-        <p:nvSpPr>
-          <p:cNvPr id="46" name="Rounded Rectangle 45"/>
-          <p:cNvSpPr/>
-          <p:nvPr/>
-        </p:nvSpPr>
-        <p:spPr>
-          <a:xfrm>
-            <a:off x="3063240" y="5633987"/>
-            <a:ext cx="3611880" cy="216888"/>
-          </a:xfrm>
-          <a:prstGeom prst="roundRect">
-            <a:avLst>
-              <a:gd name="adj" fmla="val 35000"/>
-            </a:avLst>
-          </a:prstGeom>
-          <a:solidFill>
-            <a:srgbClr val="5A8F6B"/>
-          </a:solidFill>
-          <a:ln>
-            <a:noFill/>
-          </a:ln>
-          <a:effectLst/>
-        </p:spPr>
-        <p:style>
-          <a:lnRef idx="1">
-            <a:schemeClr val="accent1"/>
-          </a:lnRef>
-          <a:fillRef idx="3">
-            <a:schemeClr val="accent1"/>
-          </a:fillRef>
-          <a:effectRef idx="2">
-            <a:schemeClr val="accent1"/>
-          </a:effectRef>
-          <a:fontRef idx="minor">
-            <a:schemeClr val="lt1"/>
-          </a:fontRef>
-        </p:style>
-        <p:txBody>
-          <a:bodyPr rtlCol="0" anchor="ctr"/>
-          <a:lstStyle/>
-          <a:p>
-            <a:pPr algn="ctr"/>
-          </a:p>
-        </p:txBody>
-      </p:sp>
-      <p:sp>
-        <p:nvSpPr>
-          <p:cNvPr id="47" name="TextBox 46"/>
-          <p:cNvSpPr txBox="1"/>
-          <p:nvPr/>
-        </p:nvSpPr>
-        <p:spPr>
-          <a:xfrm>
-            <a:off x="6748272" y="5618987"/>
-            <a:ext cx="868680" cy="246888"/>
-          </a:xfrm>
-          <a:prstGeom prst="rect">
-            <a:avLst/>
-          </a:prstGeom>
-          <a:noFill/>
-        </p:spPr>
-        <p:txBody>
-          <a:bodyPr wrap="square" anchor="ctr" lIns="0" rIns="0" tIns="0" bIns="0">
-            <a:spAutoFit/>
-          </a:bodyPr>
-          <a:lstStyle/>
-          <a:p>
-            <a:pPr algn="l">
-              <a:lnSpc>
-                <a:spcPct val="106000"/>
-              </a:lnSpc>
-              <a:spcBef>
-                <a:spcPts val="0"/>
-              </a:spcBef>
-              <a:spcAft>
-                <a:spcPts val="0"/>
-              </a:spcAft>
-            </a:pPr>
-            <a:r>
-              <a:rPr sz="1250" b="1" i="0">
-                <a:solidFill>
-                  <a:srgbClr val="5A8F6B"/>
-                </a:solidFill>
-                <a:latin typeface="Calibri"/>
-              </a:rPr>
-              <a:t>6</a:t>
-            </a:r>
-          </a:p>
-        </p:txBody>
-      </p:sp>
-      <p:sp>
-        <p:nvSpPr>
-          <p:cNvPr id="48" name="TextBox 47"/>
-          <p:cNvSpPr txBox="1"/>
-          <p:nvPr/>
-        </p:nvSpPr>
-        <p:spPr>
-          <a:xfrm>
-            <a:off x="685800" y="5907023"/>
-            <a:ext cx="2286000" cy="246888"/>
-          </a:xfrm>
-          <a:prstGeom prst="rect">
-            <a:avLst/>
-          </a:prstGeom>
-          <a:noFill/>
-        </p:spPr>
-        <p:txBody>
-          <a:bodyPr wrap="square" anchor="ctr" lIns="0" rIns="0" tIns="0" bIns="0">
-            <a:spAutoFit/>
-          </a:bodyPr>
-          <a:lstStyle/>
-          <a:p>
-            <a:pPr algn="r">
-              <a:lnSpc>
-                <a:spcPct val="106000"/>
-              </a:lnSpc>
-              <a:spcBef>
-                <a:spcPts val="0"/>
-              </a:spcBef>
-              <a:spcAft>
-                <a:spcPts val="0"/>
-              </a:spcAft>
-            </a:pPr>
-            <a:r>
-              <a:rPr sz="1250" b="1" i="0">
-                <a:solidFill>
-                  <a:srgbClr val="2B3038"/>
-                </a:solidFill>
-                <a:latin typeface="Calibri"/>
-              </a:rPr>
-              <a:t>Ciudad</a:t>
-            </a:r>
-          </a:p>
-        </p:txBody>
-      </p:sp>
-      <p:sp>
-        <p:nvSpPr>
-          <p:cNvPr id="49" name="Rounded Rectangle 48"/>
-          <p:cNvSpPr/>
-          <p:nvPr/>
-        </p:nvSpPr>
-        <p:spPr>
-          <a:xfrm>
-            <a:off x="3063240" y="5922023"/>
-            <a:ext cx="2889504" cy="216888"/>
-          </a:xfrm>
-          <a:prstGeom prst="roundRect">
-            <a:avLst>
-              <a:gd name="adj" fmla="val 35000"/>
-            </a:avLst>
-          </a:prstGeom>
-          <a:solidFill>
-            <a:srgbClr val="5A8F6B"/>
-          </a:solidFill>
-          <a:ln>
-            <a:noFill/>
-          </a:ln>
-          <a:effectLst/>
-        </p:spPr>
-        <p:style>
-          <a:lnRef idx="1">
-            <a:schemeClr val="accent1"/>
-          </a:lnRef>
-          <a:fillRef idx="3">
-            <a:schemeClr val="accent1"/>
-          </a:fillRef>
-          <a:effectRef idx="2">
-            <a:schemeClr val="accent1"/>
-          </a:effectRef>
-          <a:fontRef idx="minor">
-            <a:schemeClr val="lt1"/>
-          </a:fontRef>
-        </p:style>
-        <p:txBody>
-          <a:bodyPr rtlCol="0" anchor="ctr"/>
-          <a:lstStyle/>
-          <a:p>
-            <a:pPr algn="ctr"/>
-          </a:p>
-        </p:txBody>
-      </p:sp>
-      <p:sp>
-        <p:nvSpPr>
-          <p:cNvPr id="50" name="TextBox 49"/>
-          <p:cNvSpPr txBox="1"/>
-          <p:nvPr/>
-        </p:nvSpPr>
-        <p:spPr>
-          <a:xfrm>
-            <a:off x="6025896" y="5907023"/>
-            <a:ext cx="868680" cy="246888"/>
-          </a:xfrm>
-          <a:prstGeom prst="rect">
-            <a:avLst/>
-          </a:prstGeom>
-          <a:noFill/>
-        </p:spPr>
-        <p:txBody>
-          <a:bodyPr wrap="square" anchor="ctr" lIns="0" rIns="0" tIns="0" bIns="0">
-            <a:spAutoFit/>
-          </a:bodyPr>
-          <a:lstStyle/>
-          <a:p>
-            <a:pPr algn="l">
-              <a:lnSpc>
-                <a:spcPct val="106000"/>
-              </a:lnSpc>
-              <a:spcBef>
-                <a:spcPts val="0"/>
-              </a:spcBef>
-              <a:spcAft>
-                <a:spcPts val="0"/>
-              </a:spcAft>
-            </a:pPr>
-            <a:r>
-              <a:rPr sz="1250" b="1" i="0">
-                <a:solidFill>
-                  <a:srgbClr val="5A8F6B"/>
-                </a:solidFill>
-                <a:latin typeface="Calibri"/>
-              </a:rPr>
-              <a:t>7</a:t>
+              <a:t>1</a:t>
             </a:r>
           </a:p>
         </p:txBody>
@@ -25149,7 +25149,7 @@
                 </a:solidFill>
                 <a:latin typeface="Calibri"/>
               </a:rPr>
-              <a:t>n = puntaje ICD /11</a:t>
+              <a:t>Puntaje ICD /11</a:t>
             </a:r>
           </a:p>
           <a:p>
@@ -25260,7 +25260,7 @@
                 </a:solidFill>
                 <a:latin typeface="Calibri"/>
               </a:rPr>
-              <a:t>Barra = </a:t>
+              <a:t>Menor puntaje = </a:t>
             </a:r>
             <a:r>
               <a:rPr sz="1500" b="1" i="0">
@@ -25269,7 +25269,7 @@
                 </a:solidFill>
                 <a:latin typeface="Calibri"/>
               </a:rPr>
-              <a:t>prioridad</a:t>
+              <a:t>mayor prioridad</a:t>
             </a:r>
             <a:r>
               <a:rPr sz="1500" b="0" i="0">
@@ -25278,7 +25278,7 @@
                 </a:solidFill>
                 <a:latin typeface="Calibri"/>
               </a:rPr>
-              <a:t> (mayor brecha, primero).</a:t>
+              <a:t> de inversión.</a:t>
             </a:r>
           </a:p>
           <a:p>

</xml_diff>

<commit_message>
Rediseño de portada con identidad UTDT Escuela de Gobierno / CIPUV
Nueva carátula: fondo blanco, verde manzana, negro y gris. Encabezado
institucional (UTDT · Escuela de Gobierno / CIPUV), título en negro con
subtítulo verde manzana, chips negro/gris/verde y pie de cátedra + Lincoln.
Aplicado en PPTX y HTML.

Co-Authored-By: Claude Opus 4.8 <noreply@anthropic.com>
Claude-Session: https://claude.ai/code/session_01QZiauNhtTVEiLX1MmVDGUu
</commit_message>
<xml_diff>
--- a/presentations/lujan-de-cuyo-gestion-suelo.pptx
+++ b/presentations/lujan-de-cuyo-gestion-suelo.pptx
@@ -5634,7 +5634,7 @@
     <p:bg>
       <p:bgPr>
         <a:solidFill>
-          <a:srgbClr val="3A4250"/>
+          <a:srgbClr val="FFFFFF"/>
         </a:solidFill>
         <a:effectLst/>
       </p:bgPr>
@@ -5655,13 +5655,13 @@
         <p:spPr>
           <a:xfrm>
             <a:off x="0" y="0"/>
-            <a:ext cx="292608" cy="6858000"/>
+            <a:ext cx="256032" cy="6858000"/>
           </a:xfrm>
           <a:prstGeom prst="rect">
             <a:avLst/>
           </a:prstGeom>
           <a:solidFill>
-            <a:srgbClr val="B8860B"/>
+            <a:srgbClr val="8CC63F"/>
           </a:solidFill>
           <a:ln>
             <a:noFill/>
@@ -5692,20 +5692,128 @@
       </p:sp>
       <p:sp>
         <p:nvSpPr>
-          <p:cNvPr id="3" name="Rectangle 2"/>
+          <p:cNvPr id="3" name="TextBox 2"/>
+          <p:cNvSpPr txBox="1"/>
+          <p:nvPr/>
+        </p:nvSpPr>
+        <p:spPr>
+          <a:xfrm>
+            <a:off x="868680" y="640080"/>
+            <a:ext cx="10607040" cy="365760"/>
+          </a:xfrm>
+          <a:prstGeom prst="rect">
+            <a:avLst/>
+          </a:prstGeom>
+          <a:noFill/>
+        </p:spPr>
+        <p:txBody>
+          <a:bodyPr wrap="square" anchor="t" lIns="0" rIns="0" tIns="0" bIns="0">
+            <a:spAutoFit/>
+          </a:bodyPr>
+          <a:lstStyle/>
+          <a:p>
+            <a:pPr algn="l">
+              <a:lnSpc>
+                <a:spcPct val="106000"/>
+              </a:lnSpc>
+              <a:spcBef>
+                <a:spcPts val="0"/>
+              </a:spcBef>
+              <a:spcAft>
+                <a:spcPts val="0"/>
+              </a:spcAft>
+            </a:pPr>
+            <a:r>
+              <a:rPr sz="1500" b="1" i="0">
+                <a:solidFill>
+                  <a:srgbClr val="1A1A1A"/>
+                </a:solidFill>
+                <a:latin typeface="Calibri"/>
+              </a:rPr>
+              <a:t>UNIVERSIDAD TORCUATO DI TELLA</a:t>
+            </a:r>
+            <a:r>
+              <a:rPr sz="1500" b="1" i="0">
+                <a:solidFill>
+                  <a:srgbClr val="6B6B6B"/>
+                </a:solidFill>
+                <a:latin typeface="Calibri"/>
+              </a:rPr>
+              <a:t>   ·   ESCUELA DE GOBIERNO</a:t>
+            </a:r>
+          </a:p>
+        </p:txBody>
+      </p:sp>
+      <p:sp>
+        <p:nvSpPr>
+          <p:cNvPr id="4" name="TextBox 3"/>
+          <p:cNvSpPr txBox="1"/>
+          <p:nvPr/>
+        </p:nvSpPr>
+        <p:spPr>
+          <a:xfrm>
+            <a:off x="868680" y="1024128"/>
+            <a:ext cx="10607040" cy="365760"/>
+          </a:xfrm>
+          <a:prstGeom prst="rect">
+            <a:avLst/>
+          </a:prstGeom>
+          <a:noFill/>
+        </p:spPr>
+        <p:txBody>
+          <a:bodyPr wrap="square" anchor="t" lIns="0" rIns="0" tIns="0" bIns="0">
+            <a:spAutoFit/>
+          </a:bodyPr>
+          <a:lstStyle/>
+          <a:p>
+            <a:pPr algn="l">
+              <a:lnSpc>
+                <a:spcPct val="106000"/>
+              </a:lnSpc>
+              <a:spcBef>
+                <a:spcPts val="0"/>
+              </a:spcBef>
+              <a:spcAft>
+                <a:spcPts val="0"/>
+              </a:spcAft>
+            </a:pPr>
+            <a:r>
+              <a:rPr sz="1300" b="1" i="0">
+                <a:solidFill>
+                  <a:srgbClr val="5E8C1E"/>
+                </a:solidFill>
+                <a:latin typeface="Calibri"/>
+              </a:rPr>
+              <a:t>CIPUV</a:t>
+            </a:r>
+            <a:r>
+              <a:rPr sz="1300" b="0" i="0">
+                <a:solidFill>
+                  <a:srgbClr val="6B6B6B"/>
+                </a:solidFill>
+                <a:latin typeface="Calibri"/>
+              </a:rPr>
+              <a:t>  —  Centro de Investigación de Políticas Urbanas y de Vivienda</a:t>
+            </a:r>
+          </a:p>
+        </p:txBody>
+      </p:sp>
+      <p:sp>
+        <p:nvSpPr>
+          <p:cNvPr id="5" name="Rectangle 4"/>
           <p:cNvSpPr/>
           <p:nvPr/>
         </p:nvSpPr>
         <p:spPr>
           <a:xfrm>
-            <a:off x="292608" y="6309360"/>
-            <a:ext cx="11899087" cy="548640"/>
+            <a:off x="868680" y="1572768"/>
+            <a:ext cx="2194560" cy="50800"/>
           </a:xfrm>
           <a:prstGeom prst="rect">
             <a:avLst/>
           </a:prstGeom>
           <a:solidFill>
-            <a:srgbClr val="2F8F9D"/>
+            <a:srgbClr val="8CC63F"/>
           </a:solidFill>
           <a:ln>
             <a:noFill/>
@@ -5736,20 +5844,134 @@
       </p:sp>
       <p:sp>
         <p:nvSpPr>
-          <p:cNvPr id="4" name="Rectangle 3"/>
+          <p:cNvPr id="6" name="TextBox 5"/>
+          <p:cNvSpPr txBox="1"/>
+          <p:nvPr/>
+        </p:nvSpPr>
+        <p:spPr>
+          <a:xfrm>
+            <a:off x="868680" y="2148840"/>
+            <a:ext cx="10607040" cy="2011680"/>
+          </a:xfrm>
+          <a:prstGeom prst="rect">
+            <a:avLst/>
+          </a:prstGeom>
+          <a:noFill/>
+        </p:spPr>
+        <p:txBody>
+          <a:bodyPr wrap="square" anchor="t" lIns="0" rIns="0" tIns="0" bIns="0">
+            <a:spAutoFit/>
+          </a:bodyPr>
+          <a:lstStyle/>
+          <a:p>
+            <a:pPr algn="l">
+              <a:lnSpc>
+                <a:spcPct val="102000"/>
+              </a:lnSpc>
+              <a:spcBef>
+                <a:spcPts val="0"/>
+              </a:spcBef>
+              <a:spcAft>
+                <a:spcPts val="200"/>
+              </a:spcAft>
+            </a:pPr>
+            <a:r>
+              <a:rPr sz="5000" b="1" i="0">
+                <a:solidFill>
+                  <a:srgbClr val="1A1A1A"/>
+                </a:solidFill>
+                <a:latin typeface="Calibri"/>
+              </a:rPr>
+              <a:t>Innovación en gestión del suelo</a:t>
+            </a:r>
+          </a:p>
+          <a:p>
+            <a:pPr algn="l">
+              <a:lnSpc>
+                <a:spcPct val="102000"/>
+              </a:lnSpc>
+              <a:spcBef>
+                <a:spcPts val="0"/>
+              </a:spcBef>
+              <a:spcAft>
+                <a:spcPts val="200"/>
+              </a:spcAft>
+            </a:pPr>
+            <a:r>
+              <a:rPr sz="5000" b="1" i="0">
+                <a:solidFill>
+                  <a:srgbClr val="5E8C1E"/>
+                </a:solidFill>
+                <a:latin typeface="Calibri"/>
+              </a:rPr>
+              <a:t>para financiar la adaptación climática</a:t>
+            </a:r>
+          </a:p>
+        </p:txBody>
+      </p:sp>
+      <p:sp>
+        <p:nvSpPr>
+          <p:cNvPr id="7" name="TextBox 6"/>
+          <p:cNvSpPr txBox="1"/>
+          <p:nvPr/>
+        </p:nvSpPr>
+        <p:spPr>
+          <a:xfrm>
+            <a:off x="868680" y="4343400"/>
+            <a:ext cx="10424160" cy="548640"/>
+          </a:xfrm>
+          <a:prstGeom prst="rect">
+            <a:avLst/>
+          </a:prstGeom>
+          <a:noFill/>
+        </p:spPr>
+        <p:txBody>
+          <a:bodyPr wrap="square" anchor="t" lIns="0" rIns="0" tIns="0" bIns="0">
+            <a:spAutoFit/>
+          </a:bodyPr>
+          <a:lstStyle/>
+          <a:p>
+            <a:pPr algn="l">
+              <a:lnSpc>
+                <a:spcPct val="106000"/>
+              </a:lnSpc>
+              <a:spcBef>
+                <a:spcPts val="0"/>
+              </a:spcBef>
+              <a:spcAft>
+                <a:spcPts val="0"/>
+              </a:spcAft>
+            </a:pPr>
+            <a:r>
+              <a:rPr sz="2000" b="0" i="1">
+                <a:solidFill>
+                  <a:srgbClr val="6B6B6B"/>
+                </a:solidFill>
+                <a:latin typeface="Calibri"/>
+              </a:rPr>
+              <a:t>Seis instrumentos de captura de valor · un Fideicomiso · el Índice de Ciudad Deseada</a:t>
+            </a:r>
+          </a:p>
+        </p:txBody>
+      </p:sp>
+      <p:sp>
+        <p:nvSpPr>
+          <p:cNvPr id="8" name="Rounded Rectangle 7"/>
           <p:cNvSpPr/>
           <p:nvPr/>
         </p:nvSpPr>
         <p:spPr>
           <a:xfrm>
-            <a:off x="6217920" y="6309360"/>
-            <a:ext cx="5973775" cy="548640"/>
-          </a:xfrm>
-          <a:prstGeom prst="rect">
-            <a:avLst/>
+            <a:off x="868680" y="5166360"/>
+            <a:ext cx="2971800" cy="384048"/>
+          </a:xfrm>
+          <a:prstGeom prst="roundRect">
+            <a:avLst>
+              <a:gd name="adj" fmla="val 50000"/>
+            </a:avLst>
           </a:prstGeom>
           <a:solidFill>
-            <a:srgbClr val="5A8F6B"/>
+            <a:srgbClr val="1A1A1A"/>
           </a:solidFill>
           <a:ln>
             <a:noFill/>
@@ -5780,27 +6002,27 @@
       </p:sp>
       <p:sp>
         <p:nvSpPr>
-          <p:cNvPr id="5" name="TextBox 4"/>
-          <p:cNvSpPr txBox="1"/>
-          <p:nvPr/>
-        </p:nvSpPr>
-        <p:spPr>
-          <a:xfrm>
-            <a:off x="868680" y="777240"/>
-            <a:ext cx="10058400" cy="365760"/>
-          </a:xfrm>
-          <a:prstGeom prst="rect">
-            <a:avLst/>
-          </a:prstGeom>
-          <a:noFill/>
-        </p:spPr>
-        <p:txBody>
-          <a:bodyPr wrap="square" anchor="t" lIns="0" rIns="0" tIns="0" bIns="0">
-            <a:spAutoFit/>
-          </a:bodyPr>
-          <a:lstStyle/>
-          <a:p>
-            <a:pPr algn="l">
+          <p:cNvPr id="9" name="TextBox 8"/>
+          <p:cNvSpPr txBox="1"/>
+          <p:nvPr/>
+        </p:nvSpPr>
+        <p:spPr>
+          <a:xfrm>
+            <a:off x="868680" y="5166360"/>
+            <a:ext cx="2971800" cy="384048"/>
+          </a:xfrm>
+          <a:prstGeom prst="rect">
+            <a:avLst/>
+          </a:prstGeom>
+          <a:noFill/>
+        </p:spPr>
+        <p:txBody>
+          <a:bodyPr wrap="square" anchor="ctr" lIns="0" rIns="0" tIns="0" bIns="0">
+            <a:spAutoFit/>
+          </a:bodyPr>
+          <a:lstStyle/>
+          <a:p>
+            <a:pPr algn="ctr">
               <a:lnSpc>
                 <a:spcPct val="106000"/>
               </a:lnSpc>
@@ -5812,184 +6034,27 @@
               </a:spcAft>
             </a:pPr>
             <a:r>
-              <a:rPr sz="1500" b="1" i="0">
-                <a:solidFill>
-                  <a:srgbClr val="D4C088"/>
-                </a:solidFill>
-                <a:latin typeface="Calibri"/>
-              </a:rPr>
-              <a:t>CIPUV–UTDT · LINCOLN INSTITUTE</a:t>
-            </a:r>
-          </a:p>
-        </p:txBody>
-      </p:sp>
-      <p:sp>
-        <p:nvSpPr>
-          <p:cNvPr id="6" name="TextBox 5"/>
-          <p:cNvSpPr txBox="1"/>
-          <p:nvPr/>
-        </p:nvSpPr>
-        <p:spPr>
-          <a:xfrm>
-            <a:off x="868680" y="1234440"/>
-            <a:ext cx="10515600" cy="457200"/>
-          </a:xfrm>
-          <a:prstGeom prst="rect">
-            <a:avLst/>
-          </a:prstGeom>
-          <a:noFill/>
-        </p:spPr>
-        <p:txBody>
-          <a:bodyPr wrap="square" anchor="t" lIns="0" rIns="0" tIns="0" bIns="0">
-            <a:spAutoFit/>
-          </a:bodyPr>
-          <a:lstStyle/>
-          <a:p>
-            <a:pPr algn="l">
-              <a:lnSpc>
-                <a:spcPct val="106000"/>
-              </a:lnSpc>
-              <a:spcBef>
-                <a:spcPts val="0"/>
-              </a:spcBef>
-              <a:spcAft>
-                <a:spcPts val="0"/>
-              </a:spcAft>
-            </a:pPr>
-            <a:r>
-              <a:rPr sz="1400" b="1" i="0">
-                <a:solidFill>
-                  <a:srgbClr val="C9D0DA"/>
-                </a:solidFill>
-                <a:latin typeface="Calibri"/>
-              </a:rPr>
-              <a:t>LUJÁN DE CUYO · MENDOZA, ARGENTINA</a:t>
-            </a:r>
-          </a:p>
-        </p:txBody>
-      </p:sp>
-      <p:sp>
-        <p:nvSpPr>
-          <p:cNvPr id="7" name="TextBox 6"/>
-          <p:cNvSpPr txBox="1"/>
-          <p:nvPr/>
-        </p:nvSpPr>
-        <p:spPr>
-          <a:xfrm>
-            <a:off x="868680" y="1965960"/>
-            <a:ext cx="10424160" cy="2011680"/>
-          </a:xfrm>
-          <a:prstGeom prst="rect">
-            <a:avLst/>
-          </a:prstGeom>
-          <a:noFill/>
-        </p:spPr>
-        <p:txBody>
-          <a:bodyPr wrap="square" anchor="t" lIns="0" rIns="0" tIns="0" bIns="0">
-            <a:spAutoFit/>
-          </a:bodyPr>
-          <a:lstStyle/>
-          <a:p>
-            <a:pPr algn="l">
-              <a:lnSpc>
-                <a:spcPct val="102000"/>
-              </a:lnSpc>
-              <a:spcBef>
-                <a:spcPts val="0"/>
-              </a:spcBef>
-              <a:spcAft>
-                <a:spcPts val="200"/>
-              </a:spcAft>
-            </a:pPr>
-            <a:r>
-              <a:rPr sz="5000" b="1" i="0">
+              <a:rPr sz="1300" b="1" i="0">
                 <a:solidFill>
                   <a:srgbClr val="FFFFFF"/>
                 </a:solidFill>
                 <a:latin typeface="Calibri"/>
               </a:rPr>
-              <a:t>Innovación en gestión del suelo</a:t>
-            </a:r>
-          </a:p>
-          <a:p>
-            <a:pPr algn="l">
-              <a:lnSpc>
-                <a:spcPct val="102000"/>
-              </a:lnSpc>
-              <a:spcBef>
-                <a:spcPts val="0"/>
-              </a:spcBef>
-              <a:spcAft>
-                <a:spcPts val="200"/>
-              </a:spcAft>
-            </a:pPr>
-            <a:r>
-              <a:rPr sz="5000" b="1" i="0">
-                <a:solidFill>
-                  <a:srgbClr val="D4C088"/>
-                </a:solidFill>
-                <a:latin typeface="Calibri"/>
-              </a:rPr>
-              <a:t>para financiar la adaptación climática</a:t>
-            </a:r>
-          </a:p>
-        </p:txBody>
-      </p:sp>
-      <p:sp>
-        <p:nvSpPr>
-          <p:cNvPr id="8" name="TextBox 7"/>
-          <p:cNvSpPr txBox="1"/>
-          <p:nvPr/>
-        </p:nvSpPr>
-        <p:spPr>
-          <a:xfrm>
-            <a:off x="868680" y="4160520"/>
-            <a:ext cx="10241280" cy="548640"/>
-          </a:xfrm>
-          <a:prstGeom prst="rect">
-            <a:avLst/>
-          </a:prstGeom>
-          <a:noFill/>
-        </p:spPr>
-        <p:txBody>
-          <a:bodyPr wrap="square" anchor="t" lIns="0" rIns="0" tIns="0" bIns="0">
-            <a:spAutoFit/>
-          </a:bodyPr>
-          <a:lstStyle/>
-          <a:p>
-            <a:pPr algn="l">
-              <a:lnSpc>
-                <a:spcPct val="106000"/>
-              </a:lnSpc>
-              <a:spcBef>
-                <a:spcPts val="0"/>
-              </a:spcBef>
-              <a:spcAft>
-                <a:spcPts val="0"/>
-              </a:spcAft>
-            </a:pPr>
-            <a:r>
-              <a:rPr sz="2000" b="0" i="1">
-                <a:solidFill>
-                  <a:srgbClr val="D8DDE4"/>
-                </a:solidFill>
-                <a:latin typeface="Calibri"/>
-              </a:rPr>
-              <a:t>Seis instrumentos de captura de valor · un Fideicomiso · el Índice de Ciudad Deseada</a:t>
-            </a:r>
-          </a:p>
-        </p:txBody>
-      </p:sp>
-      <p:sp>
-        <p:nvSpPr>
-          <p:cNvPr id="9" name="Rounded Rectangle 8"/>
+              <a:t>Caso · Luján de Cuyo, Mendoza</a:t>
+            </a:r>
+          </a:p>
+        </p:txBody>
+      </p:sp>
+      <p:sp>
+        <p:nvSpPr>
+          <p:cNvPr id="10" name="Rounded Rectangle 9"/>
           <p:cNvSpPr/>
           <p:nvPr/>
         </p:nvSpPr>
         <p:spPr>
           <a:xfrm>
-            <a:off x="868680" y="5029200"/>
-            <a:ext cx="2926080" cy="384048"/>
+            <a:off x="4023360" y="5166360"/>
+            <a:ext cx="3291840" cy="384048"/>
           </a:xfrm>
           <a:prstGeom prst="roundRect">
             <a:avLst>
@@ -5997,7 +6062,7 @@
             </a:avLst>
           </a:prstGeom>
           <a:solidFill>
-            <a:srgbClr val="2F8F9D"/>
+            <a:srgbClr val="6B6B6B"/>
           </a:solidFill>
           <a:ln>
             <a:noFill/>
@@ -6028,14 +6093,14 @@
       </p:sp>
       <p:sp>
         <p:nvSpPr>
-          <p:cNvPr id="10" name="TextBox 9"/>
-          <p:cNvSpPr txBox="1"/>
-          <p:nvPr/>
-        </p:nvSpPr>
-        <p:spPr>
-          <a:xfrm>
-            <a:off x="868680" y="5029200"/>
-            <a:ext cx="2926080" cy="384048"/>
+          <p:cNvPr id="11" name="TextBox 10"/>
+          <p:cNvSpPr txBox="1"/>
+          <p:nvPr/>
+        </p:nvSpPr>
+        <p:spPr>
+          <a:xfrm>
+            <a:off x="4023360" y="5166360"/>
+            <a:ext cx="3291840" cy="384048"/>
           </a:xfrm>
           <a:prstGeom prst="rect">
             <a:avLst/>
@@ -6066,21 +6131,21 @@
                 </a:solidFill>
                 <a:latin typeface="Calibri"/>
               </a:rPr>
-              <a:t>Caso: Mendoza, Argentina</a:t>
-            </a:r>
-          </a:p>
-        </p:txBody>
-      </p:sp>
-      <p:sp>
-        <p:nvSpPr>
-          <p:cNvPr id="11" name="Rounded Rectangle 10"/>
+              <a:t>Land Value Capture + clima</a:t>
+            </a:r>
+          </a:p>
+        </p:txBody>
+      </p:sp>
+      <p:sp>
+        <p:nvSpPr>
+          <p:cNvPr id="12" name="Rounded Rectangle 11"/>
           <p:cNvSpPr/>
           <p:nvPr/>
         </p:nvSpPr>
         <p:spPr>
           <a:xfrm>
-            <a:off x="3977639" y="5029200"/>
-            <a:ext cx="3200400" cy="384048"/>
+            <a:off x="7498079" y="5166360"/>
+            <a:ext cx="2560320" cy="384048"/>
           </a:xfrm>
           <a:prstGeom prst="roundRect">
             <a:avLst>
@@ -6088,7 +6153,7 @@
             </a:avLst>
           </a:prstGeom>
           <a:solidFill>
-            <a:srgbClr val="5A8F6B"/>
+            <a:srgbClr val="8CC63F"/>
           </a:solidFill>
           <a:ln>
             <a:noFill/>
@@ -6119,14 +6184,14 @@
       </p:sp>
       <p:sp>
         <p:nvSpPr>
-          <p:cNvPr id="12" name="TextBox 11"/>
-          <p:cNvSpPr txBox="1"/>
-          <p:nvPr/>
-        </p:nvSpPr>
-        <p:spPr>
-          <a:xfrm>
-            <a:off x="3977639" y="5029200"/>
-            <a:ext cx="3200400" cy="384048"/>
+          <p:cNvPr id="13" name="TextBox 12"/>
+          <p:cNvSpPr txBox="1"/>
+          <p:nvPr/>
+        </p:nvSpPr>
+        <p:spPr>
+          <a:xfrm>
+            <a:off x="7498079" y="5166360"/>
+            <a:ext cx="2560320" cy="384048"/>
           </a:xfrm>
           <a:prstGeom prst="rect">
             <a:avLst/>
@@ -6153,33 +6218,31 @@
             <a:r>
               <a:rPr sz="1300" b="1" i="0">
                 <a:solidFill>
-                  <a:srgbClr val="FFFFFF"/>
-                </a:solidFill>
-                <a:latin typeface="Calibri"/>
-              </a:rPr>
-              <a:t>Enfoque: Land Value Capture + clima</a:t>
-            </a:r>
-          </a:p>
-        </p:txBody>
-      </p:sp>
-      <p:sp>
-        <p:nvSpPr>
-          <p:cNvPr id="13" name="Rounded Rectangle 12"/>
+                  <a:srgbClr val="1A1A1A"/>
+                </a:solidFill>
+                <a:latin typeface="Calibri"/>
+              </a:rPr>
+              <a:t>Clase · 30 minutos</a:t>
+            </a:r>
+          </a:p>
+        </p:txBody>
+      </p:sp>
+      <p:sp>
+        <p:nvSpPr>
+          <p:cNvPr id="14" name="Rectangle 13"/>
           <p:cNvSpPr/>
           <p:nvPr/>
         </p:nvSpPr>
         <p:spPr>
           <a:xfrm>
-            <a:off x="7360920" y="5029200"/>
-            <a:ext cx="2743200" cy="384048"/>
-          </a:xfrm>
-          <a:prstGeom prst="roundRect">
-            <a:avLst>
-              <a:gd name="adj" fmla="val 50000"/>
-            </a:avLst>
+            <a:off x="868680" y="6144768"/>
+            <a:ext cx="10469880" cy="19050"/>
+          </a:xfrm>
+          <a:prstGeom prst="rect">
+            <a:avLst/>
           </a:prstGeom>
           <a:solidFill>
-            <a:srgbClr val="B8860B"/>
+            <a:srgbClr val="E0E0E0"/>
           </a:solidFill>
           <a:ln>
             <a:noFill/>
@@ -6210,27 +6273,27 @@
       </p:sp>
       <p:sp>
         <p:nvSpPr>
-          <p:cNvPr id="14" name="TextBox 13"/>
-          <p:cNvSpPr txBox="1"/>
-          <p:nvPr/>
-        </p:nvSpPr>
-        <p:spPr>
-          <a:xfrm>
-            <a:off x="7360920" y="5029200"/>
-            <a:ext cx="2743200" cy="384048"/>
-          </a:xfrm>
-          <a:prstGeom prst="rect">
-            <a:avLst/>
-          </a:prstGeom>
-          <a:noFill/>
-        </p:spPr>
-        <p:txBody>
-          <a:bodyPr wrap="square" anchor="ctr" lIns="0" rIns="0" tIns="0" bIns="0">
-            <a:spAutoFit/>
-          </a:bodyPr>
-          <a:lstStyle/>
-          <a:p>
-            <a:pPr algn="ctr">
+          <p:cNvPr id="15" name="TextBox 14"/>
+          <p:cNvSpPr txBox="1"/>
+          <p:nvPr/>
+        </p:nvSpPr>
+        <p:spPr>
+          <a:xfrm>
+            <a:off x="868680" y="6263640"/>
+            <a:ext cx="10469880" cy="365760"/>
+          </a:xfrm>
+          <a:prstGeom prst="rect">
+            <a:avLst/>
+          </a:prstGeom>
+          <a:noFill/>
+        </p:spPr>
+        <p:txBody>
+          <a:bodyPr wrap="square" anchor="t" lIns="0" rIns="0" tIns="0" bIns="0">
+            <a:spAutoFit/>
+          </a:bodyPr>
+          <a:lstStyle/>
+          <a:p>
+            <a:pPr algn="l">
               <a:lnSpc>
                 <a:spcPct val="106000"/>
               </a:lnSpc>
@@ -6242,13 +6305,13 @@
               </a:spcAft>
             </a:pPr>
             <a:r>
-              <a:rPr sz="1300" b="1" i="0">
-                <a:solidFill>
-                  <a:srgbClr val="FFFFFF"/>
-                </a:solidFill>
-                <a:latin typeface="Calibri"/>
-              </a:rPr>
-              <a:t>Clase · 30 minutos</a:t>
+              <a:rPr sz="1200" b="0" i="0">
+                <a:solidFill>
+                  <a:srgbClr val="9A9A9A"/>
+                </a:solidFill>
+                <a:latin typeface="Calibri"/>
+              </a:rPr>
+              <a:t>Cátedra de Economía Urbana · MEU   ·   en colaboración con el Lincoln Institute of Land Policy</a:t>
             </a:r>
           </a:p>
         </p:txBody>

</xml_diff>

<commit_message>
Extender identidad UTDT (verde manzana) al marco del deck: barra, kickers y divisoras
Barra superior, kickers por defecto y acentos de las láminas divisoras pasan a
verde manzana (antes dorado), coherente con la nueva portada. Se preservan los
colores que codifican datos (tramos de la tabla, acentos de instrumentos).
Aplicado en PPTX y HTML.

Co-Authored-By: Claude Opus 4.8 <noreply@anthropic.com>
Claude-Session: https://claude.ai/code/session_01QZiauNhtTVEiLX1MmVDGUu
</commit_message>
<xml_diff>
--- a/presentations/lujan-de-cuyo-gestion-suelo.pptx
+++ b/presentations/lujan-de-cuyo-gestion-suelo.pptx
@@ -6357,7 +6357,7 @@
             <a:avLst/>
           </a:prstGeom>
           <a:solidFill>
-            <a:srgbClr val="B8860B"/>
+            <a:srgbClr val="8CC63F"/>
           </a:solidFill>
           <a:ln>
             <a:noFill/>
@@ -6422,7 +6422,7 @@
             <a:r>
               <a:rPr sz="1600" b="1" i="0">
                 <a:solidFill>
-                  <a:srgbClr val="D4C088"/>
+                  <a:srgbClr val="8CC63F"/>
                 </a:solidFill>
                 <a:latin typeface="Calibri"/>
               </a:rPr>
@@ -7654,7 +7654,7 @@
             <a:avLst/>
           </a:prstGeom>
           <a:solidFill>
-            <a:srgbClr val="B8860B"/>
+            <a:srgbClr val="8CC63F"/>
           </a:solidFill>
           <a:ln>
             <a:noFill/>
@@ -8307,7 +8307,7 @@
             <a:avLst/>
           </a:prstGeom>
           <a:solidFill>
-            <a:srgbClr val="B8860B"/>
+            <a:srgbClr val="8CC63F"/>
           </a:solidFill>
           <a:ln>
             <a:noFill/>
@@ -8951,7 +8951,7 @@
             <a:avLst/>
           </a:prstGeom>
           <a:solidFill>
-            <a:srgbClr val="B8860B"/>
+            <a:srgbClr val="8CC63F"/>
           </a:solidFill>
           <a:ln>
             <a:noFill/>
@@ -9963,7 +9963,7 @@
             <a:avLst/>
           </a:prstGeom>
           <a:solidFill>
-            <a:srgbClr val="B8860B"/>
+            <a:srgbClr val="8CC63F"/>
           </a:solidFill>
           <a:ln>
             <a:noFill/>
@@ -10616,7 +10616,7 @@
             <a:avLst/>
           </a:prstGeom>
           <a:solidFill>
-            <a:srgbClr val="B8860B"/>
+            <a:srgbClr val="8CC63F"/>
           </a:solidFill>
           <a:ln>
             <a:noFill/>
@@ -10660,7 +10660,7 @@
             <a:avLst/>
           </a:prstGeom>
           <a:solidFill>
-            <a:srgbClr val="B8860B"/>
+            <a:srgbClr val="5E8C1E"/>
           </a:solidFill>
           <a:ln>
             <a:noFill/>
@@ -10725,7 +10725,7 @@
             <a:r>
               <a:rPr sz="1500" b="1" i="0">
                 <a:solidFill>
-                  <a:srgbClr val="B8860B"/>
+                  <a:srgbClr val="5E8C1E"/>
                 </a:solidFill>
                 <a:latin typeface="Calibri"/>
               </a:rPr>
@@ -11475,7 +11475,7 @@
             <a:avLst/>
           </a:prstGeom>
           <a:solidFill>
-            <a:srgbClr val="B8860B"/>
+            <a:srgbClr val="8CC63F"/>
           </a:solidFill>
           <a:ln>
             <a:noFill/>
@@ -11540,7 +11540,7 @@
             <a:r>
               <a:rPr sz="1500" b="1" i="0">
                 <a:solidFill>
-                  <a:srgbClr val="D4C088"/>
+                  <a:srgbClr val="8CC63F"/>
                 </a:solidFill>
                 <a:latin typeface="Calibri"/>
               </a:rPr>
@@ -12169,7 +12169,7 @@
             <a:avLst/>
           </a:prstGeom>
           <a:solidFill>
-            <a:srgbClr val="B8860B"/>
+            <a:srgbClr val="8CC63F"/>
           </a:solidFill>
           <a:ln>
             <a:noFill/>
@@ -12213,7 +12213,7 @@
             <a:avLst/>
           </a:prstGeom>
           <a:solidFill>
-            <a:srgbClr val="B8860B"/>
+            <a:srgbClr val="5E8C1E"/>
           </a:solidFill>
           <a:ln>
             <a:noFill/>
@@ -12278,7 +12278,7 @@
             <a:r>
               <a:rPr sz="1500" b="1" i="0">
                 <a:solidFill>
-                  <a:srgbClr val="B8860B"/>
+                  <a:srgbClr val="5E8C1E"/>
                 </a:solidFill>
                 <a:latin typeface="Calibri"/>
               </a:rPr>
@@ -14264,7 +14264,7 @@
             <a:avLst/>
           </a:prstGeom>
           <a:solidFill>
-            <a:srgbClr val="B8860B"/>
+            <a:srgbClr val="8CC63F"/>
           </a:solidFill>
           <a:ln>
             <a:noFill/>
@@ -14308,7 +14308,7 @@
             <a:avLst/>
           </a:prstGeom>
           <a:solidFill>
-            <a:srgbClr val="B8860B"/>
+            <a:srgbClr val="5E8C1E"/>
           </a:solidFill>
           <a:ln>
             <a:noFill/>
@@ -14373,7 +14373,7 @@
             <a:r>
               <a:rPr sz="1500" b="1" i="0">
                 <a:solidFill>
-                  <a:srgbClr val="B8860B"/>
+                  <a:srgbClr val="5E8C1E"/>
                 </a:solidFill>
                 <a:latin typeface="Calibri"/>
               </a:rPr>
@@ -15191,7 +15191,7 @@
             <a:avLst/>
           </a:prstGeom>
           <a:solidFill>
-            <a:srgbClr val="B8860B"/>
+            <a:srgbClr val="8CC63F"/>
           </a:solidFill>
           <a:ln>
             <a:noFill/>
@@ -16249,7 +16249,7 @@
             <a:avLst/>
           </a:prstGeom>
           <a:solidFill>
-            <a:srgbClr val="B8860B"/>
+            <a:srgbClr val="8CC63F"/>
           </a:solidFill>
           <a:ln>
             <a:noFill/>
@@ -16293,7 +16293,7 @@
             <a:avLst/>
           </a:prstGeom>
           <a:solidFill>
-            <a:srgbClr val="B8860B"/>
+            <a:srgbClr val="5E8C1E"/>
           </a:solidFill>
           <a:ln>
             <a:noFill/>
@@ -16358,7 +16358,7 @@
             <a:r>
               <a:rPr sz="1500" b="1" i="0">
                 <a:solidFill>
-                  <a:srgbClr val="B8860B"/>
+                  <a:srgbClr val="5E8C1E"/>
                 </a:solidFill>
                 <a:latin typeface="Calibri"/>
               </a:rPr>
@@ -17686,7 +17686,7 @@
             <a:avLst/>
           </a:prstGeom>
           <a:solidFill>
-            <a:srgbClr val="B8860B"/>
+            <a:srgbClr val="8CC63F"/>
           </a:solidFill>
           <a:ln>
             <a:noFill/>
@@ -18604,7 +18604,7 @@
             <a:avLst/>
           </a:prstGeom>
           <a:solidFill>
-            <a:srgbClr val="B8860B"/>
+            <a:srgbClr val="8CC63F"/>
           </a:solidFill>
           <a:ln>
             <a:noFill/>
@@ -18648,7 +18648,7 @@
             <a:avLst/>
           </a:prstGeom>
           <a:solidFill>
-            <a:srgbClr val="B8860B"/>
+            <a:srgbClr val="5E8C1E"/>
           </a:solidFill>
           <a:ln>
             <a:noFill/>
@@ -18713,7 +18713,7 @@
             <a:r>
               <a:rPr sz="1500" b="1" i="0">
                 <a:solidFill>
-                  <a:srgbClr val="B8860B"/>
+                  <a:srgbClr val="5E8C1E"/>
                 </a:solidFill>
                 <a:latin typeface="Calibri"/>
               </a:rPr>
@@ -19660,7 +19660,7 @@
             <a:avLst/>
           </a:prstGeom>
           <a:solidFill>
-            <a:srgbClr val="B8860B"/>
+            <a:srgbClr val="8CC63F"/>
           </a:solidFill>
           <a:ln>
             <a:noFill/>
@@ -21619,7 +21619,7 @@
             <a:avLst/>
           </a:prstGeom>
           <a:solidFill>
-            <a:srgbClr val="B8860B"/>
+            <a:srgbClr val="8CC63F"/>
           </a:solidFill>
           <a:ln>
             <a:noFill/>
@@ -22923,7 +22923,7 @@
             <a:avLst/>
           </a:prstGeom>
           <a:solidFill>
-            <a:srgbClr val="B8860B"/>
+            <a:srgbClr val="8CC63F"/>
           </a:solidFill>
           <a:ln>
             <a:noFill/>
@@ -25530,7 +25530,7 @@
             <a:avLst/>
           </a:prstGeom>
           <a:solidFill>
-            <a:srgbClr val="B8860B"/>
+            <a:srgbClr val="8CC63F"/>
           </a:solidFill>
           <a:ln>
             <a:noFill/>
@@ -26130,7 +26130,7 @@
             <a:avLst/>
           </a:prstGeom>
           <a:solidFill>
-            <a:srgbClr val="B8860B"/>
+            <a:srgbClr val="8CC63F"/>
           </a:solidFill>
           <a:ln>
             <a:noFill/>
@@ -26648,7 +26648,7 @@
             <a:avLst/>
           </a:prstGeom>
           <a:solidFill>
-            <a:srgbClr val="B8860B"/>
+            <a:srgbClr val="8CC63F"/>
           </a:solidFill>
           <a:ln>
             <a:noFill/>
@@ -26692,7 +26692,7 @@
             <a:avLst/>
           </a:prstGeom>
           <a:solidFill>
-            <a:srgbClr val="B8860B"/>
+            <a:srgbClr val="5E8C1E"/>
           </a:solidFill>
           <a:ln>
             <a:noFill/>
@@ -26757,7 +26757,7 @@
             <a:r>
               <a:rPr sz="1500" b="1" i="0">
                 <a:solidFill>
-                  <a:srgbClr val="B8860B"/>
+                  <a:srgbClr val="5E8C1E"/>
                 </a:solidFill>
                 <a:latin typeface="Calibri"/>
               </a:rPr>
@@ -27563,7 +27563,7 @@
             <a:avLst/>
           </a:prstGeom>
           <a:solidFill>
-            <a:srgbClr val="B8860B"/>
+            <a:srgbClr val="8CC63F"/>
           </a:solidFill>
           <a:ln>
             <a:noFill/>
@@ -28103,7 +28103,7 @@
             <a:r>
               <a:rPr sz="1900" b="1" i="0">
                 <a:solidFill>
-                  <a:srgbClr val="D4C088"/>
+                  <a:srgbClr val="8CC63F"/>
                 </a:solidFill>
                 <a:latin typeface="Calibri"/>
               </a:rPr>
@@ -28252,7 +28252,7 @@
             <a:avLst/>
           </a:prstGeom>
           <a:solidFill>
-            <a:srgbClr val="B8860B"/>
+            <a:srgbClr val="8CC63F"/>
           </a:solidFill>
           <a:ln>
             <a:noFill/>
@@ -28752,7 +28752,7 @@
             <a:avLst/>
           </a:prstGeom>
           <a:solidFill>
-            <a:srgbClr val="B8860B"/>
+            <a:srgbClr val="8CC63F"/>
           </a:solidFill>
           <a:ln>
             <a:noFill/>
@@ -28796,7 +28796,7 @@
             <a:avLst/>
           </a:prstGeom>
           <a:solidFill>
-            <a:srgbClr val="B8860B"/>
+            <a:srgbClr val="5E8C1E"/>
           </a:solidFill>
           <a:ln>
             <a:noFill/>
@@ -28861,7 +28861,7 @@
             <a:r>
               <a:rPr sz="1500" b="1" i="0">
                 <a:solidFill>
-                  <a:srgbClr val="B8860B"/>
+                  <a:srgbClr val="5E8C1E"/>
                 </a:solidFill>
                 <a:latin typeface="Calibri"/>
               </a:rPr>
@@ -29983,7 +29983,7 @@
             <a:avLst/>
           </a:prstGeom>
           <a:solidFill>
-            <a:srgbClr val="B8860B"/>
+            <a:srgbClr val="8CC63F"/>
           </a:solidFill>
           <a:ln>
             <a:noFill/>
@@ -30048,7 +30048,7 @@
             <a:r>
               <a:rPr sz="1600" b="1" i="0">
                 <a:solidFill>
-                  <a:srgbClr val="D4C088"/>
+                  <a:srgbClr val="8CC63F"/>
                 </a:solidFill>
                 <a:latin typeface="Calibri"/>
               </a:rPr>
@@ -30813,7 +30813,7 @@
             <a:avLst/>
           </a:prstGeom>
           <a:solidFill>
-            <a:srgbClr val="B8860B"/>
+            <a:srgbClr val="8CC63F"/>
           </a:solidFill>
           <a:ln>
             <a:noFill/>
@@ -30857,7 +30857,7 @@
             <a:avLst/>
           </a:prstGeom>
           <a:solidFill>
-            <a:srgbClr val="B8860B"/>
+            <a:srgbClr val="5E8C1E"/>
           </a:solidFill>
           <a:ln>
             <a:noFill/>
@@ -30922,7 +30922,7 @@
             <a:r>
               <a:rPr sz="1500" b="1" i="0">
                 <a:solidFill>
-                  <a:srgbClr val="B8860B"/>
+                  <a:srgbClr val="5E8C1E"/>
                 </a:solidFill>
                 <a:latin typeface="Calibri"/>
               </a:rPr>
@@ -31999,7 +31999,7 @@
             <a:avLst/>
           </a:prstGeom>
           <a:solidFill>
-            <a:srgbClr val="B8860B"/>
+            <a:srgbClr val="8CC63F"/>
           </a:solidFill>
           <a:ln>
             <a:noFill/>
@@ -32620,7 +32620,7 @@
             <a:avLst/>
           </a:prstGeom>
           <a:solidFill>
-            <a:srgbClr val="B8860B"/>
+            <a:srgbClr val="8CC63F"/>
           </a:solidFill>
           <a:ln>
             <a:noFill/>
@@ -33319,7 +33319,7 @@
             <a:avLst/>
           </a:prstGeom>
           <a:solidFill>
-            <a:srgbClr val="B8860B"/>
+            <a:srgbClr val="8CC63F"/>
           </a:solidFill>
           <a:ln>
             <a:noFill/>
@@ -33859,7 +33859,7 @@
             <a:r>
               <a:rPr sz="2000" b="1" i="0">
                 <a:solidFill>
-                  <a:srgbClr val="D4C088"/>
+                  <a:srgbClr val="8CC63F"/>
                 </a:solidFill>
                 <a:latin typeface="Calibri"/>
               </a:rPr>
@@ -34008,7 +34008,7 @@
             <a:avLst/>
           </a:prstGeom>
           <a:solidFill>
-            <a:srgbClr val="B8860B"/>
+            <a:srgbClr val="8CC63F"/>
           </a:solidFill>
           <a:ln>
             <a:noFill/>
@@ -34052,7 +34052,7 @@
             <a:avLst/>
           </a:prstGeom>
           <a:solidFill>
-            <a:srgbClr val="B8860B"/>
+            <a:srgbClr val="5E8C1E"/>
           </a:solidFill>
           <a:ln>
             <a:noFill/>
@@ -34117,7 +34117,7 @@
             <a:r>
               <a:rPr sz="1500" b="1" i="0">
                 <a:solidFill>
-                  <a:srgbClr val="B8860B"/>
+                  <a:srgbClr val="5E8C1E"/>
                 </a:solidFill>
                 <a:latin typeface="Calibri"/>
               </a:rPr>
@@ -34517,7 +34517,7 @@
             <a:avLst/>
           </a:prstGeom>
           <a:solidFill>
-            <a:srgbClr val="B8860B"/>
+            <a:srgbClr val="8CC63F"/>
           </a:solidFill>
           <a:ln>
             <a:noFill/>
@@ -34561,7 +34561,7 @@
             <a:avLst/>
           </a:prstGeom>
           <a:solidFill>
-            <a:srgbClr val="B8860B"/>
+            <a:srgbClr val="5E8C1E"/>
           </a:solidFill>
           <a:ln>
             <a:noFill/>
@@ -34626,7 +34626,7 @@
             <a:r>
               <a:rPr sz="1500" b="1" i="0">
                 <a:solidFill>
-                  <a:srgbClr val="B8860B"/>
+                  <a:srgbClr val="5E8C1E"/>
                 </a:solidFill>
                 <a:latin typeface="Calibri"/>
               </a:rPr>
@@ -35157,7 +35157,7 @@
             <a:avLst/>
           </a:prstGeom>
           <a:solidFill>
-            <a:srgbClr val="B8860B"/>
+            <a:srgbClr val="8CC63F"/>
           </a:solidFill>
           <a:ln>
             <a:noFill/>
@@ -35201,7 +35201,7 @@
             <a:avLst/>
           </a:prstGeom>
           <a:solidFill>
-            <a:srgbClr val="B8860B"/>
+            <a:srgbClr val="5E8C1E"/>
           </a:solidFill>
           <a:ln>
             <a:noFill/>
@@ -35266,7 +35266,7 @@
             <a:r>
               <a:rPr sz="1500" b="1" i="0">
                 <a:solidFill>
-                  <a:srgbClr val="B8860B"/>
+                  <a:srgbClr val="5E8C1E"/>
                 </a:solidFill>
                 <a:latin typeface="Calibri"/>
               </a:rPr>

</xml_diff>

<commit_message>
Corrige dato de crecimiento: 42,6% (real, INDEC/CIPUV) y elimina repetición
El slide de contexto mostraba +46% y el siguiente +42,6% para el mismo período.
El valor correcto es +42,6% / +50.546 hab. (censo 2022, del mapa CIPUV). Se quita
el dato del slide de contexto —que ahora destaca ~200 mm/año, el presupuesto de
agua— y el crecimiento queda una sola vez, en el slide del mapa de población.

Co-Authored-By: Claude Opus 4.8 <noreply@anthropic.com>
Claude-Session: https://claude.ai/code/session_01QZiauNhtTVEiLX1MmVDGUu
</commit_message>
<xml_diff>
--- a/presentations/lujan-de-cuyo-gestion-suelo.pptx
+++ b/presentations/lujan-de-cuyo-gestion-suelo.pptx
@@ -2282,7 +2282,7 @@
           <a:lstStyle/>
           <a:p>
             <a:r>
-              <a:t>El dato duro: crece 46% en doce años sobre 200 mm de lluvia. Cada hectárea que se urbaniza suma demanda de agua y resta recarga del acuífero.</a:t>
+              <a:t>El dato que define todo: apenas ~200 mm de lluvia al año; el resto llega del deshielo andino. Sobre ese presupuesto de agua, la ciudad crece —cuánto y dónde, en la lámina siguiente. Cada hectárea urbanizada suma demanda y resta recarga del acuífero.</a:t>
             </a:r>
           </a:p>
         </p:txBody>
@@ -32254,22 +32254,22 @@
               <a:t>▪  </a:t>
             </a:r>
             <a:r>
+              <a:rPr sz="2100" b="0" i="0">
+                <a:solidFill>
+                  <a:srgbClr val="2B3038"/>
+                </a:solidFill>
+                <a:latin typeface="Calibri"/>
+              </a:rPr>
+              <a:t>Todo el sistema productivo y urbano </a:t>
+            </a:r>
+            <a:r>
               <a:rPr sz="2100" b="1" i="0">
                 <a:solidFill>
                   <a:srgbClr val="2B3038"/>
                 </a:solidFill>
                 <a:latin typeface="Calibri"/>
               </a:rPr>
-              <a:t>~200 mm de lluvia al año:</a:t>
-            </a:r>
-            <a:r>
-              <a:rPr sz="2100" b="0" i="0">
-                <a:solidFill>
-                  <a:srgbClr val="2B3038"/>
-                </a:solidFill>
-                <a:latin typeface="Calibri"/>
-              </a:rPr>
-              <a:t> todo el sistema depende del deshielo andino.</a:t>
+              <a:t>depende del deshielo andino.</a:t>
             </a:r>
           </a:p>
           <a:p>
@@ -32447,13 +32447,13 @@
               </a:spcAft>
             </a:pPr>
             <a:r>
-              <a:rPr sz="5200" b="1" i="0">
+              <a:rPr sz="4400" b="1" i="0">
                 <a:solidFill>
                   <a:srgbClr val="2F8F9D"/>
                 </a:solidFill>
                 <a:latin typeface="Calibri"/>
               </a:rPr>
-              <a:t>+46%</a:t>
+              <a:t>~200 mm</a:t>
             </a:r>
           </a:p>
           <a:p>
@@ -32475,7 +32475,7 @@
                 </a:solidFill>
                 <a:latin typeface="Calibri"/>
               </a:rPr>
-              <a:t>crecimiento poblacional 2010–2022</a:t>
+              <a:t>de lluvia al año — el presupuesto de agua de la ciudad</a:t>
             </a:r>
           </a:p>
         </p:txBody>

</xml_diff>

<commit_message>
Data check: corrige población total a ~169.000 (consistente con +50.546 / +42,6%)
El slide de contexto decía ~175.000 hab., pero +50.546 hab. y +42,6% implican
169.298 (censo 2022), que además es la suma exacta de la población por distrito
del mapa. Se ajusta a ~169.000 en PPTX y HTML.

Co-Authored-By: Claude Opus 4.8 <noreply@anthropic.com>
Claude-Session: https://claude.ai/code/session_01QZiauNhtTVEiLX1MmVDGUu
</commit_message>
<xml_diff>
--- a/presentations/lujan-de-cuyo-gestion-suelo.pptx
+++ b/presentations/lujan-de-cuyo-gestion-suelo.pptx
@@ -32220,7 +32220,7 @@
                 </a:solidFill>
                 <a:latin typeface="Calibri"/>
               </a:rPr>
-              <a:t>~175.000 habitantes</a:t>
+              <a:t>~169.000 habitantes</a:t>
             </a:r>
             <a:r>
               <a:rPr sz="2100" b="0" i="0">
@@ -32229,7 +32229,7 @@
                 </a:solidFill>
                 <a:latin typeface="Calibri"/>
               </a:rPr>
-              <a:t> en un oasis semiárido al pie de los Andes.</a:t>
+              <a:t> (censo 2022) en un oasis semiárido al pie de los Andes.</a:t>
             </a:r>
           </a:p>
           <a:p>

</xml_diff>

<commit_message>
Dedup ARS 1.200 M: la cifra de microplazas queda solo en el slide de primeras obras
El slide de la regla ICD (26) ya no repite 'microplazas (ARS 1.200 M)'; enuncia
el resultado en general. La cifra concreta queda una sola vez, en el slide 20.

Co-Authored-By: Claude Opus 4.8 <noreply@anthropic.com>
Claude-Session: https://claude.ai/code/session_01QZiauNhtTVEiLX1MmVDGUu
</commit_message>
<xml_diff>
--- a/presentations/lujan-de-cuyo-gestion-suelo.pptx
+++ b/presentations/lujan-de-cuyo-gestion-suelo.pptx
@@ -26440,7 +26440,7 @@
                 </a:solidFill>
                 <a:latin typeface="Calibri"/>
               </a:rPr>
-              <a:t>Primer movimiento: </a:t>
+              <a:t>Resultado: </a:t>
             </a:r>
             <a:r>
               <a:rPr sz="2100" b="1" i="0">
@@ -26449,7 +26449,7 @@
                 </a:solidFill>
                 <a:latin typeface="Calibri"/>
               </a:rPr>
-              <a:t>microplazas (ARS 1.200 M) a los barrios que más lo necesitan</a:t>
+              <a:t>la obra se dirige a los barrios que más lo necesitan</a:t>
             </a:r>
             <a:r>
               <a:rPr sz="2100" b="0" i="0">
@@ -26458,7 +26458,7 @@
                 </a:solidFill>
                 <a:latin typeface="Calibri"/>
               </a:rPr>
-              <a:t>.</a:t>
+              <a:t>, no a los que ya puntúan bien.</a:t>
             </a:r>
           </a:p>
         </p:txBody>

</xml_diff>

<commit_message>
Slide 27: reemplaza brecha USD 56 M por recaudación realista a 10 años (~USD 30 M)
El salto a USD 56 M (brecha total de espacio verde) no era comparable con la
recaudación y sugería un salto poco realista. Se reemplaza por el acumulado a
10 años del paquete (~USD 3 M/año × 10 ≈ ~USD 30 M), antes de apalancar.
Aplicado en PPTX y HTML.

Co-Authored-By: Claude Opus 4.8 <noreply@anthropic.com>
Claude-Session: https://claude.ai/code/session_01QZiauNhtTVEiLX1MmVDGUu
</commit_message>
<xml_diff>
--- a/presentations/lujan-de-cuyo-gestion-suelo.pptx
+++ b/presentations/lujan-de-cuyo-gestion-suelo.pptx
@@ -1862,7 +1862,7 @@
           <a:lstStyle/>
           <a:p>
             <a:r>
-              <a:t>La escala en tres cifras: lo que ya hay, el potencial propio y la brecha que sólo cierra el apalancamiento. El fideicomiso es el puente entre la segunda y la tercera.</a:t>
+              <a:t>La escala en tres cifras: lo que ya se recauda, el potencial anual del paquete y el acumulado realista a diez años (~USD 30 M, a ~3 M/año, de forma conservadora y antes de apalancar con el bono verde). El fideicomiso convierte ese flujo en repago y contrapartida.</a:t>
             </a:r>
           </a:p>
         </p:txBody>
@@ -27184,7 +27184,7 @@
                 </a:solidFill>
                 <a:latin typeface="Calibri"/>
               </a:rPr>
-              <a:t>potencial del paquete completo (base)</a:t>
+              <a:t>por año, con el paquete completo (base)</a:t>
             </a:r>
           </a:p>
         </p:txBody>
@@ -27328,7 +27328,7 @@
                 </a:solidFill>
                 <a:latin typeface="Calibri"/>
               </a:rPr>
-              <a:t>USD 56 M</a:t>
+              <a:t>~USD 30 M</a:t>
             </a:r>
           </a:p>
         </p:txBody>
@@ -27373,7 +27373,7 @@
                 </a:solidFill>
                 <a:latin typeface="Calibri"/>
               </a:rPr>
-              <a:t>brecha de espacio verde → la cierra el bono verde</a:t>
+              <a:t>recaudación acumulada a 10 años (~3 M/año)</a:t>
             </a:r>
           </a:p>
         </p:txBody>
@@ -27418,7 +27418,7 @@
                 </a:solidFill>
                 <a:latin typeface="Calibri"/>
               </a:rPr>
-              <a:t>De ~1 a ~3 con el paquete; y del recurso propio, un salto a decenas con el bono verde.</a:t>
+              <a:t>De ~1 a ~3 M por año con el paquete; en una década, más de USD 30 M de recurso propio —antes de apalancar.</a:t>
             </a:r>
           </a:p>
         </p:txBody>

</xml_diff>